<commit_message>
Receipts slide goes three-way (machine / market / man): Corey's Week 3 calls, margin miss + points off the final score; his score-slide convention corrected (Tech 35-24, not Houston); boards notes + handoff
Co-Authored-By: Claude Fable 5.1 <noreply@anthropic.com>
</commit_message>
<xml_diff>
--- a/decks/2026_Week4_Episode5.pptx
+++ b/decks/2026_Week4_Episode5.pptx
@@ -12070,7 +12070,7 @@
                 </a:solidFill>
                 <a:latin typeface="Arial"/>
               </a:rPr>
-              <a:t>–14</a:t>
+              <a:t>–14 / –14</a:t>
             </a:r>
           </a:p>
         </p:txBody>
@@ -12105,7 +12105,7 @@
                 </a:solidFill>
                 <a:latin typeface="Arial"/>
               </a:rPr>
-              <a:t>market (DK / Bovada) · DK Georgia -675 / Oklahoma +490</a:t>
+              <a:t>market (DK / Bovada) · DK Georgia -625 / Oklahoma +455 · Bov Georgia -650 / Oklahoma +450</a:t>
             </a:r>
           </a:p>
         </p:txBody>
@@ -12140,7 +12140,7 @@
                 </a:solidFill>
                 <a:latin typeface="Arial"/>
               </a:rPr>
-              <a:t>Georgia 30 – Oklahoma 16</a:t>
+              <a:t>Georgia 29 – Oklahoma 15</a:t>
             </a:r>
           </a:p>
         </p:txBody>
@@ -14251,7 +14251,7 @@
                 </a:solidFill>
                 <a:latin typeface="Arial"/>
               </a:rPr>
-              <a:t>+1.5</a:t>
+              <a:t>+3 / +3</a:t>
             </a:r>
           </a:p>
         </p:txBody>
@@ -14286,7 +14286,7 @@
                 </a:solidFill>
                 <a:latin typeface="Arial"/>
               </a:rPr>
-              <a:t>market (DK / Bovada) · DK USC +102 / Oregon -122</a:t>
+              <a:t>market (DK / Bovada) · DK USC +120 / Oregon -142 · Bov USC +125 / Oregon -140</a:t>
             </a:r>
           </a:p>
         </p:txBody>
@@ -16432,7 +16432,7 @@
                 </a:solidFill>
                 <a:latin typeface="Arial"/>
               </a:rPr>
-              <a:t>–8.5</a:t>
+              <a:t>–9.5 / –10</a:t>
             </a:r>
           </a:p>
         </p:txBody>
@@ -16467,7 +16467,7 @@
                 </a:solidFill>
                 <a:latin typeface="Arial"/>
               </a:rPr>
-              <a:t>market (DK / Bovada) · DK LSU -395 / Texas A&amp;M +310</a:t>
+              <a:t>market (DK / Bovada) · DK LSU -380 / Texas A&amp;M +300 · Bov LSU -380 / Texas A&amp;M +290</a:t>
             </a:r>
           </a:p>
         </p:txBody>
@@ -16502,7 +16502,7 @@
                 </a:solidFill>
                 <a:latin typeface="Arial"/>
               </a:rPr>
-              <a:t>LSU 30 – Texas A&amp;M 24</a:t>
+              <a:t>LSU 29 – Texas A&amp;M 23</a:t>
             </a:r>
           </a:p>
         </p:txBody>
@@ -23363,7 +23363,7 @@
                 </a:solidFill>
                 <a:latin typeface="Arial"/>
               </a:rPr>
-              <a:t>market +5.5</a:t>
+              <a:t>market +3.5</a:t>
             </a:r>
           </a:p>
         </p:txBody>
@@ -23613,7 +23613,7 @@
                 </a:solidFill>
                 <a:latin typeface="Arial"/>
               </a:rPr>
-              <a:t>Florida 31 – Ole Miss 28</a:t>
+              <a:t>Florida 32 – Ole Miss 29</a:t>
             </a:r>
           </a:p>
         </p:txBody>
@@ -23648,7 +23648,7 @@
                 </a:solidFill>
                 <a:latin typeface="Arial"/>
               </a:rPr>
-              <a:t>market –2.5</a:t>
+              <a:t>market –3</a:t>
             </a:r>
           </a:p>
         </p:txBody>
@@ -23898,7 +23898,7 @@
                 </a:solidFill>
                 <a:latin typeface="Arial"/>
               </a:rPr>
-              <a:t>Georgia 30 – Oklahoma 16</a:t>
+              <a:t>Georgia 29 – Oklahoma 15</a:t>
             </a:r>
           </a:p>
         </p:txBody>
@@ -24218,7 +24218,7 @@
                 </a:solidFill>
                 <a:latin typeface="Arial"/>
               </a:rPr>
-              <a:t>market +1.5</a:t>
+              <a:t>market +3</a:t>
             </a:r>
           </a:p>
         </p:txBody>
@@ -24468,7 +24468,7 @@
                 </a:solidFill>
                 <a:latin typeface="Arial"/>
               </a:rPr>
-              <a:t>LSU 30 – Texas A&amp;M 24</a:t>
+              <a:t>LSU 29 – Texas A&amp;M 23</a:t>
             </a:r>
           </a:p>
         </p:txBody>
@@ -24503,7 +24503,7 @@
                 </a:solidFill>
                 <a:latin typeface="Arial"/>
               </a:rPr>
-              <a:t>market –8.5</a:t>
+              <a:t>market –9.5</a:t>
             </a:r>
           </a:p>
         </p:txBody>
@@ -24617,7 +24617,7 @@
                 </a:solidFill>
                 <a:latin typeface="Arial"/>
               </a:rPr>
-              <a:t>Charlotte +14 vs Louisiana · ML +425</a:t>
+              <a:t>Charlotte +10 vs Louisiana · ML +350</a:t>
             </a:r>
           </a:p>
         </p:txBody>
@@ -24687,7 +24687,7 @@
                 </a:solidFill>
                 <a:latin typeface="Arial"/>
               </a:rPr>
-              <a:t>Georgia Southern +19.5 vs #25 Houston · ML +900</a:t>
+              <a:t>Georgia Southern +17.5 vs #25 Houston · ML +625</a:t>
             </a:r>
           </a:p>
         </p:txBody>
@@ -28165,7 +28165,7 @@
                 </a:solidFill>
                 <a:latin typeface="Arial"/>
               </a:rPr>
-              <a:t>Texas –9   ·   +5.5</a:t>
+              <a:t>Texas –9   ·   +3.5 / +3.5</a:t>
             </a:r>
           </a:p>
         </p:txBody>
@@ -28485,7 +28485,7 @@
                 </a:solidFill>
                 <a:latin typeface="Arial"/>
               </a:rPr>
-              <a:t>Florida –3   ·   –2.5</a:t>
+              <a:t>Florida –3   ·   –3 / –3</a:t>
             </a:r>
           </a:p>
         </p:txBody>
@@ -28805,7 +28805,7 @@
                 </a:solidFill>
                 <a:latin typeface="Arial"/>
               </a:rPr>
-              <a:t>Georgia –14   ·   –14</a:t>
+              <a:t>Georgia –14   ·   –14 / –14</a:t>
             </a:r>
           </a:p>
         </p:txBody>
@@ -29125,7 +29125,7 @@
                 </a:solidFill>
                 <a:latin typeface="Arial"/>
               </a:rPr>
-              <a:t>Oregon –0.5   ·   +1.5</a:t>
+              <a:t>Oregon –0.5   ·   +3 / +3</a:t>
             </a:r>
           </a:p>
         </p:txBody>
@@ -29445,7 +29445,7 @@
                 </a:solidFill>
                 <a:latin typeface="Arial"/>
               </a:rPr>
-              <a:t>LSU –5.5   ·   –8.5</a:t>
+              <a:t>LSU –5.5   ·   –9.5 / –10</a:t>
             </a:r>
           </a:p>
         </p:txBody>
@@ -29515,7 +29515,7 @@
                 </a:solidFill>
                 <a:latin typeface="Arial"/>
               </a:rPr>
-              <a:t>Machine = our in-season rating + 2.5 home field · lines as of Sep 20</a:t>
+              <a:t>Machine = our in-season rating + 2.5 home field · lines as of Sep 21</a:t>
             </a:r>
           </a:p>
         </p:txBody>
@@ -29773,7 +29773,7 @@
                 </a:solidFill>
                 <a:latin typeface="Arial"/>
               </a:rPr>
-              <a:t>we called Texas Tech 33–20 · FINAL Texas Tech 28–26</a:t>
+              <a:t>Machine TTU 33–20 · Man TTU 35–24 · FINAL TTU 28–26</a:t>
             </a:r>
           </a:p>
         </p:txBody>
@@ -29843,7 +29843,7 @@
                 </a:solidFill>
                 <a:latin typeface="Arial"/>
               </a:rPr>
-              <a:t>machine off by 11 · market off by 5.5 — market closer</a:t>
+              <a:t>off by · machine 11 · market 5.5 · man 9 — market closest</a:t>
             </a:r>
           </a:p>
         </p:txBody>
@@ -30005,7 +30005,7 @@
                 </a:solidFill>
                 <a:latin typeface="Arial"/>
               </a:rPr>
-              <a:t>we called Louisville 30–29 · FINAL Louisville 41–31</a:t>
+              <a:t>Machine LOU 30–29 · Man LOU 35–34 · FINAL LOU 41–31</a:t>
             </a:r>
           </a:p>
         </p:txBody>
@@ -30075,7 +30075,7 @@
                 </a:solidFill>
                 <a:latin typeface="Arial"/>
               </a:rPr>
-              <a:t>machine off by 9 · market off by 8.5 — market closer</a:t>
+              <a:t>off by · machine 9 · market 8.5 · man 9 — market closest</a:t>
             </a:r>
           </a:p>
         </p:txBody>
@@ -30237,7 +30237,7 @@
                 </a:solidFill>
                 <a:latin typeface="Arial"/>
               </a:rPr>
-              <a:t>we called South Carolina 32–27 · FINAL Mississippi State 41–34</a:t>
+              <a:t>Machine SCAR 32–27 · Man SCAR 31–27 · FINAL MSST 41–34</a:t>
             </a:r>
           </a:p>
         </p:txBody>
@@ -30303,11 +30303,11 @@
             <a:r>
               <a:rPr sz="1000" b="1" i="0">
                 <a:solidFill>
-                  <a:srgbClr val="B5121B"/>
-                </a:solidFill>
-                <a:latin typeface="Arial"/>
-              </a:rPr>
-              <a:t>machine off by 12 · market off by 11 — market closer</a:t>
+                  <a:srgbClr val="5C6B7E"/>
+                </a:solidFill>
+                <a:latin typeface="Arial"/>
+              </a:rPr>
+              <a:t>off by · machine 12 · market 11 · man 11 — market / man tie</a:t>
             </a:r>
           </a:p>
         </p:txBody>
@@ -30469,7 +30469,7 @@
                 </a:solidFill>
                 <a:latin typeface="Arial"/>
               </a:rPr>
-              <a:t>we called Auburn 27–26 · FINAL Florida 44–39</a:t>
+              <a:t>Machine AUB 27–26 · Man AUB 28–27 · FINAL FLA 44–39</a:t>
             </a:r>
           </a:p>
         </p:txBody>
@@ -30539,7 +30539,7 @@
                 </a:solidFill>
                 <a:latin typeface="Arial"/>
               </a:rPr>
-              <a:t>machine off by 5.5 · market off by 2.5 — market closer</a:t>
+              <a:t>off by · machine 5.5 · market 2.5 · man 6 — market closest</a:t>
             </a:r>
           </a:p>
         </p:txBody>
@@ -30701,7 +30701,7 @@
                 </a:solidFill>
                 <a:latin typeface="Arial"/>
               </a:rPr>
-              <a:t>we called LSU 32–27 · FINAL Ole Miss 32–24</a:t>
+              <a:t>Machine LSU 32–27 · Man LSU 34–28 · FINAL MISS 32–24</a:t>
             </a:r>
           </a:p>
         </p:txBody>
@@ -30771,7 +30771,7 @@
                 </a:solidFill>
                 <a:latin typeface="Arial"/>
               </a:rPr>
-              <a:t>machine off by 13 · market off by 11 — market closer</a:t>
+              <a:t>off by · machine 13 · market 11 · man 14 — market closest</a:t>
             </a:r>
           </a:p>
         </p:txBody>
@@ -30844,13 +30844,13 @@
           <a:p>
             <a:pPr algn="l"/>
             <a:r>
-              <a:rPr sz="1500" b="1" i="0">
+              <a:rPr sz="1450" b="1" i="0">
                 <a:solidFill>
                   <a:srgbClr val="FFFFFF"/>
                 </a:solidFill>
                 <a:latin typeface="Arial"/>
               </a:rPr>
-              <a:t>Machine 50.5 · market 38.5 · machine closer in 0, market 5, 0 tie · vs the deserved margins: machine 73.7</a:t>
+              <a:t>Margin miss: market 38.5 · man 49.0 · machine 50.5 — closest: market 4, man 0, machine 0, 1 tie</a:t>
             </a:r>
           </a:p>
         </p:txBody>
@@ -30879,13 +30879,13 @@
           <a:p>
             <a:pPr algn="l"/>
             <a:r>
-              <a:rPr sz="1150" b="0" i="0">
+              <a:rPr sz="1050" b="0" i="0">
                 <a:solidFill>
                   <a:srgbClr val="CADCFC"/>
                 </a:solidFill>
                 <a:latin typeface="Arial"/>
               </a:rPr>
-              <a:t>Season: machine 211.5 vs market 205.5 across 20 games · stated leans 4–3 · Auburn +2.5 lost by 5</a:t>
+              <a:t>Points off the final score: man 77 · machine 83 · market-implied 76   |   Season margin: machine 211.5 vs market 205.5, 20 games · stated leans 4–3</a:t>
             </a:r>
           </a:p>
         </p:txBody>
@@ -31476,7 +31476,7 @@
                 </a:solidFill>
                 <a:latin typeface="Arial"/>
               </a:rPr>
-              <a:t>+5.5</a:t>
+              <a:t>+3.5 / +3.5</a:t>
             </a:r>
           </a:p>
         </p:txBody>
@@ -31511,7 +31511,7 @@
                 </a:solidFill>
                 <a:latin typeface="Arial"/>
               </a:rPr>
-              <a:t>market (DK / Bovada) · DK Tennessee +180 / Texas -218</a:t>
+              <a:t>market (DK / Bovada) · DK Tennessee +154 / Texas -185 · Bov Tennessee +155 / Texas -180</a:t>
             </a:r>
           </a:p>
         </p:txBody>
@@ -33657,7 +33657,7 @@
                 </a:solidFill>
                 <a:latin typeface="Arial"/>
               </a:rPr>
-              <a:t>–2.5</a:t>
+              <a:t>–3 / –3</a:t>
             </a:r>
           </a:p>
         </p:txBody>
@@ -33692,7 +33692,7 @@
                 </a:solidFill>
                 <a:latin typeface="Arial"/>
               </a:rPr>
-              <a:t>market (DK / Bovada) · DK Florida -135 / Ole Miss +114</a:t>
+              <a:t>market (DK / Bovada) · DK Florida -162 / Ole Miss +136 · Bov Florida -165 / Ole Miss +140</a:t>
             </a:r>
           </a:p>
         </p:txBody>
@@ -33727,7 +33727,7 @@
                 </a:solidFill>
                 <a:latin typeface="Arial"/>
               </a:rPr>
-              <a:t>Florida 31 – Ole Miss 28</a:t>
+              <a:t>Florida 32 – Ole Miss 29</a:t>
             </a:r>
           </a:p>
         </p:txBody>

</xml_diff>

<commit_message>
Receipts slide is man vs machine only (market internal); per-team score tracker; market_deep_dive.py (output gitignored under internal/)
Co-Authored-By: Claude Fable 5.1 <noreply@anthropic.com>
</commit_message>
<xml_diff>
--- a/decks/2026_Week4_Episode5.pptx
+++ b/decks/2026_Week4_Episode5.pptx
@@ -29611,7 +29611,7 @@
                 </a:solidFill>
                 <a:latin typeface="Arial"/>
               </a:rPr>
-              <a:t>Calls frozen at recording · closing line = last pre-kick pull · off by = miss vs the final margin · deserved = the efficiency margin</a:t>
+              <a:t>Calls frozen at recording · off by = miss vs the final margin · deserved = the efficiency margin</a:t>
             </a:r>
           </a:p>
         </p:txBody>
@@ -29808,7 +29808,7 @@
                 </a:solidFill>
                 <a:latin typeface="Arial"/>
               </a:rPr>
-              <a:t>our line Texas Tech –13 · closing Texas Tech –7.5 · deserved HOU +4.9</a:t>
+              <a:t>our line Texas Tech –13 · deserved HOU +4.9</a:t>
             </a:r>
           </a:p>
         </p:txBody>
@@ -29839,11 +29839,11 @@
             <a:r>
               <a:rPr sz="1000" b="1" i="0">
                 <a:solidFill>
-                  <a:srgbClr val="B5121B"/>
-                </a:solidFill>
-                <a:latin typeface="Arial"/>
-              </a:rPr>
-              <a:t>off by · machine 11 · market 5.5 · man 9 — market closest</a:t>
+                  <a:srgbClr val="1F7A4D"/>
+                </a:solidFill>
+                <a:latin typeface="Arial"/>
+              </a:rPr>
+              <a:t>off by · machine 11 · man 9 — man closer</a:t>
             </a:r>
           </a:p>
         </p:txBody>
@@ -30040,7 +30040,7 @@
                 </a:solidFill>
                 <a:latin typeface="Arial"/>
               </a:rPr>
-              <a:t>our line Louisville –1 · closing Louisville –1.5 · deserved LOU +24.3</a:t>
+              <a:t>our line Louisville –1 · deserved LOU +24.3</a:t>
             </a:r>
           </a:p>
         </p:txBody>
@@ -30071,11 +30071,11 @@
             <a:r>
               <a:rPr sz="1000" b="1" i="0">
                 <a:solidFill>
-                  <a:srgbClr val="B5121B"/>
-                </a:solidFill>
-                <a:latin typeface="Arial"/>
-              </a:rPr>
-              <a:t>off by · machine 9 · market 8.5 · man 9 — market closest</a:t>
+                  <a:srgbClr val="5C6B7E"/>
+                </a:solidFill>
+                <a:latin typeface="Arial"/>
+              </a:rPr>
+              <a:t>off by · machine 9 · man 9 — dead tie</a:t>
             </a:r>
           </a:p>
         </p:txBody>
@@ -30272,7 +30272,7 @@
                 </a:solidFill>
                 <a:latin typeface="Arial"/>
               </a:rPr>
-              <a:t>our line South Carolina –5 · closing South Carolina –4 · deserved MSST +6.4</a:t>
+              <a:t>our line South Carolina –5 · deserved MSST +6.4</a:t>
             </a:r>
           </a:p>
         </p:txBody>
@@ -30303,11 +30303,11 @@
             <a:r>
               <a:rPr sz="1000" b="1" i="0">
                 <a:solidFill>
-                  <a:srgbClr val="5C6B7E"/>
-                </a:solidFill>
-                <a:latin typeface="Arial"/>
-              </a:rPr>
-              <a:t>off by · machine 12 · market 11 · man 11 — market / man tie</a:t>
+                  <a:srgbClr val="1F7A4D"/>
+                </a:solidFill>
+                <a:latin typeface="Arial"/>
+              </a:rPr>
+              <a:t>off by · machine 12 · man 11 — man closer</a:t>
             </a:r>
           </a:p>
         </p:txBody>
@@ -30504,7 +30504,7 @@
                 </a:solidFill>
                 <a:latin typeface="Arial"/>
               </a:rPr>
-              <a:t>our line Auburn –0.5 · closing Florida –2.5 · deserved FLA +9.3</a:t>
+              <a:t>our line Auburn –0.5 · deserved FLA +9.3</a:t>
             </a:r>
           </a:p>
         </p:txBody>
@@ -30535,11 +30535,11 @@
             <a:r>
               <a:rPr sz="1000" b="1" i="0">
                 <a:solidFill>
-                  <a:srgbClr val="B5121B"/>
-                </a:solidFill>
-                <a:latin typeface="Arial"/>
-              </a:rPr>
-              <a:t>off by · machine 5.5 · market 2.5 · man 6 — market closest</a:t>
+                  <a:srgbClr val="F47321"/>
+                </a:solidFill>
+                <a:latin typeface="Arial"/>
+              </a:rPr>
+              <a:t>off by · machine 5.5 · man 6 — machine closer</a:t>
             </a:r>
           </a:p>
         </p:txBody>
@@ -30736,7 +30736,7 @@
                 </a:solidFill>
                 <a:latin typeface="Arial"/>
               </a:rPr>
-              <a:t>our line LSU –5 · closing LSU –3 · deserved MISS +6.3</a:t>
+              <a:t>our line LSU –5 · deserved MISS +6.3</a:t>
             </a:r>
           </a:p>
         </p:txBody>
@@ -30767,11 +30767,11 @@
             <a:r>
               <a:rPr sz="1000" b="1" i="0">
                 <a:solidFill>
-                  <a:srgbClr val="B5121B"/>
-                </a:solidFill>
-                <a:latin typeface="Arial"/>
-              </a:rPr>
-              <a:t>off by · machine 13 · market 11 · man 14 — market closest</a:t>
+                  <a:srgbClr val="F47321"/>
+                </a:solidFill>
+                <a:latin typeface="Arial"/>
+              </a:rPr>
+              <a:t>off by · machine 13 · man 14 — machine closer</a:t>
             </a:r>
           </a:p>
         </p:txBody>
@@ -30850,7 +30850,7 @@
                 </a:solidFill>
                 <a:latin typeface="Arial"/>
               </a:rPr>
-              <a:t>Margin miss: market 38.5 · man 49.0 · machine 50.5 — closest: market 4, man 0, machine 0, 1 tie</a:t>
+              <a:t>Margin miss: man 49.0 · machine 50.5 — closer: man 2, machine 2, 1 tie</a:t>
             </a:r>
           </a:p>
         </p:txBody>
@@ -30885,7 +30885,7 @@
                 </a:solidFill>
                 <a:latin typeface="Arial"/>
               </a:rPr>
-              <a:t>Points off the final score: man 77 · machine 83 · market-implied 76   |   Season margin: machine 211.5 vs market 205.5, 20 games · stated leans 4–3</a:t>
+              <a:t>Points off the final score: man 77 · machine 83   |   Machine's season: 211.5 off across 20 games · vs the deserved margins this week: 73.7</a:t>
             </a:r>
           </a:p>
         </p:txBody>

</xml_diff>

<commit_message>
Market off every slide (SLIDES_SHOW_MARKET = False): card, number box, closer, Heisman board; honesty box = the machine's confidence; Heisman stat lines through Week 3
Co-Authored-By: Claude Fable 5.1 <noreply@anthropic.com>
</commit_message>
<xml_diff>
--- a/decks/2026_Week4_Episode5.pptx
+++ b/decks/2026_Week4_Episode5.pptx
@@ -11851,7 +11851,7 @@
                 </a:solidFill>
                 <a:latin typeface="Arial"/>
               </a:rPr>
-              <a:t>Machine = market — no play</a:t>
+              <a:t>81% — the most confident call on the card</a:t>
             </a:r>
           </a:p>
         </p:txBody>
@@ -11865,7 +11865,7 @@
         <p:spPr>
           <a:xfrm>
             <a:off x="7772400" y="1600200"/>
-            <a:ext cx="3566160" cy="4206240"/>
+            <a:ext cx="3566160" cy="3611880"/>
           </a:xfrm>
           <a:prstGeom prst="roundRect">
             <a:avLst/>
@@ -12048,8 +12048,8 @@
         </p:nvSpPr>
         <p:spPr>
           <a:xfrm>
-            <a:off x="8046720" y="3246120"/>
-            <a:ext cx="3017520" cy="411480"/>
+            <a:off x="8046720" y="3383280"/>
+            <a:ext cx="3017520" cy="365760"/>
           </a:xfrm>
           <a:prstGeom prst="rect">
             <a:avLst/>
@@ -12064,13 +12064,13 @@
           <a:p>
             <a:pPr algn="l"/>
             <a:r>
-              <a:rPr sz="2000" b="1" i="0">
-                <a:solidFill>
-                  <a:srgbClr val="FFFFFF"/>
-                </a:solidFill>
-                <a:latin typeface="Arial"/>
-              </a:rPr>
-              <a:t>–14 / –14</a:t>
+              <a:rPr sz="1300" b="1" i="0">
+                <a:solidFill>
+                  <a:srgbClr val="F47321"/>
+                </a:solidFill>
+                <a:latin typeface="Arial"/>
+              </a:rPr>
+              <a:t>Georgia 29 – Oklahoma 15</a:t>
             </a:r>
           </a:p>
         </p:txBody>
@@ -12083,8 +12083,8 @@
         </p:nvSpPr>
         <p:spPr>
           <a:xfrm>
-            <a:off x="8046720" y="3639312"/>
-            <a:ext cx="3017520" cy="365760"/>
+            <a:off x="8046720" y="3767328"/>
+            <a:ext cx="3017520" cy="228600"/>
           </a:xfrm>
           <a:prstGeom prst="rect">
             <a:avLst/>
@@ -12105,76 +12105,6 @@
                 </a:solidFill>
                 <a:latin typeface="Arial"/>
               </a:rPr>
-              <a:t>market (DK / Bovada) · DK Georgia -625 / Oklahoma +455 · Bov Georgia -650 / Oklahoma +450</a:t>
-            </a:r>
-          </a:p>
-        </p:txBody>
-      </p:sp>
-      <p:sp>
-        <p:nvSpPr>
-          <p:cNvPr id="19" name="TextBox 18"/>
-          <p:cNvSpPr txBox="1"/>
-          <p:nvPr/>
-        </p:nvSpPr>
-        <p:spPr>
-          <a:xfrm>
-            <a:off x="8046720" y="4069080"/>
-            <a:ext cx="3017520" cy="365760"/>
-          </a:xfrm>
-          <a:prstGeom prst="rect">
-            <a:avLst/>
-          </a:prstGeom>
-          <a:noFill/>
-        </p:spPr>
-        <p:txBody>
-          <a:bodyPr wrap="square" lIns="0" rIns="0" tIns="0" bIns="0">
-            <a:spAutoFit/>
-          </a:bodyPr>
-          <a:lstStyle/>
-          <a:p>
-            <a:pPr algn="l"/>
-            <a:r>
-              <a:rPr sz="1300" b="1" i="0">
-                <a:solidFill>
-                  <a:srgbClr val="F47321"/>
-                </a:solidFill>
-                <a:latin typeface="Arial"/>
-              </a:rPr>
-              <a:t>Georgia 29 – Oklahoma 15</a:t>
-            </a:r>
-          </a:p>
-        </p:txBody>
-      </p:sp>
-      <p:sp>
-        <p:nvSpPr>
-          <p:cNvPr id="20" name="TextBox 19"/>
-          <p:cNvSpPr txBox="1"/>
-          <p:nvPr/>
-        </p:nvSpPr>
-        <p:spPr>
-          <a:xfrm>
-            <a:off x="8046720" y="4407408"/>
-            <a:ext cx="3017520" cy="228600"/>
-          </a:xfrm>
-          <a:prstGeom prst="rect">
-            <a:avLst/>
-          </a:prstGeom>
-          <a:noFill/>
-        </p:spPr>
-        <p:txBody>
-          <a:bodyPr wrap="square" lIns="0" rIns="0" tIns="0" bIns="0">
-            <a:spAutoFit/>
-          </a:bodyPr>
-          <a:lstStyle/>
-          <a:p>
-            <a:pPr algn="l"/>
-            <a:r>
-              <a:rPr sz="850" b="0" i="0">
-                <a:solidFill>
-                  <a:srgbClr val="CADCFC"/>
-                </a:solidFill>
-                <a:latin typeface="Arial"/>
-              </a:rPr>
               <a:t>score prediction</a:t>
             </a:r>
           </a:p>
@@ -12182,13 +12112,13 @@
       </p:sp>
       <p:sp>
         <p:nvSpPr>
-          <p:cNvPr id="21" name="Rounded Rectangle 20"/>
+          <p:cNvPr id="19" name="Rounded Rectangle 18"/>
           <p:cNvSpPr/>
           <p:nvPr/>
         </p:nvSpPr>
         <p:spPr>
           <a:xfrm>
-            <a:off x="8046720" y="4754880"/>
+            <a:off x="8046720" y="4206240"/>
             <a:ext cx="3017520" cy="365760"/>
           </a:xfrm>
           <a:prstGeom prst="roundRect">
@@ -12226,13 +12156,13 @@
       </p:sp>
       <p:sp>
         <p:nvSpPr>
-          <p:cNvPr id="22" name="Rounded Rectangle 21"/>
+          <p:cNvPr id="20" name="Rounded Rectangle 19"/>
           <p:cNvSpPr/>
           <p:nvPr/>
         </p:nvSpPr>
         <p:spPr>
           <a:xfrm>
-            <a:off x="8046720" y="4754880"/>
+            <a:off x="8046720" y="4206240"/>
             <a:ext cx="2444191" cy="365760"/>
           </a:xfrm>
           <a:prstGeom prst="roundRect">
@@ -12270,83 +12200,83 @@
       </p:sp>
       <p:sp>
         <p:nvSpPr>
+          <p:cNvPr id="21" name="TextBox 20"/>
+          <p:cNvSpPr txBox="1"/>
+          <p:nvPr/>
+        </p:nvSpPr>
+        <p:spPr>
+          <a:xfrm>
+            <a:off x="8119872" y="4288536"/>
+            <a:ext cx="2194560" cy="228600"/>
+          </a:xfrm>
+          <a:prstGeom prst="rect">
+            <a:avLst/>
+          </a:prstGeom>
+          <a:noFill/>
+        </p:spPr>
+        <p:txBody>
+          <a:bodyPr wrap="square" lIns="0" rIns="0" tIns="0" bIns="0">
+            <a:spAutoFit/>
+          </a:bodyPr>
+          <a:lstStyle/>
+          <a:p>
+            <a:pPr algn="l"/>
+            <a:r>
+              <a:rPr sz="1050" b="1" i="0">
+                <a:solidFill>
+                  <a:srgbClr val="FFFFFF"/>
+                </a:solidFill>
+                <a:latin typeface="Arial"/>
+              </a:rPr>
+              <a:t>UGA 81%</a:t>
+            </a:r>
+          </a:p>
+        </p:txBody>
+      </p:sp>
+      <p:sp>
+        <p:nvSpPr>
+          <p:cNvPr id="22" name="TextBox 21"/>
+          <p:cNvSpPr txBox="1"/>
+          <p:nvPr/>
+        </p:nvSpPr>
+        <p:spPr>
+          <a:xfrm>
+            <a:off x="8796528" y="4288536"/>
+            <a:ext cx="2194560" cy="228600"/>
+          </a:xfrm>
+          <a:prstGeom prst="rect">
+            <a:avLst/>
+          </a:prstGeom>
+          <a:noFill/>
+        </p:spPr>
+        <p:txBody>
+          <a:bodyPr wrap="square" lIns="0" rIns="0" tIns="0" bIns="0">
+            <a:spAutoFit/>
+          </a:bodyPr>
+          <a:lstStyle/>
+          <a:p>
+            <a:pPr algn="r"/>
+            <a:r>
+              <a:rPr sz="1050" b="1" i="0">
+                <a:solidFill>
+                  <a:srgbClr val="FFFFFF"/>
+                </a:solidFill>
+                <a:latin typeface="Arial"/>
+              </a:rPr>
+              <a:t>19% OU</a:t>
+            </a:r>
+          </a:p>
+        </p:txBody>
+      </p:sp>
+      <p:sp>
+        <p:nvSpPr>
           <p:cNvPr id="23" name="TextBox 22"/>
           <p:cNvSpPr txBox="1"/>
           <p:nvPr/>
         </p:nvSpPr>
         <p:spPr>
           <a:xfrm>
-            <a:off x="8119872" y="4837176"/>
-            <a:ext cx="2194560" cy="228600"/>
-          </a:xfrm>
-          <a:prstGeom prst="rect">
-            <a:avLst/>
-          </a:prstGeom>
-          <a:noFill/>
-        </p:spPr>
-        <p:txBody>
-          <a:bodyPr wrap="square" lIns="0" rIns="0" tIns="0" bIns="0">
-            <a:spAutoFit/>
-          </a:bodyPr>
-          <a:lstStyle/>
-          <a:p>
-            <a:pPr algn="l"/>
-            <a:r>
-              <a:rPr sz="1050" b="1" i="0">
-                <a:solidFill>
-                  <a:srgbClr val="FFFFFF"/>
-                </a:solidFill>
-                <a:latin typeface="Arial"/>
-              </a:rPr>
-              <a:t>UGA 81%</a:t>
-            </a:r>
-          </a:p>
-        </p:txBody>
-      </p:sp>
-      <p:sp>
-        <p:nvSpPr>
-          <p:cNvPr id="24" name="TextBox 23"/>
-          <p:cNvSpPr txBox="1"/>
-          <p:nvPr/>
-        </p:nvSpPr>
-        <p:spPr>
-          <a:xfrm>
-            <a:off x="8796528" y="4837176"/>
-            <a:ext cx="2194560" cy="228600"/>
-          </a:xfrm>
-          <a:prstGeom prst="rect">
-            <a:avLst/>
-          </a:prstGeom>
-          <a:noFill/>
-        </p:spPr>
-        <p:txBody>
-          <a:bodyPr wrap="square" lIns="0" rIns="0" tIns="0" bIns="0">
-            <a:spAutoFit/>
-          </a:bodyPr>
-          <a:lstStyle/>
-          <a:p>
-            <a:pPr algn="r"/>
-            <a:r>
-              <a:rPr sz="1050" b="1" i="0">
-                <a:solidFill>
-                  <a:srgbClr val="FFFFFF"/>
-                </a:solidFill>
-                <a:latin typeface="Arial"/>
-              </a:rPr>
-              <a:t>19% OU</a:t>
-            </a:r>
-          </a:p>
-        </p:txBody>
-      </p:sp>
-      <p:sp>
-        <p:nvSpPr>
-          <p:cNvPr id="25" name="TextBox 24"/>
-          <p:cNvSpPr txBox="1"/>
-          <p:nvPr/>
-        </p:nvSpPr>
-        <p:spPr>
-          <a:xfrm>
-            <a:off x="8046720" y="5175504"/>
+            <a:off x="8046720" y="4626864"/>
             <a:ext cx="3017520" cy="228600"/>
           </a:xfrm>
           <a:prstGeom prst="rect">
@@ -14032,7 +13962,7 @@
                 </a:solidFill>
                 <a:latin typeface="Arial"/>
               </a:rPr>
-              <a:t>Pick'em — no position</a:t>
+              <a:t>A coin flip — the machine's honest answer</a:t>
             </a:r>
           </a:p>
         </p:txBody>
@@ -14046,7 +13976,7 @@
         <p:spPr>
           <a:xfrm>
             <a:off x="7772400" y="1600200"/>
-            <a:ext cx="3566160" cy="4206240"/>
+            <a:ext cx="3566160" cy="3611880"/>
           </a:xfrm>
           <a:prstGeom prst="roundRect">
             <a:avLst/>
@@ -14229,8 +14159,8 @@
         </p:nvSpPr>
         <p:spPr>
           <a:xfrm>
-            <a:off x="8046720" y="3246120"/>
-            <a:ext cx="3017520" cy="411480"/>
+            <a:off x="8046720" y="3383280"/>
+            <a:ext cx="3017520" cy="365760"/>
           </a:xfrm>
           <a:prstGeom prst="rect">
             <a:avLst/>
@@ -14245,13 +14175,13 @@
           <a:p>
             <a:pPr algn="l"/>
             <a:r>
-              <a:rPr sz="2000" b="1" i="0">
-                <a:solidFill>
-                  <a:srgbClr val="FFFFFF"/>
-                </a:solidFill>
-                <a:latin typeface="Arial"/>
-              </a:rPr>
-              <a:t>+3 / +3</a:t>
+              <a:rPr sz="1700" b="1" i="0">
+                <a:solidFill>
+                  <a:srgbClr val="F47321"/>
+                </a:solidFill>
+                <a:latin typeface="Arial"/>
+              </a:rPr>
+              <a:t>Oregon 32 – USC 31</a:t>
             </a:r>
           </a:p>
         </p:txBody>
@@ -14264,8 +14194,8 @@
         </p:nvSpPr>
         <p:spPr>
           <a:xfrm>
-            <a:off x="8046720" y="3639312"/>
-            <a:ext cx="3017520" cy="365760"/>
+            <a:off x="8046720" y="3767328"/>
+            <a:ext cx="3017520" cy="228600"/>
           </a:xfrm>
           <a:prstGeom prst="rect">
             <a:avLst/>
@@ -14286,76 +14216,6 @@
                 </a:solidFill>
                 <a:latin typeface="Arial"/>
               </a:rPr>
-              <a:t>market (DK / Bovada) · DK USC +120 / Oregon -142 · Bov USC +125 / Oregon -140</a:t>
-            </a:r>
-          </a:p>
-        </p:txBody>
-      </p:sp>
-      <p:sp>
-        <p:nvSpPr>
-          <p:cNvPr id="19" name="TextBox 18"/>
-          <p:cNvSpPr txBox="1"/>
-          <p:nvPr/>
-        </p:nvSpPr>
-        <p:spPr>
-          <a:xfrm>
-            <a:off x="8046720" y="4069080"/>
-            <a:ext cx="3017520" cy="365760"/>
-          </a:xfrm>
-          <a:prstGeom prst="rect">
-            <a:avLst/>
-          </a:prstGeom>
-          <a:noFill/>
-        </p:spPr>
-        <p:txBody>
-          <a:bodyPr wrap="square" lIns="0" rIns="0" tIns="0" bIns="0">
-            <a:spAutoFit/>
-          </a:bodyPr>
-          <a:lstStyle/>
-          <a:p>
-            <a:pPr algn="l"/>
-            <a:r>
-              <a:rPr sz="1500" b="1" i="0">
-                <a:solidFill>
-                  <a:srgbClr val="F47321"/>
-                </a:solidFill>
-                <a:latin typeface="Arial"/>
-              </a:rPr>
-              <a:t>Oregon 32 – USC 31</a:t>
-            </a:r>
-          </a:p>
-        </p:txBody>
-      </p:sp>
-      <p:sp>
-        <p:nvSpPr>
-          <p:cNvPr id="20" name="TextBox 19"/>
-          <p:cNvSpPr txBox="1"/>
-          <p:nvPr/>
-        </p:nvSpPr>
-        <p:spPr>
-          <a:xfrm>
-            <a:off x="8046720" y="4407408"/>
-            <a:ext cx="3017520" cy="228600"/>
-          </a:xfrm>
-          <a:prstGeom prst="rect">
-            <a:avLst/>
-          </a:prstGeom>
-          <a:noFill/>
-        </p:spPr>
-        <p:txBody>
-          <a:bodyPr wrap="square" lIns="0" rIns="0" tIns="0" bIns="0">
-            <a:spAutoFit/>
-          </a:bodyPr>
-          <a:lstStyle/>
-          <a:p>
-            <a:pPr algn="l"/>
-            <a:r>
-              <a:rPr sz="850" b="0" i="0">
-                <a:solidFill>
-                  <a:srgbClr val="CADCFC"/>
-                </a:solidFill>
-                <a:latin typeface="Arial"/>
-              </a:rPr>
               <a:t>score prediction</a:t>
             </a:r>
           </a:p>
@@ -14363,13 +14223,13 @@
       </p:sp>
       <p:sp>
         <p:nvSpPr>
-          <p:cNvPr id="21" name="Rounded Rectangle 20"/>
+          <p:cNvPr id="19" name="Rounded Rectangle 18"/>
           <p:cNvSpPr/>
           <p:nvPr/>
         </p:nvSpPr>
         <p:spPr>
           <a:xfrm>
-            <a:off x="8046720" y="4754880"/>
+            <a:off x="8046720" y="4206240"/>
             <a:ext cx="3017520" cy="365760"/>
           </a:xfrm>
           <a:prstGeom prst="roundRect">
@@ -14407,13 +14267,13 @@
       </p:sp>
       <p:sp>
         <p:nvSpPr>
-          <p:cNvPr id="22" name="Rounded Rectangle 21"/>
+          <p:cNvPr id="20" name="Rounded Rectangle 19"/>
           <p:cNvSpPr/>
           <p:nvPr/>
         </p:nvSpPr>
         <p:spPr>
           <a:xfrm>
-            <a:off x="8046720" y="4754880"/>
+            <a:off x="8046720" y="4206240"/>
             <a:ext cx="1508760" cy="365760"/>
           </a:xfrm>
           <a:prstGeom prst="roundRect">
@@ -14451,83 +14311,83 @@
       </p:sp>
       <p:sp>
         <p:nvSpPr>
+          <p:cNvPr id="21" name="TextBox 20"/>
+          <p:cNvSpPr txBox="1"/>
+          <p:nvPr/>
+        </p:nvSpPr>
+        <p:spPr>
+          <a:xfrm>
+            <a:off x="8119872" y="4288536"/>
+            <a:ext cx="2194560" cy="228600"/>
+          </a:xfrm>
+          <a:prstGeom prst="rect">
+            <a:avLst/>
+          </a:prstGeom>
+          <a:noFill/>
+        </p:spPr>
+        <p:txBody>
+          <a:bodyPr wrap="square" lIns="0" rIns="0" tIns="0" bIns="0">
+            <a:spAutoFit/>
+          </a:bodyPr>
+          <a:lstStyle/>
+          <a:p>
+            <a:pPr algn="l"/>
+            <a:r>
+              <a:rPr sz="1050" b="1" i="0">
+                <a:solidFill>
+                  <a:srgbClr val="FFFFFF"/>
+                </a:solidFill>
+                <a:latin typeface="Arial"/>
+              </a:rPr>
+              <a:t>USC 50%</a:t>
+            </a:r>
+          </a:p>
+        </p:txBody>
+      </p:sp>
+      <p:sp>
+        <p:nvSpPr>
+          <p:cNvPr id="22" name="TextBox 21"/>
+          <p:cNvSpPr txBox="1"/>
+          <p:nvPr/>
+        </p:nvSpPr>
+        <p:spPr>
+          <a:xfrm>
+            <a:off x="8796528" y="4288536"/>
+            <a:ext cx="2194560" cy="228600"/>
+          </a:xfrm>
+          <a:prstGeom prst="rect">
+            <a:avLst/>
+          </a:prstGeom>
+          <a:noFill/>
+        </p:spPr>
+        <p:txBody>
+          <a:bodyPr wrap="square" lIns="0" rIns="0" tIns="0" bIns="0">
+            <a:spAutoFit/>
+          </a:bodyPr>
+          <a:lstStyle/>
+          <a:p>
+            <a:pPr algn="r"/>
+            <a:r>
+              <a:rPr sz="1050" b="1" i="0">
+                <a:solidFill>
+                  <a:srgbClr val="FFFFFF"/>
+                </a:solidFill>
+                <a:latin typeface="Arial"/>
+              </a:rPr>
+              <a:t>50% ORE</a:t>
+            </a:r>
+          </a:p>
+        </p:txBody>
+      </p:sp>
+      <p:sp>
+        <p:nvSpPr>
           <p:cNvPr id="23" name="TextBox 22"/>
           <p:cNvSpPr txBox="1"/>
           <p:nvPr/>
         </p:nvSpPr>
         <p:spPr>
           <a:xfrm>
-            <a:off x="8119872" y="4837176"/>
-            <a:ext cx="2194560" cy="228600"/>
-          </a:xfrm>
-          <a:prstGeom prst="rect">
-            <a:avLst/>
-          </a:prstGeom>
-          <a:noFill/>
-        </p:spPr>
-        <p:txBody>
-          <a:bodyPr wrap="square" lIns="0" rIns="0" tIns="0" bIns="0">
-            <a:spAutoFit/>
-          </a:bodyPr>
-          <a:lstStyle/>
-          <a:p>
-            <a:pPr algn="l"/>
-            <a:r>
-              <a:rPr sz="1050" b="1" i="0">
-                <a:solidFill>
-                  <a:srgbClr val="FFFFFF"/>
-                </a:solidFill>
-                <a:latin typeface="Arial"/>
-              </a:rPr>
-              <a:t>USC 50%</a:t>
-            </a:r>
-          </a:p>
-        </p:txBody>
-      </p:sp>
-      <p:sp>
-        <p:nvSpPr>
-          <p:cNvPr id="24" name="TextBox 23"/>
-          <p:cNvSpPr txBox="1"/>
-          <p:nvPr/>
-        </p:nvSpPr>
-        <p:spPr>
-          <a:xfrm>
-            <a:off x="8796528" y="4837176"/>
-            <a:ext cx="2194560" cy="228600"/>
-          </a:xfrm>
-          <a:prstGeom prst="rect">
-            <a:avLst/>
-          </a:prstGeom>
-          <a:noFill/>
-        </p:spPr>
-        <p:txBody>
-          <a:bodyPr wrap="square" lIns="0" rIns="0" tIns="0" bIns="0">
-            <a:spAutoFit/>
-          </a:bodyPr>
-          <a:lstStyle/>
-          <a:p>
-            <a:pPr algn="r"/>
-            <a:r>
-              <a:rPr sz="1050" b="1" i="0">
-                <a:solidFill>
-                  <a:srgbClr val="FFFFFF"/>
-                </a:solidFill>
-                <a:latin typeface="Arial"/>
-              </a:rPr>
-              <a:t>50% ORE</a:t>
-            </a:r>
-          </a:p>
-        </p:txBody>
-      </p:sp>
-      <p:sp>
-        <p:nvSpPr>
-          <p:cNvPr id="25" name="TextBox 24"/>
-          <p:cNvSpPr txBox="1"/>
-          <p:nvPr/>
-        </p:nvSpPr>
-        <p:spPr>
-          <a:xfrm>
-            <a:off x="8046720" y="5175504"/>
+            <a:off x="8046720" y="4626864"/>
             <a:ext cx="3017520" cy="228600"/>
           </a:xfrm>
           <a:prstGeom prst="rect">
@@ -16213,7 +16073,7 @@
                 </a:solidFill>
                 <a:latin typeface="Arial"/>
               </a:rPr>
-              <a:t>3 to A&amp;M — the market ran past us · no position</a:t>
+              <a:t>64% — the machine counts Kentucky as one bad game</a:t>
             </a:r>
           </a:p>
         </p:txBody>
@@ -16227,7 +16087,7 @@
         <p:spPr>
           <a:xfrm>
             <a:off x="7772400" y="1600200"/>
-            <a:ext cx="3566160" cy="4206240"/>
+            <a:ext cx="3566160" cy="3611880"/>
           </a:xfrm>
           <a:prstGeom prst="roundRect">
             <a:avLst/>
@@ -16410,8 +16270,8 @@
         </p:nvSpPr>
         <p:spPr>
           <a:xfrm>
-            <a:off x="8046720" y="3246120"/>
-            <a:ext cx="3017520" cy="411480"/>
+            <a:off x="8046720" y="3383280"/>
+            <a:ext cx="3017520" cy="365760"/>
           </a:xfrm>
           <a:prstGeom prst="rect">
             <a:avLst/>
@@ -16426,13 +16286,13 @@
           <a:p>
             <a:pPr algn="l"/>
             <a:r>
-              <a:rPr sz="2000" b="1" i="0">
-                <a:solidFill>
-                  <a:srgbClr val="FFFFFF"/>
-                </a:solidFill>
-                <a:latin typeface="Arial"/>
-              </a:rPr>
-              <a:t>–9.5 / –10</a:t>
+              <a:rPr sz="1700" b="1" i="0">
+                <a:solidFill>
+                  <a:srgbClr val="F47321"/>
+                </a:solidFill>
+                <a:latin typeface="Arial"/>
+              </a:rPr>
+              <a:t>LSU 29 – Texas A&amp;M 23</a:t>
             </a:r>
           </a:p>
         </p:txBody>
@@ -16445,8 +16305,8 @@
         </p:nvSpPr>
         <p:spPr>
           <a:xfrm>
-            <a:off x="8046720" y="3639312"/>
-            <a:ext cx="3017520" cy="365760"/>
+            <a:off x="8046720" y="3767328"/>
+            <a:ext cx="3017520" cy="228600"/>
           </a:xfrm>
           <a:prstGeom prst="rect">
             <a:avLst/>
@@ -16467,76 +16327,6 @@
                 </a:solidFill>
                 <a:latin typeface="Arial"/>
               </a:rPr>
-              <a:t>market (DK / Bovada) · DK LSU -380 / Texas A&amp;M +300 · Bov LSU -380 / Texas A&amp;M +290</a:t>
-            </a:r>
-          </a:p>
-        </p:txBody>
-      </p:sp>
-      <p:sp>
-        <p:nvSpPr>
-          <p:cNvPr id="19" name="TextBox 18"/>
-          <p:cNvSpPr txBox="1"/>
-          <p:nvPr/>
-        </p:nvSpPr>
-        <p:spPr>
-          <a:xfrm>
-            <a:off x="8046720" y="4069080"/>
-            <a:ext cx="3017520" cy="365760"/>
-          </a:xfrm>
-          <a:prstGeom prst="rect">
-            <a:avLst/>
-          </a:prstGeom>
-          <a:noFill/>
-        </p:spPr>
-        <p:txBody>
-          <a:bodyPr wrap="square" lIns="0" rIns="0" tIns="0" bIns="0">
-            <a:spAutoFit/>
-          </a:bodyPr>
-          <a:lstStyle/>
-          <a:p>
-            <a:pPr algn="l"/>
-            <a:r>
-              <a:rPr sz="1500" b="1" i="0">
-                <a:solidFill>
-                  <a:srgbClr val="F47321"/>
-                </a:solidFill>
-                <a:latin typeface="Arial"/>
-              </a:rPr>
-              <a:t>LSU 29 – Texas A&amp;M 23</a:t>
-            </a:r>
-          </a:p>
-        </p:txBody>
-      </p:sp>
-      <p:sp>
-        <p:nvSpPr>
-          <p:cNvPr id="20" name="TextBox 19"/>
-          <p:cNvSpPr txBox="1"/>
-          <p:nvPr/>
-        </p:nvSpPr>
-        <p:spPr>
-          <a:xfrm>
-            <a:off x="8046720" y="4407408"/>
-            <a:ext cx="3017520" cy="228600"/>
-          </a:xfrm>
-          <a:prstGeom prst="rect">
-            <a:avLst/>
-          </a:prstGeom>
-          <a:noFill/>
-        </p:spPr>
-        <p:txBody>
-          <a:bodyPr wrap="square" lIns="0" rIns="0" tIns="0" bIns="0">
-            <a:spAutoFit/>
-          </a:bodyPr>
-          <a:lstStyle/>
-          <a:p>
-            <a:pPr algn="l"/>
-            <a:r>
-              <a:rPr sz="850" b="0" i="0">
-                <a:solidFill>
-                  <a:srgbClr val="CADCFC"/>
-                </a:solidFill>
-                <a:latin typeface="Arial"/>
-              </a:rPr>
               <a:t>score prediction</a:t>
             </a:r>
           </a:p>
@@ -16544,13 +16334,13 @@
       </p:sp>
       <p:sp>
         <p:nvSpPr>
-          <p:cNvPr id="21" name="Rounded Rectangle 20"/>
+          <p:cNvPr id="19" name="Rounded Rectangle 18"/>
           <p:cNvSpPr/>
           <p:nvPr/>
         </p:nvSpPr>
         <p:spPr>
           <a:xfrm>
-            <a:off x="8046720" y="4754880"/>
+            <a:off x="8046720" y="4206240"/>
             <a:ext cx="3017520" cy="365760"/>
           </a:xfrm>
           <a:prstGeom prst="roundRect">
@@ -16588,13 +16378,13 @@
       </p:sp>
       <p:sp>
         <p:nvSpPr>
-          <p:cNvPr id="22" name="Rounded Rectangle 21"/>
+          <p:cNvPr id="20" name="Rounded Rectangle 19"/>
           <p:cNvSpPr/>
           <p:nvPr/>
         </p:nvSpPr>
         <p:spPr>
           <a:xfrm>
-            <a:off x="8046720" y="4754880"/>
+            <a:off x="8046720" y="4206240"/>
             <a:ext cx="1931212" cy="365760"/>
           </a:xfrm>
           <a:prstGeom prst="roundRect">
@@ -16632,83 +16422,83 @@
       </p:sp>
       <p:sp>
         <p:nvSpPr>
+          <p:cNvPr id="21" name="TextBox 20"/>
+          <p:cNvSpPr txBox="1"/>
+          <p:nvPr/>
+        </p:nvSpPr>
+        <p:spPr>
+          <a:xfrm>
+            <a:off x="8119872" y="4288536"/>
+            <a:ext cx="2194560" cy="228600"/>
+          </a:xfrm>
+          <a:prstGeom prst="rect">
+            <a:avLst/>
+          </a:prstGeom>
+          <a:noFill/>
+        </p:spPr>
+        <p:txBody>
+          <a:bodyPr wrap="square" lIns="0" rIns="0" tIns="0" bIns="0">
+            <a:spAutoFit/>
+          </a:bodyPr>
+          <a:lstStyle/>
+          <a:p>
+            <a:pPr algn="l"/>
+            <a:r>
+              <a:rPr sz="1050" b="1" i="0">
+                <a:solidFill>
+                  <a:srgbClr val="FFFFFF"/>
+                </a:solidFill>
+                <a:latin typeface="Arial"/>
+              </a:rPr>
+              <a:t>LSU 64%</a:t>
+            </a:r>
+          </a:p>
+        </p:txBody>
+      </p:sp>
+      <p:sp>
+        <p:nvSpPr>
+          <p:cNvPr id="22" name="TextBox 21"/>
+          <p:cNvSpPr txBox="1"/>
+          <p:nvPr/>
+        </p:nvSpPr>
+        <p:spPr>
+          <a:xfrm>
+            <a:off x="8796528" y="4288536"/>
+            <a:ext cx="2194560" cy="228600"/>
+          </a:xfrm>
+          <a:prstGeom prst="rect">
+            <a:avLst/>
+          </a:prstGeom>
+          <a:noFill/>
+        </p:spPr>
+        <p:txBody>
+          <a:bodyPr wrap="square" lIns="0" rIns="0" tIns="0" bIns="0">
+            <a:spAutoFit/>
+          </a:bodyPr>
+          <a:lstStyle/>
+          <a:p>
+            <a:pPr algn="r"/>
+            <a:r>
+              <a:rPr sz="1050" b="1" i="0">
+                <a:solidFill>
+                  <a:srgbClr val="FFFFFF"/>
+                </a:solidFill>
+                <a:latin typeface="Arial"/>
+              </a:rPr>
+              <a:t>36% TAMU</a:t>
+            </a:r>
+          </a:p>
+        </p:txBody>
+      </p:sp>
+      <p:sp>
+        <p:nvSpPr>
           <p:cNvPr id="23" name="TextBox 22"/>
           <p:cNvSpPr txBox="1"/>
           <p:nvPr/>
         </p:nvSpPr>
         <p:spPr>
           <a:xfrm>
-            <a:off x="8119872" y="4837176"/>
-            <a:ext cx="2194560" cy="228600"/>
-          </a:xfrm>
-          <a:prstGeom prst="rect">
-            <a:avLst/>
-          </a:prstGeom>
-          <a:noFill/>
-        </p:spPr>
-        <p:txBody>
-          <a:bodyPr wrap="square" lIns="0" rIns="0" tIns="0" bIns="0">
-            <a:spAutoFit/>
-          </a:bodyPr>
-          <a:lstStyle/>
-          <a:p>
-            <a:pPr algn="l"/>
-            <a:r>
-              <a:rPr sz="1050" b="1" i="0">
-                <a:solidFill>
-                  <a:srgbClr val="FFFFFF"/>
-                </a:solidFill>
-                <a:latin typeface="Arial"/>
-              </a:rPr>
-              <a:t>LSU 64%</a:t>
-            </a:r>
-          </a:p>
-        </p:txBody>
-      </p:sp>
-      <p:sp>
-        <p:nvSpPr>
-          <p:cNvPr id="24" name="TextBox 23"/>
-          <p:cNvSpPr txBox="1"/>
-          <p:nvPr/>
-        </p:nvSpPr>
-        <p:spPr>
-          <a:xfrm>
-            <a:off x="8796528" y="4837176"/>
-            <a:ext cx="2194560" cy="228600"/>
-          </a:xfrm>
-          <a:prstGeom prst="rect">
-            <a:avLst/>
-          </a:prstGeom>
-          <a:noFill/>
-        </p:spPr>
-        <p:txBody>
-          <a:bodyPr wrap="square" lIns="0" rIns="0" tIns="0" bIns="0">
-            <a:spAutoFit/>
-          </a:bodyPr>
-          <a:lstStyle/>
-          <a:p>
-            <a:pPr algn="r"/>
-            <a:r>
-              <a:rPr sz="1050" b="1" i="0">
-                <a:solidFill>
-                  <a:srgbClr val="FFFFFF"/>
-                </a:solidFill>
-                <a:latin typeface="Arial"/>
-              </a:rPr>
-              <a:t>36% TAMU</a:t>
-            </a:r>
-          </a:p>
-        </p:txBody>
-      </p:sp>
-      <p:sp>
-        <p:nvSpPr>
-          <p:cNvPr id="25" name="TextBox 24"/>
-          <p:cNvSpPr txBox="1"/>
-          <p:nvPr/>
-        </p:nvSpPr>
-        <p:spPr>
-          <a:xfrm>
-            <a:off x="8046720" y="5175504"/>
+            <a:off x="8046720" y="4626864"/>
             <a:ext cx="3017520" cy="228600"/>
           </a:xfrm>
           <a:prstGeom prst="rect">
@@ -23306,7 +23096,7 @@
         </p:nvSpPr>
         <p:spPr>
           <a:xfrm>
-            <a:off x="6400800" y="1837943"/>
+            <a:off x="6400800" y="1911095"/>
             <a:ext cx="4754880" cy="411480"/>
           </a:xfrm>
           <a:prstGeom prst="rect">
@@ -23335,42 +23125,7 @@
       </p:sp>
       <p:sp>
         <p:nvSpPr>
-          <p:cNvPr id="11" name="TextBox 10"/>
-          <p:cNvSpPr txBox="1"/>
-          <p:nvPr/>
-        </p:nvSpPr>
-        <p:spPr>
-          <a:xfrm>
-            <a:off x="6400800" y="2212848"/>
-            <a:ext cx="4754880" cy="228600"/>
-          </a:xfrm>
-          <a:prstGeom prst="rect">
-            <a:avLst/>
-          </a:prstGeom>
-          <a:noFill/>
-        </p:spPr>
-        <p:txBody>
-          <a:bodyPr wrap="square" lIns="0" rIns="0" tIns="0" bIns="0">
-            <a:spAutoFit/>
-          </a:bodyPr>
-          <a:lstStyle/>
-          <a:p>
-            <a:pPr algn="r"/>
-            <a:r>
-              <a:rPr sz="950" b="0" i="0">
-                <a:solidFill>
-                  <a:srgbClr val="CADCFC"/>
-                </a:solidFill>
-                <a:latin typeface="Arial"/>
-              </a:rPr>
-              <a:t>market +3.5</a:t>
-            </a:r>
-          </a:p>
-        </p:txBody>
-      </p:sp>
-      <p:sp>
-        <p:nvSpPr>
-          <p:cNvPr id="12" name="Rounded Rectangle 11"/>
+          <p:cNvPr id="11" name="Rounded Rectangle 10"/>
           <p:cNvSpPr/>
           <p:nvPr/>
         </p:nvSpPr>
@@ -23414,7 +23169,7 @@
       </p:sp>
       <p:sp>
         <p:nvSpPr>
-          <p:cNvPr id="13" name="Oval 12"/>
+          <p:cNvPr id="12" name="Oval 11"/>
           <p:cNvSpPr/>
           <p:nvPr/>
         </p:nvSpPr>
@@ -23458,7 +23213,7 @@
       </p:sp>
       <p:pic>
         <p:nvPicPr>
-          <p:cNvPr id="14" name="Picture 13" descr="olemiss.png"/>
+          <p:cNvPr id="13" name="Picture 12" descr="olemiss.png"/>
           <p:cNvPicPr>
             <a:picLocks noChangeAspect="1"/>
           </p:cNvPicPr>
@@ -23482,7 +23237,7 @@
       </p:pic>
       <p:sp>
         <p:nvSpPr>
-          <p:cNvPr id="15" name="Oval 14"/>
+          <p:cNvPr id="14" name="Oval 13"/>
           <p:cNvSpPr/>
           <p:nvPr/>
         </p:nvSpPr>
@@ -23526,7 +23281,7 @@
       </p:sp>
       <p:pic>
         <p:nvPicPr>
-          <p:cNvPr id="16" name="Picture 15" descr="florida.png"/>
+          <p:cNvPr id="15" name="Picture 14" descr="florida.png"/>
           <p:cNvPicPr>
             <a:picLocks noChangeAspect="1"/>
           </p:cNvPicPr>
@@ -23550,7 +23305,7 @@
       </p:pic>
       <p:sp>
         <p:nvSpPr>
-          <p:cNvPr id="17" name="TextBox 16"/>
+          <p:cNvPr id="16" name="TextBox 15"/>
           <p:cNvSpPr txBox="1"/>
           <p:nvPr/>
         </p:nvSpPr>
@@ -23585,13 +23340,13 @@
       </p:sp>
       <p:sp>
         <p:nvSpPr>
-          <p:cNvPr id="18" name="TextBox 17"/>
-          <p:cNvSpPr txBox="1"/>
-          <p:nvPr/>
-        </p:nvSpPr>
-        <p:spPr>
-          <a:xfrm>
-            <a:off x="6400800" y="2569464"/>
+          <p:cNvPr id="17" name="TextBox 16"/>
+          <p:cNvSpPr txBox="1"/>
+          <p:nvPr/>
+        </p:nvSpPr>
+        <p:spPr>
+          <a:xfrm>
+            <a:off x="6400800" y="2642616"/>
             <a:ext cx="4754880" cy="411480"/>
           </a:xfrm>
           <a:prstGeom prst="rect">
@@ -23620,42 +23375,7 @@
       </p:sp>
       <p:sp>
         <p:nvSpPr>
-          <p:cNvPr id="19" name="TextBox 18"/>
-          <p:cNvSpPr txBox="1"/>
-          <p:nvPr/>
-        </p:nvSpPr>
-        <p:spPr>
-          <a:xfrm>
-            <a:off x="6400800" y="2944368"/>
-            <a:ext cx="4754880" cy="228600"/>
-          </a:xfrm>
-          <a:prstGeom prst="rect">
-            <a:avLst/>
-          </a:prstGeom>
-          <a:noFill/>
-        </p:spPr>
-        <p:txBody>
-          <a:bodyPr wrap="square" lIns="0" rIns="0" tIns="0" bIns="0">
-            <a:spAutoFit/>
-          </a:bodyPr>
-          <a:lstStyle/>
-          <a:p>
-            <a:pPr algn="r"/>
-            <a:r>
-              <a:rPr sz="950" b="0" i="0">
-                <a:solidFill>
-                  <a:srgbClr val="CADCFC"/>
-                </a:solidFill>
-                <a:latin typeface="Arial"/>
-              </a:rPr>
-              <a:t>market –3</a:t>
-            </a:r>
-          </a:p>
-        </p:txBody>
-      </p:sp>
-      <p:sp>
-        <p:nvSpPr>
-          <p:cNvPr id="20" name="Rounded Rectangle 19"/>
+          <p:cNvPr id="18" name="Rounded Rectangle 17"/>
           <p:cNvSpPr/>
           <p:nvPr/>
         </p:nvSpPr>
@@ -23699,7 +23419,7 @@
       </p:sp>
       <p:sp>
         <p:nvSpPr>
-          <p:cNvPr id="21" name="Oval 20"/>
+          <p:cNvPr id="19" name="Oval 18"/>
           <p:cNvSpPr/>
           <p:nvPr/>
         </p:nvSpPr>
@@ -23743,7 +23463,7 @@
       </p:sp>
       <p:pic>
         <p:nvPicPr>
-          <p:cNvPr id="22" name="Picture 21" descr="oklahoma.png"/>
+          <p:cNvPr id="20" name="Picture 19" descr="oklahoma.png"/>
           <p:cNvPicPr>
             <a:picLocks noChangeAspect="1"/>
           </p:cNvPicPr>
@@ -23767,7 +23487,7 @@
       </p:pic>
       <p:sp>
         <p:nvSpPr>
-          <p:cNvPr id="23" name="Oval 22"/>
+          <p:cNvPr id="21" name="Oval 20"/>
           <p:cNvSpPr/>
           <p:nvPr/>
         </p:nvSpPr>
@@ -23811,7 +23531,7 @@
       </p:sp>
       <p:pic>
         <p:nvPicPr>
-          <p:cNvPr id="24" name="Picture 23" descr="georgia.png"/>
+          <p:cNvPr id="22" name="Picture 21" descr="georgia.png"/>
           <p:cNvPicPr>
             <a:picLocks noChangeAspect="1"/>
           </p:cNvPicPr>
@@ -23835,7 +23555,7 @@
       </p:pic>
       <p:sp>
         <p:nvSpPr>
-          <p:cNvPr id="25" name="TextBox 24"/>
+          <p:cNvPr id="23" name="TextBox 22"/>
           <p:cNvSpPr txBox="1"/>
           <p:nvPr/>
         </p:nvSpPr>
@@ -23870,13 +23590,13 @@
       </p:sp>
       <p:sp>
         <p:nvSpPr>
-          <p:cNvPr id="26" name="TextBox 25"/>
-          <p:cNvSpPr txBox="1"/>
-          <p:nvPr/>
-        </p:nvSpPr>
-        <p:spPr>
-          <a:xfrm>
-            <a:off x="6400800" y="3300984"/>
+          <p:cNvPr id="24" name="TextBox 23"/>
+          <p:cNvSpPr txBox="1"/>
+          <p:nvPr/>
+        </p:nvSpPr>
+        <p:spPr>
+          <a:xfrm>
+            <a:off x="6400800" y="3374136"/>
             <a:ext cx="4754880" cy="411480"/>
           </a:xfrm>
           <a:prstGeom prst="rect">
@@ -23905,42 +23625,7 @@
       </p:sp>
       <p:sp>
         <p:nvSpPr>
-          <p:cNvPr id="27" name="TextBox 26"/>
-          <p:cNvSpPr txBox="1"/>
-          <p:nvPr/>
-        </p:nvSpPr>
-        <p:spPr>
-          <a:xfrm>
-            <a:off x="6400800" y="3675887"/>
-            <a:ext cx="4754880" cy="228600"/>
-          </a:xfrm>
-          <a:prstGeom prst="rect">
-            <a:avLst/>
-          </a:prstGeom>
-          <a:noFill/>
-        </p:spPr>
-        <p:txBody>
-          <a:bodyPr wrap="square" lIns="0" rIns="0" tIns="0" bIns="0">
-            <a:spAutoFit/>
-          </a:bodyPr>
-          <a:lstStyle/>
-          <a:p>
-            <a:pPr algn="r"/>
-            <a:r>
-              <a:rPr sz="950" b="0" i="0">
-                <a:solidFill>
-                  <a:srgbClr val="CADCFC"/>
-                </a:solidFill>
-                <a:latin typeface="Arial"/>
-              </a:rPr>
-              <a:t>market –14</a:t>
-            </a:r>
-          </a:p>
-        </p:txBody>
-      </p:sp>
-      <p:sp>
-        <p:nvSpPr>
-          <p:cNvPr id="28" name="Rounded Rectangle 27"/>
+          <p:cNvPr id="25" name="Rounded Rectangle 24"/>
           <p:cNvSpPr/>
           <p:nvPr/>
         </p:nvSpPr>
@@ -23984,7 +23669,7 @@
       </p:sp>
       <p:sp>
         <p:nvSpPr>
-          <p:cNvPr id="29" name="Oval 28"/>
+          <p:cNvPr id="26" name="Oval 25"/>
           <p:cNvSpPr/>
           <p:nvPr/>
         </p:nvSpPr>
@@ -24028,7 +23713,7 @@
       </p:sp>
       <p:pic>
         <p:nvPicPr>
-          <p:cNvPr id="30" name="Picture 29" descr="oregon.png"/>
+          <p:cNvPr id="27" name="Picture 26" descr="oregon.png"/>
           <p:cNvPicPr>
             <a:picLocks noChangeAspect="1"/>
           </p:cNvPicPr>
@@ -24052,7 +23737,7 @@
       </p:pic>
       <p:sp>
         <p:nvSpPr>
-          <p:cNvPr id="31" name="Oval 30"/>
+          <p:cNvPr id="28" name="Oval 27"/>
           <p:cNvSpPr/>
           <p:nvPr/>
         </p:nvSpPr>
@@ -24096,7 +23781,7 @@
       </p:sp>
       <p:pic>
         <p:nvPicPr>
-          <p:cNvPr id="32" name="Picture 31" descr="usc.png"/>
+          <p:cNvPr id="29" name="Picture 28" descr="usc.png"/>
           <p:cNvPicPr>
             <a:picLocks noChangeAspect="1"/>
           </p:cNvPicPr>
@@ -24120,7 +23805,7 @@
       </p:pic>
       <p:sp>
         <p:nvSpPr>
-          <p:cNvPr id="33" name="TextBox 32"/>
+          <p:cNvPr id="30" name="TextBox 29"/>
           <p:cNvSpPr txBox="1"/>
           <p:nvPr/>
         </p:nvSpPr>
@@ -24155,13 +23840,13 @@
       </p:sp>
       <p:sp>
         <p:nvSpPr>
-          <p:cNvPr id="34" name="TextBox 33"/>
-          <p:cNvSpPr txBox="1"/>
-          <p:nvPr/>
-        </p:nvSpPr>
-        <p:spPr>
-          <a:xfrm>
-            <a:off x="6400800" y="4032503"/>
+          <p:cNvPr id="31" name="TextBox 30"/>
+          <p:cNvSpPr txBox="1"/>
+          <p:nvPr/>
+        </p:nvSpPr>
+        <p:spPr>
+          <a:xfrm>
+            <a:off x="6400800" y="4105655"/>
             <a:ext cx="4754880" cy="411480"/>
           </a:xfrm>
           <a:prstGeom prst="rect">
@@ -24190,42 +23875,7 @@
       </p:sp>
       <p:sp>
         <p:nvSpPr>
-          <p:cNvPr id="35" name="TextBox 34"/>
-          <p:cNvSpPr txBox="1"/>
-          <p:nvPr/>
-        </p:nvSpPr>
-        <p:spPr>
-          <a:xfrm>
-            <a:off x="6400800" y="4407407"/>
-            <a:ext cx="4754880" cy="228600"/>
-          </a:xfrm>
-          <a:prstGeom prst="rect">
-            <a:avLst/>
-          </a:prstGeom>
-          <a:noFill/>
-        </p:spPr>
-        <p:txBody>
-          <a:bodyPr wrap="square" lIns="0" rIns="0" tIns="0" bIns="0">
-            <a:spAutoFit/>
-          </a:bodyPr>
-          <a:lstStyle/>
-          <a:p>
-            <a:pPr algn="r"/>
-            <a:r>
-              <a:rPr sz="950" b="0" i="0">
-                <a:solidFill>
-                  <a:srgbClr val="CADCFC"/>
-                </a:solidFill>
-                <a:latin typeface="Arial"/>
-              </a:rPr>
-              <a:t>market +3</a:t>
-            </a:r>
-          </a:p>
-        </p:txBody>
-      </p:sp>
-      <p:sp>
-        <p:nvSpPr>
-          <p:cNvPr id="36" name="Rounded Rectangle 35"/>
+          <p:cNvPr id="32" name="Rounded Rectangle 31"/>
           <p:cNvSpPr/>
           <p:nvPr/>
         </p:nvSpPr>
@@ -24269,7 +23919,7 @@
       </p:sp>
       <p:sp>
         <p:nvSpPr>
-          <p:cNvPr id="37" name="Oval 36"/>
+          <p:cNvPr id="33" name="Oval 32"/>
           <p:cNvSpPr/>
           <p:nvPr/>
         </p:nvSpPr>
@@ -24313,7 +23963,7 @@
       </p:sp>
       <p:pic>
         <p:nvPicPr>
-          <p:cNvPr id="38" name="Picture 37" descr="texasam.png"/>
+          <p:cNvPr id="34" name="Picture 33" descr="texasam.png"/>
           <p:cNvPicPr>
             <a:picLocks noChangeAspect="1"/>
           </p:cNvPicPr>
@@ -24337,7 +23987,7 @@
       </p:pic>
       <p:sp>
         <p:nvSpPr>
-          <p:cNvPr id="39" name="Oval 38"/>
+          <p:cNvPr id="35" name="Oval 34"/>
           <p:cNvSpPr/>
           <p:nvPr/>
         </p:nvSpPr>
@@ -24381,7 +24031,7 @@
       </p:sp>
       <p:pic>
         <p:nvPicPr>
-          <p:cNvPr id="40" name="Picture 39" descr="lsu.png"/>
+          <p:cNvPr id="36" name="Picture 35" descr="lsu.png"/>
           <p:cNvPicPr>
             <a:picLocks noChangeAspect="1"/>
           </p:cNvPicPr>
@@ -24405,7 +24055,7 @@
       </p:pic>
       <p:sp>
         <p:nvSpPr>
-          <p:cNvPr id="41" name="TextBox 40"/>
+          <p:cNvPr id="37" name="TextBox 36"/>
           <p:cNvSpPr txBox="1"/>
           <p:nvPr/>
         </p:nvSpPr>
@@ -24440,13 +24090,13 @@
       </p:sp>
       <p:sp>
         <p:nvSpPr>
-          <p:cNvPr id="42" name="TextBox 41"/>
-          <p:cNvSpPr txBox="1"/>
-          <p:nvPr/>
-        </p:nvSpPr>
-        <p:spPr>
-          <a:xfrm>
-            <a:off x="6400800" y="4764023"/>
+          <p:cNvPr id="38" name="TextBox 37"/>
+          <p:cNvSpPr txBox="1"/>
+          <p:nvPr/>
+        </p:nvSpPr>
+        <p:spPr>
+          <a:xfrm>
+            <a:off x="6400800" y="4837175"/>
             <a:ext cx="4754880" cy="411480"/>
           </a:xfrm>
           <a:prstGeom prst="rect">
@@ -24475,42 +24125,7 @@
       </p:sp>
       <p:sp>
         <p:nvSpPr>
-          <p:cNvPr id="43" name="TextBox 42"/>
-          <p:cNvSpPr txBox="1"/>
-          <p:nvPr/>
-        </p:nvSpPr>
-        <p:spPr>
-          <a:xfrm>
-            <a:off x="6400800" y="5138927"/>
-            <a:ext cx="4754880" cy="228600"/>
-          </a:xfrm>
-          <a:prstGeom prst="rect">
-            <a:avLst/>
-          </a:prstGeom>
-          <a:noFill/>
-        </p:spPr>
-        <p:txBody>
-          <a:bodyPr wrap="square" lIns="0" rIns="0" tIns="0" bIns="0">
-            <a:spAutoFit/>
-          </a:bodyPr>
-          <a:lstStyle/>
-          <a:p>
-            <a:pPr algn="r"/>
-            <a:r>
-              <a:rPr sz="950" b="0" i="0">
-                <a:solidFill>
-                  <a:srgbClr val="CADCFC"/>
-                </a:solidFill>
-                <a:latin typeface="Arial"/>
-              </a:rPr>
-              <a:t>market –9.5</a:t>
-            </a:r>
-          </a:p>
-        </p:txBody>
-      </p:sp>
-      <p:sp>
-        <p:nvSpPr>
-          <p:cNvPr id="44" name="Rounded Rectangle 43"/>
+          <p:cNvPr id="39" name="Rounded Rectangle 38"/>
           <p:cNvSpPr/>
           <p:nvPr/>
         </p:nvSpPr>
@@ -24554,7 +24169,7 @@
       </p:sp>
       <p:sp>
         <p:nvSpPr>
-          <p:cNvPr id="45" name="TextBox 44"/>
+          <p:cNvPr id="40" name="TextBox 39"/>
           <p:cNvSpPr txBox="1"/>
           <p:nvPr/>
         </p:nvSpPr>
@@ -24589,7 +24204,7 @@
       </p:sp>
       <p:sp>
         <p:nvSpPr>
-          <p:cNvPr id="46" name="TextBox 45"/>
+          <p:cNvPr id="41" name="TextBox 40"/>
           <p:cNvSpPr txBox="1"/>
           <p:nvPr/>
         </p:nvSpPr>
@@ -24617,14 +24232,14 @@
                 </a:solidFill>
                 <a:latin typeface="Arial"/>
               </a:rPr>
-              <a:t>Charlotte +10 vs Louisiana · ML +350</a:t>
-            </a:r>
-          </a:p>
-        </p:txBody>
-      </p:sp>
-      <p:sp>
-        <p:nvSpPr>
-          <p:cNvPr id="47" name="TextBox 46"/>
+              <a:t>Charlotte +10 vs Louisiana</a:t>
+            </a:r>
+          </a:p>
+        </p:txBody>
+      </p:sp>
+      <p:sp>
+        <p:nvSpPr>
+          <p:cNvPr id="42" name="TextBox 41"/>
           <p:cNvSpPr txBox="1"/>
           <p:nvPr/>
         </p:nvSpPr>
@@ -24659,7 +24274,7 @@
       </p:sp>
       <p:sp>
         <p:nvSpPr>
-          <p:cNvPr id="48" name="TextBox 47"/>
+          <p:cNvPr id="43" name="TextBox 42"/>
           <p:cNvSpPr txBox="1"/>
           <p:nvPr/>
         </p:nvSpPr>
@@ -24687,14 +24302,14 @@
                 </a:solidFill>
                 <a:latin typeface="Arial"/>
               </a:rPr>
-              <a:t>Georgia Southern +17.5 vs #25 Houston · ML +625</a:t>
-            </a:r>
-          </a:p>
-        </p:txBody>
-      </p:sp>
-      <p:sp>
-        <p:nvSpPr>
-          <p:cNvPr id="49" name="TextBox 48"/>
+              <a:t>Georgia Southern +17.5 vs #25 Houston</a:t>
+            </a:r>
+          </a:p>
+        </p:txBody>
+      </p:sp>
+      <p:sp>
+        <p:nvSpPr>
+          <p:cNvPr id="44" name="TextBox 43"/>
           <p:cNvSpPr txBox="1"/>
           <p:nvPr/>
         </p:nvSpPr>
@@ -24853,7 +24468,7 @@
                 </a:solidFill>
                 <a:latin typeface="Arial"/>
               </a:rPr>
-              <a:t>Team factor × QB efficiency (PPA per play) · market = DraftKings</a:t>
+              <a:t>Team factor × QB efficiency (PPA per play)</a:t>
             </a:r>
           </a:p>
         </p:txBody>
@@ -24901,7 +24516,7 @@
         </p:nvSpPr>
         <p:spPr>
           <a:xfrm>
-            <a:off x="4114800" y="1673352"/>
+            <a:off x="6858000" y="1673352"/>
             <a:ext cx="1097280" cy="201168"/>
           </a:xfrm>
           <a:prstGeom prst="rect">
@@ -24936,7 +24551,7 @@
         </p:nvSpPr>
         <p:spPr>
           <a:xfrm>
-            <a:off x="5257800" y="1673352"/>
+            <a:off x="8001000" y="1673352"/>
             <a:ext cx="731520" cy="201168"/>
           </a:xfrm>
           <a:prstGeom prst="rect">
@@ -24971,7 +24586,7 @@
         </p:nvSpPr>
         <p:spPr>
           <a:xfrm>
-            <a:off x="6035040" y="1673352"/>
+            <a:off x="8778240" y="1673352"/>
             <a:ext cx="640080" cy="201168"/>
           </a:xfrm>
           <a:prstGeom prst="rect">
@@ -25006,7 +24621,7 @@
         </p:nvSpPr>
         <p:spPr>
           <a:xfrm>
-            <a:off x="6720840" y="1673352"/>
+            <a:off x="9464040" y="1673352"/>
             <a:ext cx="822960" cy="201168"/>
           </a:xfrm>
           <a:prstGeom prst="rect">
@@ -25041,7 +24656,7 @@
         </p:nvSpPr>
         <p:spPr>
           <a:xfrm>
-            <a:off x="7589520" y="1673352"/>
+            <a:off x="10332720" y="1673352"/>
             <a:ext cx="640080" cy="201168"/>
           </a:xfrm>
           <a:prstGeom prst="rect">
@@ -25070,112 +24685,7 @@
       </p:sp>
       <p:sp>
         <p:nvSpPr>
-          <p:cNvPr id="11" name="TextBox 10"/>
-          <p:cNvSpPr txBox="1"/>
-          <p:nvPr/>
-        </p:nvSpPr>
-        <p:spPr>
-          <a:xfrm>
-            <a:off x="8275320" y="1673352"/>
-            <a:ext cx="822960" cy="201168"/>
-          </a:xfrm>
-          <a:prstGeom prst="rect">
-            <a:avLst/>
-          </a:prstGeom>
-          <a:noFill/>
-        </p:spPr>
-        <p:txBody>
-          <a:bodyPr wrap="square" lIns="0" rIns="0" tIns="0" bIns="0">
-            <a:spAutoFit/>
-          </a:bodyPr>
-          <a:lstStyle/>
-          <a:p>
-            <a:pPr algn="r"/>
-            <a:r>
-              <a:rPr sz="800" b="1" i="0">
-                <a:solidFill>
-                  <a:srgbClr val="CADCFC"/>
-                </a:solidFill>
-                <a:latin typeface="Arial"/>
-              </a:rPr>
-              <a:t>MARKET</a:t>
-            </a:r>
-          </a:p>
-        </p:txBody>
-      </p:sp>
-      <p:sp>
-        <p:nvSpPr>
-          <p:cNvPr id="12" name="TextBox 11"/>
-          <p:cNvSpPr txBox="1"/>
-          <p:nvPr/>
-        </p:nvSpPr>
-        <p:spPr>
-          <a:xfrm>
-            <a:off x="9144000" y="1673352"/>
-            <a:ext cx="822960" cy="201168"/>
-          </a:xfrm>
-          <a:prstGeom prst="rect">
-            <a:avLst/>
-          </a:prstGeom>
-          <a:noFill/>
-        </p:spPr>
-        <p:txBody>
-          <a:bodyPr wrap="square" lIns="0" rIns="0" tIns="0" bIns="0">
-            <a:spAutoFit/>
-          </a:bodyPr>
-          <a:lstStyle/>
-          <a:p>
-            <a:pPr algn="r"/>
-            <a:r>
-              <a:rPr sz="800" b="1" i="0">
-                <a:solidFill>
-                  <a:srgbClr val="CADCFC"/>
-                </a:solidFill>
-                <a:latin typeface="Arial"/>
-              </a:rPr>
-              <a:t>MKT RANK</a:t>
-            </a:r>
-          </a:p>
-        </p:txBody>
-      </p:sp>
-      <p:sp>
-        <p:nvSpPr>
-          <p:cNvPr id="13" name="TextBox 12"/>
-          <p:cNvSpPr txBox="1"/>
-          <p:nvPr/>
-        </p:nvSpPr>
-        <p:spPr>
-          <a:xfrm>
-            <a:off x="10012680" y="1673352"/>
-            <a:ext cx="1325880" cy="201168"/>
-          </a:xfrm>
-          <a:prstGeom prst="rect">
-            <a:avLst/>
-          </a:prstGeom>
-          <a:noFill/>
-        </p:spPr>
-        <p:txBody>
-          <a:bodyPr wrap="square" lIns="0" rIns="0" tIns="0" bIns="0">
-            <a:spAutoFit/>
-          </a:bodyPr>
-          <a:lstStyle/>
-          <a:p>
-            <a:pPr algn="r"/>
-            <a:r>
-              <a:rPr sz="800" b="1" i="0">
-                <a:solidFill>
-                  <a:srgbClr val="CADCFC"/>
-                </a:solidFill>
-                <a:latin typeface="Arial"/>
-              </a:rPr>
-              <a:t>MAN VS MACHINE</a:t>
-            </a:r>
-          </a:p>
-        </p:txBody>
-      </p:sp>
-      <p:sp>
-        <p:nvSpPr>
-          <p:cNvPr id="14" name="Rectangle 13"/>
+          <p:cNvPr id="11" name="Rectangle 10"/>
           <p:cNvSpPr/>
           <p:nvPr/>
         </p:nvSpPr>
@@ -25219,7 +24729,7 @@
       </p:sp>
       <p:sp>
         <p:nvSpPr>
-          <p:cNvPr id="15" name="TextBox 14"/>
+          <p:cNvPr id="12" name="TextBox 11"/>
           <p:cNvSpPr txBox="1"/>
           <p:nvPr/>
         </p:nvSpPr>
@@ -25254,7 +24764,7 @@
       </p:sp>
       <p:sp>
         <p:nvSpPr>
-          <p:cNvPr id="16" name="Oval 15"/>
+          <p:cNvPr id="13" name="Oval 12"/>
           <p:cNvSpPr/>
           <p:nvPr/>
         </p:nvSpPr>
@@ -25298,7 +24808,7 @@
       </p:sp>
       <p:pic>
         <p:nvPicPr>
-          <p:cNvPr id="17" name="Picture 16" descr="miami.png"/>
+          <p:cNvPr id="14" name="Picture 13" descr="miami.png"/>
           <p:cNvPicPr>
             <a:picLocks noChangeAspect="1"/>
           </p:cNvPicPr>
@@ -25322,7 +24832,7 @@
       </p:pic>
       <p:sp>
         <p:nvSpPr>
-          <p:cNvPr id="18" name="TextBox 17"/>
+          <p:cNvPr id="15" name="TextBox 14"/>
           <p:cNvSpPr txBox="1"/>
           <p:nvPr/>
         </p:nvSpPr>
@@ -25350,14 +24860,14 @@
                 </a:solidFill>
                 <a:latin typeface="Arial"/>
               </a:rPr>
-              <a:t>41-of-45, 653 yards, 8 TD, 0 INT through two</a:t>
-            </a:r>
-          </a:p>
-        </p:txBody>
-      </p:sp>
-      <p:sp>
-        <p:nvSpPr>
-          <p:cNvPr id="19" name="TextBox 18"/>
+              <a:t>71-of-79, 873 yards, 11 TD, 0 INT through three</a:t>
+            </a:r>
+          </a:p>
+        </p:txBody>
+      </p:sp>
+      <p:sp>
+        <p:nvSpPr>
+          <p:cNvPr id="16" name="TextBox 15"/>
           <p:cNvSpPr txBox="1"/>
           <p:nvPr/>
         </p:nvSpPr>
@@ -25392,14 +24902,119 @@
       </p:sp>
       <p:sp>
         <p:nvSpPr>
+          <p:cNvPr id="17" name="TextBox 16"/>
+          <p:cNvSpPr txBox="1"/>
+          <p:nvPr/>
+        </p:nvSpPr>
+        <p:spPr>
+          <a:xfrm>
+            <a:off x="6858000" y="1947672"/>
+            <a:ext cx="1097280" cy="274320"/>
+          </a:xfrm>
+          <a:prstGeom prst="rect">
+            <a:avLst/>
+          </a:prstGeom>
+          <a:noFill/>
+        </p:spPr>
+        <p:txBody>
+          <a:bodyPr wrap="square" lIns="0" rIns="0" tIns="0" bIns="0">
+            <a:spAutoFit/>
+          </a:bodyPr>
+          <a:lstStyle/>
+          <a:p>
+            <a:pPr algn="r"/>
+            <a:r>
+              <a:rPr sz="1050" b="0" i="0">
+                <a:solidFill>
+                  <a:srgbClr val="FFFFFF"/>
+                </a:solidFill>
+                <a:latin typeface="Arial"/>
+              </a:rPr>
+              <a:t>0.844 (83)</a:t>
+            </a:r>
+          </a:p>
+        </p:txBody>
+      </p:sp>
+      <p:sp>
+        <p:nvSpPr>
+          <p:cNvPr id="18" name="TextBox 17"/>
+          <p:cNvSpPr txBox="1"/>
+          <p:nvPr/>
+        </p:nvSpPr>
+        <p:spPr>
+          <a:xfrm>
+            <a:off x="8001000" y="1947672"/>
+            <a:ext cx="731520" cy="274320"/>
+          </a:xfrm>
+          <a:prstGeom prst="rect">
+            <a:avLst/>
+          </a:prstGeom>
+          <a:noFill/>
+        </p:spPr>
+        <p:txBody>
+          <a:bodyPr wrap="square" lIns="0" rIns="0" tIns="0" bIns="0">
+            <a:spAutoFit/>
+          </a:bodyPr>
+          <a:lstStyle/>
+          <a:p>
+            <a:pPr algn="r"/>
+            <a:r>
+              <a:rPr sz="1050" b="0" i="0">
+                <a:solidFill>
+                  <a:srgbClr val="CADCFC"/>
+                </a:solidFill>
+                <a:latin typeface="Arial"/>
+              </a:rPr>
+              <a:t>0.371</a:t>
+            </a:r>
+          </a:p>
+        </p:txBody>
+      </p:sp>
+      <p:sp>
+        <p:nvSpPr>
+          <p:cNvPr id="19" name="TextBox 18"/>
+          <p:cNvSpPr txBox="1"/>
+          <p:nvPr/>
+        </p:nvSpPr>
+        <p:spPr>
+          <a:xfrm>
+            <a:off x="8778240" y="1947672"/>
+            <a:ext cx="640080" cy="274320"/>
+          </a:xfrm>
+          <a:prstGeom prst="rect">
+            <a:avLst/>
+          </a:prstGeom>
+          <a:noFill/>
+        </p:spPr>
+        <p:txBody>
+          <a:bodyPr wrap="square" lIns="0" rIns="0" tIns="0" bIns="0">
+            <a:spAutoFit/>
+          </a:bodyPr>
+          <a:lstStyle/>
+          <a:p>
+            <a:pPr algn="r"/>
+            <a:r>
+              <a:rPr sz="1050" b="0" i="0">
+                <a:solidFill>
+                  <a:srgbClr val="FFFFFF"/>
+                </a:solidFill>
+                <a:latin typeface="Arial"/>
+              </a:rPr>
+              <a:t>0.539</a:t>
+            </a:r>
+          </a:p>
+        </p:txBody>
+      </p:sp>
+      <p:sp>
+        <p:nvSpPr>
           <p:cNvPr id="20" name="TextBox 19"/>
           <p:cNvSpPr txBox="1"/>
           <p:nvPr/>
         </p:nvSpPr>
         <p:spPr>
           <a:xfrm>
-            <a:off x="4114800" y="1947672"/>
-            <a:ext cx="1097280" cy="274320"/>
+            <a:off x="9464040" y="1947672"/>
+            <a:ext cx="822960" cy="274320"/>
           </a:xfrm>
           <a:prstGeom prst="rect">
             <a:avLst/>
@@ -25420,7 +25035,7 @@
                 </a:solidFill>
                 <a:latin typeface="Arial"/>
               </a:rPr>
-              <a:t>0.844 (83)</a:t>
+              <a:t>74%</a:t>
             </a:r>
           </a:p>
         </p:txBody>
@@ -25433,8 +25048,8 @@
         </p:nvSpPr>
         <p:spPr>
           <a:xfrm>
-            <a:off x="5257800" y="1947672"/>
-            <a:ext cx="731520" cy="274320"/>
+            <a:off x="10332720" y="1938528"/>
+            <a:ext cx="640080" cy="274320"/>
           </a:xfrm>
           <a:prstGeom prst="rect">
             <a:avLst/>
@@ -25449,13 +25064,13 @@
           <a:p>
             <a:pPr algn="r"/>
             <a:r>
-              <a:rPr sz="1050" b="0" i="0">
-                <a:solidFill>
-                  <a:srgbClr val="CADCFC"/>
-                </a:solidFill>
-                <a:latin typeface="Arial"/>
-              </a:rPr>
-              <a:t>0.371</a:t>
+              <a:rPr sz="1250" b="1" i="0">
+                <a:solidFill>
+                  <a:srgbClr val="F47321"/>
+                </a:solidFill>
+                <a:latin typeface="Arial"/>
+              </a:rPr>
+              <a:t>46.8</a:t>
             </a:r>
           </a:p>
         </p:txBody>
@@ -25463,216 +25078,6 @@
       <p:sp>
         <p:nvSpPr>
           <p:cNvPr id="22" name="TextBox 21"/>
-          <p:cNvSpPr txBox="1"/>
-          <p:nvPr/>
-        </p:nvSpPr>
-        <p:spPr>
-          <a:xfrm>
-            <a:off x="6035040" y="1947672"/>
-            <a:ext cx="640080" cy="274320"/>
-          </a:xfrm>
-          <a:prstGeom prst="rect">
-            <a:avLst/>
-          </a:prstGeom>
-          <a:noFill/>
-        </p:spPr>
-        <p:txBody>
-          <a:bodyPr wrap="square" lIns="0" rIns="0" tIns="0" bIns="0">
-            <a:spAutoFit/>
-          </a:bodyPr>
-          <a:lstStyle/>
-          <a:p>
-            <a:pPr algn="r"/>
-            <a:r>
-              <a:rPr sz="1050" b="0" i="0">
-                <a:solidFill>
-                  <a:srgbClr val="FFFFFF"/>
-                </a:solidFill>
-                <a:latin typeface="Arial"/>
-              </a:rPr>
-              <a:t>0.539</a:t>
-            </a:r>
-          </a:p>
-        </p:txBody>
-      </p:sp>
-      <p:sp>
-        <p:nvSpPr>
-          <p:cNvPr id="23" name="TextBox 22"/>
-          <p:cNvSpPr txBox="1"/>
-          <p:nvPr/>
-        </p:nvSpPr>
-        <p:spPr>
-          <a:xfrm>
-            <a:off x="6720840" y="1947672"/>
-            <a:ext cx="822960" cy="274320"/>
-          </a:xfrm>
-          <a:prstGeom prst="rect">
-            <a:avLst/>
-          </a:prstGeom>
-          <a:noFill/>
-        </p:spPr>
-        <p:txBody>
-          <a:bodyPr wrap="square" lIns="0" rIns="0" tIns="0" bIns="0">
-            <a:spAutoFit/>
-          </a:bodyPr>
-          <a:lstStyle/>
-          <a:p>
-            <a:pPr algn="r"/>
-            <a:r>
-              <a:rPr sz="1050" b="0" i="0">
-                <a:solidFill>
-                  <a:srgbClr val="FFFFFF"/>
-                </a:solidFill>
-                <a:latin typeface="Arial"/>
-              </a:rPr>
-              <a:t>74%</a:t>
-            </a:r>
-          </a:p>
-        </p:txBody>
-      </p:sp>
-      <p:sp>
-        <p:nvSpPr>
-          <p:cNvPr id="24" name="TextBox 23"/>
-          <p:cNvSpPr txBox="1"/>
-          <p:nvPr/>
-        </p:nvSpPr>
-        <p:spPr>
-          <a:xfrm>
-            <a:off x="7589520" y="1938528"/>
-            <a:ext cx="640080" cy="274320"/>
-          </a:xfrm>
-          <a:prstGeom prst="rect">
-            <a:avLst/>
-          </a:prstGeom>
-          <a:noFill/>
-        </p:spPr>
-        <p:txBody>
-          <a:bodyPr wrap="square" lIns="0" rIns="0" tIns="0" bIns="0">
-            <a:spAutoFit/>
-          </a:bodyPr>
-          <a:lstStyle/>
-          <a:p>
-            <a:pPr algn="r"/>
-            <a:r>
-              <a:rPr sz="1250" b="1" i="0">
-                <a:solidFill>
-                  <a:srgbClr val="F47321"/>
-                </a:solidFill>
-                <a:latin typeface="Arial"/>
-              </a:rPr>
-              <a:t>46.8</a:t>
-            </a:r>
-          </a:p>
-        </p:txBody>
-      </p:sp>
-      <p:sp>
-        <p:nvSpPr>
-          <p:cNvPr id="25" name="TextBox 24"/>
-          <p:cNvSpPr txBox="1"/>
-          <p:nvPr/>
-        </p:nvSpPr>
-        <p:spPr>
-          <a:xfrm>
-            <a:off x="8275320" y="1947672"/>
-            <a:ext cx="822960" cy="274320"/>
-          </a:xfrm>
-          <a:prstGeom prst="rect">
-            <a:avLst/>
-          </a:prstGeom>
-          <a:noFill/>
-        </p:spPr>
-        <p:txBody>
-          <a:bodyPr wrap="square" lIns="0" rIns="0" tIns="0" bIns="0">
-            <a:spAutoFit/>
-          </a:bodyPr>
-          <a:lstStyle/>
-          <a:p>
-            <a:pPr algn="r"/>
-            <a:r>
-              <a:rPr sz="1050" b="0" i="0">
-                <a:solidFill>
-                  <a:srgbClr val="FFFFFF"/>
-                </a:solidFill>
-                <a:latin typeface="Arial"/>
-              </a:rPr>
-              <a:t>+550</a:t>
-            </a:r>
-          </a:p>
-        </p:txBody>
-      </p:sp>
-      <p:sp>
-        <p:nvSpPr>
-          <p:cNvPr id="26" name="TextBox 25"/>
-          <p:cNvSpPr txBox="1"/>
-          <p:nvPr/>
-        </p:nvSpPr>
-        <p:spPr>
-          <a:xfrm>
-            <a:off x="9144000" y="1947672"/>
-            <a:ext cx="822960" cy="274320"/>
-          </a:xfrm>
-          <a:prstGeom prst="rect">
-            <a:avLst/>
-          </a:prstGeom>
-          <a:noFill/>
-        </p:spPr>
-        <p:txBody>
-          <a:bodyPr wrap="square" lIns="0" rIns="0" tIns="0" bIns="0">
-            <a:spAutoFit/>
-          </a:bodyPr>
-          <a:lstStyle/>
-          <a:p>
-            <a:pPr algn="r"/>
-            <a:r>
-              <a:rPr sz="1050" b="0" i="0">
-                <a:solidFill>
-                  <a:srgbClr val="CADCFC"/>
-                </a:solidFill>
-                <a:latin typeface="Arial"/>
-              </a:rPr>
-              <a:t>#1</a:t>
-            </a:r>
-          </a:p>
-        </p:txBody>
-      </p:sp>
-      <p:sp>
-        <p:nvSpPr>
-          <p:cNvPr id="27" name="TextBox 26"/>
-          <p:cNvSpPr txBox="1"/>
-          <p:nvPr/>
-        </p:nvSpPr>
-        <p:spPr>
-          <a:xfrm>
-            <a:off x="10012680" y="1947672"/>
-            <a:ext cx="1325880" cy="274320"/>
-          </a:xfrm>
-          <a:prstGeom prst="rect">
-            <a:avLst/>
-          </a:prstGeom>
-          <a:noFill/>
-        </p:spPr>
-        <p:txBody>
-          <a:bodyPr wrap="square" lIns="0" rIns="0" tIns="0" bIns="0">
-            <a:spAutoFit/>
-          </a:bodyPr>
-          <a:lstStyle/>
-          <a:p>
-            <a:pPr algn="r"/>
-            <a:r>
-              <a:rPr sz="950" b="0" i="0">
-                <a:solidFill>
-                  <a:srgbClr val="CADCFC"/>
-                </a:solidFill>
-                <a:latin typeface="Arial"/>
-              </a:rPr>
-              <a:t>agree</a:t>
-            </a:r>
-          </a:p>
-        </p:txBody>
-      </p:sp>
-      <p:sp>
-        <p:nvSpPr>
-          <p:cNvPr id="28" name="TextBox 27"/>
           <p:cNvSpPr txBox="1"/>
           <p:nvPr/>
         </p:nvSpPr>
@@ -25707,7 +25112,7 @@
       </p:sp>
       <p:sp>
         <p:nvSpPr>
-          <p:cNvPr id="29" name="Oval 28"/>
+          <p:cNvPr id="23" name="Oval 22"/>
           <p:cNvSpPr/>
           <p:nvPr/>
         </p:nvSpPr>
@@ -25751,7 +25156,7 @@
       </p:sp>
       <p:pic>
         <p:nvPicPr>
-          <p:cNvPr id="30" name="Picture 29" descr="indiana.png"/>
+          <p:cNvPr id="24" name="Picture 23" descr="indiana.png"/>
           <p:cNvPicPr>
             <a:picLocks noChangeAspect="1"/>
           </p:cNvPicPr>
@@ -25775,7 +25180,7 @@
       </p:pic>
       <p:sp>
         <p:nvSpPr>
-          <p:cNvPr id="31" name="TextBox 30"/>
+          <p:cNvPr id="25" name="TextBox 24"/>
           <p:cNvSpPr txBox="1"/>
           <p:nvPr/>
         </p:nvSpPr>
@@ -25803,14 +25208,14 @@
                 </a:solidFill>
                 <a:latin typeface="Arial"/>
               </a:rPr>
-              <a:t>19-of-27, 376 yards, 8 TD, 0 INT through two</a:t>
-            </a:r>
-          </a:p>
-        </p:txBody>
-      </p:sp>
-      <p:sp>
-        <p:nvSpPr>
-          <p:cNvPr id="32" name="TextBox 31"/>
+              <a:t>37-of-51, 649 yards, 10 TD, 0 INT through three</a:t>
+            </a:r>
+          </a:p>
+        </p:txBody>
+      </p:sp>
+      <p:sp>
+        <p:nvSpPr>
+          <p:cNvPr id="26" name="TextBox 25"/>
           <p:cNvSpPr txBox="1"/>
           <p:nvPr/>
         </p:nvSpPr>
@@ -25845,13 +25250,13 @@
       </p:sp>
       <p:sp>
         <p:nvSpPr>
-          <p:cNvPr id="33" name="TextBox 32"/>
-          <p:cNvSpPr txBox="1"/>
-          <p:nvPr/>
-        </p:nvSpPr>
-        <p:spPr>
-          <a:xfrm>
-            <a:off x="4114800" y="2514600"/>
+          <p:cNvPr id="27" name="TextBox 26"/>
+          <p:cNvSpPr txBox="1"/>
+          <p:nvPr/>
+        </p:nvSpPr>
+        <p:spPr>
+          <a:xfrm>
+            <a:off x="6858000" y="2514600"/>
             <a:ext cx="1097280" cy="274320"/>
           </a:xfrm>
           <a:prstGeom prst="rect">
@@ -25880,13 +25285,13 @@
       </p:sp>
       <p:sp>
         <p:nvSpPr>
-          <p:cNvPr id="34" name="TextBox 33"/>
-          <p:cNvSpPr txBox="1"/>
-          <p:nvPr/>
-        </p:nvSpPr>
-        <p:spPr>
-          <a:xfrm>
-            <a:off x="5257800" y="2514600"/>
+          <p:cNvPr id="28" name="TextBox 27"/>
+          <p:cNvSpPr txBox="1"/>
+          <p:nvPr/>
+        </p:nvSpPr>
+        <p:spPr>
+          <a:xfrm>
+            <a:off x="8001000" y="2514600"/>
             <a:ext cx="731520" cy="274320"/>
           </a:xfrm>
           <a:prstGeom prst="rect">
@@ -25915,13 +25320,13 @@
       </p:sp>
       <p:sp>
         <p:nvSpPr>
-          <p:cNvPr id="35" name="TextBox 34"/>
-          <p:cNvSpPr txBox="1"/>
-          <p:nvPr/>
-        </p:nvSpPr>
-        <p:spPr>
-          <a:xfrm>
-            <a:off x="6035040" y="2514600"/>
+          <p:cNvPr id="29" name="TextBox 28"/>
+          <p:cNvSpPr txBox="1"/>
+          <p:nvPr/>
+        </p:nvSpPr>
+        <p:spPr>
+          <a:xfrm>
+            <a:off x="8778240" y="2514600"/>
             <a:ext cx="640080" cy="274320"/>
           </a:xfrm>
           <a:prstGeom prst="rect">
@@ -25950,13 +25355,13 @@
       </p:sp>
       <p:sp>
         <p:nvSpPr>
-          <p:cNvPr id="36" name="TextBox 35"/>
-          <p:cNvSpPr txBox="1"/>
-          <p:nvPr/>
-        </p:nvSpPr>
-        <p:spPr>
-          <a:xfrm>
-            <a:off x="6720840" y="2514600"/>
+          <p:cNvPr id="30" name="TextBox 29"/>
+          <p:cNvSpPr txBox="1"/>
+          <p:nvPr/>
+        </p:nvSpPr>
+        <p:spPr>
+          <a:xfrm>
+            <a:off x="9464040" y="2514600"/>
             <a:ext cx="822960" cy="274320"/>
           </a:xfrm>
           <a:prstGeom prst="rect">
@@ -25985,13 +25390,13 @@
       </p:sp>
       <p:sp>
         <p:nvSpPr>
-          <p:cNvPr id="37" name="TextBox 36"/>
-          <p:cNvSpPr txBox="1"/>
-          <p:nvPr/>
-        </p:nvSpPr>
-        <p:spPr>
-          <a:xfrm>
-            <a:off x="7589520" y="2505456"/>
+          <p:cNvPr id="31" name="TextBox 30"/>
+          <p:cNvSpPr txBox="1"/>
+          <p:nvPr/>
+        </p:nvSpPr>
+        <p:spPr>
+          <a:xfrm>
+            <a:off x="10332720" y="2505456"/>
             <a:ext cx="640080" cy="274320"/>
           </a:xfrm>
           <a:prstGeom prst="rect">
@@ -26020,112 +25425,7 @@
       </p:sp>
       <p:sp>
         <p:nvSpPr>
-          <p:cNvPr id="38" name="TextBox 37"/>
-          <p:cNvSpPr txBox="1"/>
-          <p:nvPr/>
-        </p:nvSpPr>
-        <p:spPr>
-          <a:xfrm>
-            <a:off x="8275320" y="2514600"/>
-            <a:ext cx="822960" cy="274320"/>
-          </a:xfrm>
-          <a:prstGeom prst="rect">
-            <a:avLst/>
-          </a:prstGeom>
-          <a:noFill/>
-        </p:spPr>
-        <p:txBody>
-          <a:bodyPr wrap="square" lIns="0" rIns="0" tIns="0" bIns="0">
-            <a:spAutoFit/>
-          </a:bodyPr>
-          <a:lstStyle/>
-          <a:p>
-            <a:pPr algn="r"/>
-            <a:r>
-              <a:rPr sz="1050" b="0" i="0">
-                <a:solidFill>
-                  <a:srgbClr val="FFFFFF"/>
-                </a:solidFill>
-                <a:latin typeface="Arial"/>
-              </a:rPr>
-              <a:t>+1700</a:t>
-            </a:r>
-          </a:p>
-        </p:txBody>
-      </p:sp>
-      <p:sp>
-        <p:nvSpPr>
-          <p:cNvPr id="39" name="TextBox 38"/>
-          <p:cNvSpPr txBox="1"/>
-          <p:nvPr/>
-        </p:nvSpPr>
-        <p:spPr>
-          <a:xfrm>
-            <a:off x="9144000" y="2514600"/>
-            <a:ext cx="822960" cy="274320"/>
-          </a:xfrm>
-          <a:prstGeom prst="rect">
-            <a:avLst/>
-          </a:prstGeom>
-          <a:noFill/>
-        </p:spPr>
-        <p:txBody>
-          <a:bodyPr wrap="square" lIns="0" rIns="0" tIns="0" bIns="0">
-            <a:spAutoFit/>
-          </a:bodyPr>
-          <a:lstStyle/>
-          <a:p>
-            <a:pPr algn="r"/>
-            <a:r>
-              <a:rPr sz="1050" b="0" i="0">
-                <a:solidFill>
-                  <a:srgbClr val="CADCFC"/>
-                </a:solidFill>
-                <a:latin typeface="Arial"/>
-              </a:rPr>
-              <a:t>#8</a:t>
-            </a:r>
-          </a:p>
-        </p:txBody>
-      </p:sp>
-      <p:sp>
-        <p:nvSpPr>
-          <p:cNvPr id="40" name="TextBox 39"/>
-          <p:cNvSpPr txBox="1"/>
-          <p:nvPr/>
-        </p:nvSpPr>
-        <p:spPr>
-          <a:xfrm>
-            <a:off x="10012680" y="2514600"/>
-            <a:ext cx="1325880" cy="274320"/>
-          </a:xfrm>
-          <a:prstGeom prst="rect">
-            <a:avLst/>
-          </a:prstGeom>
-          <a:noFill/>
-        </p:spPr>
-        <p:txBody>
-          <a:bodyPr wrap="square" lIns="0" rIns="0" tIns="0" bIns="0">
-            <a:spAutoFit/>
-          </a:bodyPr>
-          <a:lstStyle/>
-          <a:p>
-            <a:pPr algn="r"/>
-            <a:r>
-              <a:rPr sz="950" b="1" i="0">
-                <a:solidFill>
-                  <a:srgbClr val="5CD68A"/>
-                </a:solidFill>
-                <a:latin typeface="Arial"/>
-              </a:rPr>
-              <a:t>market too low</a:t>
-            </a:r>
-          </a:p>
-        </p:txBody>
-      </p:sp>
-      <p:sp>
-        <p:nvSpPr>
-          <p:cNvPr id="41" name="Rectangle 40"/>
+          <p:cNvPr id="32" name="Rectangle 31"/>
           <p:cNvSpPr/>
           <p:nvPr/>
         </p:nvSpPr>
@@ -26169,7 +25469,7 @@
       </p:sp>
       <p:sp>
         <p:nvSpPr>
-          <p:cNvPr id="42" name="TextBox 41"/>
+          <p:cNvPr id="33" name="TextBox 32"/>
           <p:cNvSpPr txBox="1"/>
           <p:nvPr/>
         </p:nvSpPr>
@@ -26204,7 +25504,7 @@
       </p:sp>
       <p:sp>
         <p:nvSpPr>
-          <p:cNvPr id="43" name="Oval 42"/>
+          <p:cNvPr id="34" name="Oval 33"/>
           <p:cNvSpPr/>
           <p:nvPr/>
         </p:nvSpPr>
@@ -26248,7 +25548,7 @@
       </p:sp>
       <p:pic>
         <p:nvPicPr>
-          <p:cNvPr id="44" name="Picture 43" descr="notredame.png"/>
+          <p:cNvPr id="35" name="Picture 34" descr="notredame.png"/>
           <p:cNvPicPr>
             <a:picLocks noChangeAspect="1"/>
           </p:cNvPicPr>
@@ -26272,7 +25572,7 @@
       </p:pic>
       <p:sp>
         <p:nvSpPr>
-          <p:cNvPr id="45" name="TextBox 44"/>
+          <p:cNvPr id="36" name="TextBox 35"/>
           <p:cNvSpPr txBox="1"/>
           <p:nvPr/>
         </p:nvSpPr>
@@ -26300,14 +25600,14 @@
                 </a:solidFill>
                 <a:latin typeface="Arial"/>
               </a:rPr>
-              <a:t>35-of-49, 492 yards, 6 TD, 0 INT · 253 and 4 TD vs Rice</a:t>
-            </a:r>
-          </a:p>
-        </p:txBody>
-      </p:sp>
-      <p:sp>
-        <p:nvSpPr>
-          <p:cNvPr id="46" name="TextBox 45"/>
+              <a:t>53-of-73, 726 yards, 6 TD, 0 INT through three</a:t>
+            </a:r>
+          </a:p>
+        </p:txBody>
+      </p:sp>
+      <p:sp>
+        <p:nvSpPr>
+          <p:cNvPr id="37" name="TextBox 36"/>
           <p:cNvSpPr txBox="1"/>
           <p:nvPr/>
         </p:nvSpPr>
@@ -26342,13 +25642,13 @@
       </p:sp>
       <p:sp>
         <p:nvSpPr>
-          <p:cNvPr id="47" name="TextBox 46"/>
-          <p:cNvSpPr txBox="1"/>
-          <p:nvPr/>
-        </p:nvSpPr>
-        <p:spPr>
-          <a:xfrm>
-            <a:off x="4114800" y="3081528"/>
+          <p:cNvPr id="38" name="TextBox 37"/>
+          <p:cNvSpPr txBox="1"/>
+          <p:nvPr/>
+        </p:nvSpPr>
+        <p:spPr>
+          <a:xfrm>
+            <a:off x="6858000" y="3081528"/>
             <a:ext cx="1097280" cy="274320"/>
           </a:xfrm>
           <a:prstGeom prst="rect">
@@ -26377,13 +25677,13 @@
       </p:sp>
       <p:sp>
         <p:nvSpPr>
-          <p:cNvPr id="48" name="TextBox 47"/>
-          <p:cNvSpPr txBox="1"/>
-          <p:nvPr/>
-        </p:nvSpPr>
-        <p:spPr>
-          <a:xfrm>
-            <a:off x="5257800" y="3081528"/>
+          <p:cNvPr id="39" name="TextBox 38"/>
+          <p:cNvSpPr txBox="1"/>
+          <p:nvPr/>
+        </p:nvSpPr>
+        <p:spPr>
+          <a:xfrm>
+            <a:off x="8001000" y="3081528"/>
             <a:ext cx="731520" cy="274320"/>
           </a:xfrm>
           <a:prstGeom prst="rect">
@@ -26412,13 +25712,13 @@
       </p:sp>
       <p:sp>
         <p:nvSpPr>
-          <p:cNvPr id="49" name="TextBox 48"/>
-          <p:cNvSpPr txBox="1"/>
-          <p:nvPr/>
-        </p:nvSpPr>
-        <p:spPr>
-          <a:xfrm>
-            <a:off x="6035040" y="3081528"/>
+          <p:cNvPr id="40" name="TextBox 39"/>
+          <p:cNvSpPr txBox="1"/>
+          <p:nvPr/>
+        </p:nvSpPr>
+        <p:spPr>
+          <a:xfrm>
+            <a:off x="8778240" y="3081528"/>
             <a:ext cx="640080" cy="274320"/>
           </a:xfrm>
           <a:prstGeom prst="rect">
@@ -26447,13 +25747,13 @@
       </p:sp>
       <p:sp>
         <p:nvSpPr>
-          <p:cNvPr id="50" name="TextBox 49"/>
-          <p:cNvSpPr txBox="1"/>
-          <p:nvPr/>
-        </p:nvSpPr>
-        <p:spPr>
-          <a:xfrm>
-            <a:off x="6720840" y="3081528"/>
+          <p:cNvPr id="41" name="TextBox 40"/>
+          <p:cNvSpPr txBox="1"/>
+          <p:nvPr/>
+        </p:nvSpPr>
+        <p:spPr>
+          <a:xfrm>
+            <a:off x="9464040" y="3081528"/>
             <a:ext cx="822960" cy="274320"/>
           </a:xfrm>
           <a:prstGeom prst="rect">
@@ -26482,13 +25782,13 @@
       </p:sp>
       <p:sp>
         <p:nvSpPr>
-          <p:cNvPr id="51" name="TextBox 50"/>
-          <p:cNvSpPr txBox="1"/>
-          <p:nvPr/>
-        </p:nvSpPr>
-        <p:spPr>
-          <a:xfrm>
-            <a:off x="7589520" y="3072384"/>
+          <p:cNvPr id="42" name="TextBox 41"/>
+          <p:cNvSpPr txBox="1"/>
+          <p:nvPr/>
+        </p:nvSpPr>
+        <p:spPr>
+          <a:xfrm>
+            <a:off x="10332720" y="3072384"/>
             <a:ext cx="640080" cy="274320"/>
           </a:xfrm>
           <a:prstGeom prst="rect">
@@ -26517,112 +25817,7 @@
       </p:sp>
       <p:sp>
         <p:nvSpPr>
-          <p:cNvPr id="52" name="TextBox 51"/>
-          <p:cNvSpPr txBox="1"/>
-          <p:nvPr/>
-        </p:nvSpPr>
-        <p:spPr>
-          <a:xfrm>
-            <a:off x="8275320" y="3081528"/>
-            <a:ext cx="822960" cy="274320"/>
-          </a:xfrm>
-          <a:prstGeom prst="rect">
-            <a:avLst/>
-          </a:prstGeom>
-          <a:noFill/>
-        </p:spPr>
-        <p:txBody>
-          <a:bodyPr wrap="square" lIns="0" rIns="0" tIns="0" bIns="0">
-            <a:spAutoFit/>
-          </a:bodyPr>
-          <a:lstStyle/>
-          <a:p>
-            <a:pPr algn="r"/>
-            <a:r>
-              <a:rPr sz="1050" b="0" i="0">
-                <a:solidFill>
-                  <a:srgbClr val="FFFFFF"/>
-                </a:solidFill>
-                <a:latin typeface="Arial"/>
-              </a:rPr>
-              <a:t>+1050</a:t>
-            </a:r>
-          </a:p>
-        </p:txBody>
-      </p:sp>
-      <p:sp>
-        <p:nvSpPr>
-          <p:cNvPr id="53" name="TextBox 52"/>
-          <p:cNvSpPr txBox="1"/>
-          <p:nvPr/>
-        </p:nvSpPr>
-        <p:spPr>
-          <a:xfrm>
-            <a:off x="9144000" y="3081528"/>
-            <a:ext cx="822960" cy="274320"/>
-          </a:xfrm>
-          <a:prstGeom prst="rect">
-            <a:avLst/>
-          </a:prstGeom>
-          <a:noFill/>
-        </p:spPr>
-        <p:txBody>
-          <a:bodyPr wrap="square" lIns="0" rIns="0" tIns="0" bIns="0">
-            <a:spAutoFit/>
-          </a:bodyPr>
-          <a:lstStyle/>
-          <a:p>
-            <a:pPr algn="r"/>
-            <a:r>
-              <a:rPr sz="1050" b="0" i="0">
-                <a:solidFill>
-                  <a:srgbClr val="CADCFC"/>
-                </a:solidFill>
-                <a:latin typeface="Arial"/>
-              </a:rPr>
-              <a:t>#4</a:t>
-            </a:r>
-          </a:p>
-        </p:txBody>
-      </p:sp>
-      <p:sp>
-        <p:nvSpPr>
-          <p:cNvPr id="54" name="TextBox 53"/>
-          <p:cNvSpPr txBox="1"/>
-          <p:nvPr/>
-        </p:nvSpPr>
-        <p:spPr>
-          <a:xfrm>
-            <a:off x="10012680" y="3081528"/>
-            <a:ext cx="1325880" cy="274320"/>
-          </a:xfrm>
-          <a:prstGeom prst="rect">
-            <a:avLst/>
-          </a:prstGeom>
-          <a:noFill/>
-        </p:spPr>
-        <p:txBody>
-          <a:bodyPr wrap="square" lIns="0" rIns="0" tIns="0" bIns="0">
-            <a:spAutoFit/>
-          </a:bodyPr>
-          <a:lstStyle/>
-          <a:p>
-            <a:pPr algn="r"/>
-            <a:r>
-              <a:rPr sz="950" b="0" i="0">
-                <a:solidFill>
-                  <a:srgbClr val="CADCFC"/>
-                </a:solidFill>
-                <a:latin typeface="Arial"/>
-              </a:rPr>
-              <a:t>agree</a:t>
-            </a:r>
-          </a:p>
-        </p:txBody>
-      </p:sp>
-      <p:sp>
-        <p:nvSpPr>
-          <p:cNvPr id="55" name="TextBox 54"/>
+          <p:cNvPr id="43" name="TextBox 42"/>
           <p:cNvSpPr txBox="1"/>
           <p:nvPr/>
         </p:nvSpPr>
@@ -26657,7 +25852,7 @@
       </p:sp>
       <p:sp>
         <p:nvSpPr>
-          <p:cNvPr id="56" name="Oval 55"/>
+          <p:cNvPr id="44" name="Oval 43"/>
           <p:cNvSpPr/>
           <p:nvPr/>
         </p:nvSpPr>
@@ -26701,7 +25896,7 @@
       </p:sp>
       <p:pic>
         <p:nvPicPr>
-          <p:cNvPr id="57" name="Picture 56" descr="ohiostate.png"/>
+          <p:cNvPr id="45" name="Picture 44" descr="ohiostate.png"/>
           <p:cNvPicPr>
             <a:picLocks noChangeAspect="1"/>
           </p:cNvPicPr>
@@ -26725,7 +25920,7 @@
       </p:pic>
       <p:sp>
         <p:nvSpPr>
-          <p:cNvPr id="58" name="TextBox 57"/>
+          <p:cNvPr id="46" name="TextBox 45"/>
           <p:cNvSpPr txBox="1"/>
           <p:nvPr/>
         </p:nvSpPr>
@@ -26753,14 +25948,14 @@
                 </a:solidFill>
                 <a:latin typeface="Arial"/>
               </a:rPr>
-              <a:t>38-of-57, 598 yards, 4 TD, 1 INT · 278 in the loss at Texas</a:t>
-            </a:r>
-          </a:p>
-        </p:txBody>
-      </p:sp>
-      <p:sp>
-        <p:nvSpPr>
-          <p:cNvPr id="59" name="TextBox 58"/>
+              <a:t>56-of-79, 839 yards, 6 TD, 1 INT through three</a:t>
+            </a:r>
+          </a:p>
+        </p:txBody>
+      </p:sp>
+      <p:sp>
+        <p:nvSpPr>
+          <p:cNvPr id="47" name="TextBox 46"/>
           <p:cNvSpPr txBox="1"/>
           <p:nvPr/>
         </p:nvSpPr>
@@ -26795,13 +25990,13 @@
       </p:sp>
       <p:sp>
         <p:nvSpPr>
-          <p:cNvPr id="60" name="TextBox 59"/>
-          <p:cNvSpPr txBox="1"/>
-          <p:nvPr/>
-        </p:nvSpPr>
-        <p:spPr>
-          <a:xfrm>
-            <a:off x="4114800" y="3648456"/>
+          <p:cNvPr id="48" name="TextBox 47"/>
+          <p:cNvSpPr txBox="1"/>
+          <p:nvPr/>
+        </p:nvSpPr>
+        <p:spPr>
+          <a:xfrm>
+            <a:off x="6858000" y="3648456"/>
             <a:ext cx="1097280" cy="274320"/>
           </a:xfrm>
           <a:prstGeom prst="rect">
@@ -26830,13 +26025,13 @@
       </p:sp>
       <p:sp>
         <p:nvSpPr>
-          <p:cNvPr id="61" name="TextBox 60"/>
-          <p:cNvSpPr txBox="1"/>
-          <p:nvPr/>
-        </p:nvSpPr>
-        <p:spPr>
-          <a:xfrm>
-            <a:off x="5257800" y="3648456"/>
+          <p:cNvPr id="49" name="TextBox 48"/>
+          <p:cNvSpPr txBox="1"/>
+          <p:nvPr/>
+        </p:nvSpPr>
+        <p:spPr>
+          <a:xfrm>
+            <a:off x="8001000" y="3648456"/>
             <a:ext cx="731520" cy="274320"/>
           </a:xfrm>
           <a:prstGeom prst="rect">
@@ -26865,13 +26060,13 @@
       </p:sp>
       <p:sp>
         <p:nvSpPr>
-          <p:cNvPr id="62" name="TextBox 61"/>
-          <p:cNvSpPr txBox="1"/>
-          <p:nvPr/>
-        </p:nvSpPr>
-        <p:spPr>
-          <a:xfrm>
-            <a:off x="6035040" y="3648456"/>
+          <p:cNvPr id="50" name="TextBox 49"/>
+          <p:cNvSpPr txBox="1"/>
+          <p:nvPr/>
+        </p:nvSpPr>
+        <p:spPr>
+          <a:xfrm>
+            <a:off x="8778240" y="3648456"/>
             <a:ext cx="640080" cy="274320"/>
           </a:xfrm>
           <a:prstGeom prst="rect">
@@ -26900,13 +26095,13 @@
       </p:sp>
       <p:sp>
         <p:nvSpPr>
-          <p:cNvPr id="63" name="TextBox 62"/>
-          <p:cNvSpPr txBox="1"/>
-          <p:nvPr/>
-        </p:nvSpPr>
-        <p:spPr>
-          <a:xfrm>
-            <a:off x="6720840" y="3648456"/>
+          <p:cNvPr id="51" name="TextBox 50"/>
+          <p:cNvSpPr txBox="1"/>
+          <p:nvPr/>
+        </p:nvSpPr>
+        <p:spPr>
+          <a:xfrm>
+            <a:off x="9464040" y="3648456"/>
             <a:ext cx="822960" cy="274320"/>
           </a:xfrm>
           <a:prstGeom prst="rect">
@@ -26935,13 +26130,13 @@
       </p:sp>
       <p:sp>
         <p:nvSpPr>
-          <p:cNvPr id="64" name="TextBox 63"/>
-          <p:cNvSpPr txBox="1"/>
-          <p:nvPr/>
-        </p:nvSpPr>
-        <p:spPr>
-          <a:xfrm>
-            <a:off x="7589520" y="3639312"/>
+          <p:cNvPr id="52" name="TextBox 51"/>
+          <p:cNvSpPr txBox="1"/>
+          <p:nvPr/>
+        </p:nvSpPr>
+        <p:spPr>
+          <a:xfrm>
+            <a:off x="10332720" y="3639312"/>
             <a:ext cx="640080" cy="274320"/>
           </a:xfrm>
           <a:prstGeom prst="rect">
@@ -26970,112 +26165,7 @@
       </p:sp>
       <p:sp>
         <p:nvSpPr>
-          <p:cNvPr id="65" name="TextBox 64"/>
-          <p:cNvSpPr txBox="1"/>
-          <p:nvPr/>
-        </p:nvSpPr>
-        <p:spPr>
-          <a:xfrm>
-            <a:off x="8275320" y="3648456"/>
-            <a:ext cx="822960" cy="274320"/>
-          </a:xfrm>
-          <a:prstGeom prst="rect">
-            <a:avLst/>
-          </a:prstGeom>
-          <a:noFill/>
-        </p:spPr>
-        <p:txBody>
-          <a:bodyPr wrap="square" lIns="0" rIns="0" tIns="0" bIns="0">
-            <a:spAutoFit/>
-          </a:bodyPr>
-          <a:lstStyle/>
-          <a:p>
-            <a:pPr algn="r"/>
-            <a:r>
-              <a:rPr sz="1050" b="0" i="0">
-                <a:solidFill>
-                  <a:srgbClr val="FFFFFF"/>
-                </a:solidFill>
-                <a:latin typeface="Arial"/>
-              </a:rPr>
-              <a:t>+1500</a:t>
-            </a:r>
-          </a:p>
-        </p:txBody>
-      </p:sp>
-      <p:sp>
-        <p:nvSpPr>
-          <p:cNvPr id="66" name="TextBox 65"/>
-          <p:cNvSpPr txBox="1"/>
-          <p:nvPr/>
-        </p:nvSpPr>
-        <p:spPr>
-          <a:xfrm>
-            <a:off x="9144000" y="3648456"/>
-            <a:ext cx="822960" cy="274320"/>
-          </a:xfrm>
-          <a:prstGeom prst="rect">
-            <a:avLst/>
-          </a:prstGeom>
-          <a:noFill/>
-        </p:spPr>
-        <p:txBody>
-          <a:bodyPr wrap="square" lIns="0" rIns="0" tIns="0" bIns="0">
-            <a:spAutoFit/>
-          </a:bodyPr>
-          <a:lstStyle/>
-          <a:p>
-            <a:pPr algn="r"/>
-            <a:r>
-              <a:rPr sz="1050" b="0" i="0">
-                <a:solidFill>
-                  <a:srgbClr val="CADCFC"/>
-                </a:solidFill>
-                <a:latin typeface="Arial"/>
-              </a:rPr>
-              <a:t>#7</a:t>
-            </a:r>
-          </a:p>
-        </p:txBody>
-      </p:sp>
-      <p:sp>
-        <p:nvSpPr>
-          <p:cNvPr id="67" name="TextBox 66"/>
-          <p:cNvSpPr txBox="1"/>
-          <p:nvPr/>
-        </p:nvSpPr>
-        <p:spPr>
-          <a:xfrm>
-            <a:off x="10012680" y="3648456"/>
-            <a:ext cx="1325880" cy="274320"/>
-          </a:xfrm>
-          <a:prstGeom prst="rect">
-            <a:avLst/>
-          </a:prstGeom>
-          <a:noFill/>
-        </p:spPr>
-        <p:txBody>
-          <a:bodyPr wrap="square" lIns="0" rIns="0" tIns="0" bIns="0">
-            <a:spAutoFit/>
-          </a:bodyPr>
-          <a:lstStyle/>
-          <a:p>
-            <a:pPr algn="r"/>
-            <a:r>
-              <a:rPr sz="950" b="1" i="0">
-                <a:solidFill>
-                  <a:srgbClr val="5CD68A"/>
-                </a:solidFill>
-                <a:latin typeface="Arial"/>
-              </a:rPr>
-              <a:t>market too low</a:t>
-            </a:r>
-          </a:p>
-        </p:txBody>
-      </p:sp>
-      <p:sp>
-        <p:nvSpPr>
-          <p:cNvPr id="68" name="Rectangle 67"/>
+          <p:cNvPr id="53" name="Rectangle 52"/>
           <p:cNvSpPr/>
           <p:nvPr/>
         </p:nvSpPr>
@@ -27119,7 +26209,7 @@
       </p:sp>
       <p:sp>
         <p:nvSpPr>
-          <p:cNvPr id="69" name="TextBox 68"/>
+          <p:cNvPr id="54" name="TextBox 53"/>
           <p:cNvSpPr txBox="1"/>
           <p:nvPr/>
         </p:nvSpPr>
@@ -27154,7 +26244,7 @@
       </p:sp>
       <p:sp>
         <p:nvSpPr>
-          <p:cNvPr id="70" name="Oval 69"/>
+          <p:cNvPr id="55" name="Oval 54"/>
           <p:cNvSpPr/>
           <p:nvPr/>
         </p:nvSpPr>
@@ -27198,7 +26288,7 @@
       </p:sp>
       <p:pic>
         <p:nvPicPr>
-          <p:cNvPr id="71" name="Picture 70" descr="utah.png"/>
+          <p:cNvPr id="56" name="Picture 55" descr="utah.png"/>
           <p:cNvPicPr>
             <a:picLocks noChangeAspect="1"/>
           </p:cNvPicPr>
@@ -27222,7 +26312,7 @@
       </p:pic>
       <p:sp>
         <p:nvSpPr>
-          <p:cNvPr id="72" name="TextBox 71"/>
+          <p:cNvPr id="57" name="TextBox 56"/>
           <p:cNvSpPr txBox="1"/>
           <p:nvPr/>
         </p:nvSpPr>
@@ -27250,14 +26340,14 @@
                 </a:solidFill>
                 <a:latin typeface="Arial"/>
               </a:rPr>
-              <a:t>31-of-42, 437 yards, 5 TD · 81 rushing, 2 TD</a:t>
-            </a:r>
-          </a:p>
-        </p:txBody>
-      </p:sp>
-      <p:sp>
-        <p:nvSpPr>
-          <p:cNvPr id="73" name="TextBox 72"/>
+              <a:t>53-of-74, 690 yards, 7 TD, 1 INT · 115 rushing, 2 TD</a:t>
+            </a:r>
+          </a:p>
+        </p:txBody>
+      </p:sp>
+      <p:sp>
+        <p:nvSpPr>
+          <p:cNvPr id="58" name="TextBox 57"/>
           <p:cNvSpPr txBox="1"/>
           <p:nvPr/>
         </p:nvSpPr>
@@ -27292,13 +26382,13 @@
       </p:sp>
       <p:sp>
         <p:nvSpPr>
-          <p:cNvPr id="74" name="TextBox 73"/>
-          <p:cNvSpPr txBox="1"/>
-          <p:nvPr/>
-        </p:nvSpPr>
-        <p:spPr>
-          <a:xfrm>
-            <a:off x="4114800" y="4215384"/>
+          <p:cNvPr id="59" name="TextBox 58"/>
+          <p:cNvSpPr txBox="1"/>
+          <p:nvPr/>
+        </p:nvSpPr>
+        <p:spPr>
+          <a:xfrm>
+            <a:off x="6858000" y="4215384"/>
             <a:ext cx="1097280" cy="274320"/>
           </a:xfrm>
           <a:prstGeom prst="rect">
@@ -27327,13 +26417,13 @@
       </p:sp>
       <p:sp>
         <p:nvSpPr>
-          <p:cNvPr id="75" name="TextBox 74"/>
-          <p:cNvSpPr txBox="1"/>
-          <p:nvPr/>
-        </p:nvSpPr>
-        <p:spPr>
-          <a:xfrm>
-            <a:off x="5257800" y="4215384"/>
+          <p:cNvPr id="60" name="TextBox 59"/>
+          <p:cNvSpPr txBox="1"/>
+          <p:nvPr/>
+        </p:nvSpPr>
+        <p:spPr>
+          <a:xfrm>
+            <a:off x="8001000" y="4215384"/>
             <a:ext cx="731520" cy="274320"/>
           </a:xfrm>
           <a:prstGeom prst="rect">
@@ -27362,13 +26452,13 @@
       </p:sp>
       <p:sp>
         <p:nvSpPr>
-          <p:cNvPr id="76" name="TextBox 75"/>
-          <p:cNvSpPr txBox="1"/>
-          <p:nvPr/>
-        </p:nvSpPr>
-        <p:spPr>
-          <a:xfrm>
-            <a:off x="6035040" y="4215384"/>
+          <p:cNvPr id="61" name="TextBox 60"/>
+          <p:cNvSpPr txBox="1"/>
+          <p:nvPr/>
+        </p:nvSpPr>
+        <p:spPr>
+          <a:xfrm>
+            <a:off x="8778240" y="4215384"/>
             <a:ext cx="640080" cy="274320"/>
           </a:xfrm>
           <a:prstGeom prst="rect">
@@ -27397,13 +26487,13 @@
       </p:sp>
       <p:sp>
         <p:nvSpPr>
-          <p:cNvPr id="77" name="TextBox 76"/>
-          <p:cNvSpPr txBox="1"/>
-          <p:nvPr/>
-        </p:nvSpPr>
-        <p:spPr>
-          <a:xfrm>
-            <a:off x="6720840" y="4215384"/>
+          <p:cNvPr id="62" name="TextBox 61"/>
+          <p:cNvSpPr txBox="1"/>
+          <p:nvPr/>
+        </p:nvSpPr>
+        <p:spPr>
+          <a:xfrm>
+            <a:off x="9464040" y="4215384"/>
             <a:ext cx="822960" cy="274320"/>
           </a:xfrm>
           <a:prstGeom prst="rect">
@@ -27432,13 +26522,13 @@
       </p:sp>
       <p:sp>
         <p:nvSpPr>
-          <p:cNvPr id="78" name="TextBox 77"/>
-          <p:cNvSpPr txBox="1"/>
-          <p:nvPr/>
-        </p:nvSpPr>
-        <p:spPr>
-          <a:xfrm>
-            <a:off x="7589520" y="4206240"/>
+          <p:cNvPr id="63" name="TextBox 62"/>
+          <p:cNvSpPr txBox="1"/>
+          <p:nvPr/>
+        </p:nvSpPr>
+        <p:spPr>
+          <a:xfrm>
+            <a:off x="10332720" y="4206240"/>
             <a:ext cx="640080" cy="274320"/>
           </a:xfrm>
           <a:prstGeom prst="rect">
@@ -27467,112 +26557,7 @@
       </p:sp>
       <p:sp>
         <p:nvSpPr>
-          <p:cNvPr id="79" name="TextBox 78"/>
-          <p:cNvSpPr txBox="1"/>
-          <p:nvPr/>
-        </p:nvSpPr>
-        <p:spPr>
-          <a:xfrm>
-            <a:off x="8275320" y="4215384"/>
-            <a:ext cx="822960" cy="274320"/>
-          </a:xfrm>
-          <a:prstGeom prst="rect">
-            <a:avLst/>
-          </a:prstGeom>
-          <a:noFill/>
-        </p:spPr>
-        <p:txBody>
-          <a:bodyPr wrap="square" lIns="0" rIns="0" tIns="0" bIns="0">
-            <a:spAutoFit/>
-          </a:bodyPr>
-          <a:lstStyle/>
-          <a:p>
-            <a:pPr algn="r"/>
-            <a:r>
-              <a:rPr sz="1050" b="0" i="0">
-                <a:solidFill>
-                  <a:srgbClr val="CADCFC"/>
-                </a:solidFill>
-                <a:latin typeface="Arial"/>
-              </a:rPr>
-              <a:t>off board</a:t>
-            </a:r>
-          </a:p>
-        </p:txBody>
-      </p:sp>
-      <p:sp>
-        <p:nvSpPr>
-          <p:cNvPr id="80" name="TextBox 79"/>
-          <p:cNvSpPr txBox="1"/>
-          <p:nvPr/>
-        </p:nvSpPr>
-        <p:spPr>
-          <a:xfrm>
-            <a:off x="9144000" y="4215384"/>
-            <a:ext cx="822960" cy="274320"/>
-          </a:xfrm>
-          <a:prstGeom prst="rect">
-            <a:avLst/>
-          </a:prstGeom>
-          <a:noFill/>
-        </p:spPr>
-        <p:txBody>
-          <a:bodyPr wrap="square" lIns="0" rIns="0" tIns="0" bIns="0">
-            <a:spAutoFit/>
-          </a:bodyPr>
-          <a:lstStyle/>
-          <a:p>
-            <a:pPr algn="r"/>
-            <a:r>
-              <a:rPr sz="1050" b="0" i="0">
-                <a:solidFill>
-                  <a:srgbClr val="CADCFC"/>
-                </a:solidFill>
-                <a:latin typeface="Arial"/>
-              </a:rPr>
-              <a:t>—</a:t>
-            </a:r>
-          </a:p>
-        </p:txBody>
-      </p:sp>
-      <p:sp>
-        <p:nvSpPr>
-          <p:cNvPr id="81" name="TextBox 80"/>
-          <p:cNvSpPr txBox="1"/>
-          <p:nvPr/>
-        </p:nvSpPr>
-        <p:spPr>
-          <a:xfrm>
-            <a:off x="10012680" y="4215384"/>
-            <a:ext cx="1325880" cy="274320"/>
-          </a:xfrm>
-          <a:prstGeom prst="rect">
-            <a:avLst/>
-          </a:prstGeom>
-          <a:noFill/>
-        </p:spPr>
-        <p:txBody>
-          <a:bodyPr wrap="square" lIns="0" rIns="0" tIns="0" bIns="0">
-            <a:spAutoFit/>
-          </a:bodyPr>
-          <a:lstStyle/>
-          <a:p>
-            <a:pPr algn="r"/>
-            <a:r>
-              <a:rPr sz="950" b="1" i="0">
-                <a:solidFill>
-                  <a:srgbClr val="CADCFC"/>
-                </a:solidFill>
-                <a:latin typeface="Arial"/>
-              </a:rPr>
-              <a:t>unpriced</a:t>
-            </a:r>
-          </a:p>
-        </p:txBody>
-      </p:sp>
-      <p:sp>
-        <p:nvSpPr>
-          <p:cNvPr id="82" name="TextBox 81"/>
+          <p:cNvPr id="64" name="TextBox 63"/>
           <p:cNvSpPr txBox="1"/>
           <p:nvPr/>
         </p:nvSpPr>
@@ -27600,14 +26585,14 @@
                 </a:solidFill>
                 <a:latin typeface="Arial"/>
               </a:rPr>
-              <a:t>Next up: Jayden Maiava 29.9 (market #9) · Will Hammond 29.2 · Lincoln Kienholz 27.7 · Keelon Russell 27.5</a:t>
-            </a:r>
-          </a:p>
-        </p:txBody>
-      </p:sp>
-      <p:sp>
-        <p:nvSpPr>
-          <p:cNvPr id="83" name="Rounded Rectangle 82"/>
+              <a:t>Next up: Jayden Maiava 29.9 · Will Hammond 29.2 · Lincoln Kienholz 27.7 · Keelon Russell 27.5</a:t>
+            </a:r>
+          </a:p>
+        </p:txBody>
+      </p:sp>
+      <p:sp>
+        <p:nvSpPr>
+          <p:cNvPr id="65" name="Rounded Rectangle 64"/>
           <p:cNvSpPr/>
           <p:nvPr/>
         </p:nvSpPr>
@@ -27651,7 +26636,7 @@
       </p:sp>
       <p:sp>
         <p:nvSpPr>
-          <p:cNvPr id="84" name="TextBox 83"/>
+          <p:cNvPr id="66" name="TextBox 65"/>
           <p:cNvSpPr txBox="1"/>
           <p:nvPr/>
         </p:nvSpPr>
@@ -27686,7 +26671,7 @@
       </p:sp>
       <p:sp>
         <p:nvSpPr>
-          <p:cNvPr id="85" name="TextBox 84"/>
+          <p:cNvPr id="67" name="TextBox 66"/>
           <p:cNvSpPr txBox="1"/>
           <p:nvPr/>
         </p:nvSpPr>
@@ -27714,14 +26699,14 @@
                 </a:solidFill>
                 <a:latin typeface="Arial"/>
               </a:rPr>
-              <a:t>Darian Mensah, Miami · index 46.8 · market +550</a:t>
-            </a:r>
-          </a:p>
-        </p:txBody>
-      </p:sp>
-      <p:sp>
-        <p:nvSpPr>
-          <p:cNvPr id="86" name="TextBox 85"/>
+              <a:t>Darian Mensah, Miami · index 46.8</a:t>
+            </a:r>
+          </a:p>
+        </p:txBody>
+      </p:sp>
+      <p:sp>
+        <p:nvSpPr>
+          <p:cNvPr id="68" name="TextBox 67"/>
           <p:cNvSpPr txBox="1"/>
           <p:nvPr/>
         </p:nvSpPr>
@@ -27749,14 +26734,14 @@
                 </a:solidFill>
                 <a:latin typeface="Arial"/>
               </a:rPr>
-              <a:t>Non-QB watch: Jeremiah Smith (+650) · Malachi Toney (+1300) · Ryan Wingo · Trent Mosley</a:t>
-            </a:r>
-          </a:p>
-        </p:txBody>
-      </p:sp>
-      <p:sp>
-        <p:nvSpPr>
-          <p:cNvPr id="87" name="TextBox 86"/>
+              <a:t>Non-QB watch: Jeremiah Smith (Ohio State) · Malachi Toney (Miami) · Ryan Wingo (Texas) · Trent Mosley (USC)</a:t>
+            </a:r>
+          </a:p>
+        </p:txBody>
+      </p:sp>
+      <p:sp>
+        <p:nvSpPr>
+          <p:cNvPr id="69" name="TextBox 68"/>
           <p:cNvSpPr txBox="1"/>
           <p:nvPr/>
         </p:nvSpPr>
@@ -28159,13 +27144,13 @@
           <a:p>
             <a:pPr algn="r"/>
             <a:r>
-              <a:rPr sz="1350" b="1" i="0">
+              <a:rPr sz="1600" b="1" i="0">
                 <a:solidFill>
                   <a:srgbClr val="F47321"/>
                 </a:solidFill>
                 <a:latin typeface="Arial"/>
               </a:rPr>
-              <a:t>Texas –9   ·   +3.5 / +3.5</a:t>
+              <a:t>Texas –9</a:t>
             </a:r>
           </a:p>
         </p:txBody>
@@ -28200,7 +27185,7 @@
                 </a:solidFill>
                 <a:latin typeface="Arial"/>
               </a:rPr>
-              <a:t>machine · market</a:t>
+              <a:t>the machine's line</a:t>
             </a:r>
           </a:p>
         </p:txBody>
@@ -28479,13 +27464,13 @@
           <a:p>
             <a:pPr algn="r"/>
             <a:r>
-              <a:rPr sz="1350" b="1" i="0">
+              <a:rPr sz="1600" b="1" i="0">
                 <a:solidFill>
                   <a:srgbClr val="F47321"/>
                 </a:solidFill>
                 <a:latin typeface="Arial"/>
               </a:rPr>
-              <a:t>Florida –3   ·   –3 / –3</a:t>
+              <a:t>Florida –3</a:t>
             </a:r>
           </a:p>
         </p:txBody>
@@ -28520,7 +27505,7 @@
                 </a:solidFill>
                 <a:latin typeface="Arial"/>
               </a:rPr>
-              <a:t>machine · market</a:t>
+              <a:t>the machine's line</a:t>
             </a:r>
           </a:p>
         </p:txBody>
@@ -28799,13 +27784,13 @@
           <a:p>
             <a:pPr algn="r"/>
             <a:r>
-              <a:rPr sz="1350" b="1" i="0">
+              <a:rPr sz="1600" b="1" i="0">
                 <a:solidFill>
                   <a:srgbClr val="F47321"/>
                 </a:solidFill>
                 <a:latin typeface="Arial"/>
               </a:rPr>
-              <a:t>Georgia –14   ·   –14 / –14</a:t>
+              <a:t>Georgia –14</a:t>
             </a:r>
           </a:p>
         </p:txBody>
@@ -28840,7 +27825,7 @@
                 </a:solidFill>
                 <a:latin typeface="Arial"/>
               </a:rPr>
-              <a:t>machine · market</a:t>
+              <a:t>the machine's line</a:t>
             </a:r>
           </a:p>
         </p:txBody>
@@ -29119,13 +28104,13 @@
           <a:p>
             <a:pPr algn="r"/>
             <a:r>
-              <a:rPr sz="1350" b="1" i="0">
+              <a:rPr sz="1600" b="1" i="0">
                 <a:solidFill>
                   <a:srgbClr val="F47321"/>
                 </a:solidFill>
                 <a:latin typeface="Arial"/>
               </a:rPr>
-              <a:t>Oregon –0.5   ·   +3 / +3</a:t>
+              <a:t>Oregon –0.5</a:t>
             </a:r>
           </a:p>
         </p:txBody>
@@ -29160,7 +28145,7 @@
                 </a:solidFill>
                 <a:latin typeface="Arial"/>
               </a:rPr>
-              <a:t>machine · market</a:t>
+              <a:t>the machine's line</a:t>
             </a:r>
           </a:p>
         </p:txBody>
@@ -29439,13 +28424,13 @@
           <a:p>
             <a:pPr algn="r"/>
             <a:r>
-              <a:rPr sz="1350" b="1" i="0">
+              <a:rPr sz="1600" b="1" i="0">
                 <a:solidFill>
                   <a:srgbClr val="F47321"/>
                 </a:solidFill>
                 <a:latin typeface="Arial"/>
               </a:rPr>
-              <a:t>LSU –5.5   ·   –9.5 / –10</a:t>
+              <a:t>LSU –5.5</a:t>
             </a:r>
           </a:p>
         </p:txBody>
@@ -29480,7 +28465,7 @@
                 </a:solidFill>
                 <a:latin typeface="Arial"/>
               </a:rPr>
-              <a:t>machine · market</a:t>
+              <a:t>the machine's line</a:t>
             </a:r>
           </a:p>
         </p:txBody>
@@ -29515,7 +28500,7 @@
                 </a:solidFill>
                 <a:latin typeface="Arial"/>
               </a:rPr>
-              <a:t>Machine = our in-season rating + 2.5 home field · lines as of Sep 21</a:t>
+              <a:t>Machine = our in-season rating + 2.5 home field</a:t>
             </a:r>
           </a:p>
         </p:txBody>
@@ -31257,7 +30242,7 @@
                 </a:solidFill>
                 <a:latin typeface="Arial"/>
               </a:rPr>
-              <a:t>3.5 to Texas — quibble, not a position</a:t>
+              <a:t>71% — but Texas has not left Austin yet</a:t>
             </a:r>
           </a:p>
         </p:txBody>
@@ -31271,7 +30256,7 @@
         <p:spPr>
           <a:xfrm>
             <a:off x="7772400" y="1600200"/>
-            <a:ext cx="3566160" cy="4206240"/>
+            <a:ext cx="3566160" cy="3611880"/>
           </a:xfrm>
           <a:prstGeom prst="roundRect">
             <a:avLst/>
@@ -31454,8 +30439,8 @@
         </p:nvSpPr>
         <p:spPr>
           <a:xfrm>
-            <a:off x="8046720" y="3246120"/>
-            <a:ext cx="3017520" cy="411480"/>
+            <a:off x="8046720" y="3383280"/>
+            <a:ext cx="3017520" cy="365760"/>
           </a:xfrm>
           <a:prstGeom prst="rect">
             <a:avLst/>
@@ -31470,13 +30455,13 @@
           <a:p>
             <a:pPr algn="l"/>
             <a:r>
-              <a:rPr sz="2000" b="1" i="0">
-                <a:solidFill>
-                  <a:srgbClr val="FFFFFF"/>
-                </a:solidFill>
-                <a:latin typeface="Arial"/>
-              </a:rPr>
-              <a:t>+3.5 / +3.5</a:t>
+              <a:rPr sz="1300" b="1" i="0">
+                <a:solidFill>
+                  <a:srgbClr val="F47321"/>
+                </a:solidFill>
+                <a:latin typeface="Arial"/>
+              </a:rPr>
+              <a:t>Texas 33 – Tennessee 24</a:t>
             </a:r>
           </a:p>
         </p:txBody>
@@ -31489,8 +30474,8 @@
         </p:nvSpPr>
         <p:spPr>
           <a:xfrm>
-            <a:off x="8046720" y="3639312"/>
-            <a:ext cx="3017520" cy="365760"/>
+            <a:off x="8046720" y="3767328"/>
+            <a:ext cx="3017520" cy="228600"/>
           </a:xfrm>
           <a:prstGeom prst="rect">
             <a:avLst/>
@@ -31511,76 +30496,6 @@
                 </a:solidFill>
                 <a:latin typeface="Arial"/>
               </a:rPr>
-              <a:t>market (DK / Bovada) · DK Tennessee +154 / Texas -185 · Bov Tennessee +155 / Texas -180</a:t>
-            </a:r>
-          </a:p>
-        </p:txBody>
-      </p:sp>
-      <p:sp>
-        <p:nvSpPr>
-          <p:cNvPr id="19" name="TextBox 18"/>
-          <p:cNvSpPr txBox="1"/>
-          <p:nvPr/>
-        </p:nvSpPr>
-        <p:spPr>
-          <a:xfrm>
-            <a:off x="8046720" y="4069080"/>
-            <a:ext cx="3017520" cy="365760"/>
-          </a:xfrm>
-          <a:prstGeom prst="rect">
-            <a:avLst/>
-          </a:prstGeom>
-          <a:noFill/>
-        </p:spPr>
-        <p:txBody>
-          <a:bodyPr wrap="square" lIns="0" rIns="0" tIns="0" bIns="0">
-            <a:spAutoFit/>
-          </a:bodyPr>
-          <a:lstStyle/>
-          <a:p>
-            <a:pPr algn="l"/>
-            <a:r>
-              <a:rPr sz="1300" b="1" i="0">
-                <a:solidFill>
-                  <a:srgbClr val="F47321"/>
-                </a:solidFill>
-                <a:latin typeface="Arial"/>
-              </a:rPr>
-              <a:t>Texas 33 – Tennessee 24</a:t>
-            </a:r>
-          </a:p>
-        </p:txBody>
-      </p:sp>
-      <p:sp>
-        <p:nvSpPr>
-          <p:cNvPr id="20" name="TextBox 19"/>
-          <p:cNvSpPr txBox="1"/>
-          <p:nvPr/>
-        </p:nvSpPr>
-        <p:spPr>
-          <a:xfrm>
-            <a:off x="8046720" y="4407408"/>
-            <a:ext cx="3017520" cy="228600"/>
-          </a:xfrm>
-          <a:prstGeom prst="rect">
-            <a:avLst/>
-          </a:prstGeom>
-          <a:noFill/>
-        </p:spPr>
-        <p:txBody>
-          <a:bodyPr wrap="square" lIns="0" rIns="0" tIns="0" bIns="0">
-            <a:spAutoFit/>
-          </a:bodyPr>
-          <a:lstStyle/>
-          <a:p>
-            <a:pPr algn="l"/>
-            <a:r>
-              <a:rPr sz="850" b="0" i="0">
-                <a:solidFill>
-                  <a:srgbClr val="CADCFC"/>
-                </a:solidFill>
-                <a:latin typeface="Arial"/>
-              </a:rPr>
               <a:t>score prediction</a:t>
             </a:r>
           </a:p>
@@ -31588,13 +30503,13 @@
       </p:sp>
       <p:sp>
         <p:nvSpPr>
-          <p:cNvPr id="21" name="Rounded Rectangle 20"/>
+          <p:cNvPr id="19" name="Rounded Rectangle 18"/>
           <p:cNvSpPr/>
           <p:nvPr/>
         </p:nvSpPr>
         <p:spPr>
           <a:xfrm>
-            <a:off x="8046720" y="4754880"/>
+            <a:off x="8046720" y="4206240"/>
             <a:ext cx="3017520" cy="365760"/>
           </a:xfrm>
           <a:prstGeom prst="roundRect">
@@ -31632,13 +30547,13 @@
       </p:sp>
       <p:sp>
         <p:nvSpPr>
-          <p:cNvPr id="22" name="Rounded Rectangle 21"/>
+          <p:cNvPr id="20" name="Rounded Rectangle 19"/>
           <p:cNvSpPr/>
           <p:nvPr/>
         </p:nvSpPr>
         <p:spPr>
           <a:xfrm>
-            <a:off x="8046720" y="4754880"/>
+            <a:off x="8046720" y="4206240"/>
             <a:ext cx="875080" cy="365760"/>
           </a:xfrm>
           <a:prstGeom prst="roundRect">
@@ -31676,83 +30591,83 @@
       </p:sp>
       <p:sp>
         <p:nvSpPr>
+          <p:cNvPr id="21" name="TextBox 20"/>
+          <p:cNvSpPr txBox="1"/>
+          <p:nvPr/>
+        </p:nvSpPr>
+        <p:spPr>
+          <a:xfrm>
+            <a:off x="8119872" y="4288536"/>
+            <a:ext cx="2194560" cy="228600"/>
+          </a:xfrm>
+          <a:prstGeom prst="rect">
+            <a:avLst/>
+          </a:prstGeom>
+          <a:noFill/>
+        </p:spPr>
+        <p:txBody>
+          <a:bodyPr wrap="square" lIns="0" rIns="0" tIns="0" bIns="0">
+            <a:spAutoFit/>
+          </a:bodyPr>
+          <a:lstStyle/>
+          <a:p>
+            <a:pPr algn="l"/>
+            <a:r>
+              <a:rPr sz="1050" b="1" i="0">
+                <a:solidFill>
+                  <a:srgbClr val="16273D"/>
+                </a:solidFill>
+                <a:latin typeface="Arial"/>
+              </a:rPr>
+              <a:t>TENN 29%</a:t>
+            </a:r>
+          </a:p>
+        </p:txBody>
+      </p:sp>
+      <p:sp>
+        <p:nvSpPr>
+          <p:cNvPr id="22" name="TextBox 21"/>
+          <p:cNvSpPr txBox="1"/>
+          <p:nvPr/>
+        </p:nvSpPr>
+        <p:spPr>
+          <a:xfrm>
+            <a:off x="8796528" y="4288536"/>
+            <a:ext cx="2194560" cy="228600"/>
+          </a:xfrm>
+          <a:prstGeom prst="rect">
+            <a:avLst/>
+          </a:prstGeom>
+          <a:noFill/>
+        </p:spPr>
+        <p:txBody>
+          <a:bodyPr wrap="square" lIns="0" rIns="0" tIns="0" bIns="0">
+            <a:spAutoFit/>
+          </a:bodyPr>
+          <a:lstStyle/>
+          <a:p>
+            <a:pPr algn="r"/>
+            <a:r>
+              <a:rPr sz="1050" b="1" i="0">
+                <a:solidFill>
+                  <a:srgbClr val="FFFFFF"/>
+                </a:solidFill>
+                <a:latin typeface="Arial"/>
+              </a:rPr>
+              <a:t>71% TEX</a:t>
+            </a:r>
+          </a:p>
+        </p:txBody>
+      </p:sp>
+      <p:sp>
+        <p:nvSpPr>
           <p:cNvPr id="23" name="TextBox 22"/>
           <p:cNvSpPr txBox="1"/>
           <p:nvPr/>
         </p:nvSpPr>
         <p:spPr>
           <a:xfrm>
-            <a:off x="8119872" y="4837176"/>
-            <a:ext cx="2194560" cy="228600"/>
-          </a:xfrm>
-          <a:prstGeom prst="rect">
-            <a:avLst/>
-          </a:prstGeom>
-          <a:noFill/>
-        </p:spPr>
-        <p:txBody>
-          <a:bodyPr wrap="square" lIns="0" rIns="0" tIns="0" bIns="0">
-            <a:spAutoFit/>
-          </a:bodyPr>
-          <a:lstStyle/>
-          <a:p>
-            <a:pPr algn="l"/>
-            <a:r>
-              <a:rPr sz="1050" b="1" i="0">
-                <a:solidFill>
-                  <a:srgbClr val="16273D"/>
-                </a:solidFill>
-                <a:latin typeface="Arial"/>
-              </a:rPr>
-              <a:t>TENN 29%</a:t>
-            </a:r>
-          </a:p>
-        </p:txBody>
-      </p:sp>
-      <p:sp>
-        <p:nvSpPr>
-          <p:cNvPr id="24" name="TextBox 23"/>
-          <p:cNvSpPr txBox="1"/>
-          <p:nvPr/>
-        </p:nvSpPr>
-        <p:spPr>
-          <a:xfrm>
-            <a:off x="8796528" y="4837176"/>
-            <a:ext cx="2194560" cy="228600"/>
-          </a:xfrm>
-          <a:prstGeom prst="rect">
-            <a:avLst/>
-          </a:prstGeom>
-          <a:noFill/>
-        </p:spPr>
-        <p:txBody>
-          <a:bodyPr wrap="square" lIns="0" rIns="0" tIns="0" bIns="0">
-            <a:spAutoFit/>
-          </a:bodyPr>
-          <a:lstStyle/>
-          <a:p>
-            <a:pPr algn="r"/>
-            <a:r>
-              <a:rPr sz="1050" b="1" i="0">
-                <a:solidFill>
-                  <a:srgbClr val="FFFFFF"/>
-                </a:solidFill>
-                <a:latin typeface="Arial"/>
-              </a:rPr>
-              <a:t>71% TEX</a:t>
-            </a:r>
-          </a:p>
-        </p:txBody>
-      </p:sp>
-      <p:sp>
-        <p:nvSpPr>
-          <p:cNvPr id="25" name="TextBox 24"/>
-          <p:cNvSpPr txBox="1"/>
-          <p:nvPr/>
-        </p:nvSpPr>
-        <p:spPr>
-          <a:xfrm>
-            <a:off x="8046720" y="5175504"/>
+            <a:off x="8046720" y="4626864"/>
             <a:ext cx="3017520" cy="228600"/>
           </a:xfrm>
           <a:prstGeom prst="rect">
@@ -33438,7 +32353,7 @@
                 </a:solidFill>
                 <a:latin typeface="Arial"/>
               </a:rPr>
-              <a:t>Machine = market — no play</a:t>
+              <a:t>59% — a field-goal game between two 3–0 teams</a:t>
             </a:r>
           </a:p>
         </p:txBody>
@@ -33452,7 +32367,7 @@
         <p:spPr>
           <a:xfrm>
             <a:off x="7772400" y="1600200"/>
-            <a:ext cx="3566160" cy="4206240"/>
+            <a:ext cx="3566160" cy="3611880"/>
           </a:xfrm>
           <a:prstGeom prst="roundRect">
             <a:avLst/>
@@ -33635,8 +32550,8 @@
         </p:nvSpPr>
         <p:spPr>
           <a:xfrm>
-            <a:off x="8046720" y="3246120"/>
-            <a:ext cx="3017520" cy="411480"/>
+            <a:off x="8046720" y="3383280"/>
+            <a:ext cx="3017520" cy="365760"/>
           </a:xfrm>
           <a:prstGeom prst="rect">
             <a:avLst/>
@@ -33651,13 +32566,13 @@
           <a:p>
             <a:pPr algn="l"/>
             <a:r>
-              <a:rPr sz="2000" b="1" i="0">
-                <a:solidFill>
-                  <a:srgbClr val="FFFFFF"/>
-                </a:solidFill>
-                <a:latin typeface="Arial"/>
-              </a:rPr>
-              <a:t>–3 / –3</a:t>
+              <a:rPr sz="1300" b="1" i="0">
+                <a:solidFill>
+                  <a:srgbClr val="F47321"/>
+                </a:solidFill>
+                <a:latin typeface="Arial"/>
+              </a:rPr>
+              <a:t>Florida 32 – Ole Miss 29</a:t>
             </a:r>
           </a:p>
         </p:txBody>
@@ -33670,8 +32585,8 @@
         </p:nvSpPr>
         <p:spPr>
           <a:xfrm>
-            <a:off x="8046720" y="3639312"/>
-            <a:ext cx="3017520" cy="365760"/>
+            <a:off x="8046720" y="3767328"/>
+            <a:ext cx="3017520" cy="228600"/>
           </a:xfrm>
           <a:prstGeom prst="rect">
             <a:avLst/>
@@ -33692,76 +32607,6 @@
                 </a:solidFill>
                 <a:latin typeface="Arial"/>
               </a:rPr>
-              <a:t>market (DK / Bovada) · DK Florida -162 / Ole Miss +136 · Bov Florida -165 / Ole Miss +140</a:t>
-            </a:r>
-          </a:p>
-        </p:txBody>
-      </p:sp>
-      <p:sp>
-        <p:nvSpPr>
-          <p:cNvPr id="19" name="TextBox 18"/>
-          <p:cNvSpPr txBox="1"/>
-          <p:nvPr/>
-        </p:nvSpPr>
-        <p:spPr>
-          <a:xfrm>
-            <a:off x="8046720" y="4069080"/>
-            <a:ext cx="3017520" cy="365760"/>
-          </a:xfrm>
-          <a:prstGeom prst="rect">
-            <a:avLst/>
-          </a:prstGeom>
-          <a:noFill/>
-        </p:spPr>
-        <p:txBody>
-          <a:bodyPr wrap="square" lIns="0" rIns="0" tIns="0" bIns="0">
-            <a:spAutoFit/>
-          </a:bodyPr>
-          <a:lstStyle/>
-          <a:p>
-            <a:pPr algn="l"/>
-            <a:r>
-              <a:rPr sz="1300" b="1" i="0">
-                <a:solidFill>
-                  <a:srgbClr val="F47321"/>
-                </a:solidFill>
-                <a:latin typeface="Arial"/>
-              </a:rPr>
-              <a:t>Florida 32 – Ole Miss 29</a:t>
-            </a:r>
-          </a:p>
-        </p:txBody>
-      </p:sp>
-      <p:sp>
-        <p:nvSpPr>
-          <p:cNvPr id="20" name="TextBox 19"/>
-          <p:cNvSpPr txBox="1"/>
-          <p:nvPr/>
-        </p:nvSpPr>
-        <p:spPr>
-          <a:xfrm>
-            <a:off x="8046720" y="4407408"/>
-            <a:ext cx="3017520" cy="228600"/>
-          </a:xfrm>
-          <a:prstGeom prst="rect">
-            <a:avLst/>
-          </a:prstGeom>
-          <a:noFill/>
-        </p:spPr>
-        <p:txBody>
-          <a:bodyPr wrap="square" lIns="0" rIns="0" tIns="0" bIns="0">
-            <a:spAutoFit/>
-          </a:bodyPr>
-          <a:lstStyle/>
-          <a:p>
-            <a:pPr algn="l"/>
-            <a:r>
-              <a:rPr sz="850" b="0" i="0">
-                <a:solidFill>
-                  <a:srgbClr val="CADCFC"/>
-                </a:solidFill>
-                <a:latin typeface="Arial"/>
-              </a:rPr>
               <a:t>score prediction</a:t>
             </a:r>
           </a:p>
@@ -33769,13 +32614,13 @@
       </p:sp>
       <p:sp>
         <p:nvSpPr>
-          <p:cNvPr id="21" name="Rounded Rectangle 20"/>
+          <p:cNvPr id="19" name="Rounded Rectangle 18"/>
           <p:cNvSpPr/>
           <p:nvPr/>
         </p:nvSpPr>
         <p:spPr>
           <a:xfrm>
-            <a:off x="8046720" y="4754880"/>
+            <a:off x="8046720" y="4206240"/>
             <a:ext cx="3017520" cy="365760"/>
           </a:xfrm>
           <a:prstGeom prst="roundRect">
@@ -33813,13 +32658,13 @@
       </p:sp>
       <p:sp>
         <p:nvSpPr>
-          <p:cNvPr id="22" name="Rounded Rectangle 21"/>
+          <p:cNvPr id="20" name="Rounded Rectangle 19"/>
           <p:cNvSpPr/>
           <p:nvPr/>
         </p:nvSpPr>
         <p:spPr>
           <a:xfrm>
-            <a:off x="8046720" y="4754880"/>
+            <a:off x="8046720" y="4206240"/>
             <a:ext cx="1780336" cy="365760"/>
           </a:xfrm>
           <a:prstGeom prst="roundRect">
@@ -33857,83 +32702,83 @@
       </p:sp>
       <p:sp>
         <p:nvSpPr>
+          <p:cNvPr id="21" name="TextBox 20"/>
+          <p:cNvSpPr txBox="1"/>
+          <p:nvPr/>
+        </p:nvSpPr>
+        <p:spPr>
+          <a:xfrm>
+            <a:off x="8119872" y="4288536"/>
+            <a:ext cx="2194560" cy="228600"/>
+          </a:xfrm>
+          <a:prstGeom prst="rect">
+            <a:avLst/>
+          </a:prstGeom>
+          <a:noFill/>
+        </p:spPr>
+        <p:txBody>
+          <a:bodyPr wrap="square" lIns="0" rIns="0" tIns="0" bIns="0">
+            <a:spAutoFit/>
+          </a:bodyPr>
+          <a:lstStyle/>
+          <a:p>
+            <a:pPr algn="l"/>
+            <a:r>
+              <a:rPr sz="1050" b="1" i="0">
+                <a:solidFill>
+                  <a:srgbClr val="FFFFFF"/>
+                </a:solidFill>
+                <a:latin typeface="Arial"/>
+              </a:rPr>
+              <a:t>FLA 59%</a:t>
+            </a:r>
+          </a:p>
+        </p:txBody>
+      </p:sp>
+      <p:sp>
+        <p:nvSpPr>
+          <p:cNvPr id="22" name="TextBox 21"/>
+          <p:cNvSpPr txBox="1"/>
+          <p:nvPr/>
+        </p:nvSpPr>
+        <p:spPr>
+          <a:xfrm>
+            <a:off x="8796528" y="4288536"/>
+            <a:ext cx="2194560" cy="228600"/>
+          </a:xfrm>
+          <a:prstGeom prst="rect">
+            <a:avLst/>
+          </a:prstGeom>
+          <a:noFill/>
+        </p:spPr>
+        <p:txBody>
+          <a:bodyPr wrap="square" lIns="0" rIns="0" tIns="0" bIns="0">
+            <a:spAutoFit/>
+          </a:bodyPr>
+          <a:lstStyle/>
+          <a:p>
+            <a:pPr algn="r"/>
+            <a:r>
+              <a:rPr sz="1050" b="1" i="0">
+                <a:solidFill>
+                  <a:srgbClr val="FFFFFF"/>
+                </a:solidFill>
+                <a:latin typeface="Arial"/>
+              </a:rPr>
+              <a:t>41% MISS</a:t>
+            </a:r>
+          </a:p>
+        </p:txBody>
+      </p:sp>
+      <p:sp>
+        <p:nvSpPr>
           <p:cNvPr id="23" name="TextBox 22"/>
           <p:cNvSpPr txBox="1"/>
           <p:nvPr/>
         </p:nvSpPr>
         <p:spPr>
           <a:xfrm>
-            <a:off x="8119872" y="4837176"/>
-            <a:ext cx="2194560" cy="228600"/>
-          </a:xfrm>
-          <a:prstGeom prst="rect">
-            <a:avLst/>
-          </a:prstGeom>
-          <a:noFill/>
-        </p:spPr>
-        <p:txBody>
-          <a:bodyPr wrap="square" lIns="0" rIns="0" tIns="0" bIns="0">
-            <a:spAutoFit/>
-          </a:bodyPr>
-          <a:lstStyle/>
-          <a:p>
-            <a:pPr algn="l"/>
-            <a:r>
-              <a:rPr sz="1050" b="1" i="0">
-                <a:solidFill>
-                  <a:srgbClr val="FFFFFF"/>
-                </a:solidFill>
-                <a:latin typeface="Arial"/>
-              </a:rPr>
-              <a:t>FLA 59%</a:t>
-            </a:r>
-          </a:p>
-        </p:txBody>
-      </p:sp>
-      <p:sp>
-        <p:nvSpPr>
-          <p:cNvPr id="24" name="TextBox 23"/>
-          <p:cNvSpPr txBox="1"/>
-          <p:nvPr/>
-        </p:nvSpPr>
-        <p:spPr>
-          <a:xfrm>
-            <a:off x="8796528" y="4837176"/>
-            <a:ext cx="2194560" cy="228600"/>
-          </a:xfrm>
-          <a:prstGeom prst="rect">
-            <a:avLst/>
-          </a:prstGeom>
-          <a:noFill/>
-        </p:spPr>
-        <p:txBody>
-          <a:bodyPr wrap="square" lIns="0" rIns="0" tIns="0" bIns="0">
-            <a:spAutoFit/>
-          </a:bodyPr>
-          <a:lstStyle/>
-          <a:p>
-            <a:pPr algn="r"/>
-            <a:r>
-              <a:rPr sz="1050" b="1" i="0">
-                <a:solidFill>
-                  <a:srgbClr val="FFFFFF"/>
-                </a:solidFill>
-                <a:latin typeface="Arial"/>
-              </a:rPr>
-              <a:t>41% MISS</a:t>
-            </a:r>
-          </a:p>
-        </p:txBody>
-      </p:sp>
-      <p:sp>
-        <p:nvSpPr>
-          <p:cNvPr id="25" name="TextBox 24"/>
-          <p:cNvSpPr txBox="1"/>
-          <p:nvPr/>
-        </p:nvSpPr>
-        <p:spPr>
-          <a:xfrm>
-            <a:off x="8046720" y="5175504"/>
+            <a:off x="8046720" y="4626864"/>
             <a:ext cx="3017520" cy="228600"/>
           </a:xfrm>
           <a:prstGeom prst="rect">

</xml_diff>

<commit_message>
Predictions slide shows the market number and whether the machine agrees (the one market exception; receipts stay man vs machine)
Co-Authored-By: Claude Fable 5.1 <noreply@anthropic.com>
</commit_message>
<xml_diff>
--- a/decks/2026_Week4_Episode5.pptx
+++ b/decks/2026_Week4_Episode5.pptx
@@ -23096,7 +23096,7 @@
         </p:nvSpPr>
         <p:spPr>
           <a:xfrm>
-            <a:off x="6400800" y="1911095"/>
+            <a:off x="6400800" y="1837943"/>
             <a:ext cx="4754880" cy="411480"/>
           </a:xfrm>
           <a:prstGeom prst="rect">
@@ -23125,7 +23125,42 @@
       </p:sp>
       <p:sp>
         <p:nvSpPr>
-          <p:cNvPr id="11" name="Rounded Rectangle 10"/>
+          <p:cNvPr id="11" name="TextBox 10"/>
+          <p:cNvSpPr txBox="1"/>
+          <p:nvPr/>
+        </p:nvSpPr>
+        <p:spPr>
+          <a:xfrm>
+            <a:off x="4206240" y="2212848"/>
+            <a:ext cx="6949440" cy="228600"/>
+          </a:xfrm>
+          <a:prstGeom prst="rect">
+            <a:avLst/>
+          </a:prstGeom>
+          <a:noFill/>
+        </p:spPr>
+        <p:txBody>
+          <a:bodyPr wrap="square" lIns="0" rIns="0" tIns="0" bIns="0">
+            <a:spAutoFit/>
+          </a:bodyPr>
+          <a:lstStyle/>
+          <a:p>
+            <a:pPr algn="r"/>
+            <a:r>
+              <a:rPr sz="950" b="0" i="0">
+                <a:solidFill>
+                  <a:srgbClr val="CADCFC"/>
+                </a:solidFill>
+                <a:latin typeface="Arial"/>
+              </a:rPr>
+              <a:t>machine Texas –9  ·  market Texas –3.5  ·  machine 5.5 higher on Texas</a:t>
+            </a:r>
+          </a:p>
+        </p:txBody>
+      </p:sp>
+      <p:sp>
+        <p:nvSpPr>
+          <p:cNvPr id="12" name="Rounded Rectangle 11"/>
           <p:cNvSpPr/>
           <p:nvPr/>
         </p:nvSpPr>
@@ -23169,7 +23204,7 @@
       </p:sp>
       <p:sp>
         <p:nvSpPr>
-          <p:cNvPr id="12" name="Oval 11"/>
+          <p:cNvPr id="13" name="Oval 12"/>
           <p:cNvSpPr/>
           <p:nvPr/>
         </p:nvSpPr>
@@ -23213,7 +23248,7 @@
       </p:sp>
       <p:pic>
         <p:nvPicPr>
-          <p:cNvPr id="13" name="Picture 12" descr="olemiss.png"/>
+          <p:cNvPr id="14" name="Picture 13" descr="olemiss.png"/>
           <p:cNvPicPr>
             <a:picLocks noChangeAspect="1"/>
           </p:cNvPicPr>
@@ -23237,7 +23272,7 @@
       </p:pic>
       <p:sp>
         <p:nvSpPr>
-          <p:cNvPr id="14" name="Oval 13"/>
+          <p:cNvPr id="15" name="Oval 14"/>
           <p:cNvSpPr/>
           <p:nvPr/>
         </p:nvSpPr>
@@ -23281,7 +23316,7 @@
       </p:sp>
       <p:pic>
         <p:nvPicPr>
-          <p:cNvPr id="15" name="Picture 14" descr="florida.png"/>
+          <p:cNvPr id="16" name="Picture 15" descr="florida.png"/>
           <p:cNvPicPr>
             <a:picLocks noChangeAspect="1"/>
           </p:cNvPicPr>
@@ -23305,7 +23340,7 @@
       </p:pic>
       <p:sp>
         <p:nvSpPr>
-          <p:cNvPr id="16" name="TextBox 15"/>
+          <p:cNvPr id="17" name="TextBox 16"/>
           <p:cNvSpPr txBox="1"/>
           <p:nvPr/>
         </p:nvSpPr>
@@ -23340,13 +23375,13 @@
       </p:sp>
       <p:sp>
         <p:nvSpPr>
-          <p:cNvPr id="17" name="TextBox 16"/>
-          <p:cNvSpPr txBox="1"/>
-          <p:nvPr/>
-        </p:nvSpPr>
-        <p:spPr>
-          <a:xfrm>
-            <a:off x="6400800" y="2642616"/>
+          <p:cNvPr id="18" name="TextBox 17"/>
+          <p:cNvSpPr txBox="1"/>
+          <p:nvPr/>
+        </p:nvSpPr>
+        <p:spPr>
+          <a:xfrm>
+            <a:off x="6400800" y="2569464"/>
             <a:ext cx="4754880" cy="411480"/>
           </a:xfrm>
           <a:prstGeom prst="rect">
@@ -23375,7 +23410,42 @@
       </p:sp>
       <p:sp>
         <p:nvSpPr>
-          <p:cNvPr id="18" name="Rounded Rectangle 17"/>
+          <p:cNvPr id="19" name="TextBox 18"/>
+          <p:cNvSpPr txBox="1"/>
+          <p:nvPr/>
+        </p:nvSpPr>
+        <p:spPr>
+          <a:xfrm>
+            <a:off x="4206240" y="2944368"/>
+            <a:ext cx="6949440" cy="228600"/>
+          </a:xfrm>
+          <a:prstGeom prst="rect">
+            <a:avLst/>
+          </a:prstGeom>
+          <a:noFill/>
+        </p:spPr>
+        <p:txBody>
+          <a:bodyPr wrap="square" lIns="0" rIns="0" tIns="0" bIns="0">
+            <a:spAutoFit/>
+          </a:bodyPr>
+          <a:lstStyle/>
+          <a:p>
+            <a:pPr algn="r"/>
+            <a:r>
+              <a:rPr sz="950" b="0" i="0">
+                <a:solidFill>
+                  <a:srgbClr val="CADCFC"/>
+                </a:solidFill>
+                <a:latin typeface="Arial"/>
+              </a:rPr>
+              <a:t>machine Florida –3  ·  market Florida –3  ·  machine agrees</a:t>
+            </a:r>
+          </a:p>
+        </p:txBody>
+      </p:sp>
+      <p:sp>
+        <p:nvSpPr>
+          <p:cNvPr id="20" name="Rounded Rectangle 19"/>
           <p:cNvSpPr/>
           <p:nvPr/>
         </p:nvSpPr>
@@ -23419,7 +23489,7 @@
       </p:sp>
       <p:sp>
         <p:nvSpPr>
-          <p:cNvPr id="19" name="Oval 18"/>
+          <p:cNvPr id="21" name="Oval 20"/>
           <p:cNvSpPr/>
           <p:nvPr/>
         </p:nvSpPr>
@@ -23463,7 +23533,7 @@
       </p:sp>
       <p:pic>
         <p:nvPicPr>
-          <p:cNvPr id="20" name="Picture 19" descr="oklahoma.png"/>
+          <p:cNvPr id="22" name="Picture 21" descr="oklahoma.png"/>
           <p:cNvPicPr>
             <a:picLocks noChangeAspect="1"/>
           </p:cNvPicPr>
@@ -23487,7 +23557,7 @@
       </p:pic>
       <p:sp>
         <p:nvSpPr>
-          <p:cNvPr id="21" name="Oval 20"/>
+          <p:cNvPr id="23" name="Oval 22"/>
           <p:cNvSpPr/>
           <p:nvPr/>
         </p:nvSpPr>
@@ -23531,7 +23601,7 @@
       </p:sp>
       <p:pic>
         <p:nvPicPr>
-          <p:cNvPr id="22" name="Picture 21" descr="georgia.png"/>
+          <p:cNvPr id="24" name="Picture 23" descr="georgia.png"/>
           <p:cNvPicPr>
             <a:picLocks noChangeAspect="1"/>
           </p:cNvPicPr>
@@ -23555,7 +23625,7 @@
       </p:pic>
       <p:sp>
         <p:nvSpPr>
-          <p:cNvPr id="23" name="TextBox 22"/>
+          <p:cNvPr id="25" name="TextBox 24"/>
           <p:cNvSpPr txBox="1"/>
           <p:nvPr/>
         </p:nvSpPr>
@@ -23590,13 +23660,13 @@
       </p:sp>
       <p:sp>
         <p:nvSpPr>
-          <p:cNvPr id="24" name="TextBox 23"/>
-          <p:cNvSpPr txBox="1"/>
-          <p:nvPr/>
-        </p:nvSpPr>
-        <p:spPr>
-          <a:xfrm>
-            <a:off x="6400800" y="3374136"/>
+          <p:cNvPr id="26" name="TextBox 25"/>
+          <p:cNvSpPr txBox="1"/>
+          <p:nvPr/>
+        </p:nvSpPr>
+        <p:spPr>
+          <a:xfrm>
+            <a:off x="6400800" y="3300984"/>
             <a:ext cx="4754880" cy="411480"/>
           </a:xfrm>
           <a:prstGeom prst="rect">
@@ -23625,7 +23695,42 @@
       </p:sp>
       <p:sp>
         <p:nvSpPr>
-          <p:cNvPr id="25" name="Rounded Rectangle 24"/>
+          <p:cNvPr id="27" name="TextBox 26"/>
+          <p:cNvSpPr txBox="1"/>
+          <p:nvPr/>
+        </p:nvSpPr>
+        <p:spPr>
+          <a:xfrm>
+            <a:off x="4206240" y="3675887"/>
+            <a:ext cx="6949440" cy="228600"/>
+          </a:xfrm>
+          <a:prstGeom prst="rect">
+            <a:avLst/>
+          </a:prstGeom>
+          <a:noFill/>
+        </p:spPr>
+        <p:txBody>
+          <a:bodyPr wrap="square" lIns="0" rIns="0" tIns="0" bIns="0">
+            <a:spAutoFit/>
+          </a:bodyPr>
+          <a:lstStyle/>
+          <a:p>
+            <a:pPr algn="r"/>
+            <a:r>
+              <a:rPr sz="950" b="0" i="0">
+                <a:solidFill>
+                  <a:srgbClr val="CADCFC"/>
+                </a:solidFill>
+                <a:latin typeface="Arial"/>
+              </a:rPr>
+              <a:t>machine Georgia –14  ·  market Georgia –14  ·  machine agrees</a:t>
+            </a:r>
+          </a:p>
+        </p:txBody>
+      </p:sp>
+      <p:sp>
+        <p:nvSpPr>
+          <p:cNvPr id="28" name="Rounded Rectangle 27"/>
           <p:cNvSpPr/>
           <p:nvPr/>
         </p:nvSpPr>
@@ -23669,7 +23774,7 @@
       </p:sp>
       <p:sp>
         <p:nvSpPr>
-          <p:cNvPr id="26" name="Oval 25"/>
+          <p:cNvPr id="29" name="Oval 28"/>
           <p:cNvSpPr/>
           <p:nvPr/>
         </p:nvSpPr>
@@ -23713,7 +23818,7 @@
       </p:sp>
       <p:pic>
         <p:nvPicPr>
-          <p:cNvPr id="27" name="Picture 26" descr="oregon.png"/>
+          <p:cNvPr id="30" name="Picture 29" descr="oregon.png"/>
           <p:cNvPicPr>
             <a:picLocks noChangeAspect="1"/>
           </p:cNvPicPr>
@@ -23737,7 +23842,7 @@
       </p:pic>
       <p:sp>
         <p:nvSpPr>
-          <p:cNvPr id="28" name="Oval 27"/>
+          <p:cNvPr id="31" name="Oval 30"/>
           <p:cNvSpPr/>
           <p:nvPr/>
         </p:nvSpPr>
@@ -23781,7 +23886,7 @@
       </p:sp>
       <p:pic>
         <p:nvPicPr>
-          <p:cNvPr id="29" name="Picture 28" descr="usc.png"/>
+          <p:cNvPr id="32" name="Picture 31" descr="usc.png"/>
           <p:cNvPicPr>
             <a:picLocks noChangeAspect="1"/>
           </p:cNvPicPr>
@@ -23805,7 +23910,7 @@
       </p:pic>
       <p:sp>
         <p:nvSpPr>
-          <p:cNvPr id="30" name="TextBox 29"/>
+          <p:cNvPr id="33" name="TextBox 32"/>
           <p:cNvSpPr txBox="1"/>
           <p:nvPr/>
         </p:nvSpPr>
@@ -23840,13 +23945,13 @@
       </p:sp>
       <p:sp>
         <p:nvSpPr>
-          <p:cNvPr id="31" name="TextBox 30"/>
-          <p:cNvSpPr txBox="1"/>
-          <p:nvPr/>
-        </p:nvSpPr>
-        <p:spPr>
-          <a:xfrm>
-            <a:off x="6400800" y="4105655"/>
+          <p:cNvPr id="34" name="TextBox 33"/>
+          <p:cNvSpPr txBox="1"/>
+          <p:nvPr/>
+        </p:nvSpPr>
+        <p:spPr>
+          <a:xfrm>
+            <a:off x="6400800" y="4032503"/>
             <a:ext cx="4754880" cy="411480"/>
           </a:xfrm>
           <a:prstGeom prst="rect">
@@ -23875,7 +23980,42 @@
       </p:sp>
       <p:sp>
         <p:nvSpPr>
-          <p:cNvPr id="32" name="Rounded Rectangle 31"/>
+          <p:cNvPr id="35" name="TextBox 34"/>
+          <p:cNvSpPr txBox="1"/>
+          <p:nvPr/>
+        </p:nvSpPr>
+        <p:spPr>
+          <a:xfrm>
+            <a:off x="4206240" y="4407407"/>
+            <a:ext cx="6949440" cy="228600"/>
+          </a:xfrm>
+          <a:prstGeom prst="rect">
+            <a:avLst/>
+          </a:prstGeom>
+          <a:noFill/>
+        </p:spPr>
+        <p:txBody>
+          <a:bodyPr wrap="square" lIns="0" rIns="0" tIns="0" bIns="0">
+            <a:spAutoFit/>
+          </a:bodyPr>
+          <a:lstStyle/>
+          <a:p>
+            <a:pPr algn="r"/>
+            <a:r>
+              <a:rPr sz="950" b="0" i="0">
+                <a:solidFill>
+                  <a:srgbClr val="CADCFC"/>
+                </a:solidFill>
+                <a:latin typeface="Arial"/>
+              </a:rPr>
+              <a:t>machine Oregon –0.5  ·  market Oregon –3  ·  machine 2.5 higher on USC</a:t>
+            </a:r>
+          </a:p>
+        </p:txBody>
+      </p:sp>
+      <p:sp>
+        <p:nvSpPr>
+          <p:cNvPr id="36" name="Rounded Rectangle 35"/>
           <p:cNvSpPr/>
           <p:nvPr/>
         </p:nvSpPr>
@@ -23919,7 +24059,7 @@
       </p:sp>
       <p:sp>
         <p:nvSpPr>
-          <p:cNvPr id="33" name="Oval 32"/>
+          <p:cNvPr id="37" name="Oval 36"/>
           <p:cNvSpPr/>
           <p:nvPr/>
         </p:nvSpPr>
@@ -23963,7 +24103,7 @@
       </p:sp>
       <p:pic>
         <p:nvPicPr>
-          <p:cNvPr id="34" name="Picture 33" descr="texasam.png"/>
+          <p:cNvPr id="38" name="Picture 37" descr="texasam.png"/>
           <p:cNvPicPr>
             <a:picLocks noChangeAspect="1"/>
           </p:cNvPicPr>
@@ -23987,7 +24127,7 @@
       </p:pic>
       <p:sp>
         <p:nvSpPr>
-          <p:cNvPr id="35" name="Oval 34"/>
+          <p:cNvPr id="39" name="Oval 38"/>
           <p:cNvSpPr/>
           <p:nvPr/>
         </p:nvSpPr>
@@ -24031,7 +24171,7 @@
       </p:sp>
       <p:pic>
         <p:nvPicPr>
-          <p:cNvPr id="36" name="Picture 35" descr="lsu.png"/>
+          <p:cNvPr id="40" name="Picture 39" descr="lsu.png"/>
           <p:cNvPicPr>
             <a:picLocks noChangeAspect="1"/>
           </p:cNvPicPr>
@@ -24055,7 +24195,7 @@
       </p:pic>
       <p:sp>
         <p:nvSpPr>
-          <p:cNvPr id="37" name="TextBox 36"/>
+          <p:cNvPr id="41" name="TextBox 40"/>
           <p:cNvSpPr txBox="1"/>
           <p:nvPr/>
         </p:nvSpPr>
@@ -24090,13 +24230,13 @@
       </p:sp>
       <p:sp>
         <p:nvSpPr>
-          <p:cNvPr id="38" name="TextBox 37"/>
-          <p:cNvSpPr txBox="1"/>
-          <p:nvPr/>
-        </p:nvSpPr>
-        <p:spPr>
-          <a:xfrm>
-            <a:off x="6400800" y="4837175"/>
+          <p:cNvPr id="42" name="TextBox 41"/>
+          <p:cNvSpPr txBox="1"/>
+          <p:nvPr/>
+        </p:nvSpPr>
+        <p:spPr>
+          <a:xfrm>
+            <a:off x="6400800" y="4764023"/>
             <a:ext cx="4754880" cy="411480"/>
           </a:xfrm>
           <a:prstGeom prst="rect">
@@ -24125,7 +24265,42 @@
       </p:sp>
       <p:sp>
         <p:nvSpPr>
-          <p:cNvPr id="39" name="Rounded Rectangle 38"/>
+          <p:cNvPr id="43" name="TextBox 42"/>
+          <p:cNvSpPr txBox="1"/>
+          <p:nvPr/>
+        </p:nvSpPr>
+        <p:spPr>
+          <a:xfrm>
+            <a:off x="4206240" y="5138927"/>
+            <a:ext cx="6949440" cy="228600"/>
+          </a:xfrm>
+          <a:prstGeom prst="rect">
+            <a:avLst/>
+          </a:prstGeom>
+          <a:noFill/>
+        </p:spPr>
+        <p:txBody>
+          <a:bodyPr wrap="square" lIns="0" rIns="0" tIns="0" bIns="0">
+            <a:spAutoFit/>
+          </a:bodyPr>
+          <a:lstStyle/>
+          <a:p>
+            <a:pPr algn="r"/>
+            <a:r>
+              <a:rPr sz="950" b="0" i="0">
+                <a:solidFill>
+                  <a:srgbClr val="CADCFC"/>
+                </a:solidFill>
+                <a:latin typeface="Arial"/>
+              </a:rPr>
+              <a:t>machine LSU –5.5  ·  market LSU –9.5  ·  machine 4 higher on Texas A&amp;M</a:t>
+            </a:r>
+          </a:p>
+        </p:txBody>
+      </p:sp>
+      <p:sp>
+        <p:nvSpPr>
+          <p:cNvPr id="44" name="Rounded Rectangle 43"/>
           <p:cNvSpPr/>
           <p:nvPr/>
         </p:nvSpPr>
@@ -24169,7 +24344,7 @@
       </p:sp>
       <p:sp>
         <p:nvSpPr>
-          <p:cNvPr id="40" name="TextBox 39"/>
+          <p:cNvPr id="45" name="TextBox 44"/>
           <p:cNvSpPr txBox="1"/>
           <p:nvPr/>
         </p:nvSpPr>
@@ -24204,7 +24379,7 @@
       </p:sp>
       <p:sp>
         <p:nvSpPr>
-          <p:cNvPr id="41" name="TextBox 40"/>
+          <p:cNvPr id="46" name="TextBox 45"/>
           <p:cNvSpPr txBox="1"/>
           <p:nvPr/>
         </p:nvSpPr>
@@ -24239,7 +24414,7 @@
       </p:sp>
       <p:sp>
         <p:nvSpPr>
-          <p:cNvPr id="42" name="TextBox 41"/>
+          <p:cNvPr id="47" name="TextBox 46"/>
           <p:cNvSpPr txBox="1"/>
           <p:nvPr/>
         </p:nvSpPr>
@@ -24274,7 +24449,7 @@
       </p:sp>
       <p:sp>
         <p:nvSpPr>
-          <p:cNvPr id="43" name="TextBox 42"/>
+          <p:cNvPr id="48" name="TextBox 47"/>
           <p:cNvSpPr txBox="1"/>
           <p:nvPr/>
         </p:nvSpPr>
@@ -24309,7 +24484,7 @@
       </p:sp>
       <p:sp>
         <p:nvSpPr>
-          <p:cNvPr id="44" name="TextBox 43"/>
+          <p:cNvPr id="49" name="TextBox 48"/>
           <p:cNvSpPr txBox="1"/>
           <p:nvPr/>
         </p:nvSpPr>
@@ -24337,7 +24512,7 @@
                 </a:solidFill>
                 <a:latin typeface="Arial"/>
               </a:rPr>
-              <a:t>Superdogs: 5 for a cover · 5 + the spread for a win · 1 for a push · research, not picks</a:t>
+              <a:t>Superdogs: 5 for a cover · 5 + the spread for a win · 1 for a push · research, not picks · market = DraftKings, Sep 21</a:t>
             </a:r>
           </a:p>
         </p:txBody>

</xml_diff>

<commit_message>
Game slides carry the market's single number (final at recording); freeze_card.py locks the card at recording and logs line paths internally
Co-Authored-By: Claude Fable 5.1 <noreply@anthropic.com>
</commit_message>
<xml_diff>
--- a/decks/2026_Week4_Episode5.pptx
+++ b/decks/2026_Week4_Episode5.pptx
@@ -11865,7 +11865,7 @@
         <p:spPr>
           <a:xfrm>
             <a:off x="7772400" y="1600200"/>
-            <a:ext cx="3566160" cy="3611880"/>
+            <a:ext cx="3566160" cy="4114800"/>
           </a:xfrm>
           <a:prstGeom prst="roundRect">
             <a:avLst/>
@@ -12048,7 +12048,7 @@
         </p:nvSpPr>
         <p:spPr>
           <a:xfrm>
-            <a:off x="8046720" y="3383280"/>
+            <a:off x="8046720" y="3218688"/>
             <a:ext cx="3017520" cy="365760"/>
           </a:xfrm>
           <a:prstGeom prst="rect">
@@ -12064,6 +12064,76 @@
           <a:p>
             <a:pPr algn="l"/>
             <a:r>
+              <a:rPr sz="1700" b="1" i="0">
+                <a:solidFill>
+                  <a:srgbClr val="FFFFFF"/>
+                </a:solidFill>
+                <a:latin typeface="Arial"/>
+              </a:rPr>
+              <a:t>Georgia –14</a:t>
+            </a:r>
+          </a:p>
+        </p:txBody>
+      </p:sp>
+      <p:sp>
+        <p:nvSpPr>
+          <p:cNvPr id="18" name="TextBox 17"/>
+          <p:cNvSpPr txBox="1"/>
+          <p:nvPr/>
+        </p:nvSpPr>
+        <p:spPr>
+          <a:xfrm>
+            <a:off x="8046720" y="3566160"/>
+            <a:ext cx="3017520" cy="228600"/>
+          </a:xfrm>
+          <a:prstGeom prst="rect">
+            <a:avLst/>
+          </a:prstGeom>
+          <a:noFill/>
+        </p:spPr>
+        <p:txBody>
+          <a:bodyPr wrap="square" lIns="0" rIns="0" tIns="0" bIns="0">
+            <a:spAutoFit/>
+          </a:bodyPr>
+          <a:lstStyle/>
+          <a:p>
+            <a:pPr algn="l"/>
+            <a:r>
+              <a:rPr sz="850" b="0" i="0">
+                <a:solidFill>
+                  <a:srgbClr val="CADCFC"/>
+                </a:solidFill>
+                <a:latin typeface="Arial"/>
+              </a:rPr>
+              <a:t>the market's number</a:t>
+            </a:r>
+          </a:p>
+        </p:txBody>
+      </p:sp>
+      <p:sp>
+        <p:nvSpPr>
+          <p:cNvPr id="19" name="TextBox 18"/>
+          <p:cNvSpPr txBox="1"/>
+          <p:nvPr/>
+        </p:nvSpPr>
+        <p:spPr>
+          <a:xfrm>
+            <a:off x="8046720" y="3886200"/>
+            <a:ext cx="3017520" cy="365760"/>
+          </a:xfrm>
+          <a:prstGeom prst="rect">
+            <a:avLst/>
+          </a:prstGeom>
+          <a:noFill/>
+        </p:spPr>
+        <p:txBody>
+          <a:bodyPr wrap="square" lIns="0" rIns="0" tIns="0" bIns="0">
+            <a:spAutoFit/>
+          </a:bodyPr>
+          <a:lstStyle/>
+          <a:p>
+            <a:pPr algn="l"/>
+            <a:r>
               <a:rPr sz="1300" b="1" i="0">
                 <a:solidFill>
                   <a:srgbClr val="F47321"/>
@@ -12077,13 +12147,13 @@
       </p:sp>
       <p:sp>
         <p:nvSpPr>
-          <p:cNvPr id="18" name="TextBox 17"/>
-          <p:cNvSpPr txBox="1"/>
-          <p:nvPr/>
-        </p:nvSpPr>
-        <p:spPr>
-          <a:xfrm>
-            <a:off x="8046720" y="3767328"/>
+          <p:cNvPr id="20" name="TextBox 19"/>
+          <p:cNvSpPr txBox="1"/>
+          <p:nvPr/>
+        </p:nvSpPr>
+        <p:spPr>
+          <a:xfrm>
+            <a:off x="8046720" y="4270248"/>
             <a:ext cx="3017520" cy="228600"/>
           </a:xfrm>
           <a:prstGeom prst="rect">
@@ -12112,13 +12182,13 @@
       </p:sp>
       <p:sp>
         <p:nvSpPr>
-          <p:cNvPr id="19" name="Rounded Rectangle 18"/>
+          <p:cNvPr id="21" name="Rounded Rectangle 20"/>
           <p:cNvSpPr/>
           <p:nvPr/>
         </p:nvSpPr>
         <p:spPr>
           <a:xfrm>
-            <a:off x="8046720" y="4206240"/>
+            <a:off x="8046720" y="4709160"/>
             <a:ext cx="3017520" cy="365760"/>
           </a:xfrm>
           <a:prstGeom prst="roundRect">
@@ -12156,13 +12226,13 @@
       </p:sp>
       <p:sp>
         <p:nvSpPr>
-          <p:cNvPr id="20" name="Rounded Rectangle 19"/>
+          <p:cNvPr id="22" name="Rounded Rectangle 21"/>
           <p:cNvSpPr/>
           <p:nvPr/>
         </p:nvSpPr>
         <p:spPr>
           <a:xfrm>
-            <a:off x="8046720" y="4206240"/>
+            <a:off x="8046720" y="4709160"/>
             <a:ext cx="2444191" cy="365760"/>
           </a:xfrm>
           <a:prstGeom prst="roundRect">
@@ -12200,13 +12270,13 @@
       </p:sp>
       <p:sp>
         <p:nvSpPr>
-          <p:cNvPr id="21" name="TextBox 20"/>
-          <p:cNvSpPr txBox="1"/>
-          <p:nvPr/>
-        </p:nvSpPr>
-        <p:spPr>
-          <a:xfrm>
-            <a:off x="8119872" y="4288536"/>
+          <p:cNvPr id="23" name="TextBox 22"/>
+          <p:cNvSpPr txBox="1"/>
+          <p:nvPr/>
+        </p:nvSpPr>
+        <p:spPr>
+          <a:xfrm>
+            <a:off x="8119872" y="4791456"/>
             <a:ext cx="2194560" cy="228600"/>
           </a:xfrm>
           <a:prstGeom prst="rect">
@@ -12235,13 +12305,13 @@
       </p:sp>
       <p:sp>
         <p:nvSpPr>
-          <p:cNvPr id="22" name="TextBox 21"/>
-          <p:cNvSpPr txBox="1"/>
-          <p:nvPr/>
-        </p:nvSpPr>
-        <p:spPr>
-          <a:xfrm>
-            <a:off x="8796528" y="4288536"/>
+          <p:cNvPr id="24" name="TextBox 23"/>
+          <p:cNvSpPr txBox="1"/>
+          <p:nvPr/>
+        </p:nvSpPr>
+        <p:spPr>
+          <a:xfrm>
+            <a:off x="8796528" y="4791456"/>
             <a:ext cx="2194560" cy="228600"/>
           </a:xfrm>
           <a:prstGeom prst="rect">
@@ -12270,13 +12340,13 @@
       </p:sp>
       <p:sp>
         <p:nvSpPr>
-          <p:cNvPr id="23" name="TextBox 22"/>
-          <p:cNvSpPr txBox="1"/>
-          <p:nvPr/>
-        </p:nvSpPr>
-        <p:spPr>
-          <a:xfrm>
-            <a:off x="8046720" y="4626864"/>
+          <p:cNvPr id="25" name="TextBox 24"/>
+          <p:cNvSpPr txBox="1"/>
+          <p:nvPr/>
+        </p:nvSpPr>
+        <p:spPr>
+          <a:xfrm>
+            <a:off x="8046720" y="5129784"/>
             <a:ext cx="3017520" cy="228600"/>
           </a:xfrm>
           <a:prstGeom prst="rect">
@@ -13976,7 +14046,7 @@
         <p:spPr>
           <a:xfrm>
             <a:off x="7772400" y="1600200"/>
-            <a:ext cx="3566160" cy="3611880"/>
+            <a:ext cx="3566160" cy="4114800"/>
           </a:xfrm>
           <a:prstGeom prst="roundRect">
             <a:avLst/>
@@ -14159,7 +14229,7 @@
         </p:nvSpPr>
         <p:spPr>
           <a:xfrm>
-            <a:off x="8046720" y="3383280"/>
+            <a:off x="8046720" y="3218688"/>
             <a:ext cx="3017520" cy="365760"/>
           </a:xfrm>
           <a:prstGeom prst="rect">
@@ -14177,6 +14247,76 @@
             <a:r>
               <a:rPr sz="1700" b="1" i="0">
                 <a:solidFill>
+                  <a:srgbClr val="FFFFFF"/>
+                </a:solidFill>
+                <a:latin typeface="Arial"/>
+              </a:rPr>
+              <a:t>Oregon –3</a:t>
+            </a:r>
+          </a:p>
+        </p:txBody>
+      </p:sp>
+      <p:sp>
+        <p:nvSpPr>
+          <p:cNvPr id="18" name="TextBox 17"/>
+          <p:cNvSpPr txBox="1"/>
+          <p:nvPr/>
+        </p:nvSpPr>
+        <p:spPr>
+          <a:xfrm>
+            <a:off x="8046720" y="3566160"/>
+            <a:ext cx="3017520" cy="228600"/>
+          </a:xfrm>
+          <a:prstGeom prst="rect">
+            <a:avLst/>
+          </a:prstGeom>
+          <a:noFill/>
+        </p:spPr>
+        <p:txBody>
+          <a:bodyPr wrap="square" lIns="0" rIns="0" tIns="0" bIns="0">
+            <a:spAutoFit/>
+          </a:bodyPr>
+          <a:lstStyle/>
+          <a:p>
+            <a:pPr algn="l"/>
+            <a:r>
+              <a:rPr sz="850" b="0" i="0">
+                <a:solidFill>
+                  <a:srgbClr val="CADCFC"/>
+                </a:solidFill>
+                <a:latin typeface="Arial"/>
+              </a:rPr>
+              <a:t>the market's number</a:t>
+            </a:r>
+          </a:p>
+        </p:txBody>
+      </p:sp>
+      <p:sp>
+        <p:nvSpPr>
+          <p:cNvPr id="19" name="TextBox 18"/>
+          <p:cNvSpPr txBox="1"/>
+          <p:nvPr/>
+        </p:nvSpPr>
+        <p:spPr>
+          <a:xfrm>
+            <a:off x="8046720" y="3886200"/>
+            <a:ext cx="3017520" cy="365760"/>
+          </a:xfrm>
+          <a:prstGeom prst="rect">
+            <a:avLst/>
+          </a:prstGeom>
+          <a:noFill/>
+        </p:spPr>
+        <p:txBody>
+          <a:bodyPr wrap="square" lIns="0" rIns="0" tIns="0" bIns="0">
+            <a:spAutoFit/>
+          </a:bodyPr>
+          <a:lstStyle/>
+          <a:p>
+            <a:pPr algn="l"/>
+            <a:r>
+              <a:rPr sz="1700" b="1" i="0">
+                <a:solidFill>
                   <a:srgbClr val="F47321"/>
                 </a:solidFill>
                 <a:latin typeface="Arial"/>
@@ -14188,13 +14328,13 @@
       </p:sp>
       <p:sp>
         <p:nvSpPr>
-          <p:cNvPr id="18" name="TextBox 17"/>
-          <p:cNvSpPr txBox="1"/>
-          <p:nvPr/>
-        </p:nvSpPr>
-        <p:spPr>
-          <a:xfrm>
-            <a:off x="8046720" y="3767328"/>
+          <p:cNvPr id="20" name="TextBox 19"/>
+          <p:cNvSpPr txBox="1"/>
+          <p:nvPr/>
+        </p:nvSpPr>
+        <p:spPr>
+          <a:xfrm>
+            <a:off x="8046720" y="4270248"/>
             <a:ext cx="3017520" cy="228600"/>
           </a:xfrm>
           <a:prstGeom prst="rect">
@@ -14223,13 +14363,13 @@
       </p:sp>
       <p:sp>
         <p:nvSpPr>
-          <p:cNvPr id="19" name="Rounded Rectangle 18"/>
+          <p:cNvPr id="21" name="Rounded Rectangle 20"/>
           <p:cNvSpPr/>
           <p:nvPr/>
         </p:nvSpPr>
         <p:spPr>
           <a:xfrm>
-            <a:off x="8046720" y="4206240"/>
+            <a:off x="8046720" y="4709160"/>
             <a:ext cx="3017520" cy="365760"/>
           </a:xfrm>
           <a:prstGeom prst="roundRect">
@@ -14267,13 +14407,13 @@
       </p:sp>
       <p:sp>
         <p:nvSpPr>
-          <p:cNvPr id="20" name="Rounded Rectangle 19"/>
+          <p:cNvPr id="22" name="Rounded Rectangle 21"/>
           <p:cNvSpPr/>
           <p:nvPr/>
         </p:nvSpPr>
         <p:spPr>
           <a:xfrm>
-            <a:off x="8046720" y="4206240"/>
+            <a:off x="8046720" y="4709160"/>
             <a:ext cx="1508760" cy="365760"/>
           </a:xfrm>
           <a:prstGeom prst="roundRect">
@@ -14311,13 +14451,13 @@
       </p:sp>
       <p:sp>
         <p:nvSpPr>
-          <p:cNvPr id="21" name="TextBox 20"/>
-          <p:cNvSpPr txBox="1"/>
-          <p:nvPr/>
-        </p:nvSpPr>
-        <p:spPr>
-          <a:xfrm>
-            <a:off x="8119872" y="4288536"/>
+          <p:cNvPr id="23" name="TextBox 22"/>
+          <p:cNvSpPr txBox="1"/>
+          <p:nvPr/>
+        </p:nvSpPr>
+        <p:spPr>
+          <a:xfrm>
+            <a:off x="8119872" y="4791456"/>
             <a:ext cx="2194560" cy="228600"/>
           </a:xfrm>
           <a:prstGeom prst="rect">
@@ -14346,13 +14486,13 @@
       </p:sp>
       <p:sp>
         <p:nvSpPr>
-          <p:cNvPr id="22" name="TextBox 21"/>
-          <p:cNvSpPr txBox="1"/>
-          <p:nvPr/>
-        </p:nvSpPr>
-        <p:spPr>
-          <a:xfrm>
-            <a:off x="8796528" y="4288536"/>
+          <p:cNvPr id="24" name="TextBox 23"/>
+          <p:cNvSpPr txBox="1"/>
+          <p:nvPr/>
+        </p:nvSpPr>
+        <p:spPr>
+          <a:xfrm>
+            <a:off x="8796528" y="4791456"/>
             <a:ext cx="2194560" cy="228600"/>
           </a:xfrm>
           <a:prstGeom prst="rect">
@@ -14381,13 +14521,13 @@
       </p:sp>
       <p:sp>
         <p:nvSpPr>
-          <p:cNvPr id="23" name="TextBox 22"/>
-          <p:cNvSpPr txBox="1"/>
-          <p:nvPr/>
-        </p:nvSpPr>
-        <p:spPr>
-          <a:xfrm>
-            <a:off x="8046720" y="4626864"/>
+          <p:cNvPr id="25" name="TextBox 24"/>
+          <p:cNvSpPr txBox="1"/>
+          <p:nvPr/>
+        </p:nvSpPr>
+        <p:spPr>
+          <a:xfrm>
+            <a:off x="8046720" y="5129784"/>
             <a:ext cx="3017520" cy="228600"/>
           </a:xfrm>
           <a:prstGeom prst="rect">
@@ -16087,7 +16227,7 @@
         <p:spPr>
           <a:xfrm>
             <a:off x="7772400" y="1600200"/>
-            <a:ext cx="3566160" cy="3611880"/>
+            <a:ext cx="3566160" cy="4114800"/>
           </a:xfrm>
           <a:prstGeom prst="roundRect">
             <a:avLst/>
@@ -16270,7 +16410,7 @@
         </p:nvSpPr>
         <p:spPr>
           <a:xfrm>
-            <a:off x="8046720" y="3383280"/>
+            <a:off x="8046720" y="3218688"/>
             <a:ext cx="3017520" cy="365760"/>
           </a:xfrm>
           <a:prstGeom prst="rect">
@@ -16288,6 +16428,76 @@
             <a:r>
               <a:rPr sz="1700" b="1" i="0">
                 <a:solidFill>
+                  <a:srgbClr val="FFFFFF"/>
+                </a:solidFill>
+                <a:latin typeface="Arial"/>
+              </a:rPr>
+              <a:t>LSU –9.5</a:t>
+            </a:r>
+          </a:p>
+        </p:txBody>
+      </p:sp>
+      <p:sp>
+        <p:nvSpPr>
+          <p:cNvPr id="18" name="TextBox 17"/>
+          <p:cNvSpPr txBox="1"/>
+          <p:nvPr/>
+        </p:nvSpPr>
+        <p:spPr>
+          <a:xfrm>
+            <a:off x="8046720" y="3566160"/>
+            <a:ext cx="3017520" cy="228600"/>
+          </a:xfrm>
+          <a:prstGeom prst="rect">
+            <a:avLst/>
+          </a:prstGeom>
+          <a:noFill/>
+        </p:spPr>
+        <p:txBody>
+          <a:bodyPr wrap="square" lIns="0" rIns="0" tIns="0" bIns="0">
+            <a:spAutoFit/>
+          </a:bodyPr>
+          <a:lstStyle/>
+          <a:p>
+            <a:pPr algn="l"/>
+            <a:r>
+              <a:rPr sz="850" b="0" i="0">
+                <a:solidFill>
+                  <a:srgbClr val="CADCFC"/>
+                </a:solidFill>
+                <a:latin typeface="Arial"/>
+              </a:rPr>
+              <a:t>the market's number</a:t>
+            </a:r>
+          </a:p>
+        </p:txBody>
+      </p:sp>
+      <p:sp>
+        <p:nvSpPr>
+          <p:cNvPr id="19" name="TextBox 18"/>
+          <p:cNvSpPr txBox="1"/>
+          <p:nvPr/>
+        </p:nvSpPr>
+        <p:spPr>
+          <a:xfrm>
+            <a:off x="8046720" y="3886200"/>
+            <a:ext cx="3017520" cy="365760"/>
+          </a:xfrm>
+          <a:prstGeom prst="rect">
+            <a:avLst/>
+          </a:prstGeom>
+          <a:noFill/>
+        </p:spPr>
+        <p:txBody>
+          <a:bodyPr wrap="square" lIns="0" rIns="0" tIns="0" bIns="0">
+            <a:spAutoFit/>
+          </a:bodyPr>
+          <a:lstStyle/>
+          <a:p>
+            <a:pPr algn="l"/>
+            <a:r>
+              <a:rPr sz="1700" b="1" i="0">
+                <a:solidFill>
                   <a:srgbClr val="F47321"/>
                 </a:solidFill>
                 <a:latin typeface="Arial"/>
@@ -16299,13 +16509,13 @@
       </p:sp>
       <p:sp>
         <p:nvSpPr>
-          <p:cNvPr id="18" name="TextBox 17"/>
-          <p:cNvSpPr txBox="1"/>
-          <p:nvPr/>
-        </p:nvSpPr>
-        <p:spPr>
-          <a:xfrm>
-            <a:off x="8046720" y="3767328"/>
+          <p:cNvPr id="20" name="TextBox 19"/>
+          <p:cNvSpPr txBox="1"/>
+          <p:nvPr/>
+        </p:nvSpPr>
+        <p:spPr>
+          <a:xfrm>
+            <a:off x="8046720" y="4270248"/>
             <a:ext cx="3017520" cy="228600"/>
           </a:xfrm>
           <a:prstGeom prst="rect">
@@ -16334,13 +16544,13 @@
       </p:sp>
       <p:sp>
         <p:nvSpPr>
-          <p:cNvPr id="19" name="Rounded Rectangle 18"/>
+          <p:cNvPr id="21" name="Rounded Rectangle 20"/>
           <p:cNvSpPr/>
           <p:nvPr/>
         </p:nvSpPr>
         <p:spPr>
           <a:xfrm>
-            <a:off x="8046720" y="4206240"/>
+            <a:off x="8046720" y="4709160"/>
             <a:ext cx="3017520" cy="365760"/>
           </a:xfrm>
           <a:prstGeom prst="roundRect">
@@ -16378,13 +16588,13 @@
       </p:sp>
       <p:sp>
         <p:nvSpPr>
-          <p:cNvPr id="20" name="Rounded Rectangle 19"/>
+          <p:cNvPr id="22" name="Rounded Rectangle 21"/>
           <p:cNvSpPr/>
           <p:nvPr/>
         </p:nvSpPr>
         <p:spPr>
           <a:xfrm>
-            <a:off x="8046720" y="4206240"/>
+            <a:off x="8046720" y="4709160"/>
             <a:ext cx="1931212" cy="365760"/>
           </a:xfrm>
           <a:prstGeom prst="roundRect">
@@ -16422,13 +16632,13 @@
       </p:sp>
       <p:sp>
         <p:nvSpPr>
-          <p:cNvPr id="21" name="TextBox 20"/>
-          <p:cNvSpPr txBox="1"/>
-          <p:nvPr/>
-        </p:nvSpPr>
-        <p:spPr>
-          <a:xfrm>
-            <a:off x="8119872" y="4288536"/>
+          <p:cNvPr id="23" name="TextBox 22"/>
+          <p:cNvSpPr txBox="1"/>
+          <p:nvPr/>
+        </p:nvSpPr>
+        <p:spPr>
+          <a:xfrm>
+            <a:off x="8119872" y="4791456"/>
             <a:ext cx="2194560" cy="228600"/>
           </a:xfrm>
           <a:prstGeom prst="rect">
@@ -16457,13 +16667,13 @@
       </p:sp>
       <p:sp>
         <p:nvSpPr>
-          <p:cNvPr id="22" name="TextBox 21"/>
-          <p:cNvSpPr txBox="1"/>
-          <p:nvPr/>
-        </p:nvSpPr>
-        <p:spPr>
-          <a:xfrm>
-            <a:off x="8796528" y="4288536"/>
+          <p:cNvPr id="24" name="TextBox 23"/>
+          <p:cNvSpPr txBox="1"/>
+          <p:nvPr/>
+        </p:nvSpPr>
+        <p:spPr>
+          <a:xfrm>
+            <a:off x="8796528" y="4791456"/>
             <a:ext cx="2194560" cy="228600"/>
           </a:xfrm>
           <a:prstGeom prst="rect">
@@ -16492,13 +16702,13 @@
       </p:sp>
       <p:sp>
         <p:nvSpPr>
-          <p:cNvPr id="23" name="TextBox 22"/>
-          <p:cNvSpPr txBox="1"/>
-          <p:nvPr/>
-        </p:nvSpPr>
-        <p:spPr>
-          <a:xfrm>
-            <a:off x="8046720" y="4626864"/>
+          <p:cNvPr id="25" name="TextBox 24"/>
+          <p:cNvSpPr txBox="1"/>
+          <p:nvPr/>
+        </p:nvSpPr>
+        <p:spPr>
+          <a:xfrm>
+            <a:off x="8046720" y="5129784"/>
             <a:ext cx="3017520" cy="228600"/>
           </a:xfrm>
           <a:prstGeom prst="rect">
@@ -23153,7 +23363,7 @@
                 </a:solidFill>
                 <a:latin typeface="Arial"/>
               </a:rPr>
-              <a:t>machine Texas –9  ·  market Texas –3.5  ·  machine 5.5 higher on Texas</a:t>
+              <a:t>machine Texas –9  ·  market Texas –4.5  ·  machine 4.5 higher on Texas</a:t>
             </a:r>
           </a:p>
         </p:txBody>
@@ -24477,7 +24687,7 @@
                 </a:solidFill>
                 <a:latin typeface="Arial"/>
               </a:rPr>
-              <a:t>Georgia Southern +17.5 vs #25 Houston</a:t>
+              <a:t>Georgia Southern +18.5 vs #25 Houston</a:t>
             </a:r>
           </a:p>
         </p:txBody>
@@ -30431,7 +30641,7 @@
         <p:spPr>
           <a:xfrm>
             <a:off x="7772400" y="1600200"/>
-            <a:ext cx="3566160" cy="3611880"/>
+            <a:ext cx="3566160" cy="4114800"/>
           </a:xfrm>
           <a:prstGeom prst="roundRect">
             <a:avLst/>
@@ -30614,7 +30824,7 @@
         </p:nvSpPr>
         <p:spPr>
           <a:xfrm>
-            <a:off x="8046720" y="3383280"/>
+            <a:off x="8046720" y="3218688"/>
             <a:ext cx="3017520" cy="365760"/>
           </a:xfrm>
           <a:prstGeom prst="rect">
@@ -30630,6 +30840,76 @@
           <a:p>
             <a:pPr algn="l"/>
             <a:r>
+              <a:rPr sz="1700" b="1" i="0">
+                <a:solidFill>
+                  <a:srgbClr val="FFFFFF"/>
+                </a:solidFill>
+                <a:latin typeface="Arial"/>
+              </a:rPr>
+              <a:t>Texas –4.5</a:t>
+            </a:r>
+          </a:p>
+        </p:txBody>
+      </p:sp>
+      <p:sp>
+        <p:nvSpPr>
+          <p:cNvPr id="18" name="TextBox 17"/>
+          <p:cNvSpPr txBox="1"/>
+          <p:nvPr/>
+        </p:nvSpPr>
+        <p:spPr>
+          <a:xfrm>
+            <a:off x="8046720" y="3566160"/>
+            <a:ext cx="3017520" cy="228600"/>
+          </a:xfrm>
+          <a:prstGeom prst="rect">
+            <a:avLst/>
+          </a:prstGeom>
+          <a:noFill/>
+        </p:spPr>
+        <p:txBody>
+          <a:bodyPr wrap="square" lIns="0" rIns="0" tIns="0" bIns="0">
+            <a:spAutoFit/>
+          </a:bodyPr>
+          <a:lstStyle/>
+          <a:p>
+            <a:pPr algn="l"/>
+            <a:r>
+              <a:rPr sz="850" b="0" i="0">
+                <a:solidFill>
+                  <a:srgbClr val="CADCFC"/>
+                </a:solidFill>
+                <a:latin typeface="Arial"/>
+              </a:rPr>
+              <a:t>the market's number</a:t>
+            </a:r>
+          </a:p>
+        </p:txBody>
+      </p:sp>
+      <p:sp>
+        <p:nvSpPr>
+          <p:cNvPr id="19" name="TextBox 18"/>
+          <p:cNvSpPr txBox="1"/>
+          <p:nvPr/>
+        </p:nvSpPr>
+        <p:spPr>
+          <a:xfrm>
+            <a:off x="8046720" y="3886200"/>
+            <a:ext cx="3017520" cy="365760"/>
+          </a:xfrm>
+          <a:prstGeom prst="rect">
+            <a:avLst/>
+          </a:prstGeom>
+          <a:noFill/>
+        </p:spPr>
+        <p:txBody>
+          <a:bodyPr wrap="square" lIns="0" rIns="0" tIns="0" bIns="0">
+            <a:spAutoFit/>
+          </a:bodyPr>
+          <a:lstStyle/>
+          <a:p>
+            <a:pPr algn="l"/>
+            <a:r>
               <a:rPr sz="1300" b="1" i="0">
                 <a:solidFill>
                   <a:srgbClr val="F47321"/>
@@ -30643,13 +30923,13 @@
       </p:sp>
       <p:sp>
         <p:nvSpPr>
-          <p:cNvPr id="18" name="TextBox 17"/>
-          <p:cNvSpPr txBox="1"/>
-          <p:nvPr/>
-        </p:nvSpPr>
-        <p:spPr>
-          <a:xfrm>
-            <a:off x="8046720" y="3767328"/>
+          <p:cNvPr id="20" name="TextBox 19"/>
+          <p:cNvSpPr txBox="1"/>
+          <p:nvPr/>
+        </p:nvSpPr>
+        <p:spPr>
+          <a:xfrm>
+            <a:off x="8046720" y="4270248"/>
             <a:ext cx="3017520" cy="228600"/>
           </a:xfrm>
           <a:prstGeom prst="rect">
@@ -30678,13 +30958,13 @@
       </p:sp>
       <p:sp>
         <p:nvSpPr>
-          <p:cNvPr id="19" name="Rounded Rectangle 18"/>
+          <p:cNvPr id="21" name="Rounded Rectangle 20"/>
           <p:cNvSpPr/>
           <p:nvPr/>
         </p:nvSpPr>
         <p:spPr>
           <a:xfrm>
-            <a:off x="8046720" y="4206240"/>
+            <a:off x="8046720" y="4709160"/>
             <a:ext cx="3017520" cy="365760"/>
           </a:xfrm>
           <a:prstGeom prst="roundRect">
@@ -30722,13 +31002,13 @@
       </p:sp>
       <p:sp>
         <p:nvSpPr>
-          <p:cNvPr id="20" name="Rounded Rectangle 19"/>
+          <p:cNvPr id="22" name="Rounded Rectangle 21"/>
           <p:cNvSpPr/>
           <p:nvPr/>
         </p:nvSpPr>
         <p:spPr>
           <a:xfrm>
-            <a:off x="8046720" y="4206240"/>
+            <a:off x="8046720" y="4709160"/>
             <a:ext cx="875080" cy="365760"/>
           </a:xfrm>
           <a:prstGeom prst="roundRect">
@@ -30766,13 +31046,13 @@
       </p:sp>
       <p:sp>
         <p:nvSpPr>
-          <p:cNvPr id="21" name="TextBox 20"/>
-          <p:cNvSpPr txBox="1"/>
-          <p:nvPr/>
-        </p:nvSpPr>
-        <p:spPr>
-          <a:xfrm>
-            <a:off x="8119872" y="4288536"/>
+          <p:cNvPr id="23" name="TextBox 22"/>
+          <p:cNvSpPr txBox="1"/>
+          <p:nvPr/>
+        </p:nvSpPr>
+        <p:spPr>
+          <a:xfrm>
+            <a:off x="8119872" y="4791456"/>
             <a:ext cx="2194560" cy="228600"/>
           </a:xfrm>
           <a:prstGeom prst="rect">
@@ -30801,13 +31081,13 @@
       </p:sp>
       <p:sp>
         <p:nvSpPr>
-          <p:cNvPr id="22" name="TextBox 21"/>
-          <p:cNvSpPr txBox="1"/>
-          <p:nvPr/>
-        </p:nvSpPr>
-        <p:spPr>
-          <a:xfrm>
-            <a:off x="8796528" y="4288536"/>
+          <p:cNvPr id="24" name="TextBox 23"/>
+          <p:cNvSpPr txBox="1"/>
+          <p:nvPr/>
+        </p:nvSpPr>
+        <p:spPr>
+          <a:xfrm>
+            <a:off x="8796528" y="4791456"/>
             <a:ext cx="2194560" cy="228600"/>
           </a:xfrm>
           <a:prstGeom prst="rect">
@@ -30836,13 +31116,13 @@
       </p:sp>
       <p:sp>
         <p:nvSpPr>
-          <p:cNvPr id="23" name="TextBox 22"/>
-          <p:cNvSpPr txBox="1"/>
-          <p:nvPr/>
-        </p:nvSpPr>
-        <p:spPr>
-          <a:xfrm>
-            <a:off x="8046720" y="4626864"/>
+          <p:cNvPr id="25" name="TextBox 24"/>
+          <p:cNvSpPr txBox="1"/>
+          <p:nvPr/>
+        </p:nvSpPr>
+        <p:spPr>
+          <a:xfrm>
+            <a:off x="8046720" y="5129784"/>
             <a:ext cx="3017520" cy="228600"/>
           </a:xfrm>
           <a:prstGeom prst="rect">
@@ -32542,7 +32822,7 @@
         <p:spPr>
           <a:xfrm>
             <a:off x="7772400" y="1600200"/>
-            <a:ext cx="3566160" cy="3611880"/>
+            <a:ext cx="3566160" cy="4114800"/>
           </a:xfrm>
           <a:prstGeom prst="roundRect">
             <a:avLst/>
@@ -32725,7 +33005,7 @@
         </p:nvSpPr>
         <p:spPr>
           <a:xfrm>
-            <a:off x="8046720" y="3383280"/>
+            <a:off x="8046720" y="3218688"/>
             <a:ext cx="3017520" cy="365760"/>
           </a:xfrm>
           <a:prstGeom prst="rect">
@@ -32741,6 +33021,76 @@
           <a:p>
             <a:pPr algn="l"/>
             <a:r>
+              <a:rPr sz="1700" b="1" i="0">
+                <a:solidFill>
+                  <a:srgbClr val="FFFFFF"/>
+                </a:solidFill>
+                <a:latin typeface="Arial"/>
+              </a:rPr>
+              <a:t>Florida –3</a:t>
+            </a:r>
+          </a:p>
+        </p:txBody>
+      </p:sp>
+      <p:sp>
+        <p:nvSpPr>
+          <p:cNvPr id="18" name="TextBox 17"/>
+          <p:cNvSpPr txBox="1"/>
+          <p:nvPr/>
+        </p:nvSpPr>
+        <p:spPr>
+          <a:xfrm>
+            <a:off x="8046720" y="3566160"/>
+            <a:ext cx="3017520" cy="228600"/>
+          </a:xfrm>
+          <a:prstGeom prst="rect">
+            <a:avLst/>
+          </a:prstGeom>
+          <a:noFill/>
+        </p:spPr>
+        <p:txBody>
+          <a:bodyPr wrap="square" lIns="0" rIns="0" tIns="0" bIns="0">
+            <a:spAutoFit/>
+          </a:bodyPr>
+          <a:lstStyle/>
+          <a:p>
+            <a:pPr algn="l"/>
+            <a:r>
+              <a:rPr sz="850" b="0" i="0">
+                <a:solidFill>
+                  <a:srgbClr val="CADCFC"/>
+                </a:solidFill>
+                <a:latin typeface="Arial"/>
+              </a:rPr>
+              <a:t>the market's number</a:t>
+            </a:r>
+          </a:p>
+        </p:txBody>
+      </p:sp>
+      <p:sp>
+        <p:nvSpPr>
+          <p:cNvPr id="19" name="TextBox 18"/>
+          <p:cNvSpPr txBox="1"/>
+          <p:nvPr/>
+        </p:nvSpPr>
+        <p:spPr>
+          <a:xfrm>
+            <a:off x="8046720" y="3886200"/>
+            <a:ext cx="3017520" cy="365760"/>
+          </a:xfrm>
+          <a:prstGeom prst="rect">
+            <a:avLst/>
+          </a:prstGeom>
+          <a:noFill/>
+        </p:spPr>
+        <p:txBody>
+          <a:bodyPr wrap="square" lIns="0" rIns="0" tIns="0" bIns="0">
+            <a:spAutoFit/>
+          </a:bodyPr>
+          <a:lstStyle/>
+          <a:p>
+            <a:pPr algn="l"/>
+            <a:r>
               <a:rPr sz="1300" b="1" i="0">
                 <a:solidFill>
                   <a:srgbClr val="F47321"/>
@@ -32754,13 +33104,13 @@
       </p:sp>
       <p:sp>
         <p:nvSpPr>
-          <p:cNvPr id="18" name="TextBox 17"/>
-          <p:cNvSpPr txBox="1"/>
-          <p:nvPr/>
-        </p:nvSpPr>
-        <p:spPr>
-          <a:xfrm>
-            <a:off x="8046720" y="3767328"/>
+          <p:cNvPr id="20" name="TextBox 19"/>
+          <p:cNvSpPr txBox="1"/>
+          <p:nvPr/>
+        </p:nvSpPr>
+        <p:spPr>
+          <a:xfrm>
+            <a:off x="8046720" y="4270248"/>
             <a:ext cx="3017520" cy="228600"/>
           </a:xfrm>
           <a:prstGeom prst="rect">
@@ -32789,13 +33139,13 @@
       </p:sp>
       <p:sp>
         <p:nvSpPr>
-          <p:cNvPr id="19" name="Rounded Rectangle 18"/>
+          <p:cNvPr id="21" name="Rounded Rectangle 20"/>
           <p:cNvSpPr/>
           <p:nvPr/>
         </p:nvSpPr>
         <p:spPr>
           <a:xfrm>
-            <a:off x="8046720" y="4206240"/>
+            <a:off x="8046720" y="4709160"/>
             <a:ext cx="3017520" cy="365760"/>
           </a:xfrm>
           <a:prstGeom prst="roundRect">
@@ -32833,13 +33183,13 @@
       </p:sp>
       <p:sp>
         <p:nvSpPr>
-          <p:cNvPr id="20" name="Rounded Rectangle 19"/>
+          <p:cNvPr id="22" name="Rounded Rectangle 21"/>
           <p:cNvSpPr/>
           <p:nvPr/>
         </p:nvSpPr>
         <p:spPr>
           <a:xfrm>
-            <a:off x="8046720" y="4206240"/>
+            <a:off x="8046720" y="4709160"/>
             <a:ext cx="1780336" cy="365760"/>
           </a:xfrm>
           <a:prstGeom prst="roundRect">
@@ -32877,13 +33227,13 @@
       </p:sp>
       <p:sp>
         <p:nvSpPr>
-          <p:cNvPr id="21" name="TextBox 20"/>
-          <p:cNvSpPr txBox="1"/>
-          <p:nvPr/>
-        </p:nvSpPr>
-        <p:spPr>
-          <a:xfrm>
-            <a:off x="8119872" y="4288536"/>
+          <p:cNvPr id="23" name="TextBox 22"/>
+          <p:cNvSpPr txBox="1"/>
+          <p:nvPr/>
+        </p:nvSpPr>
+        <p:spPr>
+          <a:xfrm>
+            <a:off x="8119872" y="4791456"/>
             <a:ext cx="2194560" cy="228600"/>
           </a:xfrm>
           <a:prstGeom prst="rect">
@@ -32912,13 +33262,13 @@
       </p:sp>
       <p:sp>
         <p:nvSpPr>
-          <p:cNvPr id="22" name="TextBox 21"/>
-          <p:cNvSpPr txBox="1"/>
-          <p:nvPr/>
-        </p:nvSpPr>
-        <p:spPr>
-          <a:xfrm>
-            <a:off x="8796528" y="4288536"/>
+          <p:cNvPr id="24" name="TextBox 23"/>
+          <p:cNvSpPr txBox="1"/>
+          <p:nvPr/>
+        </p:nvSpPr>
+        <p:spPr>
+          <a:xfrm>
+            <a:off x="8796528" y="4791456"/>
             <a:ext cx="2194560" cy="228600"/>
           </a:xfrm>
           <a:prstGeom prst="rect">
@@ -32947,13 +33297,13 @@
       </p:sp>
       <p:sp>
         <p:nvSpPr>
-          <p:cNvPr id="23" name="TextBox 22"/>
-          <p:cNvSpPr txBox="1"/>
-          <p:nvPr/>
-        </p:nvSpPr>
-        <p:spPr>
-          <a:xfrm>
-            <a:off x="8046720" y="4626864"/>
+          <p:cNvPr id="25" name="TextBox 24"/>
+          <p:cNvSpPr txBox="1"/>
+          <p:nvPr/>
+        </p:nvSpPr>
+        <p:spPr>
+          <a:xfrm>
+            <a:off x="8046720" y="5129784"/>
             <a:ext cx="3017520" cy="228600"/>
           </a:xfrm>
           <a:prstGeom prst="rect">

</xml_diff>

<commit_message>
Card slide: kickoff times instead of the spread (Lucas's Slides edit folded into the generator); ignore live-export copies
Co-Authored-By: Claude Fable 5.1 <noreply@anthropic.com>
</commit_message>
<xml_diff>
--- a/decks/2026_Week4_Episode5.pptx
+++ b/decks/2026_Week4_Episode5.pptx
@@ -27513,7 +27513,7 @@
         </p:nvSpPr>
         <p:spPr>
           <a:xfrm>
-            <a:off x="7680960" y="2286000"/>
+            <a:off x="7680960" y="2377440"/>
             <a:ext cx="3474720" cy="365760"/>
           </a:xfrm>
           <a:prstGeom prst="rect">
@@ -27529,55 +27529,20 @@
           <a:p>
             <a:pPr algn="r"/>
             <a:r>
-              <a:rPr sz="1600" b="1" i="0">
+              <a:rPr sz="1800" b="1" i="0">
                 <a:solidFill>
                   <a:srgbClr val="F47321"/>
                 </a:solidFill>
                 <a:latin typeface="Arial"/>
               </a:rPr>
-              <a:t>Texas –9</a:t>
-            </a:r>
-          </a:p>
-        </p:txBody>
-      </p:sp>
-      <p:sp>
-        <p:nvSpPr>
-          <p:cNvPr id="12" name="TextBox 11"/>
-          <p:cNvSpPr txBox="1"/>
-          <p:nvPr/>
-        </p:nvSpPr>
-        <p:spPr>
-          <a:xfrm>
-            <a:off x="7680960" y="2624328"/>
-            <a:ext cx="3474720" cy="274320"/>
-          </a:xfrm>
-          <a:prstGeom prst="rect">
-            <a:avLst/>
-          </a:prstGeom>
-          <a:noFill/>
-        </p:spPr>
-        <p:txBody>
-          <a:bodyPr wrap="square" lIns="0" rIns="0" tIns="0" bIns="0">
-            <a:spAutoFit/>
-          </a:bodyPr>
-          <a:lstStyle/>
-          <a:p>
-            <a:pPr algn="r"/>
-            <a:r>
-              <a:rPr sz="950" b="0" i="0">
-                <a:solidFill>
-                  <a:srgbClr val="CADCFC"/>
-                </a:solidFill>
-                <a:latin typeface="Arial"/>
-              </a:rPr>
-              <a:t>the machine's line</a:t>
-            </a:r>
-          </a:p>
-        </p:txBody>
-      </p:sp>
-      <p:sp>
-        <p:nvSpPr>
-          <p:cNvPr id="13" name="Rounded Rectangle 12"/>
+              <a:t>12:00 PM ET</a:t>
+            </a:r>
+          </a:p>
+        </p:txBody>
+      </p:sp>
+      <p:sp>
+        <p:nvSpPr>
+          <p:cNvPr id="12" name="Rounded Rectangle 11"/>
           <p:cNvSpPr/>
           <p:nvPr/>
         </p:nvSpPr>
@@ -27621,7 +27586,7 @@
       </p:sp>
       <p:sp>
         <p:nvSpPr>
-          <p:cNvPr id="14" name="Oval 13"/>
+          <p:cNvPr id="13" name="Oval 12"/>
           <p:cNvSpPr/>
           <p:nvPr/>
         </p:nvSpPr>
@@ -27665,7 +27630,7 @@
       </p:sp>
       <p:pic>
         <p:nvPicPr>
-          <p:cNvPr id="15" name="Picture 14" descr="olemiss.png"/>
+          <p:cNvPr id="14" name="Picture 13" descr="olemiss.png"/>
           <p:cNvPicPr>
             <a:picLocks noChangeAspect="1"/>
           </p:cNvPicPr>
@@ -27689,7 +27654,7 @@
       </p:pic>
       <p:sp>
         <p:nvSpPr>
-          <p:cNvPr id="16" name="Oval 15"/>
+          <p:cNvPr id="15" name="Oval 14"/>
           <p:cNvSpPr/>
           <p:nvPr/>
         </p:nvSpPr>
@@ -27733,7 +27698,7 @@
       </p:sp>
       <p:pic>
         <p:nvPicPr>
-          <p:cNvPr id="17" name="Picture 16" descr="florida.png"/>
+          <p:cNvPr id="16" name="Picture 15" descr="florida.png"/>
           <p:cNvPicPr>
             <a:picLocks noChangeAspect="1"/>
           </p:cNvPicPr>
@@ -27757,7 +27722,7 @@
       </p:pic>
       <p:sp>
         <p:nvSpPr>
-          <p:cNvPr id="18" name="TextBox 17"/>
+          <p:cNvPr id="17" name="TextBox 16"/>
           <p:cNvSpPr txBox="1"/>
           <p:nvPr/>
         </p:nvSpPr>
@@ -27792,7 +27757,7 @@
       </p:sp>
       <p:sp>
         <p:nvSpPr>
-          <p:cNvPr id="19" name="TextBox 18"/>
+          <p:cNvPr id="18" name="TextBox 17"/>
           <p:cNvSpPr txBox="1"/>
           <p:nvPr/>
         </p:nvSpPr>
@@ -27827,13 +27792,13 @@
       </p:sp>
       <p:sp>
         <p:nvSpPr>
-          <p:cNvPr id="20" name="TextBox 19"/>
-          <p:cNvSpPr txBox="1"/>
-          <p:nvPr/>
-        </p:nvSpPr>
-        <p:spPr>
-          <a:xfrm>
-            <a:off x="7680960" y="3090672"/>
+          <p:cNvPr id="19" name="TextBox 18"/>
+          <p:cNvSpPr txBox="1"/>
+          <p:nvPr/>
+        </p:nvSpPr>
+        <p:spPr>
+          <a:xfrm>
+            <a:off x="7680960" y="3182112"/>
             <a:ext cx="3474720" cy="365760"/>
           </a:xfrm>
           <a:prstGeom prst="rect">
@@ -27849,55 +27814,20 @@
           <a:p>
             <a:pPr algn="r"/>
             <a:r>
-              <a:rPr sz="1600" b="1" i="0">
+              <a:rPr sz="1800" b="1" i="0">
                 <a:solidFill>
                   <a:srgbClr val="F47321"/>
                 </a:solidFill>
                 <a:latin typeface="Arial"/>
               </a:rPr>
-              <a:t>Florida –3</a:t>
-            </a:r>
-          </a:p>
-        </p:txBody>
-      </p:sp>
-      <p:sp>
-        <p:nvSpPr>
-          <p:cNvPr id="21" name="TextBox 20"/>
-          <p:cNvSpPr txBox="1"/>
-          <p:nvPr/>
-        </p:nvSpPr>
-        <p:spPr>
-          <a:xfrm>
-            <a:off x="7680960" y="3429000"/>
-            <a:ext cx="3474720" cy="274320"/>
-          </a:xfrm>
-          <a:prstGeom prst="rect">
-            <a:avLst/>
-          </a:prstGeom>
-          <a:noFill/>
-        </p:spPr>
-        <p:txBody>
-          <a:bodyPr wrap="square" lIns="0" rIns="0" tIns="0" bIns="0">
-            <a:spAutoFit/>
-          </a:bodyPr>
-          <a:lstStyle/>
-          <a:p>
-            <a:pPr algn="r"/>
-            <a:r>
-              <a:rPr sz="950" b="0" i="0">
-                <a:solidFill>
-                  <a:srgbClr val="CADCFC"/>
-                </a:solidFill>
-                <a:latin typeface="Arial"/>
-              </a:rPr>
-              <a:t>the machine's line</a:t>
-            </a:r>
-          </a:p>
-        </p:txBody>
-      </p:sp>
-      <p:sp>
-        <p:nvSpPr>
-          <p:cNvPr id="22" name="Rounded Rectangle 21"/>
+              <a:t>3:30 PM ET</a:t>
+            </a:r>
+          </a:p>
+        </p:txBody>
+      </p:sp>
+      <p:sp>
+        <p:nvSpPr>
+          <p:cNvPr id="20" name="Rounded Rectangle 19"/>
           <p:cNvSpPr/>
           <p:nvPr/>
         </p:nvSpPr>
@@ -27941,7 +27871,7 @@
       </p:sp>
       <p:sp>
         <p:nvSpPr>
-          <p:cNvPr id="23" name="Oval 22"/>
+          <p:cNvPr id="21" name="Oval 20"/>
           <p:cNvSpPr/>
           <p:nvPr/>
         </p:nvSpPr>
@@ -27985,7 +27915,7 @@
       </p:sp>
       <p:pic>
         <p:nvPicPr>
-          <p:cNvPr id="24" name="Picture 23" descr="oklahoma.png"/>
+          <p:cNvPr id="22" name="Picture 21" descr="oklahoma.png"/>
           <p:cNvPicPr>
             <a:picLocks noChangeAspect="1"/>
           </p:cNvPicPr>
@@ -28009,7 +27939,7 @@
       </p:pic>
       <p:sp>
         <p:nvSpPr>
-          <p:cNvPr id="25" name="Oval 24"/>
+          <p:cNvPr id="23" name="Oval 22"/>
           <p:cNvSpPr/>
           <p:nvPr/>
         </p:nvSpPr>
@@ -28053,7 +27983,7 @@
       </p:sp>
       <p:pic>
         <p:nvPicPr>
-          <p:cNvPr id="26" name="Picture 25" descr="georgia.png"/>
+          <p:cNvPr id="24" name="Picture 23" descr="georgia.png"/>
           <p:cNvPicPr>
             <a:picLocks noChangeAspect="1"/>
           </p:cNvPicPr>
@@ -28077,7 +28007,7 @@
       </p:pic>
       <p:sp>
         <p:nvSpPr>
-          <p:cNvPr id="27" name="TextBox 26"/>
+          <p:cNvPr id="25" name="TextBox 24"/>
           <p:cNvSpPr txBox="1"/>
           <p:nvPr/>
         </p:nvSpPr>
@@ -28112,7 +28042,7 @@
       </p:sp>
       <p:sp>
         <p:nvSpPr>
-          <p:cNvPr id="28" name="TextBox 27"/>
+          <p:cNvPr id="26" name="TextBox 25"/>
           <p:cNvSpPr txBox="1"/>
           <p:nvPr/>
         </p:nvSpPr>
@@ -28147,13 +28077,13 @@
       </p:sp>
       <p:sp>
         <p:nvSpPr>
-          <p:cNvPr id="29" name="TextBox 28"/>
-          <p:cNvSpPr txBox="1"/>
-          <p:nvPr/>
-        </p:nvSpPr>
-        <p:spPr>
-          <a:xfrm>
-            <a:off x="7680960" y="3895344"/>
+          <p:cNvPr id="27" name="TextBox 26"/>
+          <p:cNvSpPr txBox="1"/>
+          <p:nvPr/>
+        </p:nvSpPr>
+        <p:spPr>
+          <a:xfrm>
+            <a:off x="7680960" y="3986784"/>
             <a:ext cx="3474720" cy="365760"/>
           </a:xfrm>
           <a:prstGeom prst="rect">
@@ -28169,55 +28099,20 @@
           <a:p>
             <a:pPr algn="r"/>
             <a:r>
-              <a:rPr sz="1600" b="1" i="0">
+              <a:rPr sz="1800" b="1" i="0">
                 <a:solidFill>
                   <a:srgbClr val="F47321"/>
                 </a:solidFill>
                 <a:latin typeface="Arial"/>
               </a:rPr>
-              <a:t>Georgia –14</a:t>
-            </a:r>
-          </a:p>
-        </p:txBody>
-      </p:sp>
-      <p:sp>
-        <p:nvSpPr>
-          <p:cNvPr id="30" name="TextBox 29"/>
-          <p:cNvSpPr txBox="1"/>
-          <p:nvPr/>
-        </p:nvSpPr>
-        <p:spPr>
-          <a:xfrm>
-            <a:off x="7680960" y="4233672"/>
-            <a:ext cx="3474720" cy="274320"/>
-          </a:xfrm>
-          <a:prstGeom prst="rect">
-            <a:avLst/>
-          </a:prstGeom>
-          <a:noFill/>
-        </p:spPr>
-        <p:txBody>
-          <a:bodyPr wrap="square" lIns="0" rIns="0" tIns="0" bIns="0">
-            <a:spAutoFit/>
-          </a:bodyPr>
-          <a:lstStyle/>
-          <a:p>
-            <a:pPr algn="r"/>
-            <a:r>
-              <a:rPr sz="950" b="0" i="0">
-                <a:solidFill>
-                  <a:srgbClr val="CADCFC"/>
-                </a:solidFill>
-                <a:latin typeface="Arial"/>
-              </a:rPr>
-              <a:t>the machine's line</a:t>
-            </a:r>
-          </a:p>
-        </p:txBody>
-      </p:sp>
-      <p:sp>
-        <p:nvSpPr>
-          <p:cNvPr id="31" name="Rounded Rectangle 30"/>
+              <a:t>3:30 PM ET</a:t>
+            </a:r>
+          </a:p>
+        </p:txBody>
+      </p:sp>
+      <p:sp>
+        <p:nvSpPr>
+          <p:cNvPr id="28" name="Rounded Rectangle 27"/>
           <p:cNvSpPr/>
           <p:nvPr/>
         </p:nvSpPr>
@@ -28261,7 +28156,7 @@
       </p:sp>
       <p:sp>
         <p:nvSpPr>
-          <p:cNvPr id="32" name="Oval 31"/>
+          <p:cNvPr id="29" name="Oval 28"/>
           <p:cNvSpPr/>
           <p:nvPr/>
         </p:nvSpPr>
@@ -28305,7 +28200,7 @@
       </p:sp>
       <p:pic>
         <p:nvPicPr>
-          <p:cNvPr id="33" name="Picture 32" descr="oregon.png"/>
+          <p:cNvPr id="30" name="Picture 29" descr="oregon.png"/>
           <p:cNvPicPr>
             <a:picLocks noChangeAspect="1"/>
           </p:cNvPicPr>
@@ -28329,7 +28224,7 @@
       </p:pic>
       <p:sp>
         <p:nvSpPr>
-          <p:cNvPr id="34" name="Oval 33"/>
+          <p:cNvPr id="31" name="Oval 30"/>
           <p:cNvSpPr/>
           <p:nvPr/>
         </p:nvSpPr>
@@ -28373,7 +28268,7 @@
       </p:sp>
       <p:pic>
         <p:nvPicPr>
-          <p:cNvPr id="35" name="Picture 34" descr="usc.png"/>
+          <p:cNvPr id="32" name="Picture 31" descr="usc.png"/>
           <p:cNvPicPr>
             <a:picLocks noChangeAspect="1"/>
           </p:cNvPicPr>
@@ -28397,7 +28292,7 @@
       </p:pic>
       <p:sp>
         <p:nvSpPr>
-          <p:cNvPr id="36" name="TextBox 35"/>
+          <p:cNvPr id="33" name="TextBox 32"/>
           <p:cNvSpPr txBox="1"/>
           <p:nvPr/>
         </p:nvSpPr>
@@ -28432,7 +28327,7 @@
       </p:sp>
       <p:sp>
         <p:nvSpPr>
-          <p:cNvPr id="37" name="TextBox 36"/>
+          <p:cNvPr id="34" name="TextBox 33"/>
           <p:cNvSpPr txBox="1"/>
           <p:nvPr/>
         </p:nvSpPr>
@@ -28467,13 +28362,13 @@
       </p:sp>
       <p:sp>
         <p:nvSpPr>
-          <p:cNvPr id="38" name="TextBox 37"/>
-          <p:cNvSpPr txBox="1"/>
-          <p:nvPr/>
-        </p:nvSpPr>
-        <p:spPr>
-          <a:xfrm>
-            <a:off x="7680960" y="4700016"/>
+          <p:cNvPr id="35" name="TextBox 34"/>
+          <p:cNvSpPr txBox="1"/>
+          <p:nvPr/>
+        </p:nvSpPr>
+        <p:spPr>
+          <a:xfrm>
+            <a:off x="7680960" y="4791456"/>
             <a:ext cx="3474720" cy="365760"/>
           </a:xfrm>
           <a:prstGeom prst="rect">
@@ -28489,55 +28384,20 @@
           <a:p>
             <a:pPr algn="r"/>
             <a:r>
-              <a:rPr sz="1600" b="1" i="0">
+              <a:rPr sz="1800" b="1" i="0">
                 <a:solidFill>
                   <a:srgbClr val="F47321"/>
                 </a:solidFill>
                 <a:latin typeface="Arial"/>
               </a:rPr>
-              <a:t>Oregon –0.5</a:t>
-            </a:r>
-          </a:p>
-        </p:txBody>
-      </p:sp>
-      <p:sp>
-        <p:nvSpPr>
-          <p:cNvPr id="39" name="TextBox 38"/>
-          <p:cNvSpPr txBox="1"/>
-          <p:nvPr/>
-        </p:nvSpPr>
-        <p:spPr>
-          <a:xfrm>
-            <a:off x="7680960" y="5038344"/>
-            <a:ext cx="3474720" cy="274320"/>
-          </a:xfrm>
-          <a:prstGeom prst="rect">
-            <a:avLst/>
-          </a:prstGeom>
-          <a:noFill/>
-        </p:spPr>
-        <p:txBody>
-          <a:bodyPr wrap="square" lIns="0" rIns="0" tIns="0" bIns="0">
-            <a:spAutoFit/>
-          </a:bodyPr>
-          <a:lstStyle/>
-          <a:p>
-            <a:pPr algn="r"/>
-            <a:r>
-              <a:rPr sz="950" b="0" i="0">
-                <a:solidFill>
-                  <a:srgbClr val="CADCFC"/>
-                </a:solidFill>
-                <a:latin typeface="Arial"/>
-              </a:rPr>
-              <a:t>the machine's line</a:t>
-            </a:r>
-          </a:p>
-        </p:txBody>
-      </p:sp>
-      <p:sp>
-        <p:nvSpPr>
-          <p:cNvPr id="40" name="Rounded Rectangle 39"/>
+              <a:t>7:30 PM ET</a:t>
+            </a:r>
+          </a:p>
+        </p:txBody>
+      </p:sp>
+      <p:sp>
+        <p:nvSpPr>
+          <p:cNvPr id="36" name="Rounded Rectangle 35"/>
           <p:cNvSpPr/>
           <p:nvPr/>
         </p:nvSpPr>
@@ -28581,7 +28441,7 @@
       </p:sp>
       <p:sp>
         <p:nvSpPr>
-          <p:cNvPr id="41" name="Oval 40"/>
+          <p:cNvPr id="37" name="Oval 36"/>
           <p:cNvSpPr/>
           <p:nvPr/>
         </p:nvSpPr>
@@ -28625,7 +28485,7 @@
       </p:sp>
       <p:pic>
         <p:nvPicPr>
-          <p:cNvPr id="42" name="Picture 41" descr="texasam.png"/>
+          <p:cNvPr id="38" name="Picture 37" descr="texasam.png"/>
           <p:cNvPicPr>
             <a:picLocks noChangeAspect="1"/>
           </p:cNvPicPr>
@@ -28649,7 +28509,7 @@
       </p:pic>
       <p:sp>
         <p:nvSpPr>
-          <p:cNvPr id="43" name="Oval 42"/>
+          <p:cNvPr id="39" name="Oval 38"/>
           <p:cNvSpPr/>
           <p:nvPr/>
         </p:nvSpPr>
@@ -28693,7 +28553,7 @@
       </p:sp>
       <p:pic>
         <p:nvPicPr>
-          <p:cNvPr id="44" name="Picture 43" descr="lsu.png"/>
+          <p:cNvPr id="40" name="Picture 39" descr="lsu.png"/>
           <p:cNvPicPr>
             <a:picLocks noChangeAspect="1"/>
           </p:cNvPicPr>
@@ -28717,7 +28577,7 @@
       </p:pic>
       <p:sp>
         <p:nvSpPr>
-          <p:cNvPr id="45" name="TextBox 44"/>
+          <p:cNvPr id="41" name="TextBox 40"/>
           <p:cNvSpPr txBox="1"/>
           <p:nvPr/>
         </p:nvSpPr>
@@ -28752,7 +28612,7 @@
       </p:sp>
       <p:sp>
         <p:nvSpPr>
-          <p:cNvPr id="46" name="TextBox 45"/>
+          <p:cNvPr id="42" name="TextBox 41"/>
           <p:cNvSpPr txBox="1"/>
           <p:nvPr/>
         </p:nvSpPr>
@@ -28787,13 +28647,13 @@
       </p:sp>
       <p:sp>
         <p:nvSpPr>
-          <p:cNvPr id="47" name="TextBox 46"/>
-          <p:cNvSpPr txBox="1"/>
-          <p:nvPr/>
-        </p:nvSpPr>
-        <p:spPr>
-          <a:xfrm>
-            <a:off x="7680960" y="5504688"/>
+          <p:cNvPr id="43" name="TextBox 42"/>
+          <p:cNvSpPr txBox="1"/>
+          <p:nvPr/>
+        </p:nvSpPr>
+        <p:spPr>
+          <a:xfrm>
+            <a:off x="7680960" y="5596128"/>
             <a:ext cx="3474720" cy="365760"/>
           </a:xfrm>
           <a:prstGeom prst="rect">
@@ -28809,55 +28669,20 @@
           <a:p>
             <a:pPr algn="r"/>
             <a:r>
-              <a:rPr sz="1600" b="1" i="0">
+              <a:rPr sz="1800" b="1" i="0">
                 <a:solidFill>
                   <a:srgbClr val="F47321"/>
                 </a:solidFill>
                 <a:latin typeface="Arial"/>
               </a:rPr>
-              <a:t>LSU –5.5</a:t>
-            </a:r>
-          </a:p>
-        </p:txBody>
-      </p:sp>
-      <p:sp>
-        <p:nvSpPr>
-          <p:cNvPr id="48" name="TextBox 47"/>
-          <p:cNvSpPr txBox="1"/>
-          <p:nvPr/>
-        </p:nvSpPr>
-        <p:spPr>
-          <a:xfrm>
-            <a:off x="7680960" y="5843016"/>
-            <a:ext cx="3474720" cy="274320"/>
-          </a:xfrm>
-          <a:prstGeom prst="rect">
-            <a:avLst/>
-          </a:prstGeom>
-          <a:noFill/>
-        </p:spPr>
-        <p:txBody>
-          <a:bodyPr wrap="square" lIns="0" rIns="0" tIns="0" bIns="0">
-            <a:spAutoFit/>
-          </a:bodyPr>
-          <a:lstStyle/>
-          <a:p>
-            <a:pPr algn="r"/>
-            <a:r>
-              <a:rPr sz="950" b="0" i="0">
-                <a:solidFill>
-                  <a:srgbClr val="CADCFC"/>
-                </a:solidFill>
-                <a:latin typeface="Arial"/>
-              </a:rPr>
-              <a:t>the machine's line</a:t>
-            </a:r>
-          </a:p>
-        </p:txBody>
-      </p:sp>
-      <p:sp>
-        <p:nvSpPr>
-          <p:cNvPr id="49" name="TextBox 48"/>
+              <a:t>7:30 PM ET</a:t>
+            </a:r>
+          </a:p>
+        </p:txBody>
+      </p:sp>
+      <p:sp>
+        <p:nvSpPr>
+          <p:cNvPr id="44" name="TextBox 43"/>
           <p:cNvSpPr txBox="1"/>
           <p:nvPr/>
         </p:nvSpPr>
@@ -28885,7 +28710,7 @@
                 </a:solidFill>
                 <a:latin typeface="Arial"/>
               </a:rPr>
-              <a:t>Machine = our in-season rating + 2.5 home field</a:t>
+              <a:t/>
             </a:r>
           </a:p>
         </p:txBody>

</xml_diff>

<commit_message>
Card slide: always show the date under the kickoff time
Co-Authored-By: Claude Fable 5.1 <noreply@anthropic.com>
</commit_message>
<xml_diff>
--- a/decks/2026_Week4_Episode5.pptx
+++ b/decks/2026_Week4_Episode5.pptx
@@ -27513,7 +27513,7 @@
         </p:nvSpPr>
         <p:spPr>
           <a:xfrm>
-            <a:off x="7680960" y="2377440"/>
+            <a:off x="7680960" y="2267712"/>
             <a:ext cx="3474720" cy="365760"/>
           </a:xfrm>
           <a:prstGeom prst="rect">
@@ -27529,7 +27529,7 @@
           <a:p>
             <a:pPr algn="r"/>
             <a:r>
-              <a:rPr sz="1800" b="1" i="0">
+              <a:rPr sz="1700" b="1" i="0">
                 <a:solidFill>
                   <a:srgbClr val="F47321"/>
                 </a:solidFill>
@@ -27542,7 +27542,42 @@
       </p:sp>
       <p:sp>
         <p:nvSpPr>
-          <p:cNvPr id="12" name="Rounded Rectangle 11"/>
+          <p:cNvPr id="12" name="TextBox 11"/>
+          <p:cNvSpPr txBox="1"/>
+          <p:nvPr/>
+        </p:nvSpPr>
+        <p:spPr>
+          <a:xfrm>
+            <a:off x="7680960" y="2615184"/>
+            <a:ext cx="3474720" cy="274320"/>
+          </a:xfrm>
+          <a:prstGeom prst="rect">
+            <a:avLst/>
+          </a:prstGeom>
+          <a:noFill/>
+        </p:spPr>
+        <p:txBody>
+          <a:bodyPr wrap="square" lIns="0" rIns="0" tIns="0" bIns="0">
+            <a:spAutoFit/>
+          </a:bodyPr>
+          <a:lstStyle/>
+          <a:p>
+            <a:pPr algn="r"/>
+            <a:r>
+              <a:rPr sz="1100" b="1" i="0">
+                <a:solidFill>
+                  <a:srgbClr val="CADCFC"/>
+                </a:solidFill>
+                <a:latin typeface="Arial"/>
+              </a:rPr>
+              <a:t>Sat Sep 26</a:t>
+            </a:r>
+          </a:p>
+        </p:txBody>
+      </p:sp>
+      <p:sp>
+        <p:nvSpPr>
+          <p:cNvPr id="13" name="Rounded Rectangle 12"/>
           <p:cNvSpPr/>
           <p:nvPr/>
         </p:nvSpPr>
@@ -27586,7 +27621,7 @@
       </p:sp>
       <p:sp>
         <p:nvSpPr>
-          <p:cNvPr id="13" name="Oval 12"/>
+          <p:cNvPr id="14" name="Oval 13"/>
           <p:cNvSpPr/>
           <p:nvPr/>
         </p:nvSpPr>
@@ -27630,7 +27665,7 @@
       </p:sp>
       <p:pic>
         <p:nvPicPr>
-          <p:cNvPr id="14" name="Picture 13" descr="olemiss.png"/>
+          <p:cNvPr id="15" name="Picture 14" descr="olemiss.png"/>
           <p:cNvPicPr>
             <a:picLocks noChangeAspect="1"/>
           </p:cNvPicPr>
@@ -27654,7 +27689,7 @@
       </p:pic>
       <p:sp>
         <p:nvSpPr>
-          <p:cNvPr id="15" name="Oval 14"/>
+          <p:cNvPr id="16" name="Oval 15"/>
           <p:cNvSpPr/>
           <p:nvPr/>
         </p:nvSpPr>
@@ -27698,7 +27733,7 @@
       </p:sp>
       <p:pic>
         <p:nvPicPr>
-          <p:cNvPr id="16" name="Picture 15" descr="florida.png"/>
+          <p:cNvPr id="17" name="Picture 16" descr="florida.png"/>
           <p:cNvPicPr>
             <a:picLocks noChangeAspect="1"/>
           </p:cNvPicPr>
@@ -27722,7 +27757,7 @@
       </p:pic>
       <p:sp>
         <p:nvSpPr>
-          <p:cNvPr id="17" name="TextBox 16"/>
+          <p:cNvPr id="18" name="TextBox 17"/>
           <p:cNvSpPr txBox="1"/>
           <p:nvPr/>
         </p:nvSpPr>
@@ -27757,7 +27792,7 @@
       </p:sp>
       <p:sp>
         <p:nvSpPr>
-          <p:cNvPr id="18" name="TextBox 17"/>
+          <p:cNvPr id="19" name="TextBox 18"/>
           <p:cNvSpPr txBox="1"/>
           <p:nvPr/>
         </p:nvSpPr>
@@ -27792,13 +27827,13 @@
       </p:sp>
       <p:sp>
         <p:nvSpPr>
-          <p:cNvPr id="19" name="TextBox 18"/>
-          <p:cNvSpPr txBox="1"/>
-          <p:nvPr/>
-        </p:nvSpPr>
-        <p:spPr>
-          <a:xfrm>
-            <a:off x="7680960" y="3182112"/>
+          <p:cNvPr id="20" name="TextBox 19"/>
+          <p:cNvSpPr txBox="1"/>
+          <p:nvPr/>
+        </p:nvSpPr>
+        <p:spPr>
+          <a:xfrm>
+            <a:off x="7680960" y="3072384"/>
             <a:ext cx="3474720" cy="365760"/>
           </a:xfrm>
           <a:prstGeom prst="rect">
@@ -27814,7 +27849,7 @@
           <a:p>
             <a:pPr algn="r"/>
             <a:r>
-              <a:rPr sz="1800" b="1" i="0">
+              <a:rPr sz="1700" b="1" i="0">
                 <a:solidFill>
                   <a:srgbClr val="F47321"/>
                 </a:solidFill>
@@ -27827,7 +27862,42 @@
       </p:sp>
       <p:sp>
         <p:nvSpPr>
-          <p:cNvPr id="20" name="Rounded Rectangle 19"/>
+          <p:cNvPr id="21" name="TextBox 20"/>
+          <p:cNvSpPr txBox="1"/>
+          <p:nvPr/>
+        </p:nvSpPr>
+        <p:spPr>
+          <a:xfrm>
+            <a:off x="7680960" y="3419856"/>
+            <a:ext cx="3474720" cy="274320"/>
+          </a:xfrm>
+          <a:prstGeom prst="rect">
+            <a:avLst/>
+          </a:prstGeom>
+          <a:noFill/>
+        </p:spPr>
+        <p:txBody>
+          <a:bodyPr wrap="square" lIns="0" rIns="0" tIns="0" bIns="0">
+            <a:spAutoFit/>
+          </a:bodyPr>
+          <a:lstStyle/>
+          <a:p>
+            <a:pPr algn="r"/>
+            <a:r>
+              <a:rPr sz="1100" b="1" i="0">
+                <a:solidFill>
+                  <a:srgbClr val="CADCFC"/>
+                </a:solidFill>
+                <a:latin typeface="Arial"/>
+              </a:rPr>
+              <a:t>Sat Sep 26</a:t>
+            </a:r>
+          </a:p>
+        </p:txBody>
+      </p:sp>
+      <p:sp>
+        <p:nvSpPr>
+          <p:cNvPr id="22" name="Rounded Rectangle 21"/>
           <p:cNvSpPr/>
           <p:nvPr/>
         </p:nvSpPr>
@@ -27871,7 +27941,7 @@
       </p:sp>
       <p:sp>
         <p:nvSpPr>
-          <p:cNvPr id="21" name="Oval 20"/>
+          <p:cNvPr id="23" name="Oval 22"/>
           <p:cNvSpPr/>
           <p:nvPr/>
         </p:nvSpPr>
@@ -27915,7 +27985,7 @@
       </p:sp>
       <p:pic>
         <p:nvPicPr>
-          <p:cNvPr id="22" name="Picture 21" descr="oklahoma.png"/>
+          <p:cNvPr id="24" name="Picture 23" descr="oklahoma.png"/>
           <p:cNvPicPr>
             <a:picLocks noChangeAspect="1"/>
           </p:cNvPicPr>
@@ -27939,7 +28009,7 @@
       </p:pic>
       <p:sp>
         <p:nvSpPr>
-          <p:cNvPr id="23" name="Oval 22"/>
+          <p:cNvPr id="25" name="Oval 24"/>
           <p:cNvSpPr/>
           <p:nvPr/>
         </p:nvSpPr>
@@ -27983,7 +28053,7 @@
       </p:sp>
       <p:pic>
         <p:nvPicPr>
-          <p:cNvPr id="24" name="Picture 23" descr="georgia.png"/>
+          <p:cNvPr id="26" name="Picture 25" descr="georgia.png"/>
           <p:cNvPicPr>
             <a:picLocks noChangeAspect="1"/>
           </p:cNvPicPr>
@@ -28007,7 +28077,7 @@
       </p:pic>
       <p:sp>
         <p:nvSpPr>
-          <p:cNvPr id="25" name="TextBox 24"/>
+          <p:cNvPr id="27" name="TextBox 26"/>
           <p:cNvSpPr txBox="1"/>
           <p:nvPr/>
         </p:nvSpPr>
@@ -28042,7 +28112,7 @@
       </p:sp>
       <p:sp>
         <p:nvSpPr>
-          <p:cNvPr id="26" name="TextBox 25"/>
+          <p:cNvPr id="28" name="TextBox 27"/>
           <p:cNvSpPr txBox="1"/>
           <p:nvPr/>
         </p:nvSpPr>
@@ -28077,13 +28147,13 @@
       </p:sp>
       <p:sp>
         <p:nvSpPr>
-          <p:cNvPr id="27" name="TextBox 26"/>
-          <p:cNvSpPr txBox="1"/>
-          <p:nvPr/>
-        </p:nvSpPr>
-        <p:spPr>
-          <a:xfrm>
-            <a:off x="7680960" y="3986784"/>
+          <p:cNvPr id="29" name="TextBox 28"/>
+          <p:cNvSpPr txBox="1"/>
+          <p:nvPr/>
+        </p:nvSpPr>
+        <p:spPr>
+          <a:xfrm>
+            <a:off x="7680960" y="3877056"/>
             <a:ext cx="3474720" cy="365760"/>
           </a:xfrm>
           <a:prstGeom prst="rect">
@@ -28099,7 +28169,7 @@
           <a:p>
             <a:pPr algn="r"/>
             <a:r>
-              <a:rPr sz="1800" b="1" i="0">
+              <a:rPr sz="1700" b="1" i="0">
                 <a:solidFill>
                   <a:srgbClr val="F47321"/>
                 </a:solidFill>
@@ -28112,7 +28182,42 @@
       </p:sp>
       <p:sp>
         <p:nvSpPr>
-          <p:cNvPr id="28" name="Rounded Rectangle 27"/>
+          <p:cNvPr id="30" name="TextBox 29"/>
+          <p:cNvSpPr txBox="1"/>
+          <p:nvPr/>
+        </p:nvSpPr>
+        <p:spPr>
+          <a:xfrm>
+            <a:off x="7680960" y="4224528"/>
+            <a:ext cx="3474720" cy="274320"/>
+          </a:xfrm>
+          <a:prstGeom prst="rect">
+            <a:avLst/>
+          </a:prstGeom>
+          <a:noFill/>
+        </p:spPr>
+        <p:txBody>
+          <a:bodyPr wrap="square" lIns="0" rIns="0" tIns="0" bIns="0">
+            <a:spAutoFit/>
+          </a:bodyPr>
+          <a:lstStyle/>
+          <a:p>
+            <a:pPr algn="r"/>
+            <a:r>
+              <a:rPr sz="1100" b="1" i="0">
+                <a:solidFill>
+                  <a:srgbClr val="CADCFC"/>
+                </a:solidFill>
+                <a:latin typeface="Arial"/>
+              </a:rPr>
+              <a:t>Sat Sep 26</a:t>
+            </a:r>
+          </a:p>
+        </p:txBody>
+      </p:sp>
+      <p:sp>
+        <p:nvSpPr>
+          <p:cNvPr id="31" name="Rounded Rectangle 30"/>
           <p:cNvSpPr/>
           <p:nvPr/>
         </p:nvSpPr>
@@ -28156,7 +28261,7 @@
       </p:sp>
       <p:sp>
         <p:nvSpPr>
-          <p:cNvPr id="29" name="Oval 28"/>
+          <p:cNvPr id="32" name="Oval 31"/>
           <p:cNvSpPr/>
           <p:nvPr/>
         </p:nvSpPr>
@@ -28200,7 +28305,7 @@
       </p:sp>
       <p:pic>
         <p:nvPicPr>
-          <p:cNvPr id="30" name="Picture 29" descr="oregon.png"/>
+          <p:cNvPr id="33" name="Picture 32" descr="oregon.png"/>
           <p:cNvPicPr>
             <a:picLocks noChangeAspect="1"/>
           </p:cNvPicPr>
@@ -28224,7 +28329,7 @@
       </p:pic>
       <p:sp>
         <p:nvSpPr>
-          <p:cNvPr id="31" name="Oval 30"/>
+          <p:cNvPr id="34" name="Oval 33"/>
           <p:cNvSpPr/>
           <p:nvPr/>
         </p:nvSpPr>
@@ -28268,7 +28373,7 @@
       </p:sp>
       <p:pic>
         <p:nvPicPr>
-          <p:cNvPr id="32" name="Picture 31" descr="usc.png"/>
+          <p:cNvPr id="35" name="Picture 34" descr="usc.png"/>
           <p:cNvPicPr>
             <a:picLocks noChangeAspect="1"/>
           </p:cNvPicPr>
@@ -28292,7 +28397,7 @@
       </p:pic>
       <p:sp>
         <p:nvSpPr>
-          <p:cNvPr id="33" name="TextBox 32"/>
+          <p:cNvPr id="36" name="TextBox 35"/>
           <p:cNvSpPr txBox="1"/>
           <p:nvPr/>
         </p:nvSpPr>
@@ -28327,7 +28432,7 @@
       </p:sp>
       <p:sp>
         <p:nvSpPr>
-          <p:cNvPr id="34" name="TextBox 33"/>
+          <p:cNvPr id="37" name="TextBox 36"/>
           <p:cNvSpPr txBox="1"/>
           <p:nvPr/>
         </p:nvSpPr>
@@ -28362,13 +28467,13 @@
       </p:sp>
       <p:sp>
         <p:nvSpPr>
-          <p:cNvPr id="35" name="TextBox 34"/>
-          <p:cNvSpPr txBox="1"/>
-          <p:nvPr/>
-        </p:nvSpPr>
-        <p:spPr>
-          <a:xfrm>
-            <a:off x="7680960" y="4791456"/>
+          <p:cNvPr id="38" name="TextBox 37"/>
+          <p:cNvSpPr txBox="1"/>
+          <p:nvPr/>
+        </p:nvSpPr>
+        <p:spPr>
+          <a:xfrm>
+            <a:off x="7680960" y="4681728"/>
             <a:ext cx="3474720" cy="365760"/>
           </a:xfrm>
           <a:prstGeom prst="rect">
@@ -28384,7 +28489,7 @@
           <a:p>
             <a:pPr algn="r"/>
             <a:r>
-              <a:rPr sz="1800" b="1" i="0">
+              <a:rPr sz="1700" b="1" i="0">
                 <a:solidFill>
                   <a:srgbClr val="F47321"/>
                 </a:solidFill>
@@ -28397,7 +28502,42 @@
       </p:sp>
       <p:sp>
         <p:nvSpPr>
-          <p:cNvPr id="36" name="Rounded Rectangle 35"/>
+          <p:cNvPr id="39" name="TextBox 38"/>
+          <p:cNvSpPr txBox="1"/>
+          <p:nvPr/>
+        </p:nvSpPr>
+        <p:spPr>
+          <a:xfrm>
+            <a:off x="7680960" y="5029200"/>
+            <a:ext cx="3474720" cy="274320"/>
+          </a:xfrm>
+          <a:prstGeom prst="rect">
+            <a:avLst/>
+          </a:prstGeom>
+          <a:noFill/>
+        </p:spPr>
+        <p:txBody>
+          <a:bodyPr wrap="square" lIns="0" rIns="0" tIns="0" bIns="0">
+            <a:spAutoFit/>
+          </a:bodyPr>
+          <a:lstStyle/>
+          <a:p>
+            <a:pPr algn="r"/>
+            <a:r>
+              <a:rPr sz="1100" b="1" i="0">
+                <a:solidFill>
+                  <a:srgbClr val="CADCFC"/>
+                </a:solidFill>
+                <a:latin typeface="Arial"/>
+              </a:rPr>
+              <a:t>Sat Sep 26</a:t>
+            </a:r>
+          </a:p>
+        </p:txBody>
+      </p:sp>
+      <p:sp>
+        <p:nvSpPr>
+          <p:cNvPr id="40" name="Rounded Rectangle 39"/>
           <p:cNvSpPr/>
           <p:nvPr/>
         </p:nvSpPr>
@@ -28441,7 +28581,7 @@
       </p:sp>
       <p:sp>
         <p:nvSpPr>
-          <p:cNvPr id="37" name="Oval 36"/>
+          <p:cNvPr id="41" name="Oval 40"/>
           <p:cNvSpPr/>
           <p:nvPr/>
         </p:nvSpPr>
@@ -28485,7 +28625,7 @@
       </p:sp>
       <p:pic>
         <p:nvPicPr>
-          <p:cNvPr id="38" name="Picture 37" descr="texasam.png"/>
+          <p:cNvPr id="42" name="Picture 41" descr="texasam.png"/>
           <p:cNvPicPr>
             <a:picLocks noChangeAspect="1"/>
           </p:cNvPicPr>
@@ -28509,7 +28649,7 @@
       </p:pic>
       <p:sp>
         <p:nvSpPr>
-          <p:cNvPr id="39" name="Oval 38"/>
+          <p:cNvPr id="43" name="Oval 42"/>
           <p:cNvSpPr/>
           <p:nvPr/>
         </p:nvSpPr>
@@ -28553,7 +28693,7 @@
       </p:sp>
       <p:pic>
         <p:nvPicPr>
-          <p:cNvPr id="40" name="Picture 39" descr="lsu.png"/>
+          <p:cNvPr id="44" name="Picture 43" descr="lsu.png"/>
           <p:cNvPicPr>
             <a:picLocks noChangeAspect="1"/>
           </p:cNvPicPr>
@@ -28577,7 +28717,7 @@
       </p:pic>
       <p:sp>
         <p:nvSpPr>
-          <p:cNvPr id="41" name="TextBox 40"/>
+          <p:cNvPr id="45" name="TextBox 44"/>
           <p:cNvSpPr txBox="1"/>
           <p:nvPr/>
         </p:nvSpPr>
@@ -28612,7 +28752,7 @@
       </p:sp>
       <p:sp>
         <p:nvSpPr>
-          <p:cNvPr id="42" name="TextBox 41"/>
+          <p:cNvPr id="46" name="TextBox 45"/>
           <p:cNvSpPr txBox="1"/>
           <p:nvPr/>
         </p:nvSpPr>
@@ -28647,13 +28787,13 @@
       </p:sp>
       <p:sp>
         <p:nvSpPr>
-          <p:cNvPr id="43" name="TextBox 42"/>
-          <p:cNvSpPr txBox="1"/>
-          <p:nvPr/>
-        </p:nvSpPr>
-        <p:spPr>
-          <a:xfrm>
-            <a:off x="7680960" y="5596128"/>
+          <p:cNvPr id="47" name="TextBox 46"/>
+          <p:cNvSpPr txBox="1"/>
+          <p:nvPr/>
+        </p:nvSpPr>
+        <p:spPr>
+          <a:xfrm>
+            <a:off x="7680960" y="5486400"/>
             <a:ext cx="3474720" cy="365760"/>
           </a:xfrm>
           <a:prstGeom prst="rect">
@@ -28669,7 +28809,7 @@
           <a:p>
             <a:pPr algn="r"/>
             <a:r>
-              <a:rPr sz="1800" b="1" i="0">
+              <a:rPr sz="1700" b="1" i="0">
                 <a:solidFill>
                   <a:srgbClr val="F47321"/>
                 </a:solidFill>
@@ -28682,7 +28822,42 @@
       </p:sp>
       <p:sp>
         <p:nvSpPr>
-          <p:cNvPr id="44" name="TextBox 43"/>
+          <p:cNvPr id="48" name="TextBox 47"/>
+          <p:cNvSpPr txBox="1"/>
+          <p:nvPr/>
+        </p:nvSpPr>
+        <p:spPr>
+          <a:xfrm>
+            <a:off x="7680960" y="5833872"/>
+            <a:ext cx="3474720" cy="274320"/>
+          </a:xfrm>
+          <a:prstGeom prst="rect">
+            <a:avLst/>
+          </a:prstGeom>
+          <a:noFill/>
+        </p:spPr>
+        <p:txBody>
+          <a:bodyPr wrap="square" lIns="0" rIns="0" tIns="0" bIns="0">
+            <a:spAutoFit/>
+          </a:bodyPr>
+          <a:lstStyle/>
+          <a:p>
+            <a:pPr algn="r"/>
+            <a:r>
+              <a:rPr sz="1100" b="1" i="0">
+                <a:solidFill>
+                  <a:srgbClr val="CADCFC"/>
+                </a:solidFill>
+                <a:latin typeface="Arial"/>
+              </a:rPr>
+              <a:t>Sat Sep 26</a:t>
+            </a:r>
+          </a:p>
+        </p:txBody>
+      </p:sp>
+      <p:sp>
+        <p:nvSpPr>
+          <p:cNvPr id="49" name="TextBox 48"/>
           <p:cNvSpPr txBox="1"/>
           <p:nvPr/>
         </p:nvSpPr>

</xml_diff>

<commit_message>
Ep5 deck: pre-mortem line off for today's recording (as practiced); flips to join for Ep6
</commit_message>
<xml_diff>
--- a/decks/2026_Week4_Episode5.pptx
+++ b/decks/2026_Week4_Episode5.pptx
@@ -11829,8 +11829,8 @@
         </p:nvSpPr>
         <p:spPr>
           <a:xfrm>
-            <a:off x="1051560" y="4846320"/>
-            <a:ext cx="6126480" cy="411480"/>
+            <a:off x="1051560" y="4983480"/>
+            <a:ext cx="6126480" cy="502920"/>
           </a:xfrm>
           <a:prstGeom prst="rect">
             <a:avLst/>
@@ -11845,7 +11845,7 @@
           <a:p>
             <a:pPr algn="l"/>
             <a:r>
-              <a:rPr sz="1600" b="1" i="0">
+              <a:rPr sz="2000" b="1" i="0">
                 <a:solidFill>
                   <a:srgbClr val="0A2851"/>
                 </a:solidFill>
@@ -11858,42 +11858,7 @@
       </p:sp>
       <p:sp>
         <p:nvSpPr>
-          <p:cNvPr id="12" name="TextBox 11"/>
-          <p:cNvSpPr txBox="1"/>
-          <p:nvPr/>
-        </p:nvSpPr>
-        <p:spPr>
-          <a:xfrm>
-            <a:off x="1051560" y="5285232"/>
-            <a:ext cx="6126480" cy="365760"/>
-          </a:xfrm>
-          <a:prstGeom prst="rect">
-            <a:avLst/>
-          </a:prstGeom>
-          <a:noFill/>
-        </p:spPr>
-        <p:txBody>
-          <a:bodyPr wrap="square" lIns="0" rIns="0" tIns="0" bIns="0">
-            <a:spAutoFit/>
-          </a:bodyPr>
-          <a:lstStyle/>
-          <a:p>
-            <a:pPr algn="l"/>
-            <a:r>
-              <a:rPr sz="1250" b="1" i="0">
-                <a:solidFill>
-                  <a:srgbClr val="F47321"/>
-                </a:solidFill>
-                <a:latin typeface="Arial"/>
-              </a:rPr>
-              <a:t>Wrong if Georgia averages under 4.5 yards a carry</a:t>
-            </a:r>
-          </a:p>
-        </p:txBody>
-      </p:sp>
-      <p:sp>
-        <p:nvSpPr>
-          <p:cNvPr id="13" name="Rounded Rectangle 12"/>
+          <p:cNvPr id="12" name="Rounded Rectangle 11"/>
           <p:cNvSpPr/>
           <p:nvPr/>
         </p:nvSpPr>
@@ -11937,7 +11902,7 @@
       </p:sp>
       <p:sp>
         <p:nvSpPr>
-          <p:cNvPr id="14" name="TextBox 13"/>
+          <p:cNvPr id="13" name="TextBox 12"/>
           <p:cNvSpPr txBox="1"/>
           <p:nvPr/>
         </p:nvSpPr>
@@ -11972,7 +11937,7 @@
       </p:sp>
       <p:sp>
         <p:nvSpPr>
-          <p:cNvPr id="15" name="TextBox 14"/>
+          <p:cNvPr id="14" name="TextBox 13"/>
           <p:cNvSpPr txBox="1"/>
           <p:nvPr/>
         </p:nvSpPr>
@@ -12007,7 +11972,7 @@
       </p:sp>
       <p:sp>
         <p:nvSpPr>
-          <p:cNvPr id="16" name="TextBox 15"/>
+          <p:cNvPr id="15" name="TextBox 14"/>
           <p:cNvSpPr txBox="1"/>
           <p:nvPr/>
         </p:nvSpPr>
@@ -12042,7 +12007,7 @@
       </p:sp>
       <p:sp>
         <p:nvSpPr>
-          <p:cNvPr id="17" name="TextBox 16"/>
+          <p:cNvPr id="16" name="TextBox 15"/>
           <p:cNvSpPr txBox="1"/>
           <p:nvPr/>
         </p:nvSpPr>
@@ -12077,7 +12042,7 @@
       </p:sp>
       <p:sp>
         <p:nvSpPr>
-          <p:cNvPr id="18" name="TextBox 17"/>
+          <p:cNvPr id="17" name="TextBox 16"/>
           <p:cNvSpPr txBox="1"/>
           <p:nvPr/>
         </p:nvSpPr>
@@ -12112,7 +12077,7 @@
       </p:sp>
       <p:sp>
         <p:nvSpPr>
-          <p:cNvPr id="19" name="TextBox 18"/>
+          <p:cNvPr id="18" name="TextBox 17"/>
           <p:cNvSpPr txBox="1"/>
           <p:nvPr/>
         </p:nvSpPr>
@@ -12147,7 +12112,7 @@
       </p:sp>
       <p:sp>
         <p:nvSpPr>
-          <p:cNvPr id="20" name="TextBox 19"/>
+          <p:cNvPr id="19" name="TextBox 18"/>
           <p:cNvSpPr txBox="1"/>
           <p:nvPr/>
         </p:nvSpPr>
@@ -12182,7 +12147,7 @@
       </p:sp>
       <p:sp>
         <p:nvSpPr>
-          <p:cNvPr id="21" name="TextBox 20"/>
+          <p:cNvPr id="20" name="TextBox 19"/>
           <p:cNvSpPr txBox="1"/>
           <p:nvPr/>
         </p:nvSpPr>
@@ -12217,7 +12182,7 @@
       </p:sp>
       <p:sp>
         <p:nvSpPr>
-          <p:cNvPr id="22" name="Rounded Rectangle 21"/>
+          <p:cNvPr id="21" name="Rounded Rectangle 20"/>
           <p:cNvSpPr/>
           <p:nvPr/>
         </p:nvSpPr>
@@ -12261,7 +12226,7 @@
       </p:sp>
       <p:sp>
         <p:nvSpPr>
-          <p:cNvPr id="23" name="Rounded Rectangle 22"/>
+          <p:cNvPr id="22" name="Rounded Rectangle 21"/>
           <p:cNvSpPr/>
           <p:nvPr/>
         </p:nvSpPr>
@@ -12305,7 +12270,7 @@
       </p:sp>
       <p:sp>
         <p:nvSpPr>
-          <p:cNvPr id="24" name="TextBox 23"/>
+          <p:cNvPr id="23" name="TextBox 22"/>
           <p:cNvSpPr txBox="1"/>
           <p:nvPr/>
         </p:nvSpPr>
@@ -12340,7 +12305,7 @@
       </p:sp>
       <p:sp>
         <p:nvSpPr>
-          <p:cNvPr id="25" name="TextBox 24"/>
+          <p:cNvPr id="24" name="TextBox 23"/>
           <p:cNvSpPr txBox="1"/>
           <p:nvPr/>
         </p:nvSpPr>
@@ -12375,7 +12340,7 @@
       </p:sp>
       <p:sp>
         <p:nvSpPr>
-          <p:cNvPr id="26" name="TextBox 25"/>
+          <p:cNvPr id="25" name="TextBox 24"/>
           <p:cNvSpPr txBox="1"/>
           <p:nvPr/>
         </p:nvSpPr>
@@ -14045,8 +14010,8 @@
         </p:nvSpPr>
         <p:spPr>
           <a:xfrm>
-            <a:off x="1051560" y="4846320"/>
-            <a:ext cx="6126480" cy="411480"/>
+            <a:off x="1051560" y="4983480"/>
+            <a:ext cx="6126480" cy="502920"/>
           </a:xfrm>
           <a:prstGeom prst="rect">
             <a:avLst/>
@@ -14061,7 +14026,7 @@
           <a:p>
             <a:pPr algn="l"/>
             <a:r>
-              <a:rPr sz="1600" b="1" i="0">
+              <a:rPr sz="2000" b="1" i="0">
                 <a:solidFill>
                   <a:srgbClr val="0A2851"/>
                 </a:solidFill>
@@ -14074,42 +14039,7 @@
       </p:sp>
       <p:sp>
         <p:nvSpPr>
-          <p:cNvPr id="12" name="TextBox 11"/>
-          <p:cNvSpPr txBox="1"/>
-          <p:nvPr/>
-        </p:nvSpPr>
-        <p:spPr>
-          <a:xfrm>
-            <a:off x="1051560" y="5285232"/>
-            <a:ext cx="6126480" cy="365760"/>
-          </a:xfrm>
-          <a:prstGeom prst="rect">
-            <a:avLst/>
-          </a:prstGeom>
-          <a:noFill/>
-        </p:spPr>
-        <p:txBody>
-          <a:bodyPr wrap="square" lIns="0" rIns="0" tIns="0" bIns="0">
-            <a:spAutoFit/>
-          </a:bodyPr>
-          <a:lstStyle/>
-          <a:p>
-            <a:pPr algn="l"/>
-            <a:r>
-              <a:rPr sz="1250" b="1" i="0">
-                <a:solidFill>
-                  <a:srgbClr val="F47321"/>
-                </a:solidFill>
-                <a:latin typeface="Arial"/>
-              </a:rPr>
-              <a:t>Wrong if USC converts more than 46% on third down</a:t>
-            </a:r>
-          </a:p>
-        </p:txBody>
-      </p:sp>
-      <p:sp>
-        <p:nvSpPr>
-          <p:cNvPr id="13" name="Rounded Rectangle 12"/>
+          <p:cNvPr id="12" name="Rounded Rectangle 11"/>
           <p:cNvSpPr/>
           <p:nvPr/>
         </p:nvSpPr>
@@ -14153,7 +14083,7 @@
       </p:sp>
       <p:sp>
         <p:nvSpPr>
-          <p:cNvPr id="14" name="TextBox 13"/>
+          <p:cNvPr id="13" name="TextBox 12"/>
           <p:cNvSpPr txBox="1"/>
           <p:nvPr/>
         </p:nvSpPr>
@@ -14188,7 +14118,7 @@
       </p:sp>
       <p:sp>
         <p:nvSpPr>
-          <p:cNvPr id="15" name="TextBox 14"/>
+          <p:cNvPr id="14" name="TextBox 13"/>
           <p:cNvSpPr txBox="1"/>
           <p:nvPr/>
         </p:nvSpPr>
@@ -14223,7 +14153,7 @@
       </p:sp>
       <p:sp>
         <p:nvSpPr>
-          <p:cNvPr id="16" name="TextBox 15"/>
+          <p:cNvPr id="15" name="TextBox 14"/>
           <p:cNvSpPr txBox="1"/>
           <p:nvPr/>
         </p:nvSpPr>
@@ -14258,7 +14188,7 @@
       </p:sp>
       <p:sp>
         <p:nvSpPr>
-          <p:cNvPr id="17" name="TextBox 16"/>
+          <p:cNvPr id="16" name="TextBox 15"/>
           <p:cNvSpPr txBox="1"/>
           <p:nvPr/>
         </p:nvSpPr>
@@ -14293,7 +14223,7 @@
       </p:sp>
       <p:sp>
         <p:nvSpPr>
-          <p:cNvPr id="18" name="TextBox 17"/>
+          <p:cNvPr id="17" name="TextBox 16"/>
           <p:cNvSpPr txBox="1"/>
           <p:nvPr/>
         </p:nvSpPr>
@@ -14328,7 +14258,7 @@
       </p:sp>
       <p:sp>
         <p:nvSpPr>
-          <p:cNvPr id="19" name="TextBox 18"/>
+          <p:cNvPr id="18" name="TextBox 17"/>
           <p:cNvSpPr txBox="1"/>
           <p:nvPr/>
         </p:nvSpPr>
@@ -14363,7 +14293,7 @@
       </p:sp>
       <p:sp>
         <p:nvSpPr>
-          <p:cNvPr id="20" name="TextBox 19"/>
+          <p:cNvPr id="19" name="TextBox 18"/>
           <p:cNvSpPr txBox="1"/>
           <p:nvPr/>
         </p:nvSpPr>
@@ -14398,7 +14328,7 @@
       </p:sp>
       <p:sp>
         <p:nvSpPr>
-          <p:cNvPr id="21" name="TextBox 20"/>
+          <p:cNvPr id="20" name="TextBox 19"/>
           <p:cNvSpPr txBox="1"/>
           <p:nvPr/>
         </p:nvSpPr>
@@ -14433,7 +14363,7 @@
       </p:sp>
       <p:sp>
         <p:nvSpPr>
-          <p:cNvPr id="22" name="Rounded Rectangle 21"/>
+          <p:cNvPr id="21" name="Rounded Rectangle 20"/>
           <p:cNvSpPr/>
           <p:nvPr/>
         </p:nvSpPr>
@@ -14477,7 +14407,7 @@
       </p:sp>
       <p:sp>
         <p:nvSpPr>
-          <p:cNvPr id="23" name="Rounded Rectangle 22"/>
+          <p:cNvPr id="22" name="Rounded Rectangle 21"/>
           <p:cNvSpPr/>
           <p:nvPr/>
         </p:nvSpPr>
@@ -14521,7 +14451,7 @@
       </p:sp>
       <p:sp>
         <p:nvSpPr>
-          <p:cNvPr id="24" name="TextBox 23"/>
+          <p:cNvPr id="23" name="TextBox 22"/>
           <p:cNvSpPr txBox="1"/>
           <p:nvPr/>
         </p:nvSpPr>
@@ -14556,7 +14486,7 @@
       </p:sp>
       <p:sp>
         <p:nvSpPr>
-          <p:cNvPr id="25" name="TextBox 24"/>
+          <p:cNvPr id="24" name="TextBox 23"/>
           <p:cNvSpPr txBox="1"/>
           <p:nvPr/>
         </p:nvSpPr>
@@ -14591,7 +14521,7 @@
       </p:sp>
       <p:sp>
         <p:nvSpPr>
-          <p:cNvPr id="26" name="TextBox 25"/>
+          <p:cNvPr id="25" name="TextBox 24"/>
           <p:cNvSpPr txBox="1"/>
           <p:nvPr/>
         </p:nvSpPr>
@@ -16261,8 +16191,8 @@
         </p:nvSpPr>
         <p:spPr>
           <a:xfrm>
-            <a:off x="1051560" y="4846320"/>
-            <a:ext cx="6126480" cy="411480"/>
+            <a:off x="1051560" y="4983480"/>
+            <a:ext cx="6126480" cy="502920"/>
           </a:xfrm>
           <a:prstGeom prst="rect">
             <a:avLst/>
@@ -16277,7 +16207,7 @@
           <a:p>
             <a:pPr algn="l"/>
             <a:r>
-              <a:rPr sz="1600" b="1" i="0">
+              <a:rPr sz="2000" b="1" i="0">
                 <a:solidFill>
                   <a:srgbClr val="0A2851"/>
                 </a:solidFill>
@@ -16290,42 +16220,7 @@
       </p:sp>
       <p:sp>
         <p:nvSpPr>
-          <p:cNvPr id="12" name="TextBox 11"/>
-          <p:cNvSpPr txBox="1"/>
-          <p:nvPr/>
-        </p:nvSpPr>
-        <p:spPr>
-          <a:xfrm>
-            <a:off x="1051560" y="5285232"/>
-            <a:ext cx="6126480" cy="365760"/>
-          </a:xfrm>
-          <a:prstGeom prst="rect">
-            <a:avLst/>
-          </a:prstGeom>
-          <a:noFill/>
-        </p:spPr>
-        <p:txBody>
-          <a:bodyPr wrap="square" lIns="0" rIns="0" tIns="0" bIns="0">
-            <a:spAutoFit/>
-          </a:bodyPr>
-          <a:lstStyle/>
-          <a:p>
-            <a:pPr algn="l"/>
-            <a:r>
-              <a:rPr sz="1250" b="1" i="0">
-                <a:solidFill>
-                  <a:srgbClr val="F47321"/>
-                </a:solidFill>
-                <a:latin typeface="Arial"/>
-              </a:rPr>
-              <a:t>Wrong if Texas A&amp;M averages more than 2.8 yards a carry</a:t>
-            </a:r>
-          </a:p>
-        </p:txBody>
-      </p:sp>
-      <p:sp>
-        <p:nvSpPr>
-          <p:cNvPr id="13" name="Rounded Rectangle 12"/>
+          <p:cNvPr id="12" name="Rounded Rectangle 11"/>
           <p:cNvSpPr/>
           <p:nvPr/>
         </p:nvSpPr>
@@ -16369,7 +16264,7 @@
       </p:sp>
       <p:sp>
         <p:nvSpPr>
-          <p:cNvPr id="14" name="TextBox 13"/>
+          <p:cNvPr id="13" name="TextBox 12"/>
           <p:cNvSpPr txBox="1"/>
           <p:nvPr/>
         </p:nvSpPr>
@@ -16404,7 +16299,7 @@
       </p:sp>
       <p:sp>
         <p:nvSpPr>
-          <p:cNvPr id="15" name="TextBox 14"/>
+          <p:cNvPr id="14" name="TextBox 13"/>
           <p:cNvSpPr txBox="1"/>
           <p:nvPr/>
         </p:nvSpPr>
@@ -16439,7 +16334,7 @@
       </p:sp>
       <p:sp>
         <p:nvSpPr>
-          <p:cNvPr id="16" name="TextBox 15"/>
+          <p:cNvPr id="15" name="TextBox 14"/>
           <p:cNvSpPr txBox="1"/>
           <p:nvPr/>
         </p:nvSpPr>
@@ -16474,7 +16369,7 @@
       </p:sp>
       <p:sp>
         <p:nvSpPr>
-          <p:cNvPr id="17" name="TextBox 16"/>
+          <p:cNvPr id="16" name="TextBox 15"/>
           <p:cNvSpPr txBox="1"/>
           <p:nvPr/>
         </p:nvSpPr>
@@ -16509,7 +16404,7 @@
       </p:sp>
       <p:sp>
         <p:nvSpPr>
-          <p:cNvPr id="18" name="TextBox 17"/>
+          <p:cNvPr id="17" name="TextBox 16"/>
           <p:cNvSpPr txBox="1"/>
           <p:nvPr/>
         </p:nvSpPr>
@@ -16544,7 +16439,7 @@
       </p:sp>
       <p:sp>
         <p:nvSpPr>
-          <p:cNvPr id="19" name="TextBox 18"/>
+          <p:cNvPr id="18" name="TextBox 17"/>
           <p:cNvSpPr txBox="1"/>
           <p:nvPr/>
         </p:nvSpPr>
@@ -16579,7 +16474,7 @@
       </p:sp>
       <p:sp>
         <p:nvSpPr>
-          <p:cNvPr id="20" name="TextBox 19"/>
+          <p:cNvPr id="19" name="TextBox 18"/>
           <p:cNvSpPr txBox="1"/>
           <p:nvPr/>
         </p:nvSpPr>
@@ -16614,7 +16509,7 @@
       </p:sp>
       <p:sp>
         <p:nvSpPr>
-          <p:cNvPr id="21" name="TextBox 20"/>
+          <p:cNvPr id="20" name="TextBox 19"/>
           <p:cNvSpPr txBox="1"/>
           <p:nvPr/>
         </p:nvSpPr>
@@ -16649,7 +16544,7 @@
       </p:sp>
       <p:sp>
         <p:nvSpPr>
-          <p:cNvPr id="22" name="Rounded Rectangle 21"/>
+          <p:cNvPr id="21" name="Rounded Rectangle 20"/>
           <p:cNvSpPr/>
           <p:nvPr/>
         </p:nvSpPr>
@@ -16693,7 +16588,7 @@
       </p:sp>
       <p:sp>
         <p:nvSpPr>
-          <p:cNvPr id="23" name="Rounded Rectangle 22"/>
+          <p:cNvPr id="22" name="Rounded Rectangle 21"/>
           <p:cNvSpPr/>
           <p:nvPr/>
         </p:nvSpPr>
@@ -16737,7 +16632,7 @@
       </p:sp>
       <p:sp>
         <p:nvSpPr>
-          <p:cNvPr id="24" name="TextBox 23"/>
+          <p:cNvPr id="23" name="TextBox 22"/>
           <p:cNvSpPr txBox="1"/>
           <p:nvPr/>
         </p:nvSpPr>
@@ -16772,7 +16667,7 @@
       </p:sp>
       <p:sp>
         <p:nvSpPr>
-          <p:cNvPr id="25" name="TextBox 24"/>
+          <p:cNvPr id="24" name="TextBox 23"/>
           <p:cNvSpPr txBox="1"/>
           <p:nvPr/>
         </p:nvSpPr>
@@ -16807,7 +16702,7 @@
       </p:sp>
       <p:sp>
         <p:nvSpPr>
-          <p:cNvPr id="26" name="TextBox 25"/>
+          <p:cNvPr id="25" name="TextBox 24"/>
           <p:cNvSpPr txBox="1"/>
           <p:nvPr/>
         </p:nvSpPr>
@@ -30710,8 +30605,8 @@
         </p:nvSpPr>
         <p:spPr>
           <a:xfrm>
-            <a:off x="1051560" y="4846320"/>
-            <a:ext cx="6126480" cy="411480"/>
+            <a:off x="1051560" y="4983480"/>
+            <a:ext cx="6126480" cy="502920"/>
           </a:xfrm>
           <a:prstGeom prst="rect">
             <a:avLst/>
@@ -30726,7 +30621,7 @@
           <a:p>
             <a:pPr algn="l"/>
             <a:r>
-              <a:rPr sz="1600" b="1" i="0">
+              <a:rPr sz="2000" b="1" i="0">
                 <a:solidFill>
                   <a:srgbClr val="0A2851"/>
                 </a:solidFill>
@@ -30739,42 +30634,7 @@
       </p:sp>
       <p:sp>
         <p:nvSpPr>
-          <p:cNvPr id="12" name="TextBox 11"/>
-          <p:cNvSpPr txBox="1"/>
-          <p:nvPr/>
-        </p:nvSpPr>
-        <p:spPr>
-          <a:xfrm>
-            <a:off x="1051560" y="5285232"/>
-            <a:ext cx="6126480" cy="365760"/>
-          </a:xfrm>
-          <a:prstGeom prst="rect">
-            <a:avLst/>
-          </a:prstGeom>
-          <a:noFill/>
-        </p:spPr>
-        <p:txBody>
-          <a:bodyPr wrap="square" lIns="0" rIns="0" tIns="0" bIns="0">
-            <a:spAutoFit/>
-          </a:bodyPr>
-          <a:lstStyle/>
-          <a:p>
-            <a:pPr algn="l"/>
-            <a:r>
-              <a:rPr sz="1250" b="1" i="0">
-                <a:solidFill>
-                  <a:srgbClr val="F47321"/>
-                </a:solidFill>
-                <a:latin typeface="Arial"/>
-              </a:rPr>
-              <a:t>Wrong if Tennessee averages more than 5.0 yards a carry</a:t>
-            </a:r>
-          </a:p>
-        </p:txBody>
-      </p:sp>
-      <p:sp>
-        <p:nvSpPr>
-          <p:cNvPr id="13" name="Rounded Rectangle 12"/>
+          <p:cNvPr id="12" name="Rounded Rectangle 11"/>
           <p:cNvSpPr/>
           <p:nvPr/>
         </p:nvSpPr>
@@ -30818,7 +30678,7 @@
       </p:sp>
       <p:sp>
         <p:nvSpPr>
-          <p:cNvPr id="14" name="TextBox 13"/>
+          <p:cNvPr id="13" name="TextBox 12"/>
           <p:cNvSpPr txBox="1"/>
           <p:nvPr/>
         </p:nvSpPr>
@@ -30853,7 +30713,7 @@
       </p:sp>
       <p:sp>
         <p:nvSpPr>
-          <p:cNvPr id="15" name="TextBox 14"/>
+          <p:cNvPr id="14" name="TextBox 13"/>
           <p:cNvSpPr txBox="1"/>
           <p:nvPr/>
         </p:nvSpPr>
@@ -30888,7 +30748,7 @@
       </p:sp>
       <p:sp>
         <p:nvSpPr>
-          <p:cNvPr id="16" name="TextBox 15"/>
+          <p:cNvPr id="15" name="TextBox 14"/>
           <p:cNvSpPr txBox="1"/>
           <p:nvPr/>
         </p:nvSpPr>
@@ -30923,7 +30783,7 @@
       </p:sp>
       <p:sp>
         <p:nvSpPr>
-          <p:cNvPr id="17" name="TextBox 16"/>
+          <p:cNvPr id="16" name="TextBox 15"/>
           <p:cNvSpPr txBox="1"/>
           <p:nvPr/>
         </p:nvSpPr>
@@ -30958,7 +30818,7 @@
       </p:sp>
       <p:sp>
         <p:nvSpPr>
-          <p:cNvPr id="18" name="TextBox 17"/>
+          <p:cNvPr id="17" name="TextBox 16"/>
           <p:cNvSpPr txBox="1"/>
           <p:nvPr/>
         </p:nvSpPr>
@@ -30993,7 +30853,7 @@
       </p:sp>
       <p:sp>
         <p:nvSpPr>
-          <p:cNvPr id="19" name="TextBox 18"/>
+          <p:cNvPr id="18" name="TextBox 17"/>
           <p:cNvSpPr txBox="1"/>
           <p:nvPr/>
         </p:nvSpPr>
@@ -31028,7 +30888,7 @@
       </p:sp>
       <p:sp>
         <p:nvSpPr>
-          <p:cNvPr id="20" name="TextBox 19"/>
+          <p:cNvPr id="19" name="TextBox 18"/>
           <p:cNvSpPr txBox="1"/>
           <p:nvPr/>
         </p:nvSpPr>
@@ -31063,7 +30923,7 @@
       </p:sp>
       <p:sp>
         <p:nvSpPr>
-          <p:cNvPr id="21" name="TextBox 20"/>
+          <p:cNvPr id="20" name="TextBox 19"/>
           <p:cNvSpPr txBox="1"/>
           <p:nvPr/>
         </p:nvSpPr>
@@ -31098,7 +30958,7 @@
       </p:sp>
       <p:sp>
         <p:nvSpPr>
-          <p:cNvPr id="22" name="Rounded Rectangle 21"/>
+          <p:cNvPr id="21" name="Rounded Rectangle 20"/>
           <p:cNvSpPr/>
           <p:nvPr/>
         </p:nvSpPr>
@@ -31142,7 +31002,7 @@
       </p:sp>
       <p:sp>
         <p:nvSpPr>
-          <p:cNvPr id="23" name="Rounded Rectangle 22"/>
+          <p:cNvPr id="22" name="Rounded Rectangle 21"/>
           <p:cNvSpPr/>
           <p:nvPr/>
         </p:nvSpPr>
@@ -31186,7 +31046,7 @@
       </p:sp>
       <p:sp>
         <p:nvSpPr>
-          <p:cNvPr id="24" name="TextBox 23"/>
+          <p:cNvPr id="23" name="TextBox 22"/>
           <p:cNvSpPr txBox="1"/>
           <p:nvPr/>
         </p:nvSpPr>
@@ -31221,7 +31081,7 @@
       </p:sp>
       <p:sp>
         <p:nvSpPr>
-          <p:cNvPr id="25" name="TextBox 24"/>
+          <p:cNvPr id="24" name="TextBox 23"/>
           <p:cNvSpPr txBox="1"/>
           <p:nvPr/>
         </p:nvSpPr>
@@ -31256,7 +31116,7 @@
       </p:sp>
       <p:sp>
         <p:nvSpPr>
-          <p:cNvPr id="26" name="TextBox 25"/>
+          <p:cNvPr id="25" name="TextBox 24"/>
           <p:cNvSpPr txBox="1"/>
           <p:nvPr/>
         </p:nvSpPr>
@@ -32926,8 +32786,8 @@
         </p:nvSpPr>
         <p:spPr>
           <a:xfrm>
-            <a:off x="1051560" y="4846320"/>
-            <a:ext cx="6126480" cy="411480"/>
+            <a:off x="1051560" y="4983480"/>
+            <a:ext cx="6126480" cy="502920"/>
           </a:xfrm>
           <a:prstGeom prst="rect">
             <a:avLst/>
@@ -32942,7 +32802,7 @@
           <a:p>
             <a:pPr algn="l"/>
             <a:r>
-              <a:rPr sz="1600" b="1" i="0">
+              <a:rPr sz="2000" b="1" i="0">
                 <a:solidFill>
                   <a:srgbClr val="0A2851"/>
                 </a:solidFill>
@@ -32955,42 +32815,7 @@
       </p:sp>
       <p:sp>
         <p:nvSpPr>
-          <p:cNvPr id="12" name="TextBox 11"/>
-          <p:cNvSpPr txBox="1"/>
-          <p:nvPr/>
-        </p:nvSpPr>
-        <p:spPr>
-          <a:xfrm>
-            <a:off x="1051560" y="5285232"/>
-            <a:ext cx="6126480" cy="365760"/>
-          </a:xfrm>
-          <a:prstGeom prst="rect">
-            <a:avLst/>
-          </a:prstGeom>
-          <a:noFill/>
-        </p:spPr>
-        <p:txBody>
-          <a:bodyPr wrap="square" lIns="0" rIns="0" tIns="0" bIns="0">
-            <a:spAutoFit/>
-          </a:bodyPr>
-          <a:lstStyle/>
-          <a:p>
-            <a:pPr algn="l"/>
-            <a:r>
-              <a:rPr sz="1250" b="1" i="0">
-                <a:solidFill>
-                  <a:srgbClr val="F47321"/>
-                </a:solidFill>
-                <a:latin typeface="Arial"/>
-              </a:rPr>
-              <a:t>Wrong if Florida averages under 9.9 yards an attempt</a:t>
-            </a:r>
-          </a:p>
-        </p:txBody>
-      </p:sp>
-      <p:sp>
-        <p:nvSpPr>
-          <p:cNvPr id="13" name="Rounded Rectangle 12"/>
+          <p:cNvPr id="12" name="Rounded Rectangle 11"/>
           <p:cNvSpPr/>
           <p:nvPr/>
         </p:nvSpPr>
@@ -33034,7 +32859,7 @@
       </p:sp>
       <p:sp>
         <p:nvSpPr>
-          <p:cNvPr id="14" name="TextBox 13"/>
+          <p:cNvPr id="13" name="TextBox 12"/>
           <p:cNvSpPr txBox="1"/>
           <p:nvPr/>
         </p:nvSpPr>
@@ -33069,7 +32894,7 @@
       </p:sp>
       <p:sp>
         <p:nvSpPr>
-          <p:cNvPr id="15" name="TextBox 14"/>
+          <p:cNvPr id="14" name="TextBox 13"/>
           <p:cNvSpPr txBox="1"/>
           <p:nvPr/>
         </p:nvSpPr>
@@ -33104,7 +32929,7 @@
       </p:sp>
       <p:sp>
         <p:nvSpPr>
-          <p:cNvPr id="16" name="TextBox 15"/>
+          <p:cNvPr id="15" name="TextBox 14"/>
           <p:cNvSpPr txBox="1"/>
           <p:nvPr/>
         </p:nvSpPr>
@@ -33139,7 +32964,7 @@
       </p:sp>
       <p:sp>
         <p:nvSpPr>
-          <p:cNvPr id="17" name="TextBox 16"/>
+          <p:cNvPr id="16" name="TextBox 15"/>
           <p:cNvSpPr txBox="1"/>
           <p:nvPr/>
         </p:nvSpPr>
@@ -33174,7 +32999,7 @@
       </p:sp>
       <p:sp>
         <p:nvSpPr>
-          <p:cNvPr id="18" name="TextBox 17"/>
+          <p:cNvPr id="17" name="TextBox 16"/>
           <p:cNvSpPr txBox="1"/>
           <p:nvPr/>
         </p:nvSpPr>
@@ -33209,7 +33034,7 @@
       </p:sp>
       <p:sp>
         <p:nvSpPr>
-          <p:cNvPr id="19" name="TextBox 18"/>
+          <p:cNvPr id="18" name="TextBox 17"/>
           <p:cNvSpPr txBox="1"/>
           <p:nvPr/>
         </p:nvSpPr>
@@ -33244,7 +33069,7 @@
       </p:sp>
       <p:sp>
         <p:nvSpPr>
-          <p:cNvPr id="20" name="TextBox 19"/>
+          <p:cNvPr id="19" name="TextBox 18"/>
           <p:cNvSpPr txBox="1"/>
           <p:nvPr/>
         </p:nvSpPr>
@@ -33279,7 +33104,7 @@
       </p:sp>
       <p:sp>
         <p:nvSpPr>
-          <p:cNvPr id="21" name="TextBox 20"/>
+          <p:cNvPr id="20" name="TextBox 19"/>
           <p:cNvSpPr txBox="1"/>
           <p:nvPr/>
         </p:nvSpPr>
@@ -33314,7 +33139,7 @@
       </p:sp>
       <p:sp>
         <p:nvSpPr>
-          <p:cNvPr id="22" name="Rounded Rectangle 21"/>
+          <p:cNvPr id="21" name="Rounded Rectangle 20"/>
           <p:cNvSpPr/>
           <p:nvPr/>
         </p:nvSpPr>
@@ -33358,7 +33183,7 @@
       </p:sp>
       <p:sp>
         <p:nvSpPr>
-          <p:cNvPr id="23" name="Rounded Rectangle 22"/>
+          <p:cNvPr id="22" name="Rounded Rectangle 21"/>
           <p:cNvSpPr/>
           <p:nvPr/>
         </p:nvSpPr>
@@ -33402,7 +33227,7 @@
       </p:sp>
       <p:sp>
         <p:nvSpPr>
-          <p:cNvPr id="24" name="TextBox 23"/>
+          <p:cNvPr id="23" name="TextBox 22"/>
           <p:cNvSpPr txBox="1"/>
           <p:nvPr/>
         </p:nvSpPr>
@@ -33437,7 +33262,7 @@
       </p:sp>
       <p:sp>
         <p:nvSpPr>
-          <p:cNvPr id="25" name="TextBox 24"/>
+          <p:cNvPr id="24" name="TextBox 23"/>
           <p:cNvSpPr txBox="1"/>
           <p:nvPr/>
         </p:nvSpPr>
@@ -33472,7 +33297,7 @@
       </p:sp>
       <p:sp>
         <p:nvSpPr>
-          <p:cNvPr id="26" name="TextBox 25"/>
+          <p:cNvPr id="25" name="TextBox 24"/>
           <p:cNvSpPr txBox="1"/>
           <p:nvPr/>
         </p:nvSpPr>

</xml_diff>

<commit_message>
Ep5 Top 25 slide: weekly change column and biggest-moves footer (Lucas 9/22); fold his Ole Miss-Florida slide edit into the generator
TOP25_DELTA = "week": the rating column shows each team's move this week from
inseason_ratings.weekly_change, with a four-line footer (up / down movers, splits, ours vs
theirs). SHORT gains extra_bullet / rank_rows and a multi-line honesty text so the live
file's hand edit on the Ole Miss at Florida slide survives whole-file pushes.

Co-Authored-By: Claude Fable 5.1 <noreply@anthropic.com>
</commit_message>
<xml_diff>
--- a/decks/2026_Week4_Episode5.pptx
+++ b/decks/2026_Week4_Episode5.pptx
@@ -3216,7 +3216,7 @@
                 </a:solidFill>
                 <a:latin typeface="Arial"/>
               </a:rPr>
-              <a:t>Machine rating · Δ vs preseason · AP week 4 poll</a:t>
+              <a:t>Machine rating · Δ this week · AP week 4 poll</a:t>
             </a:r>
           </a:p>
         </p:txBody>
@@ -3229,7 +3229,7 @@
         </p:nvSpPr>
         <p:spPr>
           <a:xfrm>
-            <a:off x="3840480" y="1591056"/>
+            <a:off x="3840480" y="1609344"/>
             <a:ext cx="685800" cy="201168"/>
           </a:xfrm>
           <a:prstGeom prst="rect">
@@ -3264,7 +3264,7 @@
         </p:nvSpPr>
         <p:spPr>
           <a:xfrm>
-            <a:off x="4526280" y="1591056"/>
+            <a:off x="4526280" y="1609344"/>
             <a:ext cx="685800" cy="201168"/>
           </a:xfrm>
           <a:prstGeom prst="rect">
@@ -3286,7 +3286,7 @@
                 </a:solidFill>
                 <a:latin typeface="Arial"/>
               </a:rPr>
-              <a:t>Δ PRE</a:t>
+              <a:t>Δ WEEK</a:t>
             </a:r>
           </a:p>
         </p:txBody>
@@ -3299,7 +3299,7 @@
         </p:nvSpPr>
         <p:spPr>
           <a:xfrm>
-            <a:off x="5212080" y="1591056"/>
+            <a:off x="5212080" y="1609344"/>
             <a:ext cx="594360" cy="201168"/>
           </a:xfrm>
           <a:prstGeom prst="rect">
@@ -3334,7 +3334,7 @@
         </p:nvSpPr>
         <p:spPr>
           <a:xfrm>
-            <a:off x="9372600" y="1591056"/>
+            <a:off x="9372600" y="1609344"/>
             <a:ext cx="685800" cy="201168"/>
           </a:xfrm>
           <a:prstGeom prst="rect">
@@ -3369,7 +3369,7 @@
         </p:nvSpPr>
         <p:spPr>
           <a:xfrm>
-            <a:off x="10058400" y="1591056"/>
+            <a:off x="10058400" y="1609344"/>
             <a:ext cx="685800" cy="201168"/>
           </a:xfrm>
           <a:prstGeom prst="rect">
@@ -3391,7 +3391,7 @@
                 </a:solidFill>
                 <a:latin typeface="Arial"/>
               </a:rPr>
-              <a:t>Δ PRE</a:t>
+              <a:t>Δ WEEK</a:t>
             </a:r>
           </a:p>
         </p:txBody>
@@ -3404,7 +3404,7 @@
         </p:nvSpPr>
         <p:spPr>
           <a:xfrm>
-            <a:off x="10744200" y="1591056"/>
+            <a:off x="10744200" y="1609344"/>
             <a:ext cx="594360" cy="201168"/>
           </a:xfrm>
           <a:prstGeom prst="rect">
@@ -3439,8 +3439,8 @@
         </p:nvSpPr>
         <p:spPr>
           <a:xfrm>
-            <a:off x="822960" y="1810512"/>
-            <a:ext cx="5029200" cy="329184"/>
+            <a:off x="822960" y="1828800"/>
+            <a:ext cx="5029200" cy="320040"/>
           </a:xfrm>
           <a:prstGeom prst="rect">
             <a:avLst/>
@@ -3483,7 +3483,7 @@
         </p:nvSpPr>
         <p:spPr>
           <a:xfrm>
-            <a:off x="841248" y="1842516"/>
+            <a:off x="841248" y="1860804"/>
             <a:ext cx="411480" cy="274320"/>
           </a:xfrm>
           <a:prstGeom prst="rect">
@@ -3518,7 +3518,7 @@
         </p:nvSpPr>
         <p:spPr>
           <a:xfrm>
-            <a:off x="1371600" y="1847088"/>
+            <a:off x="1371600" y="1865376"/>
             <a:ext cx="256032" cy="256032"/>
           </a:xfrm>
           <a:prstGeom prst="ellipse">
@@ -3570,7 +3570,7 @@
         </p:blipFill>
         <p:spPr>
           <a:xfrm>
-            <a:off x="1399032" y="1874519"/>
+            <a:off x="1399032" y="1892807"/>
             <a:ext cx="201168" cy="201168"/>
           </a:xfrm>
           <a:prstGeom prst="rect">
@@ -3586,7 +3586,7 @@
         </p:nvSpPr>
         <p:spPr>
           <a:xfrm>
-            <a:off x="1737360" y="1842516"/>
+            <a:off x="1737360" y="1860804"/>
             <a:ext cx="2103120" cy="274320"/>
           </a:xfrm>
           <a:prstGeom prst="rect">
@@ -3621,7 +3621,7 @@
         </p:nvSpPr>
         <p:spPr>
           <a:xfrm>
-            <a:off x="3840480" y="1842516"/>
+            <a:off x="3840480" y="1860804"/>
             <a:ext cx="685800" cy="274320"/>
           </a:xfrm>
           <a:prstGeom prst="rect">
@@ -3656,7 +3656,7 @@
         </p:nvSpPr>
         <p:spPr>
           <a:xfrm>
-            <a:off x="4526280" y="1856231"/>
+            <a:off x="4526280" y="1874519"/>
             <a:ext cx="685800" cy="274320"/>
           </a:xfrm>
           <a:prstGeom prst="rect">
@@ -3674,11 +3674,11 @@
             <a:r>
               <a:rPr sz="1100" b="1" i="0">
                 <a:solidFill>
-                  <a:srgbClr val="5CD68A"/>
-                </a:solidFill>
-                <a:latin typeface="Arial"/>
-              </a:rPr>
-              <a:t>+0.4</a:t>
+                  <a:srgbClr val="FF7A7A"/>
+                </a:solidFill>
+                <a:latin typeface="Arial"/>
+              </a:rPr>
+              <a:t>-0.9</a:t>
             </a:r>
           </a:p>
         </p:txBody>
@@ -3691,7 +3691,7 @@
         </p:nvSpPr>
         <p:spPr>
           <a:xfrm>
-            <a:off x="5212080" y="1856231"/>
+            <a:off x="5212080" y="1874519"/>
             <a:ext cx="594360" cy="274320"/>
           </a:xfrm>
           <a:prstGeom prst="rect">
@@ -3726,7 +3726,7 @@
         </p:nvSpPr>
         <p:spPr>
           <a:xfrm>
-            <a:off x="841248" y="2171700"/>
+            <a:off x="841248" y="2180844"/>
             <a:ext cx="411480" cy="274320"/>
           </a:xfrm>
           <a:prstGeom prst="rect">
@@ -3761,7 +3761,7 @@
         </p:nvSpPr>
         <p:spPr>
           <a:xfrm>
-            <a:off x="1371600" y="2176272"/>
+            <a:off x="1371600" y="2185416"/>
             <a:ext cx="256032" cy="256032"/>
           </a:xfrm>
           <a:prstGeom prst="ellipse">
@@ -3813,7 +3813,7 @@
         </p:blipFill>
         <p:spPr>
           <a:xfrm>
-            <a:off x="1399032" y="2203703"/>
+            <a:off x="1399032" y="2212848"/>
             <a:ext cx="201168" cy="201168"/>
           </a:xfrm>
           <a:prstGeom prst="rect">
@@ -3829,7 +3829,7 @@
         </p:nvSpPr>
         <p:spPr>
           <a:xfrm>
-            <a:off x="1737360" y="2171700"/>
+            <a:off x="1737360" y="2180844"/>
             <a:ext cx="2103120" cy="274320"/>
           </a:xfrm>
           <a:prstGeom prst="rect">
@@ -3864,7 +3864,7 @@
         </p:nvSpPr>
         <p:spPr>
           <a:xfrm>
-            <a:off x="3840480" y="2171700"/>
+            <a:off x="3840480" y="2180844"/>
             <a:ext cx="685800" cy="274320"/>
           </a:xfrm>
           <a:prstGeom prst="rect">
@@ -3899,7 +3899,7 @@
         </p:nvSpPr>
         <p:spPr>
           <a:xfrm>
-            <a:off x="4526280" y="2185415"/>
+            <a:off x="4526280" y="2194560"/>
             <a:ext cx="685800" cy="274320"/>
           </a:xfrm>
           <a:prstGeom prst="rect">
@@ -3917,11 +3917,11 @@
             <a:r>
               <a:rPr sz="1100" b="1" i="0">
                 <a:solidFill>
-                  <a:srgbClr val="5CD68A"/>
-                </a:solidFill>
-                <a:latin typeface="Arial"/>
-              </a:rPr>
-              <a:t>+1.7</a:t>
+                  <a:srgbClr val="FF7A7A"/>
+                </a:solidFill>
+                <a:latin typeface="Arial"/>
+              </a:rPr>
+              <a:t>-1.3</a:t>
             </a:r>
           </a:p>
         </p:txBody>
@@ -3934,7 +3934,7 @@
         </p:nvSpPr>
         <p:spPr>
           <a:xfrm>
-            <a:off x="5212080" y="2185415"/>
+            <a:off x="5212080" y="2194560"/>
             <a:ext cx="594360" cy="274320"/>
           </a:xfrm>
           <a:prstGeom prst="rect">
@@ -3970,7 +3970,7 @@
         <p:spPr>
           <a:xfrm>
             <a:off x="822960" y="2468880"/>
-            <a:ext cx="5029200" cy="329184"/>
+            <a:ext cx="5029200" cy="320040"/>
           </a:xfrm>
           <a:prstGeom prst="rect">
             <a:avLst/>
@@ -4208,7 +4208,7 @@
                 </a:solidFill>
                 <a:latin typeface="Arial"/>
               </a:rPr>
-              <a:t>+3.0</a:t>
+              <a:t>+0.5</a:t>
             </a:r>
           </a:p>
         </p:txBody>
@@ -4256,7 +4256,7 @@
         </p:nvSpPr>
         <p:spPr>
           <a:xfrm>
-            <a:off x="841248" y="2830068"/>
+            <a:off x="841248" y="2820924"/>
             <a:ext cx="411480" cy="274320"/>
           </a:xfrm>
           <a:prstGeom prst="rect">
@@ -4291,7 +4291,7 @@
         </p:nvSpPr>
         <p:spPr>
           <a:xfrm>
-            <a:off x="1371600" y="2834640"/>
+            <a:off x="1371600" y="2825496"/>
             <a:ext cx="256032" cy="256032"/>
           </a:xfrm>
           <a:prstGeom prst="ellipse">
@@ -4343,7 +4343,7 @@
         </p:blipFill>
         <p:spPr>
           <a:xfrm>
-            <a:off x="1399032" y="2862072"/>
+            <a:off x="1399032" y="2852927"/>
             <a:ext cx="201168" cy="201168"/>
           </a:xfrm>
           <a:prstGeom prst="rect">
@@ -4359,7 +4359,7 @@
         </p:nvSpPr>
         <p:spPr>
           <a:xfrm>
-            <a:off x="1737360" y="2830068"/>
+            <a:off x="1737360" y="2820924"/>
             <a:ext cx="2103120" cy="274320"/>
           </a:xfrm>
           <a:prstGeom prst="rect">
@@ -4394,7 +4394,7 @@
         </p:nvSpPr>
         <p:spPr>
           <a:xfrm>
-            <a:off x="3840480" y="2830068"/>
+            <a:off x="3840480" y="2820924"/>
             <a:ext cx="685800" cy="274320"/>
           </a:xfrm>
           <a:prstGeom prst="rect">
@@ -4429,7 +4429,7 @@
         </p:nvSpPr>
         <p:spPr>
           <a:xfrm>
-            <a:off x="4526280" y="2843784"/>
+            <a:off x="4526280" y="2834639"/>
             <a:ext cx="685800" cy="274320"/>
           </a:xfrm>
           <a:prstGeom prst="rect">
@@ -4447,11 +4447,11 @@
             <a:r>
               <a:rPr sz="1100" b="1" i="0">
                 <a:solidFill>
-                  <a:srgbClr val="5CD68A"/>
-                </a:solidFill>
-                <a:latin typeface="Arial"/>
-              </a:rPr>
-              <a:t>+1.8</a:t>
+                  <a:srgbClr val="FF7A7A"/>
+                </a:solidFill>
+                <a:latin typeface="Arial"/>
+              </a:rPr>
+              <a:t>-1.0</a:t>
             </a:r>
           </a:p>
         </p:txBody>
@@ -4464,7 +4464,7 @@
         </p:nvSpPr>
         <p:spPr>
           <a:xfrm>
-            <a:off x="5212080" y="2843784"/>
+            <a:off x="5212080" y="2834639"/>
             <a:ext cx="594360" cy="274320"/>
           </a:xfrm>
           <a:prstGeom prst="rect">
@@ -4499,8 +4499,8 @@
         </p:nvSpPr>
         <p:spPr>
           <a:xfrm>
-            <a:off x="822960" y="3127248"/>
-            <a:ext cx="5029200" cy="329184"/>
+            <a:off x="822960" y="3108960"/>
+            <a:ext cx="5029200" cy="320040"/>
           </a:xfrm>
           <a:prstGeom prst="rect">
             <a:avLst/>
@@ -4543,7 +4543,7 @@
         </p:nvSpPr>
         <p:spPr>
           <a:xfrm>
-            <a:off x="841248" y="3159252"/>
+            <a:off x="841248" y="3140964"/>
             <a:ext cx="411480" cy="274320"/>
           </a:xfrm>
           <a:prstGeom prst="rect">
@@ -4578,7 +4578,7 @@
         </p:nvSpPr>
         <p:spPr>
           <a:xfrm>
-            <a:off x="1371600" y="3163824"/>
+            <a:off x="1371600" y="3145536"/>
             <a:ext cx="256032" cy="256032"/>
           </a:xfrm>
           <a:prstGeom prst="ellipse">
@@ -4630,7 +4630,7 @@
         </p:blipFill>
         <p:spPr>
           <a:xfrm>
-            <a:off x="1399032" y="3191256"/>
+            <a:off x="1399032" y="3172968"/>
             <a:ext cx="201168" cy="201168"/>
           </a:xfrm>
           <a:prstGeom prst="rect">
@@ -4646,7 +4646,7 @@
         </p:nvSpPr>
         <p:spPr>
           <a:xfrm>
-            <a:off x="1737360" y="3159252"/>
+            <a:off x="1737360" y="3140964"/>
             <a:ext cx="2103120" cy="274320"/>
           </a:xfrm>
           <a:prstGeom prst="rect">
@@ -4681,7 +4681,7 @@
         </p:nvSpPr>
         <p:spPr>
           <a:xfrm>
-            <a:off x="3840480" y="3159252"/>
+            <a:off x="3840480" y="3140964"/>
             <a:ext cx="685800" cy="274320"/>
           </a:xfrm>
           <a:prstGeom prst="rect">
@@ -4716,7 +4716,7 @@
         </p:nvSpPr>
         <p:spPr>
           <a:xfrm>
-            <a:off x="4526280" y="3172968"/>
+            <a:off x="4526280" y="3154679"/>
             <a:ext cx="685800" cy="274320"/>
           </a:xfrm>
           <a:prstGeom prst="rect">
@@ -4738,7 +4738,7 @@
                 </a:solidFill>
                 <a:latin typeface="Arial"/>
               </a:rPr>
-              <a:t>+4.8</a:t>
+              <a:t>+0.2</a:t>
             </a:r>
           </a:p>
         </p:txBody>
@@ -4751,7 +4751,7 @@
         </p:nvSpPr>
         <p:spPr>
           <a:xfrm>
-            <a:off x="5212080" y="3172968"/>
+            <a:off x="5212080" y="3154679"/>
             <a:ext cx="594360" cy="274320"/>
           </a:xfrm>
           <a:prstGeom prst="rect">
@@ -4786,7 +4786,7 @@
         </p:nvSpPr>
         <p:spPr>
           <a:xfrm>
-            <a:off x="841248" y="3488436"/>
+            <a:off x="841248" y="3461004"/>
             <a:ext cx="411480" cy="274320"/>
           </a:xfrm>
           <a:prstGeom prst="rect">
@@ -4821,7 +4821,7 @@
         </p:nvSpPr>
         <p:spPr>
           <a:xfrm>
-            <a:off x="1371600" y="3493008"/>
+            <a:off x="1371600" y="3465576"/>
             <a:ext cx="256032" cy="256032"/>
           </a:xfrm>
           <a:prstGeom prst="ellipse">
@@ -4873,7 +4873,7 @@
         </p:blipFill>
         <p:spPr>
           <a:xfrm>
-            <a:off x="1399032" y="3520439"/>
+            <a:off x="1399032" y="3493008"/>
             <a:ext cx="201168" cy="201168"/>
           </a:xfrm>
           <a:prstGeom prst="rect">
@@ -4889,7 +4889,7 @@
         </p:nvSpPr>
         <p:spPr>
           <a:xfrm>
-            <a:off x="1737360" y="3488436"/>
+            <a:off x="1737360" y="3461004"/>
             <a:ext cx="2103120" cy="274320"/>
           </a:xfrm>
           <a:prstGeom prst="rect">
@@ -4924,7 +4924,7 @@
         </p:nvSpPr>
         <p:spPr>
           <a:xfrm>
-            <a:off x="3840480" y="3488436"/>
+            <a:off x="3840480" y="3461004"/>
             <a:ext cx="685800" cy="274320"/>
           </a:xfrm>
           <a:prstGeom prst="rect">
@@ -4959,7 +4959,7 @@
         </p:nvSpPr>
         <p:spPr>
           <a:xfrm>
-            <a:off x="4526280" y="3502151"/>
+            <a:off x="4526280" y="3474720"/>
             <a:ext cx="685800" cy="274320"/>
           </a:xfrm>
           <a:prstGeom prst="rect">
@@ -4977,11 +4977,11 @@
             <a:r>
               <a:rPr sz="1100" b="1" i="0">
                 <a:solidFill>
-                  <a:srgbClr val="5CD68A"/>
-                </a:solidFill>
-                <a:latin typeface="Arial"/>
-              </a:rPr>
-              <a:t>+1.1</a:t>
+                  <a:srgbClr val="FF7A7A"/>
+                </a:solidFill>
+                <a:latin typeface="Arial"/>
+              </a:rPr>
+              <a:t>-1.0</a:t>
             </a:r>
           </a:p>
         </p:txBody>
@@ -4994,7 +4994,7 @@
         </p:nvSpPr>
         <p:spPr>
           <a:xfrm>
-            <a:off x="5212080" y="3502151"/>
+            <a:off x="5212080" y="3474720"/>
             <a:ext cx="594360" cy="274320"/>
           </a:xfrm>
           <a:prstGeom prst="rect">
@@ -5029,8 +5029,8 @@
         </p:nvSpPr>
         <p:spPr>
           <a:xfrm>
-            <a:off x="822960" y="3785616"/>
-            <a:ext cx="5029200" cy="329184"/>
+            <a:off x="822960" y="3749039"/>
+            <a:ext cx="5029200" cy="320040"/>
           </a:xfrm>
           <a:prstGeom prst="rect">
             <a:avLst/>
@@ -5073,7 +5073,7 @@
         </p:nvSpPr>
         <p:spPr>
           <a:xfrm>
-            <a:off x="841248" y="3817620"/>
+            <a:off x="841248" y="3781044"/>
             <a:ext cx="411480" cy="274320"/>
           </a:xfrm>
           <a:prstGeom prst="rect">
@@ -5108,7 +5108,7 @@
         </p:nvSpPr>
         <p:spPr>
           <a:xfrm>
-            <a:off x="1371600" y="3822192"/>
+            <a:off x="1371600" y="3785615"/>
             <a:ext cx="256032" cy="256032"/>
           </a:xfrm>
           <a:prstGeom prst="ellipse">
@@ -5160,7 +5160,7 @@
         </p:blipFill>
         <p:spPr>
           <a:xfrm>
-            <a:off x="1399032" y="3849624"/>
+            <a:off x="1399032" y="3813048"/>
             <a:ext cx="201168" cy="201168"/>
           </a:xfrm>
           <a:prstGeom prst="rect">
@@ -5176,7 +5176,7 @@
         </p:nvSpPr>
         <p:spPr>
           <a:xfrm>
-            <a:off x="1737360" y="3817620"/>
+            <a:off x="1737360" y="3781044"/>
             <a:ext cx="2103120" cy="274320"/>
           </a:xfrm>
           <a:prstGeom prst="rect">
@@ -5211,7 +5211,7 @@
         </p:nvSpPr>
         <p:spPr>
           <a:xfrm>
-            <a:off x="3840480" y="3817620"/>
+            <a:off x="3840480" y="3781044"/>
             <a:ext cx="685800" cy="274320"/>
           </a:xfrm>
           <a:prstGeom prst="rect">
@@ -5246,7 +5246,7 @@
         </p:nvSpPr>
         <p:spPr>
           <a:xfrm>
-            <a:off x="4526280" y="3831336"/>
+            <a:off x="4526280" y="3794759"/>
             <a:ext cx="685800" cy="274320"/>
           </a:xfrm>
           <a:prstGeom prst="rect">
@@ -5264,11 +5264,11 @@
             <a:r>
               <a:rPr sz="1100" b="1" i="0">
                 <a:solidFill>
-                  <a:srgbClr val="5CD68A"/>
-                </a:solidFill>
-                <a:latin typeface="Arial"/>
-              </a:rPr>
-              <a:t>+1.9</a:t>
+                  <a:srgbClr val="FF7A7A"/>
+                </a:solidFill>
+                <a:latin typeface="Arial"/>
+              </a:rPr>
+              <a:t>-1.7</a:t>
             </a:r>
           </a:p>
         </p:txBody>
@@ -5281,7 +5281,7 @@
         </p:nvSpPr>
         <p:spPr>
           <a:xfrm>
-            <a:off x="5212080" y="3831336"/>
+            <a:off x="5212080" y="3794759"/>
             <a:ext cx="594360" cy="274320"/>
           </a:xfrm>
           <a:prstGeom prst="rect">
@@ -5316,7 +5316,7 @@
         </p:nvSpPr>
         <p:spPr>
           <a:xfrm>
-            <a:off x="841248" y="4146804"/>
+            <a:off x="841248" y="4101083"/>
             <a:ext cx="411480" cy="274320"/>
           </a:xfrm>
           <a:prstGeom prst="rect">
@@ -5351,7 +5351,7 @@
         </p:nvSpPr>
         <p:spPr>
           <a:xfrm>
-            <a:off x="1371600" y="4151376"/>
+            <a:off x="1371600" y="4105655"/>
             <a:ext cx="256032" cy="256032"/>
           </a:xfrm>
           <a:prstGeom prst="ellipse">
@@ -5403,7 +5403,7 @@
         </p:blipFill>
         <p:spPr>
           <a:xfrm>
-            <a:off x="1399032" y="4178808"/>
+            <a:off x="1399032" y="4133087"/>
             <a:ext cx="201168" cy="201168"/>
           </a:xfrm>
           <a:prstGeom prst="rect">
@@ -5419,7 +5419,7 @@
         </p:nvSpPr>
         <p:spPr>
           <a:xfrm>
-            <a:off x="1737360" y="4146804"/>
+            <a:off x="1737360" y="4101083"/>
             <a:ext cx="2103120" cy="274320"/>
           </a:xfrm>
           <a:prstGeom prst="rect">
@@ -5454,7 +5454,7 @@
         </p:nvSpPr>
         <p:spPr>
           <a:xfrm>
-            <a:off x="3840480" y="4146804"/>
+            <a:off x="3840480" y="4101083"/>
             <a:ext cx="685800" cy="274320"/>
           </a:xfrm>
           <a:prstGeom prst="rect">
@@ -5489,7 +5489,7 @@
         </p:nvSpPr>
         <p:spPr>
           <a:xfrm>
-            <a:off x="4526280" y="4160520"/>
+            <a:off x="4526280" y="4114799"/>
             <a:ext cx="685800" cy="274320"/>
           </a:xfrm>
           <a:prstGeom prst="rect">
@@ -5507,11 +5507,11 @@
             <a:r>
               <a:rPr sz="1100" b="1" i="0">
                 <a:solidFill>
-                  <a:srgbClr val="5CD68A"/>
-                </a:solidFill>
-                <a:latin typeface="Arial"/>
-              </a:rPr>
-              <a:t>+2.4</a:t>
+                  <a:srgbClr val="FF7A7A"/>
+                </a:solidFill>
+                <a:latin typeface="Arial"/>
+              </a:rPr>
+              <a:t>-2.0</a:t>
             </a:r>
           </a:p>
         </p:txBody>
@@ -5524,7 +5524,7 @@
         </p:nvSpPr>
         <p:spPr>
           <a:xfrm>
-            <a:off x="5212080" y="4160520"/>
+            <a:off x="5212080" y="4114799"/>
             <a:ext cx="594360" cy="274320"/>
           </a:xfrm>
           <a:prstGeom prst="rect">
@@ -5559,8 +5559,8 @@
         </p:nvSpPr>
         <p:spPr>
           <a:xfrm>
-            <a:off x="822960" y="4443983"/>
-            <a:ext cx="5029200" cy="329184"/>
+            <a:off x="822960" y="4389120"/>
+            <a:ext cx="5029200" cy="320040"/>
           </a:xfrm>
           <a:prstGeom prst="rect">
             <a:avLst/>
@@ -5603,7 +5603,7 @@
         </p:nvSpPr>
         <p:spPr>
           <a:xfrm>
-            <a:off x="841248" y="4475988"/>
+            <a:off x="841248" y="4421124"/>
             <a:ext cx="411480" cy="274320"/>
           </a:xfrm>
           <a:prstGeom prst="rect">
@@ -5638,7 +5638,7 @@
         </p:nvSpPr>
         <p:spPr>
           <a:xfrm>
-            <a:off x="1371600" y="4480559"/>
+            <a:off x="1371600" y="4425696"/>
             <a:ext cx="256032" cy="256032"/>
           </a:xfrm>
           <a:prstGeom prst="ellipse">
@@ -5690,7 +5690,7 @@
         </p:blipFill>
         <p:spPr>
           <a:xfrm>
-            <a:off x="1399032" y="4507992"/>
+            <a:off x="1399032" y="4453128"/>
             <a:ext cx="201168" cy="201168"/>
           </a:xfrm>
           <a:prstGeom prst="rect">
@@ -5706,7 +5706,7 @@
         </p:nvSpPr>
         <p:spPr>
           <a:xfrm>
-            <a:off x="1737360" y="4475988"/>
+            <a:off x="1737360" y="4421124"/>
             <a:ext cx="2103120" cy="274320"/>
           </a:xfrm>
           <a:prstGeom prst="rect">
@@ -5741,7 +5741,7 @@
         </p:nvSpPr>
         <p:spPr>
           <a:xfrm>
-            <a:off x="3840480" y="4475988"/>
+            <a:off x="3840480" y="4421124"/>
             <a:ext cx="685800" cy="274320"/>
           </a:xfrm>
           <a:prstGeom prst="rect">
@@ -5776,7 +5776,7 @@
         </p:nvSpPr>
         <p:spPr>
           <a:xfrm>
-            <a:off x="4526280" y="4489703"/>
+            <a:off x="4526280" y="4434840"/>
             <a:ext cx="685800" cy="274320"/>
           </a:xfrm>
           <a:prstGeom prst="rect">
@@ -5798,7 +5798,7 @@
                 </a:solidFill>
                 <a:latin typeface="Arial"/>
               </a:rPr>
-              <a:t>-0.7</a:t>
+              <a:t>-5.3</a:t>
             </a:r>
           </a:p>
         </p:txBody>
@@ -5811,7 +5811,7 @@
         </p:nvSpPr>
         <p:spPr>
           <a:xfrm>
-            <a:off x="5212080" y="4489703"/>
+            <a:off x="5212080" y="4434840"/>
             <a:ext cx="594360" cy="274320"/>
           </a:xfrm>
           <a:prstGeom prst="rect">
@@ -5846,7 +5846,7 @@
         </p:nvSpPr>
         <p:spPr>
           <a:xfrm>
-            <a:off x="841248" y="4805172"/>
+            <a:off x="841248" y="4741164"/>
             <a:ext cx="411480" cy="274320"/>
           </a:xfrm>
           <a:prstGeom prst="rect">
@@ -5881,7 +5881,7 @@
         </p:nvSpPr>
         <p:spPr>
           <a:xfrm>
-            <a:off x="1371600" y="4809744"/>
+            <a:off x="1371600" y="4745736"/>
             <a:ext cx="256032" cy="256032"/>
           </a:xfrm>
           <a:prstGeom prst="ellipse">
@@ -5933,7 +5933,7 @@
         </p:blipFill>
         <p:spPr>
           <a:xfrm>
-            <a:off x="1399032" y="4837176"/>
+            <a:off x="1399032" y="4773168"/>
             <a:ext cx="201168" cy="201168"/>
           </a:xfrm>
           <a:prstGeom prst="rect">
@@ -5949,7 +5949,7 @@
         </p:nvSpPr>
         <p:spPr>
           <a:xfrm>
-            <a:off x="1737360" y="4805172"/>
+            <a:off x="1737360" y="4741164"/>
             <a:ext cx="2103120" cy="274320"/>
           </a:xfrm>
           <a:prstGeom prst="rect">
@@ -5984,7 +5984,7 @@
         </p:nvSpPr>
         <p:spPr>
           <a:xfrm>
-            <a:off x="3840480" y="4805172"/>
+            <a:off x="3840480" y="4741164"/>
             <a:ext cx="685800" cy="274320"/>
           </a:xfrm>
           <a:prstGeom prst="rect">
@@ -6019,7 +6019,7 @@
         </p:nvSpPr>
         <p:spPr>
           <a:xfrm>
-            <a:off x="4526280" y="4818888"/>
+            <a:off x="4526280" y="4754880"/>
             <a:ext cx="685800" cy="274320"/>
           </a:xfrm>
           <a:prstGeom prst="rect">
@@ -6041,7 +6041,7 @@
                 </a:solidFill>
                 <a:latin typeface="Arial"/>
               </a:rPr>
-              <a:t>+4.8</a:t>
+              <a:t>+1.8</a:t>
             </a:r>
           </a:p>
         </p:txBody>
@@ -6054,7 +6054,7 @@
         </p:nvSpPr>
         <p:spPr>
           <a:xfrm>
-            <a:off x="5212080" y="4818888"/>
+            <a:off x="5212080" y="4754880"/>
             <a:ext cx="594360" cy="274320"/>
           </a:xfrm>
           <a:prstGeom prst="rect">
@@ -6089,8 +6089,8 @@
         </p:nvSpPr>
         <p:spPr>
           <a:xfrm>
-            <a:off x="822960" y="5102352"/>
-            <a:ext cx="5029200" cy="329184"/>
+            <a:off x="822960" y="5029200"/>
+            <a:ext cx="5029200" cy="320040"/>
           </a:xfrm>
           <a:prstGeom prst="rect">
             <a:avLst/>
@@ -6133,7 +6133,7 @@
         </p:nvSpPr>
         <p:spPr>
           <a:xfrm>
-            <a:off x="841248" y="5134356"/>
+            <a:off x="841248" y="5061204"/>
             <a:ext cx="411480" cy="274320"/>
           </a:xfrm>
           <a:prstGeom prst="rect">
@@ -6168,7 +6168,7 @@
         </p:nvSpPr>
         <p:spPr>
           <a:xfrm>
-            <a:off x="1371600" y="5138928"/>
+            <a:off x="1371600" y="5065776"/>
             <a:ext cx="256032" cy="256032"/>
           </a:xfrm>
           <a:prstGeom prst="ellipse">
@@ -6220,7 +6220,7 @@
         </p:blipFill>
         <p:spPr>
           <a:xfrm>
-            <a:off x="1399032" y="5166360"/>
+            <a:off x="1399032" y="5093208"/>
             <a:ext cx="201168" cy="201168"/>
           </a:xfrm>
           <a:prstGeom prst="rect">
@@ -6236,7 +6236,7 @@
         </p:nvSpPr>
         <p:spPr>
           <a:xfrm>
-            <a:off x="1737360" y="5134356"/>
+            <a:off x="1737360" y="5061204"/>
             <a:ext cx="2103120" cy="274320"/>
           </a:xfrm>
           <a:prstGeom prst="rect">
@@ -6271,7 +6271,7 @@
         </p:nvSpPr>
         <p:spPr>
           <a:xfrm>
-            <a:off x="3840480" y="5134356"/>
+            <a:off x="3840480" y="5061204"/>
             <a:ext cx="685800" cy="274320"/>
           </a:xfrm>
           <a:prstGeom prst="rect">
@@ -6306,7 +6306,7 @@
         </p:nvSpPr>
         <p:spPr>
           <a:xfrm>
-            <a:off x="4526280" y="5148072"/>
+            <a:off x="4526280" y="5074920"/>
             <a:ext cx="685800" cy="274320"/>
           </a:xfrm>
           <a:prstGeom prst="rect">
@@ -6328,7 +6328,7 @@
                 </a:solidFill>
                 <a:latin typeface="Arial"/>
               </a:rPr>
-              <a:t>+4.9</a:t>
+              <a:t>+0.6</a:t>
             </a:r>
           </a:p>
         </p:txBody>
@@ -6341,7 +6341,7 @@
         </p:nvSpPr>
         <p:spPr>
           <a:xfrm>
-            <a:off x="5212080" y="5148072"/>
+            <a:off x="5212080" y="5074920"/>
             <a:ext cx="594360" cy="274320"/>
           </a:xfrm>
           <a:prstGeom prst="rect">
@@ -6376,7 +6376,7 @@
         </p:nvSpPr>
         <p:spPr>
           <a:xfrm>
-            <a:off x="841248" y="5463540"/>
+            <a:off x="841248" y="5381244"/>
             <a:ext cx="411480" cy="274320"/>
           </a:xfrm>
           <a:prstGeom prst="rect">
@@ -6411,7 +6411,7 @@
         </p:nvSpPr>
         <p:spPr>
           <a:xfrm>
-            <a:off x="1371600" y="5468112"/>
+            <a:off x="1371600" y="5385816"/>
             <a:ext cx="256032" cy="256032"/>
           </a:xfrm>
           <a:prstGeom prst="ellipse">
@@ -6463,7 +6463,7 @@
         </p:blipFill>
         <p:spPr>
           <a:xfrm>
-            <a:off x="1399032" y="5495544"/>
+            <a:off x="1399032" y="5413248"/>
             <a:ext cx="201168" cy="201168"/>
           </a:xfrm>
           <a:prstGeom prst="rect">
@@ -6479,7 +6479,7 @@
         </p:nvSpPr>
         <p:spPr>
           <a:xfrm>
-            <a:off x="1737360" y="5463540"/>
+            <a:off x="1737360" y="5381244"/>
             <a:ext cx="2103120" cy="274320"/>
           </a:xfrm>
           <a:prstGeom prst="rect">
@@ -6514,7 +6514,7 @@
         </p:nvSpPr>
         <p:spPr>
           <a:xfrm>
-            <a:off x="3840480" y="5463540"/>
+            <a:off x="3840480" y="5381244"/>
             <a:ext cx="685800" cy="274320"/>
           </a:xfrm>
           <a:prstGeom prst="rect">
@@ -6549,7 +6549,7 @@
         </p:nvSpPr>
         <p:spPr>
           <a:xfrm>
-            <a:off x="4526280" y="5477255"/>
+            <a:off x="4526280" y="5394959"/>
             <a:ext cx="685800" cy="274320"/>
           </a:xfrm>
           <a:prstGeom prst="rect">
@@ -6571,7 +6571,7 @@
                 </a:solidFill>
                 <a:latin typeface="Arial"/>
               </a:rPr>
-              <a:t>+1.9</a:t>
+              <a:t>+2.7</a:t>
             </a:r>
           </a:p>
         </p:txBody>
@@ -6584,7 +6584,7 @@
         </p:nvSpPr>
         <p:spPr>
           <a:xfrm>
-            <a:off x="5212080" y="5477255"/>
+            <a:off x="5212080" y="5394959"/>
             <a:ext cx="594360" cy="274320"/>
           </a:xfrm>
           <a:prstGeom prst="rect">
@@ -6619,8 +6619,8 @@
         </p:nvSpPr>
         <p:spPr>
           <a:xfrm>
-            <a:off x="822960" y="5760720"/>
-            <a:ext cx="5029200" cy="329184"/>
+            <a:off x="822960" y="5669279"/>
+            <a:ext cx="5029200" cy="320040"/>
           </a:xfrm>
           <a:prstGeom prst="rect">
             <a:avLst/>
@@ -6663,7 +6663,7 @@
         </p:nvSpPr>
         <p:spPr>
           <a:xfrm>
-            <a:off x="841248" y="5792724"/>
+            <a:off x="841248" y="5701283"/>
             <a:ext cx="411480" cy="274320"/>
           </a:xfrm>
           <a:prstGeom prst="rect">
@@ -6698,7 +6698,7 @@
         </p:nvSpPr>
         <p:spPr>
           <a:xfrm>
-            <a:off x="1371600" y="5797296"/>
+            <a:off x="1371600" y="5705855"/>
             <a:ext cx="256032" cy="256032"/>
           </a:xfrm>
           <a:prstGeom prst="ellipse">
@@ -6750,7 +6750,7 @@
         </p:blipFill>
         <p:spPr>
           <a:xfrm>
-            <a:off x="1399032" y="5824728"/>
+            <a:off x="1399032" y="5733288"/>
             <a:ext cx="201168" cy="201168"/>
           </a:xfrm>
           <a:prstGeom prst="rect">
@@ -6766,7 +6766,7 @@
         </p:nvSpPr>
         <p:spPr>
           <a:xfrm>
-            <a:off x="1737360" y="5792724"/>
+            <a:off x="1737360" y="5701283"/>
             <a:ext cx="2103120" cy="274320"/>
           </a:xfrm>
           <a:prstGeom prst="rect">
@@ -6801,7 +6801,7 @@
         </p:nvSpPr>
         <p:spPr>
           <a:xfrm>
-            <a:off x="3840480" y="5792724"/>
+            <a:off x="3840480" y="5701283"/>
             <a:ext cx="685800" cy="274320"/>
           </a:xfrm>
           <a:prstGeom prst="rect">
@@ -6836,7 +6836,7 @@
         </p:nvSpPr>
         <p:spPr>
           <a:xfrm>
-            <a:off x="4526280" y="5806440"/>
+            <a:off x="4526280" y="5714999"/>
             <a:ext cx="685800" cy="274320"/>
           </a:xfrm>
           <a:prstGeom prst="rect">
@@ -6852,13 +6852,13 @@
           <a:p>
             <a:pPr algn="r"/>
             <a:r>
-              <a:rPr sz="1100" b="1" i="0">
-                <a:solidFill>
-                  <a:srgbClr val="FF7A7A"/>
-                </a:solidFill>
-                <a:latin typeface="Arial"/>
-              </a:rPr>
-              <a:t>-8.0</a:t>
+              <a:rPr sz="1100" b="0" i="0">
+                <a:solidFill>
+                  <a:srgbClr val="CADCFC"/>
+                </a:solidFill>
+                <a:latin typeface="Arial"/>
+              </a:rPr>
+              <a:t>0.0</a:t>
             </a:r>
           </a:p>
         </p:txBody>
@@ -6871,7 +6871,7 @@
         </p:nvSpPr>
         <p:spPr>
           <a:xfrm>
-            <a:off x="5212080" y="5806440"/>
+            <a:off x="5212080" y="5714999"/>
             <a:ext cx="594360" cy="274320"/>
           </a:xfrm>
           <a:prstGeom prst="rect">
@@ -6906,8 +6906,8 @@
         </p:nvSpPr>
         <p:spPr>
           <a:xfrm>
-            <a:off x="6355080" y="1810512"/>
-            <a:ext cx="5029200" cy="329184"/>
+            <a:off x="6355080" y="1828800"/>
+            <a:ext cx="5029200" cy="320040"/>
           </a:xfrm>
           <a:prstGeom prst="rect">
             <a:avLst/>
@@ -6950,7 +6950,7 @@
         </p:nvSpPr>
         <p:spPr>
           <a:xfrm>
-            <a:off x="6373368" y="1842516"/>
+            <a:off x="6373368" y="1860804"/>
             <a:ext cx="411480" cy="274320"/>
           </a:xfrm>
           <a:prstGeom prst="rect">
@@ -6985,7 +6985,7 @@
         </p:nvSpPr>
         <p:spPr>
           <a:xfrm>
-            <a:off x="6903720" y="1847088"/>
+            <a:off x="6903720" y="1865376"/>
             <a:ext cx="256032" cy="256032"/>
           </a:xfrm>
           <a:prstGeom prst="ellipse">
@@ -7037,7 +7037,7 @@
         </p:blipFill>
         <p:spPr>
           <a:xfrm>
-            <a:off x="6931152" y="1874519"/>
+            <a:off x="6931152" y="1892807"/>
             <a:ext cx="201168" cy="201168"/>
           </a:xfrm>
           <a:prstGeom prst="rect">
@@ -7053,7 +7053,7 @@
         </p:nvSpPr>
         <p:spPr>
           <a:xfrm>
-            <a:off x="7269480" y="1842516"/>
+            <a:off x="7269480" y="1860804"/>
             <a:ext cx="2103120" cy="274320"/>
           </a:xfrm>
           <a:prstGeom prst="rect">
@@ -7088,7 +7088,7 @@
         </p:nvSpPr>
         <p:spPr>
           <a:xfrm>
-            <a:off x="9372600" y="1842516"/>
+            <a:off x="9372600" y="1860804"/>
             <a:ext cx="685800" cy="274320"/>
           </a:xfrm>
           <a:prstGeom prst="rect">
@@ -7123,7 +7123,7 @@
         </p:nvSpPr>
         <p:spPr>
           <a:xfrm>
-            <a:off x="10058400" y="1856231"/>
+            <a:off x="10058400" y="1874519"/>
             <a:ext cx="685800" cy="274320"/>
           </a:xfrm>
           <a:prstGeom prst="rect">
@@ -7141,11 +7141,11 @@
             <a:r>
               <a:rPr sz="1100" b="1" i="0">
                 <a:solidFill>
-                  <a:srgbClr val="5CD68A"/>
-                </a:solidFill>
-                <a:latin typeface="Arial"/>
-              </a:rPr>
-              <a:t>+2.2</a:t>
+                  <a:srgbClr val="FF7A7A"/>
+                </a:solidFill>
+                <a:latin typeface="Arial"/>
+              </a:rPr>
+              <a:t>-0.3</a:t>
             </a:r>
           </a:p>
         </p:txBody>
@@ -7158,7 +7158,7 @@
         </p:nvSpPr>
         <p:spPr>
           <a:xfrm>
-            <a:off x="10744200" y="1856231"/>
+            <a:off x="10744200" y="1874519"/>
             <a:ext cx="594360" cy="274320"/>
           </a:xfrm>
           <a:prstGeom prst="rect">
@@ -7193,7 +7193,7 @@
         </p:nvSpPr>
         <p:spPr>
           <a:xfrm>
-            <a:off x="6373368" y="2171700"/>
+            <a:off x="6373368" y="2180844"/>
             <a:ext cx="411480" cy="274320"/>
           </a:xfrm>
           <a:prstGeom prst="rect">
@@ -7228,7 +7228,7 @@
         </p:nvSpPr>
         <p:spPr>
           <a:xfrm>
-            <a:off x="6903720" y="2176272"/>
+            <a:off x="6903720" y="2185416"/>
             <a:ext cx="256032" cy="256032"/>
           </a:xfrm>
           <a:prstGeom prst="ellipse">
@@ -7280,7 +7280,7 @@
         </p:blipFill>
         <p:spPr>
           <a:xfrm>
-            <a:off x="6931152" y="2203703"/>
+            <a:off x="6931152" y="2212848"/>
             <a:ext cx="201168" cy="201168"/>
           </a:xfrm>
           <a:prstGeom prst="rect">
@@ -7296,7 +7296,7 @@
         </p:nvSpPr>
         <p:spPr>
           <a:xfrm>
-            <a:off x="7269480" y="2171700"/>
+            <a:off x="7269480" y="2180844"/>
             <a:ext cx="2103120" cy="274320"/>
           </a:xfrm>
           <a:prstGeom prst="rect">
@@ -7331,7 +7331,7 @@
         </p:nvSpPr>
         <p:spPr>
           <a:xfrm>
-            <a:off x="9372600" y="2171700"/>
+            <a:off x="9372600" y="2180844"/>
             <a:ext cx="685800" cy="274320"/>
           </a:xfrm>
           <a:prstGeom prst="rect">
@@ -7366,7 +7366,7 @@
         </p:nvSpPr>
         <p:spPr>
           <a:xfrm>
-            <a:off x="10058400" y="2185415"/>
+            <a:off x="10058400" y="2194560"/>
             <a:ext cx="685800" cy="274320"/>
           </a:xfrm>
           <a:prstGeom prst="rect">
@@ -7388,7 +7388,7 @@
                 </a:solidFill>
                 <a:latin typeface="Arial"/>
               </a:rPr>
-              <a:t>-1.3</a:t>
+              <a:t>-1.8</a:t>
             </a:r>
           </a:p>
         </p:txBody>
@@ -7401,7 +7401,7 @@
         </p:nvSpPr>
         <p:spPr>
           <a:xfrm>
-            <a:off x="10744200" y="2185415"/>
+            <a:off x="10744200" y="2194560"/>
             <a:ext cx="594360" cy="274320"/>
           </a:xfrm>
           <a:prstGeom prst="rect">
@@ -7437,7 +7437,7 @@
         <p:spPr>
           <a:xfrm>
             <a:off x="6355080" y="2468880"/>
-            <a:ext cx="5029200" cy="329184"/>
+            <a:ext cx="5029200" cy="320040"/>
           </a:xfrm>
           <a:prstGeom prst="rect">
             <a:avLst/>
@@ -7675,7 +7675,7 @@
                 </a:solidFill>
                 <a:latin typeface="Arial"/>
               </a:rPr>
-              <a:t>+7.5</a:t>
+              <a:t>+2.2</a:t>
             </a:r>
           </a:p>
         </p:txBody>
@@ -7723,7 +7723,7 @@
         </p:nvSpPr>
         <p:spPr>
           <a:xfrm>
-            <a:off x="6373368" y="2830068"/>
+            <a:off x="6373368" y="2820924"/>
             <a:ext cx="411480" cy="274320"/>
           </a:xfrm>
           <a:prstGeom prst="rect">
@@ -7758,7 +7758,7 @@
         </p:nvSpPr>
         <p:spPr>
           <a:xfrm>
-            <a:off x="6903720" y="2834640"/>
+            <a:off x="6903720" y="2825496"/>
             <a:ext cx="256032" cy="256032"/>
           </a:xfrm>
           <a:prstGeom prst="ellipse">
@@ -7810,7 +7810,7 @@
         </p:blipFill>
         <p:spPr>
           <a:xfrm>
-            <a:off x="6931152" y="2862072"/>
+            <a:off x="6931152" y="2852927"/>
             <a:ext cx="201168" cy="201168"/>
           </a:xfrm>
           <a:prstGeom prst="rect">
@@ -7826,7 +7826,7 @@
         </p:nvSpPr>
         <p:spPr>
           <a:xfrm>
-            <a:off x="7269480" y="2830068"/>
+            <a:off x="7269480" y="2820924"/>
             <a:ext cx="2103120" cy="274320"/>
           </a:xfrm>
           <a:prstGeom prst="rect">
@@ -7861,7 +7861,7 @@
         </p:nvSpPr>
         <p:spPr>
           <a:xfrm>
-            <a:off x="9372600" y="2830068"/>
+            <a:off x="9372600" y="2820924"/>
             <a:ext cx="685800" cy="274320"/>
           </a:xfrm>
           <a:prstGeom prst="rect">
@@ -7896,7 +7896,7 @@
         </p:nvSpPr>
         <p:spPr>
           <a:xfrm>
-            <a:off x="10058400" y="2843784"/>
+            <a:off x="10058400" y="2834639"/>
             <a:ext cx="685800" cy="274320"/>
           </a:xfrm>
           <a:prstGeom prst="rect">
@@ -7918,7 +7918,7 @@
                 </a:solidFill>
                 <a:latin typeface="Arial"/>
               </a:rPr>
-              <a:t>-4.7</a:t>
+              <a:t>-1.8</a:t>
             </a:r>
           </a:p>
         </p:txBody>
@@ -7931,7 +7931,7 @@
         </p:nvSpPr>
         <p:spPr>
           <a:xfrm>
-            <a:off x="10744200" y="2843784"/>
+            <a:off x="10744200" y="2834639"/>
             <a:ext cx="594360" cy="274320"/>
           </a:xfrm>
           <a:prstGeom prst="rect">
@@ -7966,8 +7966,8 @@
         </p:nvSpPr>
         <p:spPr>
           <a:xfrm>
-            <a:off x="6355080" y="3127248"/>
-            <a:ext cx="5029200" cy="329184"/>
+            <a:off x="6355080" y="3108960"/>
+            <a:ext cx="5029200" cy="320040"/>
           </a:xfrm>
           <a:prstGeom prst="rect">
             <a:avLst/>
@@ -8010,7 +8010,7 @@
         </p:nvSpPr>
         <p:spPr>
           <a:xfrm>
-            <a:off x="6373368" y="3159252"/>
+            <a:off x="6373368" y="3140964"/>
             <a:ext cx="411480" cy="274320"/>
           </a:xfrm>
           <a:prstGeom prst="rect">
@@ -8045,7 +8045,7 @@
         </p:nvSpPr>
         <p:spPr>
           <a:xfrm>
-            <a:off x="6903720" y="3163824"/>
+            <a:off x="6903720" y="3145536"/>
             <a:ext cx="256032" cy="256032"/>
           </a:xfrm>
           <a:prstGeom prst="ellipse">
@@ -8097,7 +8097,7 @@
         </p:blipFill>
         <p:spPr>
           <a:xfrm>
-            <a:off x="6931152" y="3191256"/>
+            <a:off x="6931152" y="3172968"/>
             <a:ext cx="201168" cy="201168"/>
           </a:xfrm>
           <a:prstGeom prst="rect">
@@ -8113,7 +8113,7 @@
         </p:nvSpPr>
         <p:spPr>
           <a:xfrm>
-            <a:off x="7269480" y="3159252"/>
+            <a:off x="7269480" y="3140964"/>
             <a:ext cx="2103120" cy="274320"/>
           </a:xfrm>
           <a:prstGeom prst="rect">
@@ -8148,7 +8148,7 @@
         </p:nvSpPr>
         <p:spPr>
           <a:xfrm>
-            <a:off x="9372600" y="3159252"/>
+            <a:off x="9372600" y="3140964"/>
             <a:ext cx="685800" cy="274320"/>
           </a:xfrm>
           <a:prstGeom prst="rect">
@@ -8183,7 +8183,7 @@
         </p:nvSpPr>
         <p:spPr>
           <a:xfrm>
-            <a:off x="10058400" y="3172968"/>
+            <a:off x="10058400" y="3154679"/>
             <a:ext cx="685800" cy="274320"/>
           </a:xfrm>
           <a:prstGeom prst="rect">
@@ -8205,7 +8205,7 @@
                 </a:solidFill>
                 <a:latin typeface="Arial"/>
               </a:rPr>
-              <a:t>+10.7</a:t>
+              <a:t>+2.6</a:t>
             </a:r>
           </a:p>
         </p:txBody>
@@ -8218,7 +8218,7 @@
         </p:nvSpPr>
         <p:spPr>
           <a:xfrm>
-            <a:off x="10744200" y="3172968"/>
+            <a:off x="10744200" y="3154679"/>
             <a:ext cx="594360" cy="274320"/>
           </a:xfrm>
           <a:prstGeom prst="rect">
@@ -8253,7 +8253,7 @@
         </p:nvSpPr>
         <p:spPr>
           <a:xfrm>
-            <a:off x="6373368" y="3488436"/>
+            <a:off x="6373368" y="3461004"/>
             <a:ext cx="411480" cy="274320"/>
           </a:xfrm>
           <a:prstGeom prst="rect">
@@ -8288,7 +8288,7 @@
         </p:nvSpPr>
         <p:spPr>
           <a:xfrm>
-            <a:off x="6903720" y="3493008"/>
+            <a:off x="6903720" y="3465576"/>
             <a:ext cx="256032" cy="256032"/>
           </a:xfrm>
           <a:prstGeom prst="ellipse">
@@ -8340,7 +8340,7 @@
         </p:blipFill>
         <p:spPr>
           <a:xfrm>
-            <a:off x="6931152" y="3520439"/>
+            <a:off x="6931152" y="3493008"/>
             <a:ext cx="201168" cy="201168"/>
           </a:xfrm>
           <a:prstGeom prst="rect">
@@ -8356,7 +8356,7 @@
         </p:nvSpPr>
         <p:spPr>
           <a:xfrm>
-            <a:off x="7269480" y="3488436"/>
+            <a:off x="7269480" y="3461004"/>
             <a:ext cx="2103120" cy="274320"/>
           </a:xfrm>
           <a:prstGeom prst="rect">
@@ -8391,7 +8391,7 @@
         </p:nvSpPr>
         <p:spPr>
           <a:xfrm>
-            <a:off x="9372600" y="3488436"/>
+            <a:off x="9372600" y="3461004"/>
             <a:ext cx="685800" cy="274320"/>
           </a:xfrm>
           <a:prstGeom prst="rect">
@@ -8426,7 +8426,7 @@
         </p:nvSpPr>
         <p:spPr>
           <a:xfrm>
-            <a:off x="10058400" y="3502151"/>
+            <a:off x="10058400" y="3474720"/>
             <a:ext cx="685800" cy="274320"/>
           </a:xfrm>
           <a:prstGeom prst="rect">
@@ -8448,7 +8448,7 @@
                 </a:solidFill>
                 <a:latin typeface="Arial"/>
               </a:rPr>
-              <a:t>-2.5</a:t>
+              <a:t>-2.1</a:t>
             </a:r>
           </a:p>
         </p:txBody>
@@ -8461,7 +8461,7 @@
         </p:nvSpPr>
         <p:spPr>
           <a:xfrm>
-            <a:off x="10744200" y="3502151"/>
+            <a:off x="10744200" y="3474720"/>
             <a:ext cx="594360" cy="274320"/>
           </a:xfrm>
           <a:prstGeom prst="rect">
@@ -8496,8 +8496,8 @@
         </p:nvSpPr>
         <p:spPr>
           <a:xfrm>
-            <a:off x="6355080" y="3785616"/>
-            <a:ext cx="5029200" cy="329184"/>
+            <a:off x="6355080" y="3749039"/>
+            <a:ext cx="5029200" cy="320040"/>
           </a:xfrm>
           <a:prstGeom prst="rect">
             <a:avLst/>
@@ -8540,7 +8540,7 @@
         </p:nvSpPr>
         <p:spPr>
           <a:xfrm>
-            <a:off x="6373368" y="3817620"/>
+            <a:off x="6373368" y="3781044"/>
             <a:ext cx="411480" cy="274320"/>
           </a:xfrm>
           <a:prstGeom prst="rect">
@@ -8575,7 +8575,7 @@
         </p:nvSpPr>
         <p:spPr>
           <a:xfrm>
-            <a:off x="6903720" y="3822192"/>
+            <a:off x="6903720" y="3785615"/>
             <a:ext cx="256032" cy="256032"/>
           </a:xfrm>
           <a:prstGeom prst="ellipse">
@@ -8627,7 +8627,7 @@
         </p:blipFill>
         <p:spPr>
           <a:xfrm>
-            <a:off x="6931152" y="3849624"/>
+            <a:off x="6931152" y="3813048"/>
             <a:ext cx="201168" cy="201168"/>
           </a:xfrm>
           <a:prstGeom prst="rect">
@@ -8643,7 +8643,7 @@
         </p:nvSpPr>
         <p:spPr>
           <a:xfrm>
-            <a:off x="7269480" y="3817620"/>
+            <a:off x="7269480" y="3781044"/>
             <a:ext cx="2103120" cy="274320"/>
           </a:xfrm>
           <a:prstGeom prst="rect">
@@ -8678,7 +8678,7 @@
         </p:nvSpPr>
         <p:spPr>
           <a:xfrm>
-            <a:off x="9372600" y="3817620"/>
+            <a:off x="9372600" y="3781044"/>
             <a:ext cx="685800" cy="274320"/>
           </a:xfrm>
           <a:prstGeom prst="rect">
@@ -8713,7 +8713,7 @@
         </p:nvSpPr>
         <p:spPr>
           <a:xfrm>
-            <a:off x="10058400" y="3831336"/>
+            <a:off x="10058400" y="3794759"/>
             <a:ext cx="685800" cy="274320"/>
           </a:xfrm>
           <a:prstGeom prst="rect">
@@ -8731,11 +8731,11 @@
             <a:r>
               <a:rPr sz="1100" b="1" i="0">
                 <a:solidFill>
-                  <a:srgbClr val="5CD68A"/>
-                </a:solidFill>
-                <a:latin typeface="Arial"/>
-              </a:rPr>
-              <a:t>+2.5</a:t>
+                  <a:srgbClr val="FF7A7A"/>
+                </a:solidFill>
+                <a:latin typeface="Arial"/>
+              </a:rPr>
+              <a:t>-2.4</a:t>
             </a:r>
           </a:p>
         </p:txBody>
@@ -8748,7 +8748,7 @@
         </p:nvSpPr>
         <p:spPr>
           <a:xfrm>
-            <a:off x="10744200" y="3831336"/>
+            <a:off x="10744200" y="3794759"/>
             <a:ext cx="594360" cy="274320"/>
           </a:xfrm>
           <a:prstGeom prst="rect">
@@ -8783,7 +8783,7 @@
         </p:nvSpPr>
         <p:spPr>
           <a:xfrm>
-            <a:off x="6373368" y="4146804"/>
+            <a:off x="6373368" y="4101083"/>
             <a:ext cx="411480" cy="274320"/>
           </a:xfrm>
           <a:prstGeom prst="rect">
@@ -8818,7 +8818,7 @@
         </p:nvSpPr>
         <p:spPr>
           <a:xfrm>
-            <a:off x="6903720" y="4151376"/>
+            <a:off x="6903720" y="4105655"/>
             <a:ext cx="256032" cy="256032"/>
           </a:xfrm>
           <a:prstGeom prst="ellipse">
@@ -8870,7 +8870,7 @@
         </p:blipFill>
         <p:spPr>
           <a:xfrm>
-            <a:off x="6931152" y="4178808"/>
+            <a:off x="6931152" y="4133087"/>
             <a:ext cx="201168" cy="201168"/>
           </a:xfrm>
           <a:prstGeom prst="rect">
@@ -8886,7 +8886,7 @@
         </p:nvSpPr>
         <p:spPr>
           <a:xfrm>
-            <a:off x="7269480" y="4146804"/>
+            <a:off x="7269480" y="4101083"/>
             <a:ext cx="2103120" cy="274320"/>
           </a:xfrm>
           <a:prstGeom prst="rect">
@@ -8921,7 +8921,7 @@
         </p:nvSpPr>
         <p:spPr>
           <a:xfrm>
-            <a:off x="9372600" y="4146804"/>
+            <a:off x="9372600" y="4101083"/>
             <a:ext cx="685800" cy="274320"/>
           </a:xfrm>
           <a:prstGeom prst="rect">
@@ -8956,7 +8956,7 @@
         </p:nvSpPr>
         <p:spPr>
           <a:xfrm>
-            <a:off x="10058400" y="4160520"/>
+            <a:off x="10058400" y="4114799"/>
             <a:ext cx="685800" cy="274320"/>
           </a:xfrm>
           <a:prstGeom prst="rect">
@@ -8974,11 +8974,11 @@
             <a:r>
               <a:rPr sz="1100" b="1" i="0">
                 <a:solidFill>
-                  <a:srgbClr val="5CD68A"/>
-                </a:solidFill>
-                <a:latin typeface="Arial"/>
-              </a:rPr>
-              <a:t>+4.5</a:t>
+                  <a:srgbClr val="FF7A7A"/>
+                </a:solidFill>
+                <a:latin typeface="Arial"/>
+              </a:rPr>
+              <a:t>-0.7</a:t>
             </a:r>
           </a:p>
         </p:txBody>
@@ -8991,7 +8991,7 @@
         </p:nvSpPr>
         <p:spPr>
           <a:xfrm>
-            <a:off x="10744200" y="4160520"/>
+            <a:off x="10744200" y="4114799"/>
             <a:ext cx="594360" cy="274320"/>
           </a:xfrm>
           <a:prstGeom prst="rect">
@@ -9026,8 +9026,8 @@
         </p:nvSpPr>
         <p:spPr>
           <a:xfrm>
-            <a:off x="6355080" y="4443983"/>
-            <a:ext cx="5029200" cy="329184"/>
+            <a:off x="6355080" y="4389120"/>
+            <a:ext cx="5029200" cy="320040"/>
           </a:xfrm>
           <a:prstGeom prst="rect">
             <a:avLst/>
@@ -9070,7 +9070,7 @@
         </p:nvSpPr>
         <p:spPr>
           <a:xfrm>
-            <a:off x="6373368" y="4475988"/>
+            <a:off x="6373368" y="4421124"/>
             <a:ext cx="411480" cy="274320"/>
           </a:xfrm>
           <a:prstGeom prst="rect">
@@ -9105,7 +9105,7 @@
         </p:nvSpPr>
         <p:spPr>
           <a:xfrm>
-            <a:off x="6903720" y="4480559"/>
+            <a:off x="6903720" y="4425696"/>
             <a:ext cx="256032" cy="256032"/>
           </a:xfrm>
           <a:prstGeom prst="ellipse">
@@ -9157,7 +9157,7 @@
         </p:blipFill>
         <p:spPr>
           <a:xfrm>
-            <a:off x="6931152" y="4507992"/>
+            <a:off x="6931152" y="4453128"/>
             <a:ext cx="201168" cy="201168"/>
           </a:xfrm>
           <a:prstGeom prst="rect">
@@ -9173,7 +9173,7 @@
         </p:nvSpPr>
         <p:spPr>
           <a:xfrm>
-            <a:off x="7269480" y="4475988"/>
+            <a:off x="7269480" y="4421124"/>
             <a:ext cx="2103120" cy="274320"/>
           </a:xfrm>
           <a:prstGeom prst="rect">
@@ -9208,7 +9208,7 @@
         </p:nvSpPr>
         <p:spPr>
           <a:xfrm>
-            <a:off x="9372600" y="4475988"/>
+            <a:off x="9372600" y="4421124"/>
             <a:ext cx="685800" cy="274320"/>
           </a:xfrm>
           <a:prstGeom prst="rect">
@@ -9243,7 +9243,7 @@
         </p:nvSpPr>
         <p:spPr>
           <a:xfrm>
-            <a:off x="10058400" y="4489703"/>
+            <a:off x="10058400" y="4434840"/>
             <a:ext cx="685800" cy="274320"/>
           </a:xfrm>
           <a:prstGeom prst="rect">
@@ -9265,7 +9265,7 @@
                 </a:solidFill>
                 <a:latin typeface="Arial"/>
               </a:rPr>
-              <a:t>-2.7</a:t>
+              <a:t>-0.8</a:t>
             </a:r>
           </a:p>
         </p:txBody>
@@ -9278,7 +9278,7 @@
         </p:nvSpPr>
         <p:spPr>
           <a:xfrm>
-            <a:off x="10744200" y="4489703"/>
+            <a:off x="10744200" y="4434840"/>
             <a:ext cx="594360" cy="274320"/>
           </a:xfrm>
           <a:prstGeom prst="rect">
@@ -9313,7 +9313,7 @@
         </p:nvSpPr>
         <p:spPr>
           <a:xfrm>
-            <a:off x="6373368" y="4805172"/>
+            <a:off x="6373368" y="4741164"/>
             <a:ext cx="411480" cy="274320"/>
           </a:xfrm>
           <a:prstGeom prst="rect">
@@ -9348,7 +9348,7 @@
         </p:nvSpPr>
         <p:spPr>
           <a:xfrm>
-            <a:off x="6903720" y="4809744"/>
+            <a:off x="6903720" y="4745736"/>
             <a:ext cx="256032" cy="256032"/>
           </a:xfrm>
           <a:prstGeom prst="ellipse">
@@ -9400,7 +9400,7 @@
         </p:blipFill>
         <p:spPr>
           <a:xfrm>
-            <a:off x="6931152" y="4837176"/>
+            <a:off x="6931152" y="4773168"/>
             <a:ext cx="201168" cy="201168"/>
           </a:xfrm>
           <a:prstGeom prst="rect">
@@ -9416,7 +9416,7 @@
         </p:nvSpPr>
         <p:spPr>
           <a:xfrm>
-            <a:off x="7269480" y="4805172"/>
+            <a:off x="7269480" y="4741164"/>
             <a:ext cx="2103120" cy="274320"/>
           </a:xfrm>
           <a:prstGeom prst="rect">
@@ -9451,7 +9451,7 @@
         </p:nvSpPr>
         <p:spPr>
           <a:xfrm>
-            <a:off x="9372600" y="4805172"/>
+            <a:off x="9372600" y="4741164"/>
             <a:ext cx="685800" cy="274320"/>
           </a:xfrm>
           <a:prstGeom prst="rect">
@@ -9486,7 +9486,7 @@
         </p:nvSpPr>
         <p:spPr>
           <a:xfrm>
-            <a:off x="10058400" y="4818888"/>
+            <a:off x="10058400" y="4754880"/>
             <a:ext cx="685800" cy="274320"/>
           </a:xfrm>
           <a:prstGeom prst="rect">
@@ -9504,11 +9504,11 @@
             <a:r>
               <a:rPr sz="1100" b="1" i="0">
                 <a:solidFill>
-                  <a:srgbClr val="5CD68A"/>
-                </a:solidFill>
-                <a:latin typeface="Arial"/>
-              </a:rPr>
-              <a:t>+0.1</a:t>
+                  <a:srgbClr val="FF7A7A"/>
+                </a:solidFill>
+                <a:latin typeface="Arial"/>
+              </a:rPr>
+              <a:t>-0.4</a:t>
             </a:r>
           </a:p>
         </p:txBody>
@@ -9521,7 +9521,7 @@
         </p:nvSpPr>
         <p:spPr>
           <a:xfrm>
-            <a:off x="10744200" y="4818888"/>
+            <a:off x="10744200" y="4754880"/>
             <a:ext cx="594360" cy="274320"/>
           </a:xfrm>
           <a:prstGeom prst="rect">
@@ -9556,8 +9556,8 @@
         </p:nvSpPr>
         <p:spPr>
           <a:xfrm>
-            <a:off x="6355080" y="5102352"/>
-            <a:ext cx="5029200" cy="329184"/>
+            <a:off x="6355080" y="5029200"/>
+            <a:ext cx="5029200" cy="320040"/>
           </a:xfrm>
           <a:prstGeom prst="rect">
             <a:avLst/>
@@ -9600,7 +9600,7 @@
         </p:nvSpPr>
         <p:spPr>
           <a:xfrm>
-            <a:off x="6373368" y="5134356"/>
+            <a:off x="6373368" y="5061204"/>
             <a:ext cx="411480" cy="274320"/>
           </a:xfrm>
           <a:prstGeom prst="rect">
@@ -9635,7 +9635,7 @@
         </p:nvSpPr>
         <p:spPr>
           <a:xfrm>
-            <a:off x="6903720" y="5138928"/>
+            <a:off x="6903720" y="5065776"/>
             <a:ext cx="256032" cy="256032"/>
           </a:xfrm>
           <a:prstGeom prst="ellipse">
@@ -9687,7 +9687,7 @@
         </p:blipFill>
         <p:spPr>
           <a:xfrm>
-            <a:off x="6931152" y="5166360"/>
+            <a:off x="6931152" y="5093208"/>
             <a:ext cx="201168" cy="201168"/>
           </a:xfrm>
           <a:prstGeom prst="rect">
@@ -9703,7 +9703,7 @@
         </p:nvSpPr>
         <p:spPr>
           <a:xfrm>
-            <a:off x="7269480" y="5134356"/>
+            <a:off x="7269480" y="5061204"/>
             <a:ext cx="2103120" cy="274320"/>
           </a:xfrm>
           <a:prstGeom prst="rect">
@@ -9738,7 +9738,7 @@
         </p:nvSpPr>
         <p:spPr>
           <a:xfrm>
-            <a:off x="9372600" y="5134356"/>
+            <a:off x="9372600" y="5061204"/>
             <a:ext cx="685800" cy="274320"/>
           </a:xfrm>
           <a:prstGeom prst="rect">
@@ -9773,7 +9773,7 @@
         </p:nvSpPr>
         <p:spPr>
           <a:xfrm>
-            <a:off x="10058400" y="5148072"/>
+            <a:off x="10058400" y="5074920"/>
             <a:ext cx="685800" cy="274320"/>
           </a:xfrm>
           <a:prstGeom prst="rect">
@@ -9791,11 +9791,11 @@
             <a:r>
               <a:rPr sz="1100" b="1" i="0">
                 <a:solidFill>
-                  <a:srgbClr val="5CD68A"/>
-                </a:solidFill>
-                <a:latin typeface="Arial"/>
-              </a:rPr>
-              <a:t>+0.4</a:t>
+                  <a:srgbClr val="FF7A7A"/>
+                </a:solidFill>
+                <a:latin typeface="Arial"/>
+              </a:rPr>
+              <a:t>-1.4</a:t>
             </a:r>
           </a:p>
         </p:txBody>
@@ -9808,7 +9808,7 @@
         </p:nvSpPr>
         <p:spPr>
           <a:xfrm>
-            <a:off x="10744200" y="5148072"/>
+            <a:off x="10744200" y="5074920"/>
             <a:ext cx="594360" cy="274320"/>
           </a:xfrm>
           <a:prstGeom prst="rect">
@@ -9843,7 +9843,7 @@
         </p:nvSpPr>
         <p:spPr>
           <a:xfrm>
-            <a:off x="6373368" y="5463540"/>
+            <a:off x="6373368" y="5381244"/>
             <a:ext cx="411480" cy="274320"/>
           </a:xfrm>
           <a:prstGeom prst="rect">
@@ -9878,7 +9878,7 @@
         </p:nvSpPr>
         <p:spPr>
           <a:xfrm>
-            <a:off x="6903720" y="5468112"/>
+            <a:off x="6903720" y="5385816"/>
             <a:ext cx="256032" cy="256032"/>
           </a:xfrm>
           <a:prstGeom prst="ellipse">
@@ -9930,7 +9930,7 @@
         </p:blipFill>
         <p:spPr>
           <a:xfrm>
-            <a:off x="6931152" y="5495544"/>
+            <a:off x="6931152" y="5413248"/>
             <a:ext cx="201168" cy="201168"/>
           </a:xfrm>
           <a:prstGeom prst="rect">
@@ -9946,7 +9946,7 @@
         </p:nvSpPr>
         <p:spPr>
           <a:xfrm>
-            <a:off x="7269480" y="5463540"/>
+            <a:off x="7269480" y="5381244"/>
             <a:ext cx="2103120" cy="274320"/>
           </a:xfrm>
           <a:prstGeom prst="rect">
@@ -9981,7 +9981,7 @@
         </p:nvSpPr>
         <p:spPr>
           <a:xfrm>
-            <a:off x="9372600" y="5463540"/>
+            <a:off x="9372600" y="5381244"/>
             <a:ext cx="685800" cy="274320"/>
           </a:xfrm>
           <a:prstGeom prst="rect">
@@ -10016,7 +10016,7 @@
         </p:nvSpPr>
         <p:spPr>
           <a:xfrm>
-            <a:off x="10058400" y="5477255"/>
+            <a:off x="10058400" y="5394959"/>
             <a:ext cx="685800" cy="274320"/>
           </a:xfrm>
           <a:prstGeom prst="rect">
@@ -10038,7 +10038,7 @@
                 </a:solidFill>
                 <a:latin typeface="Arial"/>
               </a:rPr>
-              <a:t>+2.7</a:t>
+              <a:t>+2.1</a:t>
             </a:r>
           </a:p>
         </p:txBody>
@@ -10051,7 +10051,7 @@
         </p:nvSpPr>
         <p:spPr>
           <a:xfrm>
-            <a:off x="10744200" y="5477255"/>
+            <a:off x="10744200" y="5394959"/>
             <a:ext cx="594360" cy="274320"/>
           </a:xfrm>
           <a:prstGeom prst="rect">
@@ -10086,8 +10086,8 @@
         </p:nvSpPr>
         <p:spPr>
           <a:xfrm>
-            <a:off x="822960" y="6163056"/>
-            <a:ext cx="10561320" cy="566928"/>
+            <a:off x="822960" y="6062472"/>
+            <a:ext cx="10561320" cy="749808"/>
           </a:xfrm>
           <a:prstGeom prst="roundRect">
             <a:avLst/>
@@ -10130,8 +10130,8 @@
         </p:nvSpPr>
         <p:spPr>
           <a:xfrm>
-            <a:off x="1005840" y="6208776"/>
-            <a:ext cx="10241280" cy="256032"/>
+            <a:off x="1005840" y="6089904"/>
+            <a:ext cx="10241280" cy="219456"/>
           </a:xfrm>
           <a:prstGeom prst="rect">
             <a:avLst/>
@@ -10146,9 +10146,79 @@
           <a:p>
             <a:pPr algn="l"/>
             <a:r>
-              <a:rPr sz="1100" b="1" i="0">
-                <a:solidFill>
-                  <a:srgbClr val="FFFFFF"/>
+              <a:rPr sz="1000" b="1" i="0">
+                <a:solidFill>
+                  <a:srgbClr val="5CD68A"/>
+                </a:solidFill>
+                <a:latin typeface="Arial"/>
+              </a:rPr>
+              <a:t>Biggest moves this week — up: Ole Miss +2.7 #18→#12 · Mississippi State +2.6 #25→#18 · Utah +2.2 #23→#16</a:t>
+            </a:r>
+          </a:p>
+        </p:txBody>
+      </p:sp>
+      <p:sp>
+        <p:nvSpPr>
+          <p:cNvPr id="201" name="TextBox 200"/>
+          <p:cNvSpPr txBox="1"/>
+          <p:nvPr/>
+        </p:nvSpPr>
+        <p:spPr>
+          <a:xfrm>
+            <a:off x="1005840" y="6263640"/>
+            <a:ext cx="10241280" cy="219456"/>
+          </a:xfrm>
+          <a:prstGeom prst="rect">
+            <a:avLst/>
+          </a:prstGeom>
+          <a:noFill/>
+        </p:spPr>
+        <p:txBody>
+          <a:bodyPr wrap="square" lIns="0" rIns="0" tIns="0" bIns="0">
+            <a:spAutoFit/>
+          </a:bodyPr>
+          <a:lstStyle/>
+          <a:p>
+            <a:pPr algn="l"/>
+            <a:r>
+              <a:rPr sz="1000" b="1" i="0">
+                <a:solidFill>
+                  <a:srgbClr val="FF7A7A"/>
+                </a:solidFill>
+                <a:latin typeface="Arial"/>
+              </a:rPr>
+              <a:t>Down: Texas A&amp;M -5.3 #8→#9 · South Carolina -2.4 #15→#20 · USC -2.1 #17→#19</a:t>
+            </a:r>
+          </a:p>
+        </p:txBody>
+      </p:sp>
+      <p:sp>
+        <p:nvSpPr>
+          <p:cNvPr id="202" name="TextBox 201"/>
+          <p:cNvSpPr txBox="1"/>
+          <p:nvPr/>
+        </p:nvSpPr>
+        <p:spPr>
+          <a:xfrm>
+            <a:off x="1005840" y="6437376"/>
+            <a:ext cx="10241280" cy="201168"/>
+          </a:xfrm>
+          <a:prstGeom prst="rect">
+            <a:avLst/>
+          </a:prstGeom>
+          <a:noFill/>
+        </p:spPr>
+        <p:txBody>
+          <a:bodyPr wrap="square" lIns="0" rIns="0" tIns="0" bIns="0">
+            <a:spAutoFit/>
+          </a:bodyPr>
+          <a:lstStyle/>
+          <a:p>
+            <a:pPr algn="l"/>
+            <a:r>
+              <a:rPr sz="900" b="1" i="0">
+                <a:solidFill>
+                  <a:srgbClr val="CADCFC"/>
                 </a:solidFill>
                 <a:latin typeface="Arial"/>
               </a:rPr>
@@ -10159,14 +10229,14 @@
       </p:sp>
       <p:sp>
         <p:nvSpPr>
-          <p:cNvPr id="201" name="TextBox 200"/>
-          <p:cNvSpPr txBox="1"/>
-          <p:nvPr/>
-        </p:nvSpPr>
-        <p:spPr>
-          <a:xfrm>
-            <a:off x="1005840" y="6455664"/>
-            <a:ext cx="10241280" cy="256032"/>
+          <p:cNvPr id="203" name="TextBox 202"/>
+          <p:cNvSpPr txBox="1"/>
+          <p:nvPr/>
+        </p:nvSpPr>
+        <p:spPr>
+          <a:xfrm>
+            <a:off x="1005840" y="6601968"/>
+            <a:ext cx="10241280" cy="201168"/>
           </a:xfrm>
           <a:prstGeom prst="rect">
             <a:avLst/>
@@ -10181,7 +10251,7 @@
           <a:p>
             <a:pPr algn="l"/>
             <a:r>
-              <a:rPr sz="1050" b="0" i="0">
+              <a:rPr sz="900" b="0" i="0">
                 <a:solidFill>
                   <a:srgbClr val="CADCFC"/>
                 </a:solidFill>
@@ -32736,7 +32806,660 @@
       </p:sp>
       <p:sp>
         <p:nvSpPr>
-          <p:cNvPr id="10" name="Rounded Rectangle 9"/>
+          <p:cNvPr id="10" name="Oval 9"/>
+          <p:cNvSpPr/>
+          <p:nvPr/>
+        </p:nvSpPr>
+        <p:spPr>
+          <a:xfrm>
+            <a:off x="868680" y="2944368"/>
+            <a:ext cx="128016" cy="128016"/>
+          </a:xfrm>
+          <a:prstGeom prst="ellipse">
+            <a:avLst/>
+          </a:prstGeom>
+          <a:solidFill>
+            <a:srgbClr val="F47321"/>
+          </a:solidFill>
+          <a:ln>
+            <a:noFill/>
+          </a:ln>
+          <a:effectLst/>
+        </p:spPr>
+        <p:style>
+          <a:lnRef idx="1">
+            <a:schemeClr val="accent1"/>
+          </a:lnRef>
+          <a:fillRef idx="3">
+            <a:schemeClr val="accent1"/>
+          </a:fillRef>
+          <a:effectRef idx="2">
+            <a:schemeClr val="accent1"/>
+          </a:effectRef>
+          <a:fontRef idx="minor">
+            <a:schemeClr val="lt1"/>
+          </a:fontRef>
+        </p:style>
+        <p:txBody>
+          <a:bodyPr rtlCol="0" anchor="ctr"/>
+          <a:lstStyle/>
+          <a:p>
+            <a:pPr algn="ctr"/>
+          </a:p>
+        </p:txBody>
+      </p:sp>
+      <p:sp>
+        <p:nvSpPr>
+          <p:cNvPr id="11" name="TextBox 10"/>
+          <p:cNvSpPr txBox="1"/>
+          <p:nvPr/>
+        </p:nvSpPr>
+        <p:spPr>
+          <a:xfrm>
+            <a:off x="1188720" y="2770632"/>
+            <a:ext cx="6217920" cy="822960"/>
+          </a:xfrm>
+          <a:prstGeom prst="rect">
+            <a:avLst/>
+          </a:prstGeom>
+          <a:noFill/>
+        </p:spPr>
+        <p:txBody>
+          <a:bodyPr wrap="square" lIns="0" rIns="0" tIns="0" bIns="0">
+            <a:spAutoFit/>
+          </a:bodyPr>
+          <a:lstStyle/>
+          <a:p>
+            <a:pPr algn="l"/>
+            <a:r>
+              <a:rPr sz="2400" b="1" i="0">
+                <a:solidFill>
+                  <a:srgbClr val="16273D"/>
+                </a:solidFill>
+                <a:latin typeface="Arial"/>
+              </a:rPr>
+              <a:t>The Machine’s Rankings</a:t>
+            </a:r>
+          </a:p>
+        </p:txBody>
+      </p:sp>
+      <p:sp>
+        <p:nvSpPr>
+          <p:cNvPr id="12" name="Rectangle 11"/>
+          <p:cNvSpPr/>
+          <p:nvPr/>
+        </p:nvSpPr>
+        <p:spPr>
+          <a:xfrm>
+            <a:off x="1051560" y="3465576"/>
+            <a:ext cx="6400800" cy="329184"/>
+          </a:xfrm>
+          <a:prstGeom prst="rect">
+            <a:avLst/>
+          </a:prstGeom>
+          <a:solidFill>
+            <a:srgbClr val="123568"/>
+          </a:solidFill>
+          <a:ln>
+            <a:noFill/>
+          </a:ln>
+          <a:effectLst/>
+        </p:spPr>
+        <p:style>
+          <a:lnRef idx="1">
+            <a:schemeClr val="accent1"/>
+          </a:lnRef>
+          <a:fillRef idx="3">
+            <a:schemeClr val="accent1"/>
+          </a:fillRef>
+          <a:effectRef idx="2">
+            <a:schemeClr val="accent1"/>
+          </a:effectRef>
+          <a:fontRef idx="minor">
+            <a:schemeClr val="lt1"/>
+          </a:fontRef>
+        </p:style>
+        <p:txBody>
+          <a:bodyPr rtlCol="0" anchor="ctr"/>
+          <a:lstStyle/>
+          <a:p>
+            <a:pPr algn="ctr"/>
+          </a:p>
+        </p:txBody>
+      </p:sp>
+      <p:sp>
+        <p:nvSpPr>
+          <p:cNvPr id="13" name="TextBox 12"/>
+          <p:cNvSpPr txBox="1"/>
+          <p:nvPr/>
+        </p:nvSpPr>
+        <p:spPr>
+          <a:xfrm>
+            <a:off x="1069848" y="3497580"/>
+            <a:ext cx="411480" cy="274320"/>
+          </a:xfrm>
+          <a:prstGeom prst="rect">
+            <a:avLst/>
+          </a:prstGeom>
+          <a:noFill/>
+        </p:spPr>
+        <p:txBody>
+          <a:bodyPr wrap="square" lIns="0" rIns="0" tIns="0" bIns="0">
+            <a:spAutoFit/>
+          </a:bodyPr>
+          <a:lstStyle/>
+          <a:p>
+            <a:pPr algn="r"/>
+            <a:r>
+              <a:rPr sz="1300" b="1" i="0">
+                <a:solidFill>
+                  <a:srgbClr val="F47321"/>
+                </a:solidFill>
+                <a:latin typeface="Arial"/>
+              </a:rPr>
+              <a:t>11</a:t>
+            </a:r>
+          </a:p>
+        </p:txBody>
+      </p:sp>
+      <p:sp>
+        <p:nvSpPr>
+          <p:cNvPr id="14" name="Oval 13"/>
+          <p:cNvSpPr/>
+          <p:nvPr/>
+        </p:nvSpPr>
+        <p:spPr>
+          <a:xfrm>
+            <a:off x="1600200" y="3502152"/>
+            <a:ext cx="256032" cy="256032"/>
+          </a:xfrm>
+          <a:prstGeom prst="ellipse">
+            <a:avLst/>
+          </a:prstGeom>
+          <a:solidFill>
+            <a:srgbClr val="FFFFFF"/>
+          </a:solidFill>
+          <a:ln>
+            <a:noFill/>
+          </a:ln>
+          <a:effectLst/>
+        </p:spPr>
+        <p:style>
+          <a:lnRef idx="1">
+            <a:schemeClr val="accent1"/>
+          </a:lnRef>
+          <a:fillRef idx="3">
+            <a:schemeClr val="accent1"/>
+          </a:fillRef>
+          <a:effectRef idx="2">
+            <a:schemeClr val="accent1"/>
+          </a:effectRef>
+          <a:fontRef idx="minor">
+            <a:schemeClr val="lt1"/>
+          </a:fontRef>
+        </p:style>
+        <p:txBody>
+          <a:bodyPr rtlCol="0" anchor="ctr"/>
+          <a:lstStyle/>
+          <a:p>
+            <a:pPr algn="ctr"/>
+          </a:p>
+        </p:txBody>
+      </p:sp>
+      <p:pic>
+        <p:nvPicPr>
+          <p:cNvPr id="15" name="Picture 14" descr="florida.png"/>
+          <p:cNvPicPr>
+            <a:picLocks noChangeAspect="1"/>
+          </p:cNvPicPr>
+          <p:nvPr/>
+        </p:nvPicPr>
+        <p:blipFill>
+          <a:blip r:embed="rId3"/>
+          <a:stretch>
+            <a:fillRect/>
+          </a:stretch>
+        </p:blipFill>
+        <p:spPr>
+          <a:xfrm>
+            <a:off x="1627632" y="3529584"/>
+            <a:ext cx="201168" cy="201168"/>
+          </a:xfrm>
+          <a:prstGeom prst="rect">
+            <a:avLst/>
+          </a:prstGeom>
+        </p:spPr>
+      </p:pic>
+      <p:sp>
+        <p:nvSpPr>
+          <p:cNvPr id="16" name="TextBox 15"/>
+          <p:cNvSpPr txBox="1"/>
+          <p:nvPr/>
+        </p:nvSpPr>
+        <p:spPr>
+          <a:xfrm>
+            <a:off x="1965960" y="3497580"/>
+            <a:ext cx="2560320" cy="274320"/>
+          </a:xfrm>
+          <a:prstGeom prst="rect">
+            <a:avLst/>
+          </a:prstGeom>
+          <a:noFill/>
+        </p:spPr>
+        <p:txBody>
+          <a:bodyPr wrap="square" lIns="0" rIns="0" tIns="0" bIns="0">
+            <a:spAutoFit/>
+          </a:bodyPr>
+          <a:lstStyle/>
+          <a:p>
+            <a:pPr algn="l"/>
+            <a:r>
+              <a:rPr sz="1250" b="1" i="0">
+                <a:solidFill>
+                  <a:srgbClr val="FFFFFF"/>
+                </a:solidFill>
+                <a:latin typeface="Arial"/>
+              </a:rPr>
+              <a:t>Florida</a:t>
+            </a:r>
+          </a:p>
+        </p:txBody>
+      </p:sp>
+      <p:sp>
+        <p:nvSpPr>
+          <p:cNvPr id="17" name="TextBox 16"/>
+          <p:cNvSpPr txBox="1"/>
+          <p:nvPr/>
+        </p:nvSpPr>
+        <p:spPr>
+          <a:xfrm>
+            <a:off x="4480560" y="3497580"/>
+            <a:ext cx="822960" cy="274320"/>
+          </a:xfrm>
+          <a:prstGeom prst="rect">
+            <a:avLst/>
+          </a:prstGeom>
+          <a:noFill/>
+        </p:spPr>
+        <p:txBody>
+          <a:bodyPr wrap="square" lIns="0" rIns="0" tIns="0" bIns="0">
+            <a:spAutoFit/>
+          </a:bodyPr>
+          <a:lstStyle/>
+          <a:p>
+            <a:pPr algn="r"/>
+            <a:r>
+              <a:rPr sz="1250" b="0" i="0">
+                <a:solidFill>
+                  <a:srgbClr val="FFFFFF"/>
+                </a:solidFill>
+                <a:latin typeface="Arial"/>
+              </a:rPr>
+              <a:t>18.5</a:t>
+            </a:r>
+          </a:p>
+        </p:txBody>
+      </p:sp>
+      <p:sp>
+        <p:nvSpPr>
+          <p:cNvPr id="18" name="TextBox 17"/>
+          <p:cNvSpPr txBox="1"/>
+          <p:nvPr/>
+        </p:nvSpPr>
+        <p:spPr>
+          <a:xfrm>
+            <a:off x="5349240" y="3511296"/>
+            <a:ext cx="822960" cy="274320"/>
+          </a:xfrm>
+          <a:prstGeom prst="rect">
+            <a:avLst/>
+          </a:prstGeom>
+          <a:noFill/>
+        </p:spPr>
+        <p:txBody>
+          <a:bodyPr wrap="square" lIns="0" rIns="0" tIns="0" bIns="0">
+            <a:spAutoFit/>
+          </a:bodyPr>
+          <a:lstStyle/>
+          <a:p>
+            <a:pPr algn="r"/>
+            <a:r>
+              <a:rPr sz="1100" b="1" i="0">
+                <a:solidFill>
+                  <a:srgbClr val="5CD68A"/>
+                </a:solidFill>
+                <a:latin typeface="Arial"/>
+              </a:rPr>
+              <a:t>+0.6</a:t>
+            </a:r>
+          </a:p>
+        </p:txBody>
+      </p:sp>
+      <p:sp>
+        <p:nvSpPr>
+          <p:cNvPr id="19" name="TextBox 18"/>
+          <p:cNvSpPr txBox="1"/>
+          <p:nvPr/>
+        </p:nvSpPr>
+        <p:spPr>
+          <a:xfrm>
+            <a:off x="6263640" y="3511296"/>
+            <a:ext cx="1051560" cy="274320"/>
+          </a:xfrm>
+          <a:prstGeom prst="rect">
+            <a:avLst/>
+          </a:prstGeom>
+          <a:noFill/>
+        </p:spPr>
+        <p:txBody>
+          <a:bodyPr wrap="square" lIns="0" rIns="0" tIns="0" bIns="0">
+            <a:spAutoFit/>
+          </a:bodyPr>
+          <a:lstStyle/>
+          <a:p>
+            <a:pPr algn="r"/>
+            <a:r>
+              <a:rPr sz="1000" b="0" i="0">
+                <a:solidFill>
+                  <a:srgbClr val="CADCFC"/>
+                </a:solidFill>
+                <a:latin typeface="Arial"/>
+              </a:rPr>
+              <a:t>AP 21</a:t>
+            </a:r>
+          </a:p>
+        </p:txBody>
+      </p:sp>
+      <p:sp>
+        <p:nvSpPr>
+          <p:cNvPr id="20" name="Rectangle 19"/>
+          <p:cNvSpPr/>
+          <p:nvPr/>
+        </p:nvSpPr>
+        <p:spPr>
+          <a:xfrm>
+            <a:off x="1051560" y="3803904"/>
+            <a:ext cx="6400800" cy="329184"/>
+          </a:xfrm>
+          <a:prstGeom prst="rect">
+            <a:avLst/>
+          </a:prstGeom>
+          <a:solidFill>
+            <a:srgbClr val="123568"/>
+          </a:solidFill>
+          <a:ln>
+            <a:noFill/>
+          </a:ln>
+          <a:effectLst/>
+        </p:spPr>
+        <p:style>
+          <a:lnRef idx="1">
+            <a:schemeClr val="accent1"/>
+          </a:lnRef>
+          <a:fillRef idx="3">
+            <a:schemeClr val="accent1"/>
+          </a:fillRef>
+          <a:effectRef idx="2">
+            <a:schemeClr val="accent1"/>
+          </a:effectRef>
+          <a:fontRef idx="minor">
+            <a:schemeClr val="lt1"/>
+          </a:fontRef>
+        </p:style>
+        <p:txBody>
+          <a:bodyPr rtlCol="0" anchor="ctr"/>
+          <a:lstStyle/>
+          <a:p>
+            <a:pPr algn="ctr"/>
+          </a:p>
+        </p:txBody>
+      </p:sp>
+      <p:sp>
+        <p:nvSpPr>
+          <p:cNvPr id="21" name="TextBox 20"/>
+          <p:cNvSpPr txBox="1"/>
+          <p:nvPr/>
+        </p:nvSpPr>
+        <p:spPr>
+          <a:xfrm>
+            <a:off x="1069848" y="3835908"/>
+            <a:ext cx="411480" cy="274320"/>
+          </a:xfrm>
+          <a:prstGeom prst="rect">
+            <a:avLst/>
+          </a:prstGeom>
+          <a:noFill/>
+        </p:spPr>
+        <p:txBody>
+          <a:bodyPr wrap="square" lIns="0" rIns="0" tIns="0" bIns="0">
+            <a:spAutoFit/>
+          </a:bodyPr>
+          <a:lstStyle/>
+          <a:p>
+            <a:pPr algn="r"/>
+            <a:r>
+              <a:rPr sz="1300" b="1" i="0">
+                <a:solidFill>
+                  <a:srgbClr val="F47321"/>
+                </a:solidFill>
+                <a:latin typeface="Arial"/>
+              </a:rPr>
+              <a:t>12</a:t>
+            </a:r>
+          </a:p>
+        </p:txBody>
+      </p:sp>
+      <p:sp>
+        <p:nvSpPr>
+          <p:cNvPr id="22" name="Oval 21"/>
+          <p:cNvSpPr/>
+          <p:nvPr/>
+        </p:nvSpPr>
+        <p:spPr>
+          <a:xfrm>
+            <a:off x="1600200" y="3840480"/>
+            <a:ext cx="256032" cy="256032"/>
+          </a:xfrm>
+          <a:prstGeom prst="ellipse">
+            <a:avLst/>
+          </a:prstGeom>
+          <a:solidFill>
+            <a:srgbClr val="FFFFFF"/>
+          </a:solidFill>
+          <a:ln>
+            <a:noFill/>
+          </a:ln>
+          <a:effectLst/>
+        </p:spPr>
+        <p:style>
+          <a:lnRef idx="1">
+            <a:schemeClr val="accent1"/>
+          </a:lnRef>
+          <a:fillRef idx="3">
+            <a:schemeClr val="accent1"/>
+          </a:fillRef>
+          <a:effectRef idx="2">
+            <a:schemeClr val="accent1"/>
+          </a:effectRef>
+          <a:fontRef idx="minor">
+            <a:schemeClr val="lt1"/>
+          </a:fontRef>
+        </p:style>
+        <p:txBody>
+          <a:bodyPr rtlCol="0" anchor="ctr"/>
+          <a:lstStyle/>
+          <a:p>
+            <a:pPr algn="ctr"/>
+          </a:p>
+        </p:txBody>
+      </p:sp>
+      <p:pic>
+        <p:nvPicPr>
+          <p:cNvPr id="23" name="Picture 22" descr="olemiss.png"/>
+          <p:cNvPicPr>
+            <a:picLocks noChangeAspect="1"/>
+          </p:cNvPicPr>
+          <p:nvPr/>
+        </p:nvPicPr>
+        <p:blipFill>
+          <a:blip r:embed="rId2"/>
+          <a:stretch>
+            <a:fillRect/>
+          </a:stretch>
+        </p:blipFill>
+        <p:spPr>
+          <a:xfrm>
+            <a:off x="1627632" y="3867912"/>
+            <a:ext cx="201168" cy="201168"/>
+          </a:xfrm>
+          <a:prstGeom prst="rect">
+            <a:avLst/>
+          </a:prstGeom>
+        </p:spPr>
+      </p:pic>
+      <p:sp>
+        <p:nvSpPr>
+          <p:cNvPr id="24" name="TextBox 23"/>
+          <p:cNvSpPr txBox="1"/>
+          <p:nvPr/>
+        </p:nvSpPr>
+        <p:spPr>
+          <a:xfrm>
+            <a:off x="1965960" y="3835908"/>
+            <a:ext cx="2560320" cy="274320"/>
+          </a:xfrm>
+          <a:prstGeom prst="rect">
+            <a:avLst/>
+          </a:prstGeom>
+          <a:noFill/>
+        </p:spPr>
+        <p:txBody>
+          <a:bodyPr wrap="square" lIns="0" rIns="0" tIns="0" bIns="0">
+            <a:spAutoFit/>
+          </a:bodyPr>
+          <a:lstStyle/>
+          <a:p>
+            <a:pPr algn="l"/>
+            <a:r>
+              <a:rPr sz="1250" b="1" i="0">
+                <a:solidFill>
+                  <a:srgbClr val="FFFFFF"/>
+                </a:solidFill>
+                <a:latin typeface="Arial"/>
+              </a:rPr>
+              <a:t>Ole Miss</a:t>
+            </a:r>
+          </a:p>
+        </p:txBody>
+      </p:sp>
+      <p:sp>
+        <p:nvSpPr>
+          <p:cNvPr id="25" name="TextBox 24"/>
+          <p:cNvSpPr txBox="1"/>
+          <p:nvPr/>
+        </p:nvSpPr>
+        <p:spPr>
+          <a:xfrm>
+            <a:off x="4480560" y="3835908"/>
+            <a:ext cx="822960" cy="274320"/>
+          </a:xfrm>
+          <a:prstGeom prst="rect">
+            <a:avLst/>
+          </a:prstGeom>
+          <a:noFill/>
+        </p:spPr>
+        <p:txBody>
+          <a:bodyPr wrap="square" lIns="0" rIns="0" tIns="0" bIns="0">
+            <a:spAutoFit/>
+          </a:bodyPr>
+          <a:lstStyle/>
+          <a:p>
+            <a:pPr algn="r"/>
+            <a:r>
+              <a:rPr sz="1250" b="0" i="0">
+                <a:solidFill>
+                  <a:srgbClr val="FFFFFF"/>
+                </a:solidFill>
+                <a:latin typeface="Arial"/>
+              </a:rPr>
+              <a:t>17.9</a:t>
+            </a:r>
+          </a:p>
+        </p:txBody>
+      </p:sp>
+      <p:sp>
+        <p:nvSpPr>
+          <p:cNvPr id="26" name="TextBox 25"/>
+          <p:cNvSpPr txBox="1"/>
+          <p:nvPr/>
+        </p:nvSpPr>
+        <p:spPr>
+          <a:xfrm>
+            <a:off x="5349240" y="3849624"/>
+            <a:ext cx="822960" cy="274320"/>
+          </a:xfrm>
+          <a:prstGeom prst="rect">
+            <a:avLst/>
+          </a:prstGeom>
+          <a:noFill/>
+        </p:spPr>
+        <p:txBody>
+          <a:bodyPr wrap="square" lIns="0" rIns="0" tIns="0" bIns="0">
+            <a:spAutoFit/>
+          </a:bodyPr>
+          <a:lstStyle/>
+          <a:p>
+            <a:pPr algn="r"/>
+            <a:r>
+              <a:rPr sz="1100" b="1" i="0">
+                <a:solidFill>
+                  <a:srgbClr val="5CD68A"/>
+                </a:solidFill>
+                <a:latin typeface="Arial"/>
+              </a:rPr>
+              <a:t>+2.7</a:t>
+            </a:r>
+          </a:p>
+        </p:txBody>
+      </p:sp>
+      <p:sp>
+        <p:nvSpPr>
+          <p:cNvPr id="27" name="TextBox 26"/>
+          <p:cNvSpPr txBox="1"/>
+          <p:nvPr/>
+        </p:nvSpPr>
+        <p:spPr>
+          <a:xfrm>
+            <a:off x="6263640" y="3849624"/>
+            <a:ext cx="1051560" cy="274320"/>
+          </a:xfrm>
+          <a:prstGeom prst="rect">
+            <a:avLst/>
+          </a:prstGeom>
+          <a:noFill/>
+        </p:spPr>
+        <p:txBody>
+          <a:bodyPr wrap="square" lIns="0" rIns="0" tIns="0" bIns="0">
+            <a:spAutoFit/>
+          </a:bodyPr>
+          <a:lstStyle/>
+          <a:p>
+            <a:pPr algn="r"/>
+            <a:r>
+              <a:rPr sz="1000" b="0" i="0">
+                <a:solidFill>
+                  <a:srgbClr val="CADCFC"/>
+                </a:solidFill>
+                <a:latin typeface="Arial"/>
+              </a:rPr>
+              <a:t>AP 4</a:t>
+            </a:r>
+          </a:p>
+        </p:txBody>
+      </p:sp>
+      <p:sp>
+        <p:nvSpPr>
+          <p:cNvPr id="28" name="Rounded Rectangle 27"/>
           <p:cNvSpPr/>
           <p:nvPr/>
         </p:nvSpPr>
@@ -32780,14 +33503,14 @@
       </p:sp>
       <p:sp>
         <p:nvSpPr>
-          <p:cNvPr id="11" name="TextBox 10"/>
-          <p:cNvSpPr txBox="1"/>
-          <p:nvPr/>
-        </p:nvSpPr>
-        <p:spPr>
-          <a:xfrm>
-            <a:off x="1051560" y="4983480"/>
-            <a:ext cx="6126480" cy="502920"/>
+          <p:cNvPr id="29" name="TextBox 28"/>
+          <p:cNvSpPr txBox="1"/>
+          <p:nvPr/>
+        </p:nvSpPr>
+        <p:spPr>
+          <a:xfrm>
+            <a:off x="1051560" y="4809744"/>
+            <a:ext cx="6126480" cy="868680"/>
           </a:xfrm>
           <a:prstGeom prst="rect">
             <a:avLst/>
@@ -32802,20 +33525,32 @@
           <a:p>
             <a:pPr algn="l"/>
             <a:r>
-              <a:rPr sz="2000" b="1" i="0">
+              <a:rPr sz="1400" b="1" i="0">
                 <a:solidFill>
                   <a:srgbClr val="0A2851"/>
                 </a:solidFill>
                 <a:latin typeface="Arial"/>
               </a:rPr>
-              <a:t>59% — a field-goal game between two 3–0 teams</a:t>
-            </a:r>
-          </a:p>
-        </p:txBody>
-      </p:sp>
-      <p:sp>
-        <p:nvSpPr>
-          <p:cNvPr id="12" name="Rounded Rectangle 11"/>
+              <a:t>The home team has won the last two.</a:t>
+            </a:r>
+          </a:p>
+          <a:p>
+            <a:pPr algn="l"/>
+            <a:r>
+              <a:rPr sz="1400" b="1" i="0">
+                <a:solidFill>
+                  <a:srgbClr val="0A2851"/>
+                </a:solidFill>
+                <a:latin typeface="Arial"/>
+              </a:rPr>
+              <a:t>Ole Miss 34–24 last year. Florida 24–17 in 2024 (the loss that kept Ole Miss out of the playoff).</a:t>
+            </a:r>
+          </a:p>
+        </p:txBody>
+      </p:sp>
+      <p:sp>
+        <p:nvSpPr>
+          <p:cNvPr id="30" name="Rounded Rectangle 29"/>
           <p:cNvSpPr/>
           <p:nvPr/>
         </p:nvSpPr>
@@ -32859,7 +33594,7 @@
       </p:sp>
       <p:sp>
         <p:nvSpPr>
-          <p:cNvPr id="13" name="TextBox 12"/>
+          <p:cNvPr id="31" name="TextBox 30"/>
           <p:cNvSpPr txBox="1"/>
           <p:nvPr/>
         </p:nvSpPr>
@@ -32894,7 +33629,7 @@
       </p:sp>
       <p:sp>
         <p:nvSpPr>
-          <p:cNvPr id="14" name="TextBox 13"/>
+          <p:cNvPr id="32" name="TextBox 31"/>
           <p:cNvSpPr txBox="1"/>
           <p:nvPr/>
         </p:nvSpPr>
@@ -32929,7 +33664,7 @@
       </p:sp>
       <p:sp>
         <p:nvSpPr>
-          <p:cNvPr id="15" name="TextBox 14"/>
+          <p:cNvPr id="33" name="TextBox 32"/>
           <p:cNvSpPr txBox="1"/>
           <p:nvPr/>
         </p:nvSpPr>
@@ -32964,7 +33699,7 @@
       </p:sp>
       <p:sp>
         <p:nvSpPr>
-          <p:cNvPr id="16" name="TextBox 15"/>
+          <p:cNvPr id="34" name="TextBox 33"/>
           <p:cNvSpPr txBox="1"/>
           <p:nvPr/>
         </p:nvSpPr>
@@ -32999,7 +33734,7 @@
       </p:sp>
       <p:sp>
         <p:nvSpPr>
-          <p:cNvPr id="17" name="TextBox 16"/>
+          <p:cNvPr id="35" name="TextBox 34"/>
           <p:cNvSpPr txBox="1"/>
           <p:nvPr/>
         </p:nvSpPr>
@@ -33034,7 +33769,7 @@
       </p:sp>
       <p:sp>
         <p:nvSpPr>
-          <p:cNvPr id="18" name="TextBox 17"/>
+          <p:cNvPr id="36" name="TextBox 35"/>
           <p:cNvSpPr txBox="1"/>
           <p:nvPr/>
         </p:nvSpPr>
@@ -33069,7 +33804,7 @@
       </p:sp>
       <p:sp>
         <p:nvSpPr>
-          <p:cNvPr id="19" name="TextBox 18"/>
+          <p:cNvPr id="37" name="TextBox 36"/>
           <p:cNvSpPr txBox="1"/>
           <p:nvPr/>
         </p:nvSpPr>
@@ -33104,7 +33839,7 @@
       </p:sp>
       <p:sp>
         <p:nvSpPr>
-          <p:cNvPr id="20" name="TextBox 19"/>
+          <p:cNvPr id="38" name="TextBox 37"/>
           <p:cNvSpPr txBox="1"/>
           <p:nvPr/>
         </p:nvSpPr>
@@ -33139,7 +33874,7 @@
       </p:sp>
       <p:sp>
         <p:nvSpPr>
-          <p:cNvPr id="21" name="Rounded Rectangle 20"/>
+          <p:cNvPr id="39" name="Rounded Rectangle 38"/>
           <p:cNvSpPr/>
           <p:nvPr/>
         </p:nvSpPr>
@@ -33183,7 +33918,7 @@
       </p:sp>
       <p:sp>
         <p:nvSpPr>
-          <p:cNvPr id="22" name="Rounded Rectangle 21"/>
+          <p:cNvPr id="40" name="Rounded Rectangle 39"/>
           <p:cNvSpPr/>
           <p:nvPr/>
         </p:nvSpPr>
@@ -33227,7 +33962,7 @@
       </p:sp>
       <p:sp>
         <p:nvSpPr>
-          <p:cNvPr id="23" name="TextBox 22"/>
+          <p:cNvPr id="41" name="TextBox 40"/>
           <p:cNvSpPr txBox="1"/>
           <p:nvPr/>
         </p:nvSpPr>
@@ -33262,7 +33997,7 @@
       </p:sp>
       <p:sp>
         <p:nvSpPr>
-          <p:cNvPr id="24" name="TextBox 23"/>
+          <p:cNvPr id="42" name="TextBox 41"/>
           <p:cNvSpPr txBox="1"/>
           <p:nvPr/>
         </p:nvSpPr>
@@ -33297,7 +34032,7 @@
       </p:sp>
       <p:sp>
         <p:nvSpPr>
-          <p:cNvPr id="25" name="TextBox 24"/>
+          <p:cNvPr id="43" name="TextBox 42"/>
           <p:cNvSpPr txBox="1"/>
           <p:nvPr/>
         </p:nvSpPr>

</xml_diff>

<commit_message>
Ep5 Ole Miss-Florida slide: series note as a third point, percentage line back in the honesty box (Lucas 9/22)
Co-Authored-By: Claude Fable 5.1 <noreply@anthropic.com>
</commit_message>
<xml_diff>
--- a/decks/2026_Week4_Episode5.pptx
+++ b/decks/2026_Week4_Episode5.pptx
@@ -32812,7 +32812,7 @@
         </p:nvSpPr>
         <p:spPr>
           <a:xfrm>
-            <a:off x="868680" y="2944368"/>
+            <a:off x="868680" y="2798064"/>
             <a:ext cx="128016" cy="128016"/>
           </a:xfrm>
           <a:prstGeom prst="ellipse">
@@ -32856,7 +32856,7 @@
         </p:nvSpPr>
         <p:spPr>
           <a:xfrm>
-            <a:off x="1188720" y="2770632"/>
+            <a:off x="1188720" y="2624328"/>
             <a:ext cx="6217920" cy="822960"/>
           </a:xfrm>
           <a:prstGeom prst="rect">
@@ -32891,7 +32891,7 @@
         </p:nvSpPr>
         <p:spPr>
           <a:xfrm>
-            <a:off x="1051560" y="3465576"/>
+            <a:off x="1051560" y="3145536"/>
             <a:ext cx="6400800" cy="329184"/>
           </a:xfrm>
           <a:prstGeom prst="rect">
@@ -32935,7 +32935,7 @@
         </p:nvSpPr>
         <p:spPr>
           <a:xfrm>
-            <a:off x="1069848" y="3497580"/>
+            <a:off x="1069848" y="3177540"/>
             <a:ext cx="411480" cy="274320"/>
           </a:xfrm>
           <a:prstGeom prst="rect">
@@ -32970,7 +32970,7 @@
         </p:nvSpPr>
         <p:spPr>
           <a:xfrm>
-            <a:off x="1600200" y="3502152"/>
+            <a:off x="1600200" y="3182112"/>
             <a:ext cx="256032" cy="256032"/>
           </a:xfrm>
           <a:prstGeom prst="ellipse">
@@ -33022,7 +33022,7 @@
         </p:blipFill>
         <p:spPr>
           <a:xfrm>
-            <a:off x="1627632" y="3529584"/>
+            <a:off x="1627632" y="3209544"/>
             <a:ext cx="201168" cy="201168"/>
           </a:xfrm>
           <a:prstGeom prst="rect">
@@ -33038,7 +33038,7 @@
         </p:nvSpPr>
         <p:spPr>
           <a:xfrm>
-            <a:off x="1965960" y="3497580"/>
+            <a:off x="1965960" y="3177540"/>
             <a:ext cx="2560320" cy="274320"/>
           </a:xfrm>
           <a:prstGeom prst="rect">
@@ -33073,7 +33073,7 @@
         </p:nvSpPr>
         <p:spPr>
           <a:xfrm>
-            <a:off x="4480560" y="3497580"/>
+            <a:off x="4480560" y="3177540"/>
             <a:ext cx="822960" cy="274320"/>
           </a:xfrm>
           <a:prstGeom prst="rect">
@@ -33108,7 +33108,7 @@
         </p:nvSpPr>
         <p:spPr>
           <a:xfrm>
-            <a:off x="5349240" y="3511296"/>
+            <a:off x="5349240" y="3191256"/>
             <a:ext cx="822960" cy="274320"/>
           </a:xfrm>
           <a:prstGeom prst="rect">
@@ -33143,7 +33143,7 @@
         </p:nvSpPr>
         <p:spPr>
           <a:xfrm>
-            <a:off x="6263640" y="3511296"/>
+            <a:off x="6263640" y="3191256"/>
             <a:ext cx="1051560" cy="274320"/>
           </a:xfrm>
           <a:prstGeom prst="rect">
@@ -33178,7 +33178,7 @@
         </p:nvSpPr>
         <p:spPr>
           <a:xfrm>
-            <a:off x="1051560" y="3803904"/>
+            <a:off x="1051560" y="3483864"/>
             <a:ext cx="6400800" cy="329184"/>
           </a:xfrm>
           <a:prstGeom prst="rect">
@@ -33222,7 +33222,7 @@
         </p:nvSpPr>
         <p:spPr>
           <a:xfrm>
-            <a:off x="1069848" y="3835908"/>
+            <a:off x="1069848" y="3515868"/>
             <a:ext cx="411480" cy="274320"/>
           </a:xfrm>
           <a:prstGeom prst="rect">
@@ -33257,7 +33257,7 @@
         </p:nvSpPr>
         <p:spPr>
           <a:xfrm>
-            <a:off x="1600200" y="3840480"/>
+            <a:off x="1600200" y="3520440"/>
             <a:ext cx="256032" cy="256032"/>
           </a:xfrm>
           <a:prstGeom prst="ellipse">
@@ -33309,7 +33309,7 @@
         </p:blipFill>
         <p:spPr>
           <a:xfrm>
-            <a:off x="1627632" y="3867912"/>
+            <a:off x="1627632" y="3547872"/>
             <a:ext cx="201168" cy="201168"/>
           </a:xfrm>
           <a:prstGeom prst="rect">
@@ -33325,7 +33325,7 @@
         </p:nvSpPr>
         <p:spPr>
           <a:xfrm>
-            <a:off x="1965960" y="3835908"/>
+            <a:off x="1965960" y="3515868"/>
             <a:ext cx="2560320" cy="274320"/>
           </a:xfrm>
           <a:prstGeom prst="rect">
@@ -33360,7 +33360,7 @@
         </p:nvSpPr>
         <p:spPr>
           <a:xfrm>
-            <a:off x="4480560" y="3835908"/>
+            <a:off x="4480560" y="3515868"/>
             <a:ext cx="822960" cy="274320"/>
           </a:xfrm>
           <a:prstGeom prst="rect">
@@ -33395,7 +33395,7 @@
         </p:nvSpPr>
         <p:spPr>
           <a:xfrm>
-            <a:off x="5349240" y="3849624"/>
+            <a:off x="5349240" y="3529584"/>
             <a:ext cx="822960" cy="274320"/>
           </a:xfrm>
           <a:prstGeom prst="rect">
@@ -33430,7 +33430,7 @@
         </p:nvSpPr>
         <p:spPr>
           <a:xfrm>
-            <a:off x="6263640" y="3849624"/>
+            <a:off x="6263640" y="3529584"/>
             <a:ext cx="1051560" cy="274320"/>
           </a:xfrm>
           <a:prstGeom prst="rect">
@@ -33459,13 +33459,127 @@
       </p:sp>
       <p:sp>
         <p:nvSpPr>
-          <p:cNvPr id="28" name="Rounded Rectangle 27"/>
+          <p:cNvPr id="28" name="Oval 27"/>
           <p:cNvSpPr/>
           <p:nvPr/>
         </p:nvSpPr>
         <p:spPr>
           <a:xfrm>
-            <a:off x="822960" y="4754880"/>
+            <a:off x="868680" y="4087368"/>
+            <a:ext cx="128016" cy="128016"/>
+          </a:xfrm>
+          <a:prstGeom prst="ellipse">
+            <a:avLst/>
+          </a:prstGeom>
+          <a:solidFill>
+            <a:srgbClr val="F47321"/>
+          </a:solidFill>
+          <a:ln>
+            <a:noFill/>
+          </a:ln>
+          <a:effectLst/>
+        </p:spPr>
+        <p:style>
+          <a:lnRef idx="1">
+            <a:schemeClr val="accent1"/>
+          </a:lnRef>
+          <a:fillRef idx="3">
+            <a:schemeClr val="accent1"/>
+          </a:fillRef>
+          <a:effectRef idx="2">
+            <a:schemeClr val="accent1"/>
+          </a:effectRef>
+          <a:fontRef idx="minor">
+            <a:schemeClr val="lt1"/>
+          </a:fontRef>
+        </p:style>
+        <p:txBody>
+          <a:bodyPr rtlCol="0" anchor="ctr"/>
+          <a:lstStyle/>
+          <a:p>
+            <a:pPr algn="ctr"/>
+          </a:p>
+        </p:txBody>
+      </p:sp>
+      <p:sp>
+        <p:nvSpPr>
+          <p:cNvPr id="29" name="TextBox 28"/>
+          <p:cNvSpPr txBox="1"/>
+          <p:nvPr/>
+        </p:nvSpPr>
+        <p:spPr>
+          <a:xfrm>
+            <a:off x="1188720" y="3913632"/>
+            <a:ext cx="6217920" cy="822960"/>
+          </a:xfrm>
+          <a:prstGeom prst="rect">
+            <a:avLst/>
+          </a:prstGeom>
+          <a:noFill/>
+        </p:spPr>
+        <p:txBody>
+          <a:bodyPr wrap="square" lIns="0" rIns="0" tIns="0" bIns="0">
+            <a:spAutoFit/>
+          </a:bodyPr>
+          <a:lstStyle/>
+          <a:p>
+            <a:pPr algn="l"/>
+            <a:r>
+              <a:rPr sz="2400" b="1" i="0">
+                <a:solidFill>
+                  <a:srgbClr val="16273D"/>
+                </a:solidFill>
+                <a:latin typeface="Arial"/>
+              </a:rPr>
+              <a:t>The home team has won the last two</a:t>
+            </a:r>
+          </a:p>
+        </p:txBody>
+      </p:sp>
+      <p:sp>
+        <p:nvSpPr>
+          <p:cNvPr id="30" name="TextBox 29"/>
+          <p:cNvSpPr txBox="1"/>
+          <p:nvPr/>
+        </p:nvSpPr>
+        <p:spPr>
+          <a:xfrm>
+            <a:off x="1188720" y="4297680"/>
+            <a:ext cx="6309360" cy="274320"/>
+          </a:xfrm>
+          <a:prstGeom prst="rect">
+            <a:avLst/>
+          </a:prstGeom>
+          <a:noFill/>
+        </p:spPr>
+        <p:txBody>
+          <a:bodyPr wrap="square" lIns="0" rIns="0" tIns="0" bIns="0">
+            <a:spAutoFit/>
+          </a:bodyPr>
+          <a:lstStyle/>
+          <a:p>
+            <a:pPr algn="l"/>
+            <a:r>
+              <a:rPr sz="1100" b="0" i="0">
+                <a:solidFill>
+                  <a:srgbClr val="5C6B7E"/>
+                </a:solidFill>
+                <a:latin typeface="Arial"/>
+              </a:rPr>
+              <a:t>Ole Miss 34–24 last year · Florida 24–17 in 2024, which kept Ole Miss out of the playoff</a:t>
+            </a:r>
+          </a:p>
+        </p:txBody>
+      </p:sp>
+      <p:sp>
+        <p:nvSpPr>
+          <p:cNvPr id="31" name="Rounded Rectangle 30"/>
+          <p:cNvSpPr/>
+          <p:nvPr/>
+        </p:nvSpPr>
+        <p:spPr>
+          <a:xfrm>
+            <a:off x="822960" y="4818888"/>
             <a:ext cx="6583680" cy="960120"/>
           </a:xfrm>
           <a:prstGeom prst="roundRect">
@@ -33503,14 +33617,14 @@
       </p:sp>
       <p:sp>
         <p:nvSpPr>
-          <p:cNvPr id="29" name="TextBox 28"/>
-          <p:cNvSpPr txBox="1"/>
-          <p:nvPr/>
-        </p:nvSpPr>
-        <p:spPr>
-          <a:xfrm>
-            <a:off x="1051560" y="4809744"/>
-            <a:ext cx="6126480" cy="868680"/>
+          <p:cNvPr id="32" name="TextBox 31"/>
+          <p:cNvSpPr txBox="1"/>
+          <p:nvPr/>
+        </p:nvSpPr>
+        <p:spPr>
+          <a:xfrm>
+            <a:off x="1051560" y="5047488"/>
+            <a:ext cx="6126480" cy="502920"/>
           </a:xfrm>
           <a:prstGeom prst="rect">
             <a:avLst/>
@@ -33525,32 +33639,20 @@
           <a:p>
             <a:pPr algn="l"/>
             <a:r>
-              <a:rPr sz="1400" b="1" i="0">
+              <a:rPr sz="2000" b="1" i="0">
                 <a:solidFill>
                   <a:srgbClr val="0A2851"/>
                 </a:solidFill>
                 <a:latin typeface="Arial"/>
               </a:rPr>
-              <a:t>The home team has won the last two.</a:t>
-            </a:r>
-          </a:p>
-          <a:p>
-            <a:pPr algn="l"/>
-            <a:r>
-              <a:rPr sz="1400" b="1" i="0">
-                <a:solidFill>
-                  <a:srgbClr val="0A2851"/>
-                </a:solidFill>
-                <a:latin typeface="Arial"/>
-              </a:rPr>
-              <a:t>Ole Miss 34–24 last year. Florida 24–17 in 2024 (the loss that kept Ole Miss out of the playoff).</a:t>
-            </a:r>
-          </a:p>
-        </p:txBody>
-      </p:sp>
-      <p:sp>
-        <p:nvSpPr>
-          <p:cNvPr id="30" name="Rounded Rectangle 29"/>
+              <a:t>59% — a field-goal game between two 3–0 teams</a:t>
+            </a:r>
+          </a:p>
+        </p:txBody>
+      </p:sp>
+      <p:sp>
+        <p:nvSpPr>
+          <p:cNvPr id="33" name="Rounded Rectangle 32"/>
           <p:cNvSpPr/>
           <p:nvPr/>
         </p:nvSpPr>
@@ -33594,7 +33696,7 @@
       </p:sp>
       <p:sp>
         <p:nvSpPr>
-          <p:cNvPr id="31" name="TextBox 30"/>
+          <p:cNvPr id="34" name="TextBox 33"/>
           <p:cNvSpPr txBox="1"/>
           <p:nvPr/>
         </p:nvSpPr>
@@ -33629,7 +33731,7 @@
       </p:sp>
       <p:sp>
         <p:nvSpPr>
-          <p:cNvPr id="32" name="TextBox 31"/>
+          <p:cNvPr id="35" name="TextBox 34"/>
           <p:cNvSpPr txBox="1"/>
           <p:nvPr/>
         </p:nvSpPr>
@@ -33664,7 +33766,7 @@
       </p:sp>
       <p:sp>
         <p:nvSpPr>
-          <p:cNvPr id="33" name="TextBox 32"/>
+          <p:cNvPr id="36" name="TextBox 35"/>
           <p:cNvSpPr txBox="1"/>
           <p:nvPr/>
         </p:nvSpPr>
@@ -33699,7 +33801,7 @@
       </p:sp>
       <p:sp>
         <p:nvSpPr>
-          <p:cNvPr id="34" name="TextBox 33"/>
+          <p:cNvPr id="37" name="TextBox 36"/>
           <p:cNvSpPr txBox="1"/>
           <p:nvPr/>
         </p:nvSpPr>
@@ -33734,7 +33836,7 @@
       </p:sp>
       <p:sp>
         <p:nvSpPr>
-          <p:cNvPr id="35" name="TextBox 34"/>
+          <p:cNvPr id="38" name="TextBox 37"/>
           <p:cNvSpPr txBox="1"/>
           <p:nvPr/>
         </p:nvSpPr>
@@ -33769,7 +33871,7 @@
       </p:sp>
       <p:sp>
         <p:nvSpPr>
-          <p:cNvPr id="36" name="TextBox 35"/>
+          <p:cNvPr id="39" name="TextBox 38"/>
           <p:cNvSpPr txBox="1"/>
           <p:nvPr/>
         </p:nvSpPr>
@@ -33804,7 +33906,7 @@
       </p:sp>
       <p:sp>
         <p:nvSpPr>
-          <p:cNvPr id="37" name="TextBox 36"/>
+          <p:cNvPr id="40" name="TextBox 39"/>
           <p:cNvSpPr txBox="1"/>
           <p:nvPr/>
         </p:nvSpPr>
@@ -33839,7 +33941,7 @@
       </p:sp>
       <p:sp>
         <p:nvSpPr>
-          <p:cNvPr id="38" name="TextBox 37"/>
+          <p:cNvPr id="41" name="TextBox 40"/>
           <p:cNvSpPr txBox="1"/>
           <p:nvPr/>
         </p:nvSpPr>
@@ -33874,7 +33976,7 @@
       </p:sp>
       <p:sp>
         <p:nvSpPr>
-          <p:cNvPr id="39" name="Rounded Rectangle 38"/>
+          <p:cNvPr id="42" name="Rounded Rectangle 41"/>
           <p:cNvSpPr/>
           <p:nvPr/>
         </p:nvSpPr>
@@ -33918,7 +34020,7 @@
       </p:sp>
       <p:sp>
         <p:nvSpPr>
-          <p:cNvPr id="40" name="Rounded Rectangle 39"/>
+          <p:cNvPr id="43" name="Rounded Rectangle 42"/>
           <p:cNvSpPr/>
           <p:nvPr/>
         </p:nvSpPr>
@@ -33962,7 +34064,7 @@
       </p:sp>
       <p:sp>
         <p:nvSpPr>
-          <p:cNvPr id="41" name="TextBox 40"/>
+          <p:cNvPr id="44" name="TextBox 43"/>
           <p:cNvSpPr txBox="1"/>
           <p:nvPr/>
         </p:nvSpPr>
@@ -33997,7 +34099,7 @@
       </p:sp>
       <p:sp>
         <p:nvSpPr>
-          <p:cNvPr id="42" name="TextBox 41"/>
+          <p:cNvPr id="45" name="TextBox 44"/>
           <p:cNvSpPr txBox="1"/>
           <p:nvPr/>
         </p:nvSpPr>
@@ -34032,7 +34134,7 @@
       </p:sp>
       <p:sp>
         <p:nvSpPr>
-          <p:cNvPr id="43" name="TextBox 42"/>
+          <p:cNvPr id="46" name="TextBox 45"/>
           <p:cNvSpPr txBox="1"/>
           <p:nvPr/>
         </p:nvSpPr>

</xml_diff>

<commit_message>
Ep5 (postponed to 9/23): pre-mortem line on the game slides; record-vs-number explainer and playoff talking points in the Top 25 notes
Co-Authored-By: Claude Fable 5.1 <noreply@anthropic.com>
</commit_message>
<xml_diff>
--- a/decks/2026_Week4_Episode5.pptx
+++ b/decks/2026_Week4_Episode5.pptx
@@ -11899,8 +11899,8 @@
         </p:nvSpPr>
         <p:spPr>
           <a:xfrm>
-            <a:off x="1051560" y="4983480"/>
-            <a:ext cx="6126480" cy="502920"/>
+            <a:off x="1051560" y="4846320"/>
+            <a:ext cx="6126480" cy="411480"/>
           </a:xfrm>
           <a:prstGeom prst="rect">
             <a:avLst/>
@@ -11915,7 +11915,7 @@
           <a:p>
             <a:pPr algn="l"/>
             <a:r>
-              <a:rPr sz="2000" b="1" i="0">
+              <a:rPr sz="1600" b="1" i="0">
                 <a:solidFill>
                   <a:srgbClr val="0A2851"/>
                 </a:solidFill>
@@ -11928,7 +11928,42 @@
       </p:sp>
       <p:sp>
         <p:nvSpPr>
-          <p:cNvPr id="12" name="Rounded Rectangle 11"/>
+          <p:cNvPr id="12" name="TextBox 11"/>
+          <p:cNvSpPr txBox="1"/>
+          <p:nvPr/>
+        </p:nvSpPr>
+        <p:spPr>
+          <a:xfrm>
+            <a:off x="1051560" y="5285232"/>
+            <a:ext cx="6126480" cy="365760"/>
+          </a:xfrm>
+          <a:prstGeom prst="rect">
+            <a:avLst/>
+          </a:prstGeom>
+          <a:noFill/>
+        </p:spPr>
+        <p:txBody>
+          <a:bodyPr wrap="square" lIns="0" rIns="0" tIns="0" bIns="0">
+            <a:spAutoFit/>
+          </a:bodyPr>
+          <a:lstStyle/>
+          <a:p>
+            <a:pPr algn="l"/>
+            <a:r>
+              <a:rPr sz="1250" b="1" i="0">
+                <a:solidFill>
+                  <a:srgbClr val="F47321"/>
+                </a:solidFill>
+                <a:latin typeface="Arial"/>
+              </a:rPr>
+              <a:t>Wrong if Georgia averages under 4.5 yards a carry</a:t>
+            </a:r>
+          </a:p>
+        </p:txBody>
+      </p:sp>
+      <p:sp>
+        <p:nvSpPr>
+          <p:cNvPr id="13" name="Rounded Rectangle 12"/>
           <p:cNvSpPr/>
           <p:nvPr/>
         </p:nvSpPr>
@@ -11972,7 +12007,7 @@
       </p:sp>
       <p:sp>
         <p:nvSpPr>
-          <p:cNvPr id="13" name="TextBox 12"/>
+          <p:cNvPr id="14" name="TextBox 13"/>
           <p:cNvSpPr txBox="1"/>
           <p:nvPr/>
         </p:nvSpPr>
@@ -12007,7 +12042,7 @@
       </p:sp>
       <p:sp>
         <p:nvSpPr>
-          <p:cNvPr id="14" name="TextBox 13"/>
+          <p:cNvPr id="15" name="TextBox 14"/>
           <p:cNvSpPr txBox="1"/>
           <p:nvPr/>
         </p:nvSpPr>
@@ -12042,7 +12077,7 @@
       </p:sp>
       <p:sp>
         <p:nvSpPr>
-          <p:cNvPr id="15" name="TextBox 14"/>
+          <p:cNvPr id="16" name="TextBox 15"/>
           <p:cNvSpPr txBox="1"/>
           <p:nvPr/>
         </p:nvSpPr>
@@ -12077,7 +12112,7 @@
       </p:sp>
       <p:sp>
         <p:nvSpPr>
-          <p:cNvPr id="16" name="TextBox 15"/>
+          <p:cNvPr id="17" name="TextBox 16"/>
           <p:cNvSpPr txBox="1"/>
           <p:nvPr/>
         </p:nvSpPr>
@@ -12112,7 +12147,7 @@
       </p:sp>
       <p:sp>
         <p:nvSpPr>
-          <p:cNvPr id="17" name="TextBox 16"/>
+          <p:cNvPr id="18" name="TextBox 17"/>
           <p:cNvSpPr txBox="1"/>
           <p:nvPr/>
         </p:nvSpPr>
@@ -12147,7 +12182,7 @@
       </p:sp>
       <p:sp>
         <p:nvSpPr>
-          <p:cNvPr id="18" name="TextBox 17"/>
+          <p:cNvPr id="19" name="TextBox 18"/>
           <p:cNvSpPr txBox="1"/>
           <p:nvPr/>
         </p:nvSpPr>
@@ -12182,7 +12217,7 @@
       </p:sp>
       <p:sp>
         <p:nvSpPr>
-          <p:cNvPr id="19" name="TextBox 18"/>
+          <p:cNvPr id="20" name="TextBox 19"/>
           <p:cNvSpPr txBox="1"/>
           <p:nvPr/>
         </p:nvSpPr>
@@ -12217,7 +12252,7 @@
       </p:sp>
       <p:sp>
         <p:nvSpPr>
-          <p:cNvPr id="20" name="TextBox 19"/>
+          <p:cNvPr id="21" name="TextBox 20"/>
           <p:cNvSpPr txBox="1"/>
           <p:nvPr/>
         </p:nvSpPr>
@@ -12252,7 +12287,7 @@
       </p:sp>
       <p:sp>
         <p:nvSpPr>
-          <p:cNvPr id="21" name="Rounded Rectangle 20"/>
+          <p:cNvPr id="22" name="Rounded Rectangle 21"/>
           <p:cNvSpPr/>
           <p:nvPr/>
         </p:nvSpPr>
@@ -12296,7 +12331,7 @@
       </p:sp>
       <p:sp>
         <p:nvSpPr>
-          <p:cNvPr id="22" name="Rounded Rectangle 21"/>
+          <p:cNvPr id="23" name="Rounded Rectangle 22"/>
           <p:cNvSpPr/>
           <p:nvPr/>
         </p:nvSpPr>
@@ -12340,7 +12375,7 @@
       </p:sp>
       <p:sp>
         <p:nvSpPr>
-          <p:cNvPr id="23" name="TextBox 22"/>
+          <p:cNvPr id="24" name="TextBox 23"/>
           <p:cNvSpPr txBox="1"/>
           <p:nvPr/>
         </p:nvSpPr>
@@ -12375,7 +12410,7 @@
       </p:sp>
       <p:sp>
         <p:nvSpPr>
-          <p:cNvPr id="24" name="TextBox 23"/>
+          <p:cNvPr id="25" name="TextBox 24"/>
           <p:cNvSpPr txBox="1"/>
           <p:nvPr/>
         </p:nvSpPr>
@@ -12410,7 +12445,7 @@
       </p:sp>
       <p:sp>
         <p:nvSpPr>
-          <p:cNvPr id="25" name="TextBox 24"/>
+          <p:cNvPr id="26" name="TextBox 25"/>
           <p:cNvSpPr txBox="1"/>
           <p:nvPr/>
         </p:nvSpPr>
@@ -14080,8 +14115,8 @@
         </p:nvSpPr>
         <p:spPr>
           <a:xfrm>
-            <a:off x="1051560" y="4983480"/>
-            <a:ext cx="6126480" cy="502920"/>
+            <a:off x="1051560" y="4846320"/>
+            <a:ext cx="6126480" cy="411480"/>
           </a:xfrm>
           <a:prstGeom prst="rect">
             <a:avLst/>
@@ -14096,7 +14131,7 @@
           <a:p>
             <a:pPr algn="l"/>
             <a:r>
-              <a:rPr sz="2000" b="1" i="0">
+              <a:rPr sz="1600" b="1" i="0">
                 <a:solidFill>
                   <a:srgbClr val="0A2851"/>
                 </a:solidFill>
@@ -14109,7 +14144,42 @@
       </p:sp>
       <p:sp>
         <p:nvSpPr>
-          <p:cNvPr id="12" name="Rounded Rectangle 11"/>
+          <p:cNvPr id="12" name="TextBox 11"/>
+          <p:cNvSpPr txBox="1"/>
+          <p:nvPr/>
+        </p:nvSpPr>
+        <p:spPr>
+          <a:xfrm>
+            <a:off x="1051560" y="5285232"/>
+            <a:ext cx="6126480" cy="365760"/>
+          </a:xfrm>
+          <a:prstGeom prst="rect">
+            <a:avLst/>
+          </a:prstGeom>
+          <a:noFill/>
+        </p:spPr>
+        <p:txBody>
+          <a:bodyPr wrap="square" lIns="0" rIns="0" tIns="0" bIns="0">
+            <a:spAutoFit/>
+          </a:bodyPr>
+          <a:lstStyle/>
+          <a:p>
+            <a:pPr algn="l"/>
+            <a:r>
+              <a:rPr sz="1250" b="1" i="0">
+                <a:solidFill>
+                  <a:srgbClr val="F47321"/>
+                </a:solidFill>
+                <a:latin typeface="Arial"/>
+              </a:rPr>
+              <a:t>Wrong if USC converts more than 46% on third down</a:t>
+            </a:r>
+          </a:p>
+        </p:txBody>
+      </p:sp>
+      <p:sp>
+        <p:nvSpPr>
+          <p:cNvPr id="13" name="Rounded Rectangle 12"/>
           <p:cNvSpPr/>
           <p:nvPr/>
         </p:nvSpPr>
@@ -14153,7 +14223,7 @@
       </p:sp>
       <p:sp>
         <p:nvSpPr>
-          <p:cNvPr id="13" name="TextBox 12"/>
+          <p:cNvPr id="14" name="TextBox 13"/>
           <p:cNvSpPr txBox="1"/>
           <p:nvPr/>
         </p:nvSpPr>
@@ -14188,7 +14258,7 @@
       </p:sp>
       <p:sp>
         <p:nvSpPr>
-          <p:cNvPr id="14" name="TextBox 13"/>
+          <p:cNvPr id="15" name="TextBox 14"/>
           <p:cNvSpPr txBox="1"/>
           <p:nvPr/>
         </p:nvSpPr>
@@ -14223,7 +14293,7 @@
       </p:sp>
       <p:sp>
         <p:nvSpPr>
-          <p:cNvPr id="15" name="TextBox 14"/>
+          <p:cNvPr id="16" name="TextBox 15"/>
           <p:cNvSpPr txBox="1"/>
           <p:nvPr/>
         </p:nvSpPr>
@@ -14258,7 +14328,7 @@
       </p:sp>
       <p:sp>
         <p:nvSpPr>
-          <p:cNvPr id="16" name="TextBox 15"/>
+          <p:cNvPr id="17" name="TextBox 16"/>
           <p:cNvSpPr txBox="1"/>
           <p:nvPr/>
         </p:nvSpPr>
@@ -14293,7 +14363,7 @@
       </p:sp>
       <p:sp>
         <p:nvSpPr>
-          <p:cNvPr id="17" name="TextBox 16"/>
+          <p:cNvPr id="18" name="TextBox 17"/>
           <p:cNvSpPr txBox="1"/>
           <p:nvPr/>
         </p:nvSpPr>
@@ -14328,7 +14398,7 @@
       </p:sp>
       <p:sp>
         <p:nvSpPr>
-          <p:cNvPr id="18" name="TextBox 17"/>
+          <p:cNvPr id="19" name="TextBox 18"/>
           <p:cNvSpPr txBox="1"/>
           <p:nvPr/>
         </p:nvSpPr>
@@ -14363,7 +14433,7 @@
       </p:sp>
       <p:sp>
         <p:nvSpPr>
-          <p:cNvPr id="19" name="TextBox 18"/>
+          <p:cNvPr id="20" name="TextBox 19"/>
           <p:cNvSpPr txBox="1"/>
           <p:nvPr/>
         </p:nvSpPr>
@@ -14398,7 +14468,7 @@
       </p:sp>
       <p:sp>
         <p:nvSpPr>
-          <p:cNvPr id="20" name="TextBox 19"/>
+          <p:cNvPr id="21" name="TextBox 20"/>
           <p:cNvSpPr txBox="1"/>
           <p:nvPr/>
         </p:nvSpPr>
@@ -14433,7 +14503,7 @@
       </p:sp>
       <p:sp>
         <p:nvSpPr>
-          <p:cNvPr id="21" name="Rounded Rectangle 20"/>
+          <p:cNvPr id="22" name="Rounded Rectangle 21"/>
           <p:cNvSpPr/>
           <p:nvPr/>
         </p:nvSpPr>
@@ -14477,7 +14547,7 @@
       </p:sp>
       <p:sp>
         <p:nvSpPr>
-          <p:cNvPr id="22" name="Rounded Rectangle 21"/>
+          <p:cNvPr id="23" name="Rounded Rectangle 22"/>
           <p:cNvSpPr/>
           <p:nvPr/>
         </p:nvSpPr>
@@ -14521,7 +14591,7 @@
       </p:sp>
       <p:sp>
         <p:nvSpPr>
-          <p:cNvPr id="23" name="TextBox 22"/>
+          <p:cNvPr id="24" name="TextBox 23"/>
           <p:cNvSpPr txBox="1"/>
           <p:nvPr/>
         </p:nvSpPr>
@@ -14556,7 +14626,7 @@
       </p:sp>
       <p:sp>
         <p:nvSpPr>
-          <p:cNvPr id="24" name="TextBox 23"/>
+          <p:cNvPr id="25" name="TextBox 24"/>
           <p:cNvSpPr txBox="1"/>
           <p:nvPr/>
         </p:nvSpPr>
@@ -14591,7 +14661,7 @@
       </p:sp>
       <p:sp>
         <p:nvSpPr>
-          <p:cNvPr id="25" name="TextBox 24"/>
+          <p:cNvPr id="26" name="TextBox 25"/>
           <p:cNvSpPr txBox="1"/>
           <p:nvPr/>
         </p:nvSpPr>
@@ -16261,8 +16331,8 @@
         </p:nvSpPr>
         <p:spPr>
           <a:xfrm>
-            <a:off x="1051560" y="4983480"/>
-            <a:ext cx="6126480" cy="502920"/>
+            <a:off x="1051560" y="4846320"/>
+            <a:ext cx="6126480" cy="411480"/>
           </a:xfrm>
           <a:prstGeom prst="rect">
             <a:avLst/>
@@ -16277,7 +16347,7 @@
           <a:p>
             <a:pPr algn="l"/>
             <a:r>
-              <a:rPr sz="2000" b="1" i="0">
+              <a:rPr sz="1600" b="1" i="0">
                 <a:solidFill>
                   <a:srgbClr val="0A2851"/>
                 </a:solidFill>
@@ -16290,7 +16360,42 @@
       </p:sp>
       <p:sp>
         <p:nvSpPr>
-          <p:cNvPr id="12" name="Rounded Rectangle 11"/>
+          <p:cNvPr id="12" name="TextBox 11"/>
+          <p:cNvSpPr txBox="1"/>
+          <p:nvPr/>
+        </p:nvSpPr>
+        <p:spPr>
+          <a:xfrm>
+            <a:off x="1051560" y="5285232"/>
+            <a:ext cx="6126480" cy="365760"/>
+          </a:xfrm>
+          <a:prstGeom prst="rect">
+            <a:avLst/>
+          </a:prstGeom>
+          <a:noFill/>
+        </p:spPr>
+        <p:txBody>
+          <a:bodyPr wrap="square" lIns="0" rIns="0" tIns="0" bIns="0">
+            <a:spAutoFit/>
+          </a:bodyPr>
+          <a:lstStyle/>
+          <a:p>
+            <a:pPr algn="l"/>
+            <a:r>
+              <a:rPr sz="1250" b="1" i="0">
+                <a:solidFill>
+                  <a:srgbClr val="F47321"/>
+                </a:solidFill>
+                <a:latin typeface="Arial"/>
+              </a:rPr>
+              <a:t>Wrong if Texas A&amp;M averages more than 2.8 yards a carry</a:t>
+            </a:r>
+          </a:p>
+        </p:txBody>
+      </p:sp>
+      <p:sp>
+        <p:nvSpPr>
+          <p:cNvPr id="13" name="Rounded Rectangle 12"/>
           <p:cNvSpPr/>
           <p:nvPr/>
         </p:nvSpPr>
@@ -16334,7 +16439,7 @@
       </p:sp>
       <p:sp>
         <p:nvSpPr>
-          <p:cNvPr id="13" name="TextBox 12"/>
+          <p:cNvPr id="14" name="TextBox 13"/>
           <p:cNvSpPr txBox="1"/>
           <p:nvPr/>
         </p:nvSpPr>
@@ -16369,7 +16474,7 @@
       </p:sp>
       <p:sp>
         <p:nvSpPr>
-          <p:cNvPr id="14" name="TextBox 13"/>
+          <p:cNvPr id="15" name="TextBox 14"/>
           <p:cNvSpPr txBox="1"/>
           <p:nvPr/>
         </p:nvSpPr>
@@ -16404,7 +16509,7 @@
       </p:sp>
       <p:sp>
         <p:nvSpPr>
-          <p:cNvPr id="15" name="TextBox 14"/>
+          <p:cNvPr id="16" name="TextBox 15"/>
           <p:cNvSpPr txBox="1"/>
           <p:nvPr/>
         </p:nvSpPr>
@@ -16439,7 +16544,7 @@
       </p:sp>
       <p:sp>
         <p:nvSpPr>
-          <p:cNvPr id="16" name="TextBox 15"/>
+          <p:cNvPr id="17" name="TextBox 16"/>
           <p:cNvSpPr txBox="1"/>
           <p:nvPr/>
         </p:nvSpPr>
@@ -16474,7 +16579,7 @@
       </p:sp>
       <p:sp>
         <p:nvSpPr>
-          <p:cNvPr id="17" name="TextBox 16"/>
+          <p:cNvPr id="18" name="TextBox 17"/>
           <p:cNvSpPr txBox="1"/>
           <p:nvPr/>
         </p:nvSpPr>
@@ -16509,7 +16614,7 @@
       </p:sp>
       <p:sp>
         <p:nvSpPr>
-          <p:cNvPr id="18" name="TextBox 17"/>
+          <p:cNvPr id="19" name="TextBox 18"/>
           <p:cNvSpPr txBox="1"/>
           <p:nvPr/>
         </p:nvSpPr>
@@ -16544,7 +16649,7 @@
       </p:sp>
       <p:sp>
         <p:nvSpPr>
-          <p:cNvPr id="19" name="TextBox 18"/>
+          <p:cNvPr id="20" name="TextBox 19"/>
           <p:cNvSpPr txBox="1"/>
           <p:nvPr/>
         </p:nvSpPr>
@@ -16579,7 +16684,7 @@
       </p:sp>
       <p:sp>
         <p:nvSpPr>
-          <p:cNvPr id="20" name="TextBox 19"/>
+          <p:cNvPr id="21" name="TextBox 20"/>
           <p:cNvSpPr txBox="1"/>
           <p:nvPr/>
         </p:nvSpPr>
@@ -16614,7 +16719,7 @@
       </p:sp>
       <p:sp>
         <p:nvSpPr>
-          <p:cNvPr id="21" name="Rounded Rectangle 20"/>
+          <p:cNvPr id="22" name="Rounded Rectangle 21"/>
           <p:cNvSpPr/>
           <p:nvPr/>
         </p:nvSpPr>
@@ -16658,7 +16763,7 @@
       </p:sp>
       <p:sp>
         <p:nvSpPr>
-          <p:cNvPr id="22" name="Rounded Rectangle 21"/>
+          <p:cNvPr id="23" name="Rounded Rectangle 22"/>
           <p:cNvSpPr/>
           <p:nvPr/>
         </p:nvSpPr>
@@ -16702,7 +16807,7 @@
       </p:sp>
       <p:sp>
         <p:nvSpPr>
-          <p:cNvPr id="23" name="TextBox 22"/>
+          <p:cNvPr id="24" name="TextBox 23"/>
           <p:cNvSpPr txBox="1"/>
           <p:nvPr/>
         </p:nvSpPr>
@@ -16737,7 +16842,7 @@
       </p:sp>
       <p:sp>
         <p:nvSpPr>
-          <p:cNvPr id="24" name="TextBox 23"/>
+          <p:cNvPr id="25" name="TextBox 24"/>
           <p:cNvSpPr txBox="1"/>
           <p:nvPr/>
         </p:nvSpPr>
@@ -16772,7 +16877,7 @@
       </p:sp>
       <p:sp>
         <p:nvSpPr>
-          <p:cNvPr id="25" name="TextBox 24"/>
+          <p:cNvPr id="26" name="TextBox 25"/>
           <p:cNvSpPr txBox="1"/>
           <p:nvPr/>
         </p:nvSpPr>
@@ -30675,8 +30780,8 @@
         </p:nvSpPr>
         <p:spPr>
           <a:xfrm>
-            <a:off x="1051560" y="4983480"/>
-            <a:ext cx="6126480" cy="502920"/>
+            <a:off x="1051560" y="4846320"/>
+            <a:ext cx="6126480" cy="411480"/>
           </a:xfrm>
           <a:prstGeom prst="rect">
             <a:avLst/>
@@ -30691,7 +30796,7 @@
           <a:p>
             <a:pPr algn="l"/>
             <a:r>
-              <a:rPr sz="2000" b="1" i="0">
+              <a:rPr sz="1600" b="1" i="0">
                 <a:solidFill>
                   <a:srgbClr val="0A2851"/>
                 </a:solidFill>
@@ -30704,7 +30809,42 @@
       </p:sp>
       <p:sp>
         <p:nvSpPr>
-          <p:cNvPr id="12" name="Rounded Rectangle 11"/>
+          <p:cNvPr id="12" name="TextBox 11"/>
+          <p:cNvSpPr txBox="1"/>
+          <p:nvPr/>
+        </p:nvSpPr>
+        <p:spPr>
+          <a:xfrm>
+            <a:off x="1051560" y="5285232"/>
+            <a:ext cx="6126480" cy="365760"/>
+          </a:xfrm>
+          <a:prstGeom prst="rect">
+            <a:avLst/>
+          </a:prstGeom>
+          <a:noFill/>
+        </p:spPr>
+        <p:txBody>
+          <a:bodyPr wrap="square" lIns="0" rIns="0" tIns="0" bIns="0">
+            <a:spAutoFit/>
+          </a:bodyPr>
+          <a:lstStyle/>
+          <a:p>
+            <a:pPr algn="l"/>
+            <a:r>
+              <a:rPr sz="1250" b="1" i="0">
+                <a:solidFill>
+                  <a:srgbClr val="F47321"/>
+                </a:solidFill>
+                <a:latin typeface="Arial"/>
+              </a:rPr>
+              <a:t>Wrong if Tennessee averages more than 5.0 yards a carry</a:t>
+            </a:r>
+          </a:p>
+        </p:txBody>
+      </p:sp>
+      <p:sp>
+        <p:nvSpPr>
+          <p:cNvPr id="13" name="Rounded Rectangle 12"/>
           <p:cNvSpPr/>
           <p:nvPr/>
         </p:nvSpPr>
@@ -30748,7 +30888,7 @@
       </p:sp>
       <p:sp>
         <p:nvSpPr>
-          <p:cNvPr id="13" name="TextBox 12"/>
+          <p:cNvPr id="14" name="TextBox 13"/>
           <p:cNvSpPr txBox="1"/>
           <p:nvPr/>
         </p:nvSpPr>
@@ -30783,7 +30923,7 @@
       </p:sp>
       <p:sp>
         <p:nvSpPr>
-          <p:cNvPr id="14" name="TextBox 13"/>
+          <p:cNvPr id="15" name="TextBox 14"/>
           <p:cNvSpPr txBox="1"/>
           <p:nvPr/>
         </p:nvSpPr>
@@ -30818,7 +30958,7 @@
       </p:sp>
       <p:sp>
         <p:nvSpPr>
-          <p:cNvPr id="15" name="TextBox 14"/>
+          <p:cNvPr id="16" name="TextBox 15"/>
           <p:cNvSpPr txBox="1"/>
           <p:nvPr/>
         </p:nvSpPr>
@@ -30853,7 +30993,7 @@
       </p:sp>
       <p:sp>
         <p:nvSpPr>
-          <p:cNvPr id="16" name="TextBox 15"/>
+          <p:cNvPr id="17" name="TextBox 16"/>
           <p:cNvSpPr txBox="1"/>
           <p:nvPr/>
         </p:nvSpPr>
@@ -30888,7 +31028,7 @@
       </p:sp>
       <p:sp>
         <p:nvSpPr>
-          <p:cNvPr id="17" name="TextBox 16"/>
+          <p:cNvPr id="18" name="TextBox 17"/>
           <p:cNvSpPr txBox="1"/>
           <p:nvPr/>
         </p:nvSpPr>
@@ -30923,7 +31063,7 @@
       </p:sp>
       <p:sp>
         <p:nvSpPr>
-          <p:cNvPr id="18" name="TextBox 17"/>
+          <p:cNvPr id="19" name="TextBox 18"/>
           <p:cNvSpPr txBox="1"/>
           <p:nvPr/>
         </p:nvSpPr>
@@ -30958,7 +31098,7 @@
       </p:sp>
       <p:sp>
         <p:nvSpPr>
-          <p:cNvPr id="19" name="TextBox 18"/>
+          <p:cNvPr id="20" name="TextBox 19"/>
           <p:cNvSpPr txBox="1"/>
           <p:nvPr/>
         </p:nvSpPr>
@@ -30993,7 +31133,7 @@
       </p:sp>
       <p:sp>
         <p:nvSpPr>
-          <p:cNvPr id="20" name="TextBox 19"/>
+          <p:cNvPr id="21" name="TextBox 20"/>
           <p:cNvSpPr txBox="1"/>
           <p:nvPr/>
         </p:nvSpPr>
@@ -31028,7 +31168,7 @@
       </p:sp>
       <p:sp>
         <p:nvSpPr>
-          <p:cNvPr id="21" name="Rounded Rectangle 20"/>
+          <p:cNvPr id="22" name="Rounded Rectangle 21"/>
           <p:cNvSpPr/>
           <p:nvPr/>
         </p:nvSpPr>
@@ -31072,7 +31212,7 @@
       </p:sp>
       <p:sp>
         <p:nvSpPr>
-          <p:cNvPr id="22" name="Rounded Rectangle 21"/>
+          <p:cNvPr id="23" name="Rounded Rectangle 22"/>
           <p:cNvSpPr/>
           <p:nvPr/>
         </p:nvSpPr>
@@ -31116,7 +31256,7 @@
       </p:sp>
       <p:sp>
         <p:nvSpPr>
-          <p:cNvPr id="23" name="TextBox 22"/>
+          <p:cNvPr id="24" name="TextBox 23"/>
           <p:cNvSpPr txBox="1"/>
           <p:nvPr/>
         </p:nvSpPr>
@@ -31151,7 +31291,7 @@
       </p:sp>
       <p:sp>
         <p:nvSpPr>
-          <p:cNvPr id="24" name="TextBox 23"/>
+          <p:cNvPr id="25" name="TextBox 24"/>
           <p:cNvSpPr txBox="1"/>
           <p:nvPr/>
         </p:nvSpPr>
@@ -31186,7 +31326,7 @@
       </p:sp>
       <p:sp>
         <p:nvSpPr>
-          <p:cNvPr id="25" name="TextBox 24"/>
+          <p:cNvPr id="26" name="TextBox 25"/>
           <p:cNvSpPr txBox="1"/>
           <p:nvPr/>
         </p:nvSpPr>
@@ -33623,8 +33763,8 @@
         </p:nvSpPr>
         <p:spPr>
           <a:xfrm>
-            <a:off x="1051560" y="5047488"/>
-            <a:ext cx="6126480" cy="502920"/>
+            <a:off x="1051560" y="4910328"/>
+            <a:ext cx="6126480" cy="411480"/>
           </a:xfrm>
           <a:prstGeom prst="rect">
             <a:avLst/>
@@ -33639,7 +33779,7 @@
           <a:p>
             <a:pPr algn="l"/>
             <a:r>
-              <a:rPr sz="2000" b="1" i="0">
+              <a:rPr sz="1600" b="1" i="0">
                 <a:solidFill>
                   <a:srgbClr val="0A2851"/>
                 </a:solidFill>
@@ -33652,7 +33792,42 @@
       </p:sp>
       <p:sp>
         <p:nvSpPr>
-          <p:cNvPr id="33" name="Rounded Rectangle 32"/>
+          <p:cNvPr id="33" name="TextBox 32"/>
+          <p:cNvSpPr txBox="1"/>
+          <p:nvPr/>
+        </p:nvSpPr>
+        <p:spPr>
+          <a:xfrm>
+            <a:off x="1051560" y="5349240"/>
+            <a:ext cx="6126480" cy="365760"/>
+          </a:xfrm>
+          <a:prstGeom prst="rect">
+            <a:avLst/>
+          </a:prstGeom>
+          <a:noFill/>
+        </p:spPr>
+        <p:txBody>
+          <a:bodyPr wrap="square" lIns="0" rIns="0" tIns="0" bIns="0">
+            <a:spAutoFit/>
+          </a:bodyPr>
+          <a:lstStyle/>
+          <a:p>
+            <a:pPr algn="l"/>
+            <a:r>
+              <a:rPr sz="1250" b="1" i="0">
+                <a:solidFill>
+                  <a:srgbClr val="F47321"/>
+                </a:solidFill>
+                <a:latin typeface="Arial"/>
+              </a:rPr>
+              <a:t>Wrong if Florida averages under 9.9 yards an attempt</a:t>
+            </a:r>
+          </a:p>
+        </p:txBody>
+      </p:sp>
+      <p:sp>
+        <p:nvSpPr>
+          <p:cNvPr id="34" name="Rounded Rectangle 33"/>
           <p:cNvSpPr/>
           <p:nvPr/>
         </p:nvSpPr>
@@ -33696,7 +33871,7 @@
       </p:sp>
       <p:sp>
         <p:nvSpPr>
-          <p:cNvPr id="34" name="TextBox 33"/>
+          <p:cNvPr id="35" name="TextBox 34"/>
           <p:cNvSpPr txBox="1"/>
           <p:nvPr/>
         </p:nvSpPr>
@@ -33731,7 +33906,7 @@
       </p:sp>
       <p:sp>
         <p:nvSpPr>
-          <p:cNvPr id="35" name="TextBox 34"/>
+          <p:cNvPr id="36" name="TextBox 35"/>
           <p:cNvSpPr txBox="1"/>
           <p:nvPr/>
         </p:nvSpPr>
@@ -33766,7 +33941,7 @@
       </p:sp>
       <p:sp>
         <p:nvSpPr>
-          <p:cNvPr id="36" name="TextBox 35"/>
+          <p:cNvPr id="37" name="TextBox 36"/>
           <p:cNvSpPr txBox="1"/>
           <p:nvPr/>
         </p:nvSpPr>
@@ -33801,7 +33976,7 @@
       </p:sp>
       <p:sp>
         <p:nvSpPr>
-          <p:cNvPr id="37" name="TextBox 36"/>
+          <p:cNvPr id="38" name="TextBox 37"/>
           <p:cNvSpPr txBox="1"/>
           <p:nvPr/>
         </p:nvSpPr>
@@ -33836,7 +34011,7 @@
       </p:sp>
       <p:sp>
         <p:nvSpPr>
-          <p:cNvPr id="38" name="TextBox 37"/>
+          <p:cNvPr id="39" name="TextBox 38"/>
           <p:cNvSpPr txBox="1"/>
           <p:nvPr/>
         </p:nvSpPr>
@@ -33871,7 +34046,7 @@
       </p:sp>
       <p:sp>
         <p:nvSpPr>
-          <p:cNvPr id="39" name="TextBox 38"/>
+          <p:cNvPr id="40" name="TextBox 39"/>
           <p:cNvSpPr txBox="1"/>
           <p:nvPr/>
         </p:nvSpPr>
@@ -33906,7 +34081,7 @@
       </p:sp>
       <p:sp>
         <p:nvSpPr>
-          <p:cNvPr id="40" name="TextBox 39"/>
+          <p:cNvPr id="41" name="TextBox 40"/>
           <p:cNvSpPr txBox="1"/>
           <p:nvPr/>
         </p:nvSpPr>
@@ -33941,7 +34116,7 @@
       </p:sp>
       <p:sp>
         <p:nvSpPr>
-          <p:cNvPr id="41" name="TextBox 40"/>
+          <p:cNvPr id="42" name="TextBox 41"/>
           <p:cNvSpPr txBox="1"/>
           <p:nvPr/>
         </p:nvSpPr>
@@ -33976,7 +34151,7 @@
       </p:sp>
       <p:sp>
         <p:nvSpPr>
-          <p:cNvPr id="42" name="Rounded Rectangle 41"/>
+          <p:cNvPr id="43" name="Rounded Rectangle 42"/>
           <p:cNvSpPr/>
           <p:nvPr/>
         </p:nvSpPr>
@@ -34020,7 +34195,7 @@
       </p:sp>
       <p:sp>
         <p:nvSpPr>
-          <p:cNvPr id="43" name="Rounded Rectangle 42"/>
+          <p:cNvPr id="44" name="Rounded Rectangle 43"/>
           <p:cNvSpPr/>
           <p:nvPr/>
         </p:nvSpPr>
@@ -34064,7 +34239,7 @@
       </p:sp>
       <p:sp>
         <p:nvSpPr>
-          <p:cNvPr id="44" name="TextBox 43"/>
+          <p:cNvPr id="45" name="TextBox 44"/>
           <p:cNvSpPr txBox="1"/>
           <p:nvPr/>
         </p:nvSpPr>
@@ -34099,7 +34274,7 @@
       </p:sp>
       <p:sp>
         <p:nvSpPr>
-          <p:cNvPr id="45" name="TextBox 44"/>
+          <p:cNvPr id="46" name="TextBox 45"/>
           <p:cNvSpPr txBox="1"/>
           <p:nvPr/>
         </p:nvSpPr>
@@ -34134,7 +34309,7 @@
       </p:sp>
       <p:sp>
         <p:nvSpPr>
-          <p:cNvPr id="46" name="TextBox 45"/>
+          <p:cNvPr id="47" name="TextBox 46"/>
           <p:cNvSpPr txBox="1"/>
           <p:nvPr/>
         </p:nvSpPr>

</xml_diff>

<commit_message>
Ep5 recording day: card frozen on the final lines, Corey's Week 4 calls and boards filled, flow-based merge (merge_flow.py)
freeze_card froze the Week 4 card at 17:09 UTC (score calls Texas 32-23 and Florida 31-28 moved with
the totals; A&M at LSU market -8.5). merge_flow.py merges Corey's deck with ours on the show's slide
flow instead of text matching, which broke once he built Week 4 on top of last week's merged file.
Corey's score calls, Top 25, Heisman five, Hot Seat ten and superdog picks read from his deck (read-only).

Co-Authored-By: Claude Fable 5.1 <noreply@anthropic.com>
</commit_message>
<xml_diff>
--- a/decks/2026_Week4_Episode5.pptx
+++ b/decks/2026_Week4_Episode5.pptx
@@ -16607,7 +16607,7 @@
                 </a:solidFill>
                 <a:latin typeface="Arial"/>
               </a:rPr>
-              <a:t>LSU –9.5</a:t>
+              <a:t>LSU –8.5</a:t>
             </a:r>
           </a:p>
         </p:txBody>
@@ -23503,7 +23503,7 @@
                 </a:solidFill>
                 <a:latin typeface="Arial"/>
               </a:rPr>
-              <a:t>Texas 33 – Tennessee 24</a:t>
+              <a:t>Texas 32 – Tennessee 23</a:t>
             </a:r>
           </a:p>
         </p:txBody>
@@ -23788,7 +23788,7 @@
                 </a:solidFill>
                 <a:latin typeface="Arial"/>
               </a:rPr>
-              <a:t>Florida 32 – Ole Miss 29</a:t>
+              <a:t>Florida 31 – Ole Miss 28</a:t>
             </a:r>
           </a:p>
         </p:txBody>
@@ -24678,7 +24678,7 @@
                 </a:solidFill>
                 <a:latin typeface="Arial"/>
               </a:rPr>
-              <a:t>machine LSU –5.5  ·  market LSU –9.5  ·  machine 4 higher on Texas A&amp;M</a:t>
+              <a:t>machine LSU –5.5  ·  market LSU –8.5  ·  machine 3 higher on Texas A&amp;M</a:t>
             </a:r>
           </a:p>
         </p:txBody>
@@ -24897,7 +24897,7 @@
                 </a:solidFill>
                 <a:latin typeface="Arial"/>
               </a:rPr>
-              <a:t>Superdogs: 5 for a cover · 5 + the spread for a win · 1 for a push · research, not picks · market = DraftKings, Sep 21</a:t>
+              <a:t>Superdogs: 5 for a cover · 5 + the spread for a win · 1 for a push · research, not picks · market = DraftKings, Sep 23</a:t>
             </a:r>
           </a:p>
         </p:txBody>
@@ -31126,7 +31126,7 @@
                 </a:solidFill>
                 <a:latin typeface="Arial"/>
               </a:rPr>
-              <a:t>Texas 33 – Tennessee 24</a:t>
+              <a:t>Texas 32 – Tennessee 23</a:t>
             </a:r>
           </a:p>
         </p:txBody>
@@ -34109,7 +34109,7 @@
                 </a:solidFill>
                 <a:latin typeface="Arial"/>
               </a:rPr>
-              <a:t>Florida 32 – Ole Miss 29</a:t>
+              <a:t>Florida 31 – Ole Miss 28</a:t>
             </a:r>
           </a:p>
         </p:txBody>

</xml_diff>

<commit_message>
Closer slide: Corey's (Man) score call beside the machine's on every row; superdog spreads synced to the frozen card
Co-Authored-By: Claude Fable 5.1 <noreply@anthropic.com>
</commit_message>
<xml_diff>
--- a/decks/2026_Week4_Episode5.pptx
+++ b/decks/2026_Week4_Episode5.pptx
@@ -23253,7 +23253,7 @@
                 </a:solidFill>
                 <a:latin typeface="Arial"/>
               </a:rPr>
-              <a:t>Our predictions</a:t>
+              <a:t>Our predictions — machine and man</a:t>
             </a:r>
           </a:p>
         </p:txBody>
@@ -23447,7 +23447,7 @@
         <p:spPr>
           <a:xfrm>
             <a:off x="2286000" y="1938528"/>
-            <a:ext cx="4937760" cy="365760"/>
+            <a:ext cx="2286000" cy="365760"/>
           </a:xfrm>
           <a:prstGeom prst="rect">
             <a:avLst/>
@@ -23462,7 +23462,7 @@
           <a:p>
             <a:pPr algn="l"/>
             <a:r>
-              <a:rPr sz="1600" b="1" i="0">
+              <a:rPr sz="1500" b="1" i="0">
                 <a:solidFill>
                   <a:srgbClr val="FFFFFF"/>
                 </a:solidFill>
@@ -23481,8 +23481,8 @@
         </p:nvSpPr>
         <p:spPr>
           <a:xfrm>
-            <a:off x="6400800" y="1837943"/>
-            <a:ext cx="4754880" cy="411480"/>
+            <a:off x="4480560" y="1856231"/>
+            <a:ext cx="3931920" cy="411480"/>
           </a:xfrm>
           <a:prstGeom prst="rect">
             <a:avLst/>
@@ -23497,13 +23497,13 @@
           <a:p>
             <a:pPr algn="r"/>
             <a:r>
-              <a:rPr sz="1900" b="1" i="0">
+              <a:rPr sz="1400" b="1" i="0">
                 <a:solidFill>
                   <a:srgbClr val="F47321"/>
                 </a:solidFill>
                 <a:latin typeface="Arial"/>
               </a:rPr>
-              <a:t>Texas 32 – Tennessee 23</a:t>
+              <a:t>Machine Texas 32 – Tennessee 23</a:t>
             </a:r>
           </a:p>
         </p:txBody>
@@ -23511,6 +23511,41 @@
       <p:sp>
         <p:nvSpPr>
           <p:cNvPr id="11" name="TextBox 10"/>
+          <p:cNvSpPr txBox="1"/>
+          <p:nvPr/>
+        </p:nvSpPr>
+        <p:spPr>
+          <a:xfrm>
+            <a:off x="8503920" y="1856231"/>
+            <a:ext cx="2651760" cy="411480"/>
+          </a:xfrm>
+          <a:prstGeom prst="rect">
+            <a:avLst/>
+          </a:prstGeom>
+          <a:noFill/>
+        </p:spPr>
+        <p:txBody>
+          <a:bodyPr wrap="square" lIns="0" rIns="0" tIns="0" bIns="0">
+            <a:spAutoFit/>
+          </a:bodyPr>
+          <a:lstStyle/>
+          <a:p>
+            <a:pPr algn="r"/>
+            <a:r>
+              <a:rPr sz="1400" b="1" i="0">
+                <a:solidFill>
+                  <a:srgbClr val="5CD68A"/>
+                </a:solidFill>
+                <a:latin typeface="Arial"/>
+              </a:rPr>
+              <a:t>Man Texas 31–24</a:t>
+            </a:r>
+          </a:p>
+        </p:txBody>
+      </p:sp>
+      <p:sp>
+        <p:nvSpPr>
+          <p:cNvPr id="12" name="TextBox 11"/>
           <p:cNvSpPr txBox="1"/>
           <p:nvPr/>
         </p:nvSpPr>
@@ -23545,7 +23580,7 @@
       </p:sp>
       <p:sp>
         <p:nvSpPr>
-          <p:cNvPr id="12" name="Rounded Rectangle 11"/>
+          <p:cNvPr id="13" name="Rounded Rectangle 12"/>
           <p:cNvSpPr/>
           <p:nvPr/>
         </p:nvSpPr>
@@ -23589,7 +23624,7 @@
       </p:sp>
       <p:sp>
         <p:nvSpPr>
-          <p:cNvPr id="13" name="Oval 12"/>
+          <p:cNvPr id="14" name="Oval 13"/>
           <p:cNvSpPr/>
           <p:nvPr/>
         </p:nvSpPr>
@@ -23633,7 +23668,7 @@
       </p:sp>
       <p:pic>
         <p:nvPicPr>
-          <p:cNvPr id="14" name="Picture 13" descr="olemiss.png"/>
+          <p:cNvPr id="15" name="Picture 14" descr="olemiss.png"/>
           <p:cNvPicPr>
             <a:picLocks noChangeAspect="1"/>
           </p:cNvPicPr>
@@ -23657,7 +23692,7 @@
       </p:pic>
       <p:sp>
         <p:nvSpPr>
-          <p:cNvPr id="15" name="Oval 14"/>
+          <p:cNvPr id="16" name="Oval 15"/>
           <p:cNvSpPr/>
           <p:nvPr/>
         </p:nvSpPr>
@@ -23701,7 +23736,7 @@
       </p:sp>
       <p:pic>
         <p:nvPicPr>
-          <p:cNvPr id="16" name="Picture 15" descr="florida.png"/>
+          <p:cNvPr id="17" name="Picture 16" descr="florida.png"/>
           <p:cNvPicPr>
             <a:picLocks noChangeAspect="1"/>
           </p:cNvPicPr>
@@ -23725,14 +23760,14 @@
       </p:pic>
       <p:sp>
         <p:nvSpPr>
-          <p:cNvPr id="17" name="TextBox 16"/>
+          <p:cNvPr id="18" name="TextBox 17"/>
           <p:cNvSpPr txBox="1"/>
           <p:nvPr/>
         </p:nvSpPr>
         <p:spPr>
           <a:xfrm>
             <a:off x="2286000" y="2670048"/>
-            <a:ext cx="4937760" cy="365760"/>
+            <a:ext cx="2286000" cy="365760"/>
           </a:xfrm>
           <a:prstGeom prst="rect">
             <a:avLst/>
@@ -23747,7 +23782,7 @@
           <a:p>
             <a:pPr algn="l"/>
             <a:r>
-              <a:rPr sz="1600" b="1" i="0">
+              <a:rPr sz="1500" b="1" i="0">
                 <a:solidFill>
                   <a:srgbClr val="FFFFFF"/>
                 </a:solidFill>
@@ -23760,14 +23795,14 @@
       </p:sp>
       <p:sp>
         <p:nvSpPr>
-          <p:cNvPr id="18" name="TextBox 17"/>
-          <p:cNvSpPr txBox="1"/>
-          <p:nvPr/>
-        </p:nvSpPr>
-        <p:spPr>
-          <a:xfrm>
-            <a:off x="6400800" y="2569464"/>
-            <a:ext cx="4754880" cy="411480"/>
+          <p:cNvPr id="19" name="TextBox 18"/>
+          <p:cNvSpPr txBox="1"/>
+          <p:nvPr/>
+        </p:nvSpPr>
+        <p:spPr>
+          <a:xfrm>
+            <a:off x="4480560" y="2587752"/>
+            <a:ext cx="3931920" cy="411480"/>
           </a:xfrm>
           <a:prstGeom prst="rect">
             <a:avLst/>
@@ -23782,20 +23817,55 @@
           <a:p>
             <a:pPr algn="r"/>
             <a:r>
-              <a:rPr sz="1900" b="1" i="0">
+              <a:rPr sz="1400" b="1" i="0">
                 <a:solidFill>
                   <a:srgbClr val="F47321"/>
                 </a:solidFill>
                 <a:latin typeface="Arial"/>
               </a:rPr>
-              <a:t>Florida 31 – Ole Miss 28</a:t>
-            </a:r>
-          </a:p>
-        </p:txBody>
-      </p:sp>
-      <p:sp>
-        <p:nvSpPr>
-          <p:cNvPr id="19" name="TextBox 18"/>
+              <a:t>Machine Florida 31 – Ole Miss 28</a:t>
+            </a:r>
+          </a:p>
+        </p:txBody>
+      </p:sp>
+      <p:sp>
+        <p:nvSpPr>
+          <p:cNvPr id="20" name="TextBox 19"/>
+          <p:cNvSpPr txBox="1"/>
+          <p:nvPr/>
+        </p:nvSpPr>
+        <p:spPr>
+          <a:xfrm>
+            <a:off x="8503920" y="2587752"/>
+            <a:ext cx="2651760" cy="411480"/>
+          </a:xfrm>
+          <a:prstGeom prst="rect">
+            <a:avLst/>
+          </a:prstGeom>
+          <a:noFill/>
+        </p:spPr>
+        <p:txBody>
+          <a:bodyPr wrap="square" lIns="0" rIns="0" tIns="0" bIns="0">
+            <a:spAutoFit/>
+          </a:bodyPr>
+          <a:lstStyle/>
+          <a:p>
+            <a:pPr algn="r"/>
+            <a:r>
+              <a:rPr sz="1400" b="1" i="0">
+                <a:solidFill>
+                  <a:srgbClr val="5CD68A"/>
+                </a:solidFill>
+                <a:latin typeface="Arial"/>
+              </a:rPr>
+              <a:t>Man Florida 35–34</a:t>
+            </a:r>
+          </a:p>
+        </p:txBody>
+      </p:sp>
+      <p:sp>
+        <p:nvSpPr>
+          <p:cNvPr id="21" name="TextBox 20"/>
           <p:cNvSpPr txBox="1"/>
           <p:nvPr/>
         </p:nvSpPr>
@@ -23830,7 +23900,7 @@
       </p:sp>
       <p:sp>
         <p:nvSpPr>
-          <p:cNvPr id="20" name="Rounded Rectangle 19"/>
+          <p:cNvPr id="22" name="Rounded Rectangle 21"/>
           <p:cNvSpPr/>
           <p:nvPr/>
         </p:nvSpPr>
@@ -23874,7 +23944,7 @@
       </p:sp>
       <p:sp>
         <p:nvSpPr>
-          <p:cNvPr id="21" name="Oval 20"/>
+          <p:cNvPr id="23" name="Oval 22"/>
           <p:cNvSpPr/>
           <p:nvPr/>
         </p:nvSpPr>
@@ -23918,7 +23988,7 @@
       </p:sp>
       <p:pic>
         <p:nvPicPr>
-          <p:cNvPr id="22" name="Picture 21" descr="oklahoma.png"/>
+          <p:cNvPr id="24" name="Picture 23" descr="oklahoma.png"/>
           <p:cNvPicPr>
             <a:picLocks noChangeAspect="1"/>
           </p:cNvPicPr>
@@ -23942,7 +24012,7 @@
       </p:pic>
       <p:sp>
         <p:nvSpPr>
-          <p:cNvPr id="23" name="Oval 22"/>
+          <p:cNvPr id="25" name="Oval 24"/>
           <p:cNvSpPr/>
           <p:nvPr/>
         </p:nvSpPr>
@@ -23986,7 +24056,7 @@
       </p:sp>
       <p:pic>
         <p:nvPicPr>
-          <p:cNvPr id="24" name="Picture 23" descr="georgia.png"/>
+          <p:cNvPr id="26" name="Picture 25" descr="georgia.png"/>
           <p:cNvPicPr>
             <a:picLocks noChangeAspect="1"/>
           </p:cNvPicPr>
@@ -24010,14 +24080,14 @@
       </p:pic>
       <p:sp>
         <p:nvSpPr>
-          <p:cNvPr id="25" name="TextBox 24"/>
+          <p:cNvPr id="27" name="TextBox 26"/>
           <p:cNvSpPr txBox="1"/>
           <p:nvPr/>
         </p:nvSpPr>
         <p:spPr>
           <a:xfrm>
             <a:off x="2286000" y="3401568"/>
-            <a:ext cx="4937760" cy="365760"/>
+            <a:ext cx="2286000" cy="365760"/>
           </a:xfrm>
           <a:prstGeom prst="rect">
             <a:avLst/>
@@ -24032,7 +24102,7 @@
           <a:p>
             <a:pPr algn="l"/>
             <a:r>
-              <a:rPr sz="1600" b="1" i="0">
+              <a:rPr sz="1500" b="1" i="0">
                 <a:solidFill>
                   <a:srgbClr val="FFFFFF"/>
                 </a:solidFill>
@@ -24045,14 +24115,14 @@
       </p:sp>
       <p:sp>
         <p:nvSpPr>
-          <p:cNvPr id="26" name="TextBox 25"/>
-          <p:cNvSpPr txBox="1"/>
-          <p:nvPr/>
-        </p:nvSpPr>
-        <p:spPr>
-          <a:xfrm>
-            <a:off x="6400800" y="3300984"/>
-            <a:ext cx="4754880" cy="411480"/>
+          <p:cNvPr id="28" name="TextBox 27"/>
+          <p:cNvSpPr txBox="1"/>
+          <p:nvPr/>
+        </p:nvSpPr>
+        <p:spPr>
+          <a:xfrm>
+            <a:off x="4480560" y="3319272"/>
+            <a:ext cx="3931920" cy="411480"/>
           </a:xfrm>
           <a:prstGeom prst="rect">
             <a:avLst/>
@@ -24067,20 +24137,55 @@
           <a:p>
             <a:pPr algn="r"/>
             <a:r>
-              <a:rPr sz="1900" b="1" i="0">
+              <a:rPr sz="1400" b="1" i="0">
                 <a:solidFill>
                   <a:srgbClr val="F47321"/>
                 </a:solidFill>
                 <a:latin typeface="Arial"/>
               </a:rPr>
-              <a:t>Georgia 29 – Oklahoma 15</a:t>
-            </a:r>
-          </a:p>
-        </p:txBody>
-      </p:sp>
-      <p:sp>
-        <p:nvSpPr>
-          <p:cNvPr id="27" name="TextBox 26"/>
+              <a:t>Machine Georgia 29 – Oklahoma 15</a:t>
+            </a:r>
+          </a:p>
+        </p:txBody>
+      </p:sp>
+      <p:sp>
+        <p:nvSpPr>
+          <p:cNvPr id="29" name="TextBox 28"/>
+          <p:cNvSpPr txBox="1"/>
+          <p:nvPr/>
+        </p:nvSpPr>
+        <p:spPr>
+          <a:xfrm>
+            <a:off x="8503920" y="3319272"/>
+            <a:ext cx="2651760" cy="411480"/>
+          </a:xfrm>
+          <a:prstGeom prst="rect">
+            <a:avLst/>
+          </a:prstGeom>
+          <a:noFill/>
+        </p:spPr>
+        <p:txBody>
+          <a:bodyPr wrap="square" lIns="0" rIns="0" tIns="0" bIns="0">
+            <a:spAutoFit/>
+          </a:bodyPr>
+          <a:lstStyle/>
+          <a:p>
+            <a:pPr algn="r"/>
+            <a:r>
+              <a:rPr sz="1400" b="1" i="0">
+                <a:solidFill>
+                  <a:srgbClr val="5CD68A"/>
+                </a:solidFill>
+                <a:latin typeface="Arial"/>
+              </a:rPr>
+              <a:t>Man Georgia 34–20</a:t>
+            </a:r>
+          </a:p>
+        </p:txBody>
+      </p:sp>
+      <p:sp>
+        <p:nvSpPr>
+          <p:cNvPr id="30" name="TextBox 29"/>
           <p:cNvSpPr txBox="1"/>
           <p:nvPr/>
         </p:nvSpPr>
@@ -24115,7 +24220,7 @@
       </p:sp>
       <p:sp>
         <p:nvSpPr>
-          <p:cNvPr id="28" name="Rounded Rectangle 27"/>
+          <p:cNvPr id="31" name="Rounded Rectangle 30"/>
           <p:cNvSpPr/>
           <p:nvPr/>
         </p:nvSpPr>
@@ -24159,7 +24264,7 @@
       </p:sp>
       <p:sp>
         <p:nvSpPr>
-          <p:cNvPr id="29" name="Oval 28"/>
+          <p:cNvPr id="32" name="Oval 31"/>
           <p:cNvSpPr/>
           <p:nvPr/>
         </p:nvSpPr>
@@ -24203,7 +24308,7 @@
       </p:sp>
       <p:pic>
         <p:nvPicPr>
-          <p:cNvPr id="30" name="Picture 29" descr="oregon.png"/>
+          <p:cNvPr id="33" name="Picture 32" descr="oregon.png"/>
           <p:cNvPicPr>
             <a:picLocks noChangeAspect="1"/>
           </p:cNvPicPr>
@@ -24227,7 +24332,7 @@
       </p:pic>
       <p:sp>
         <p:nvSpPr>
-          <p:cNvPr id="31" name="Oval 30"/>
+          <p:cNvPr id="34" name="Oval 33"/>
           <p:cNvSpPr/>
           <p:nvPr/>
         </p:nvSpPr>
@@ -24271,7 +24376,7 @@
       </p:sp>
       <p:pic>
         <p:nvPicPr>
-          <p:cNvPr id="32" name="Picture 31" descr="usc.png"/>
+          <p:cNvPr id="35" name="Picture 34" descr="usc.png"/>
           <p:cNvPicPr>
             <a:picLocks noChangeAspect="1"/>
           </p:cNvPicPr>
@@ -24295,14 +24400,14 @@
       </p:pic>
       <p:sp>
         <p:nvSpPr>
-          <p:cNvPr id="33" name="TextBox 32"/>
+          <p:cNvPr id="36" name="TextBox 35"/>
           <p:cNvSpPr txBox="1"/>
           <p:nvPr/>
         </p:nvSpPr>
         <p:spPr>
           <a:xfrm>
             <a:off x="2286000" y="4133087"/>
-            <a:ext cx="4937760" cy="365760"/>
+            <a:ext cx="2286000" cy="365760"/>
           </a:xfrm>
           <a:prstGeom prst="rect">
             <a:avLst/>
@@ -24317,7 +24422,7 @@
           <a:p>
             <a:pPr algn="l"/>
             <a:r>
-              <a:rPr sz="1600" b="1" i="0">
+              <a:rPr sz="1500" b="1" i="0">
                 <a:solidFill>
                   <a:srgbClr val="FFFFFF"/>
                 </a:solidFill>
@@ -24330,14 +24435,14 @@
       </p:sp>
       <p:sp>
         <p:nvSpPr>
-          <p:cNvPr id="34" name="TextBox 33"/>
-          <p:cNvSpPr txBox="1"/>
-          <p:nvPr/>
-        </p:nvSpPr>
-        <p:spPr>
-          <a:xfrm>
-            <a:off x="6400800" y="4032503"/>
-            <a:ext cx="4754880" cy="411480"/>
+          <p:cNvPr id="37" name="TextBox 36"/>
+          <p:cNvSpPr txBox="1"/>
+          <p:nvPr/>
+        </p:nvSpPr>
+        <p:spPr>
+          <a:xfrm>
+            <a:off x="4480560" y="4050791"/>
+            <a:ext cx="3931920" cy="411480"/>
           </a:xfrm>
           <a:prstGeom prst="rect">
             <a:avLst/>
@@ -24352,20 +24457,55 @@
           <a:p>
             <a:pPr algn="r"/>
             <a:r>
-              <a:rPr sz="1900" b="1" i="0">
+              <a:rPr sz="1400" b="1" i="0">
                 <a:solidFill>
                   <a:srgbClr val="F47321"/>
                 </a:solidFill>
                 <a:latin typeface="Arial"/>
               </a:rPr>
-              <a:t>Oregon 32 – USC 31</a:t>
-            </a:r>
-          </a:p>
-        </p:txBody>
-      </p:sp>
-      <p:sp>
-        <p:nvSpPr>
-          <p:cNvPr id="35" name="TextBox 34"/>
+              <a:t>Machine Oregon 32 – USC 31</a:t>
+            </a:r>
+          </a:p>
+        </p:txBody>
+      </p:sp>
+      <p:sp>
+        <p:nvSpPr>
+          <p:cNvPr id="38" name="TextBox 37"/>
+          <p:cNvSpPr txBox="1"/>
+          <p:nvPr/>
+        </p:nvSpPr>
+        <p:spPr>
+          <a:xfrm>
+            <a:off x="8503920" y="4050791"/>
+            <a:ext cx="2651760" cy="411480"/>
+          </a:xfrm>
+          <a:prstGeom prst="rect">
+            <a:avLst/>
+          </a:prstGeom>
+          <a:noFill/>
+        </p:spPr>
+        <p:txBody>
+          <a:bodyPr wrap="square" lIns="0" rIns="0" tIns="0" bIns="0">
+            <a:spAutoFit/>
+          </a:bodyPr>
+          <a:lstStyle/>
+          <a:p>
+            <a:pPr algn="r"/>
+            <a:r>
+              <a:rPr sz="1400" b="1" i="0">
+                <a:solidFill>
+                  <a:srgbClr val="5CD68A"/>
+                </a:solidFill>
+                <a:latin typeface="Arial"/>
+              </a:rPr>
+              <a:t>Man Oregon 35–34</a:t>
+            </a:r>
+          </a:p>
+        </p:txBody>
+      </p:sp>
+      <p:sp>
+        <p:nvSpPr>
+          <p:cNvPr id="39" name="TextBox 38"/>
           <p:cNvSpPr txBox="1"/>
           <p:nvPr/>
         </p:nvSpPr>
@@ -24400,7 +24540,7 @@
       </p:sp>
       <p:sp>
         <p:nvSpPr>
-          <p:cNvPr id="36" name="Rounded Rectangle 35"/>
+          <p:cNvPr id="40" name="Rounded Rectangle 39"/>
           <p:cNvSpPr/>
           <p:nvPr/>
         </p:nvSpPr>
@@ -24444,7 +24584,7 @@
       </p:sp>
       <p:sp>
         <p:nvSpPr>
-          <p:cNvPr id="37" name="Oval 36"/>
+          <p:cNvPr id="41" name="Oval 40"/>
           <p:cNvSpPr/>
           <p:nvPr/>
         </p:nvSpPr>
@@ -24488,7 +24628,7 @@
       </p:sp>
       <p:pic>
         <p:nvPicPr>
-          <p:cNvPr id="38" name="Picture 37" descr="texasam.png"/>
+          <p:cNvPr id="42" name="Picture 41" descr="texasam.png"/>
           <p:cNvPicPr>
             <a:picLocks noChangeAspect="1"/>
           </p:cNvPicPr>
@@ -24512,7 +24652,7 @@
       </p:pic>
       <p:sp>
         <p:nvSpPr>
-          <p:cNvPr id="39" name="Oval 38"/>
+          <p:cNvPr id="43" name="Oval 42"/>
           <p:cNvSpPr/>
           <p:nvPr/>
         </p:nvSpPr>
@@ -24556,7 +24696,7 @@
       </p:sp>
       <p:pic>
         <p:nvPicPr>
-          <p:cNvPr id="40" name="Picture 39" descr="lsu.png"/>
+          <p:cNvPr id="44" name="Picture 43" descr="lsu.png"/>
           <p:cNvPicPr>
             <a:picLocks noChangeAspect="1"/>
           </p:cNvPicPr>
@@ -24580,14 +24720,14 @@
       </p:pic>
       <p:sp>
         <p:nvSpPr>
-          <p:cNvPr id="41" name="TextBox 40"/>
+          <p:cNvPr id="45" name="TextBox 44"/>
           <p:cNvSpPr txBox="1"/>
           <p:nvPr/>
         </p:nvSpPr>
         <p:spPr>
           <a:xfrm>
             <a:off x="2286000" y="4864607"/>
-            <a:ext cx="4937760" cy="365760"/>
+            <a:ext cx="2286000" cy="365760"/>
           </a:xfrm>
           <a:prstGeom prst="rect">
             <a:avLst/>
@@ -24602,7 +24742,7 @@
           <a:p>
             <a:pPr algn="l"/>
             <a:r>
-              <a:rPr sz="1600" b="1" i="0">
+              <a:rPr sz="1500" b="1" i="0">
                 <a:solidFill>
                   <a:srgbClr val="FFFFFF"/>
                 </a:solidFill>
@@ -24615,14 +24755,14 @@
       </p:sp>
       <p:sp>
         <p:nvSpPr>
-          <p:cNvPr id="42" name="TextBox 41"/>
-          <p:cNvSpPr txBox="1"/>
-          <p:nvPr/>
-        </p:nvSpPr>
-        <p:spPr>
-          <a:xfrm>
-            <a:off x="6400800" y="4764023"/>
-            <a:ext cx="4754880" cy="411480"/>
+          <p:cNvPr id="46" name="TextBox 45"/>
+          <p:cNvSpPr txBox="1"/>
+          <p:nvPr/>
+        </p:nvSpPr>
+        <p:spPr>
+          <a:xfrm>
+            <a:off x="4480560" y="4782312"/>
+            <a:ext cx="3931920" cy="411480"/>
           </a:xfrm>
           <a:prstGeom prst="rect">
             <a:avLst/>
@@ -24637,20 +24777,55 @@
           <a:p>
             <a:pPr algn="r"/>
             <a:r>
-              <a:rPr sz="1900" b="1" i="0">
+              <a:rPr sz="1400" b="1" i="0">
                 <a:solidFill>
                   <a:srgbClr val="F47321"/>
                 </a:solidFill>
                 <a:latin typeface="Arial"/>
               </a:rPr>
-              <a:t>LSU 29 – Texas A&amp;M 23</a:t>
-            </a:r>
-          </a:p>
-        </p:txBody>
-      </p:sp>
-      <p:sp>
-        <p:nvSpPr>
-          <p:cNvPr id="43" name="TextBox 42"/>
+              <a:t>Machine LSU 29 – Texas A&amp;M 23</a:t>
+            </a:r>
+          </a:p>
+        </p:txBody>
+      </p:sp>
+      <p:sp>
+        <p:nvSpPr>
+          <p:cNvPr id="47" name="TextBox 46"/>
+          <p:cNvSpPr txBox="1"/>
+          <p:nvPr/>
+        </p:nvSpPr>
+        <p:spPr>
+          <a:xfrm>
+            <a:off x="8503920" y="4782312"/>
+            <a:ext cx="2651760" cy="411480"/>
+          </a:xfrm>
+          <a:prstGeom prst="rect">
+            <a:avLst/>
+          </a:prstGeom>
+          <a:noFill/>
+        </p:spPr>
+        <p:txBody>
+          <a:bodyPr wrap="square" lIns="0" rIns="0" tIns="0" bIns="0">
+            <a:spAutoFit/>
+          </a:bodyPr>
+          <a:lstStyle/>
+          <a:p>
+            <a:pPr algn="r"/>
+            <a:r>
+              <a:rPr sz="1400" b="1" i="0">
+                <a:solidFill>
+                  <a:srgbClr val="5CD68A"/>
+                </a:solidFill>
+                <a:latin typeface="Arial"/>
+              </a:rPr>
+              <a:t>Man LSU 31–27</a:t>
+            </a:r>
+          </a:p>
+        </p:txBody>
+      </p:sp>
+      <p:sp>
+        <p:nvSpPr>
+          <p:cNvPr id="48" name="TextBox 47"/>
           <p:cNvSpPr txBox="1"/>
           <p:nvPr/>
         </p:nvSpPr>
@@ -24685,7 +24860,7 @@
       </p:sp>
       <p:sp>
         <p:nvSpPr>
-          <p:cNvPr id="44" name="Rounded Rectangle 43"/>
+          <p:cNvPr id="49" name="Rounded Rectangle 48"/>
           <p:cNvSpPr/>
           <p:nvPr/>
         </p:nvSpPr>
@@ -24729,7 +24904,7 @@
       </p:sp>
       <p:sp>
         <p:nvSpPr>
-          <p:cNvPr id="45" name="TextBox 44"/>
+          <p:cNvPr id="50" name="TextBox 49"/>
           <p:cNvSpPr txBox="1"/>
           <p:nvPr/>
         </p:nvSpPr>
@@ -24764,7 +24939,7 @@
       </p:sp>
       <p:sp>
         <p:nvSpPr>
-          <p:cNvPr id="46" name="TextBox 45"/>
+          <p:cNvPr id="51" name="TextBox 50"/>
           <p:cNvSpPr txBox="1"/>
           <p:nvPr/>
         </p:nvSpPr>
@@ -24799,7 +24974,7 @@
       </p:sp>
       <p:sp>
         <p:nvSpPr>
-          <p:cNvPr id="47" name="TextBox 46"/>
+          <p:cNvPr id="52" name="TextBox 51"/>
           <p:cNvSpPr txBox="1"/>
           <p:nvPr/>
         </p:nvSpPr>
@@ -24834,7 +25009,7 @@
       </p:sp>
       <p:sp>
         <p:nvSpPr>
-          <p:cNvPr id="48" name="TextBox 47"/>
+          <p:cNvPr id="53" name="TextBox 52"/>
           <p:cNvSpPr txBox="1"/>
           <p:nvPr/>
         </p:nvSpPr>
@@ -24869,7 +25044,7 @@
       </p:sp>
       <p:sp>
         <p:nvSpPr>
-          <p:cNvPr id="49" name="TextBox 48"/>
+          <p:cNvPr id="54" name="TextBox 53"/>
           <p:cNvSpPr txBox="1"/>
           <p:nvPr/>
         </p:nvSpPr>

</xml_diff>